<commit_message>
Expand deck: add 'What we've built' traction slide, team-of-4, real costed BOM budget
</commit_message>
<xml_diff>
--- a/AgriRover_Pitch.pptx
+++ b/AgriRover_Pitch.pptx
@@ -12,6 +12,7 @@
     <p:sldId id="260" r:id="rId6"/>
     <p:sldId id="261" r:id="rId7"/>
     <p:sldId id="262" r:id="rId8"/>
+    <p:sldId id="263" r:id="rId9"/>
   </p:sldIdLst>
   <p:sldSz cx="12192000" cy="6858000"/>
   <p:notesSz cx="6858000" cy="9144000"/>
@@ -104,7 +105,7 @@
       </p:grpSpPr>
       <p:sp>
         <p:nvSpPr>
-          <p:cNvPr id="20" name="stripe"/>
+          <p:cNvPr id="20" name="s1"/>
           <p:cNvSpPr/>
           <p:nvPr/>
         </p:nvSpPr>
@@ -131,7 +132,7 @@
       </p:sp>
       <p:sp>
         <p:nvSpPr>
-          <p:cNvPr id="21" name="stripe2"/>
+          <p:cNvPr id="21" name="s2"/>
           <p:cNvSpPr/>
           <p:nvPr/>
         </p:nvSpPr>
@@ -164,7 +165,7 @@
         </p:nvSpPr>
         <p:spPr>
           <a:xfrm>
-            <a:off x="731520" y="1737360"/>
+            <a:off x="731520" y="1554480"/>
             <a:ext cx="9692640" cy="1280160"/>
           </a:xfrm>
           <a:prstGeom prst="rect">
@@ -207,7 +208,7 @@
         </p:nvSpPr>
         <p:spPr>
           <a:xfrm>
-            <a:off x="777240" y="2971800"/>
+            <a:off x="777240" y="2788920"/>
             <a:ext cx="9692640" cy="914400"/>
           </a:xfrm>
           <a:prstGeom prst="rect">
@@ -250,7 +251,7 @@
         </p:nvSpPr>
         <p:spPr>
           <a:xfrm>
-            <a:off x="777240" y="4480560"/>
+            <a:off x="777240" y="4434840"/>
             <a:ext cx="9692640" cy="1097280"/>
           </a:xfrm>
           <a:prstGeom prst="rect">
@@ -293,7 +294,7 @@
         </p:nvSpPr>
         <p:spPr>
           <a:xfrm>
-            <a:off x="777240" y="5669280"/>
+            <a:off x="777240" y="5623560"/>
             <a:ext cx="9692640" cy="548640"/>
           </a:xfrm>
           <a:prstGeom prst="rect">
@@ -323,7 +324,7 @@
                 </a:solidFill>
                 <a:latin typeface="Calibri"/>
               </a:rPr>
-              <a:t>IITB-Groww INV.ENT Program  -  Track A   |   Team: [Your name / team]</a:t>
+              <a:t>IITB-Groww INV.ENT  -  Track A      |      A 4-member student team      |      Team: [Your names]</a:t>
             </a:r>
           </a:p>
         </p:txBody>
@@ -496,14 +497,14 @@
                 </a:solidFill>
                 <a:latin typeface="Calibri"/>
               </a:rPr>
-              <a:t>AgriRover  -  IITB-Groww INV.ENT Program</a:t>
-            </a:r>
-          </a:p>
-        </p:txBody>
-      </p:sp>
-      <p:sp>
-        <p:nvSpPr>
-          <p:cNvPr id="30" name="body"/>
+              <a:t>AgriRover  -  IITB-Groww INV.ENT  -  Track A  -  Team of 4</a:t>
+            </a:r>
+          </a:p>
+        </p:txBody>
+      </p:sp>
+      <p:sp>
+        <p:nvSpPr>
+          <p:cNvPr id="30" name="b"/>
           <p:cNvSpPr txBox="1"/>
           <p:nvPr/>
         </p:nvSpPr>
@@ -528,7 +529,7 @@
                 <a:spcPts val="0"/>
               </a:spcBef>
               <a:spcAft>
-                <a:spcPts val="300"/>
+                <a:spcPts val="240"/>
               </a:spcAft>
               <a:buNone/>
             </a:pPr>
@@ -548,7 +549,7 @@
                 <a:spcPts val="0"/>
               </a:spcBef>
               <a:spcAft>
-                <a:spcPts val="500"/>
+                <a:spcPts val="420"/>
               </a:spcAft>
               <a:buFont typeface="Arial"/>
               <a:buChar char="•"/>
@@ -569,7 +570,7 @@
                 <a:spcPts val="0"/>
               </a:spcBef>
               <a:spcAft>
-                <a:spcPts val="500"/>
+                <a:spcPts val="420"/>
               </a:spcAft>
               <a:buFont typeface="Arial"/>
               <a:buChar char="•"/>
@@ -590,7 +591,7 @@
                 <a:spcPts val="0"/>
               </a:spcBef>
               <a:spcAft>
-                <a:spcPts val="500"/>
+                <a:spcPts val="420"/>
               </a:spcAft>
               <a:buFont typeface="Arial"/>
               <a:buChar char="•"/>
@@ -611,7 +612,7 @@
                 <a:spcPts val="0"/>
               </a:spcBef>
               <a:spcAft>
-                <a:spcPts val="500"/>
+                <a:spcPts val="420"/>
               </a:spcAft>
               <a:buFont typeface="Arial"/>
               <a:buChar char="•"/>
@@ -632,7 +633,7 @@
                 <a:spcPts val="0"/>
               </a:spcBef>
               <a:spcAft>
-                <a:spcPts val="300"/>
+                <a:spcPts val="240"/>
               </a:spcAft>
               <a:buNone/>
             </a:pPr>
@@ -652,7 +653,7 @@
                 <a:spcPts val="0"/>
               </a:spcBef>
               <a:spcAft>
-                <a:spcPts val="500"/>
+                <a:spcPts val="420"/>
               </a:spcAft>
               <a:buFont typeface="Arial"/>
               <a:buChar char="•"/>
@@ -837,14 +838,14 @@
                 </a:solidFill>
                 <a:latin typeface="Calibri"/>
               </a:rPr>
-              <a:t>AgriRover  -  IITB-Groww INV.ENT Program</a:t>
-            </a:r>
-          </a:p>
-        </p:txBody>
-      </p:sp>
-      <p:sp>
-        <p:nvSpPr>
-          <p:cNvPr id="30" name="body"/>
+              <a:t>AgriRover  -  IITB-Groww INV.ENT  -  Track A  -  Team of 4</a:t>
+            </a:r>
+          </a:p>
+        </p:txBody>
+      </p:sp>
+      <p:sp>
+        <p:nvSpPr>
+          <p:cNvPr id="30" name="b"/>
           <p:cNvSpPr txBox="1"/>
           <p:nvPr/>
         </p:nvSpPr>
@@ -869,7 +870,7 @@
                 <a:spcPts val="0"/>
               </a:spcBef>
               <a:spcAft>
-                <a:spcPts val="300"/>
+                <a:spcPts val="240"/>
               </a:spcAft>
               <a:buNone/>
             </a:pPr>
@@ -889,7 +890,7 @@
                 <a:spcPts val="0"/>
               </a:spcBef>
               <a:spcAft>
-                <a:spcPts val="500"/>
+                <a:spcPts val="420"/>
               </a:spcAft>
               <a:buFont typeface="Arial"/>
               <a:buChar char="•"/>
@@ -901,7 +902,7 @@
                 </a:solidFill>
                 <a:latin typeface="Calibri"/>
               </a:rPr>
-              <a:t>Senses soil NPK (7-in-1 probe) plus moisture, TDS and temperature in-field.</a:t>
+              <a:t>Senses soil NPK (7-in-1 RS485 probe) plus moisture, TDS and temperature in-field.</a:t>
             </a:r>
           </a:p>
           <a:p>
@@ -910,7 +911,7 @@
                 <a:spcPts val="0"/>
               </a:spcBef>
               <a:spcAft>
-                <a:spcPts val="500"/>
+                <a:spcPts val="420"/>
               </a:spcAft>
               <a:buFont typeface="Arial"/>
               <a:buChar char="•"/>
@@ -931,7 +932,7 @@
                 <a:spcPts val="0"/>
               </a:spcBef>
               <a:spcAft>
-                <a:spcPts val="500"/>
+                <a:spcPts val="420"/>
               </a:spcAft>
               <a:buFont typeface="Arial"/>
               <a:buChar char="•"/>
@@ -952,7 +953,7 @@
                 <a:spcPts val="0"/>
               </a:spcBef>
               <a:spcAft>
-                <a:spcPts val="500"/>
+                <a:spcPts val="420"/>
               </a:spcAft>
               <a:buFont typeface="Arial"/>
               <a:buChar char="•"/>
@@ -973,7 +974,7 @@
                 <a:spcPts val="0"/>
               </a:spcBef>
               <a:spcAft>
-                <a:spcPts val="500"/>
+                <a:spcPts val="420"/>
               </a:spcAft>
               <a:buFont typeface="Arial"/>
               <a:buChar char="•"/>
@@ -994,7 +995,7 @@
                 <a:spcPts val="0"/>
               </a:spcBef>
               <a:spcAft>
-                <a:spcPts val="300"/>
+                <a:spcPts val="240"/>
               </a:spcAft>
               <a:buNone/>
             </a:pPr>
@@ -1014,7 +1015,7 @@
                 <a:spcPts val="0"/>
               </a:spcBef>
               <a:spcAft>
-                <a:spcPts val="500"/>
+                <a:spcPts val="420"/>
               </a:spcAft>
               <a:buFont typeface="Arial"/>
               <a:buChar char="•"/>
@@ -1156,7 +1157,7 @@
                 </a:solidFill>
                 <a:latin typeface="Calibri"/>
               </a:rPr>
-              <a:t>PoC Hypothesis &amp; Metrics</a:t>
+              <a:t>What We've Built  (POC/MVP)</a:t>
             </a:r>
           </a:p>
         </p:txBody>
@@ -1199,21 +1200,79 @@
                 </a:solidFill>
                 <a:latin typeface="Calibri"/>
               </a:rPr>
-              <a:t>AgriRover  -  IITB-Groww INV.ENT Program</a:t>
-            </a:r>
-          </a:p>
-        </p:txBody>
-      </p:sp>
-      <p:sp>
-        <p:nvSpPr>
-          <p:cNvPr id="30" name="body"/>
+              <a:t>AgriRover  -  IITB-Groww INV.ENT  -  Track A  -  Team of 4</a:t>
+            </a:r>
+          </a:p>
+        </p:txBody>
+      </p:sp>
+      <p:sp>
+        <p:nvSpPr>
+          <p:cNvPr id="40" name="card"/>
+          <p:cNvSpPr/>
+          <p:nvPr/>
+        </p:nvSpPr>
+        <p:spPr>
+          <a:xfrm>
+            <a:off x="502920" y="1371600"/>
+            <a:ext cx="3310128" cy="2240280"/>
+          </a:xfrm>
+          <a:prstGeom prst="roundRect">
+            <a:avLst>
+              <a:gd name="adj" fmla="val 8000"/>
+            </a:avLst>
+          </a:prstGeom>
+          <a:solidFill>
+            <a:srgbClr val="F3F8F1"/>
+          </a:solidFill>
+          <a:ln w="15875">
+            <a:solidFill>
+              <a:srgbClr val="2E7D32"/>
+            </a:solidFill>
+          </a:ln>
+        </p:spPr>
+        <p:txBody>
+          <a:bodyPr/>
+          <a:lstStyle/>
+          <a:p/>
+        </p:txBody>
+      </p:sp>
+      <p:sp>
+        <p:nvSpPr>
+          <p:cNvPr id="41" name="tab"/>
+          <p:cNvSpPr/>
+          <p:nvPr/>
+        </p:nvSpPr>
+        <p:spPr>
+          <a:xfrm>
+            <a:off x="502920" y="1371600"/>
+            <a:ext cx="109728" cy="2240280"/>
+          </a:xfrm>
+          <a:prstGeom prst="rect">
+            <a:avLst/>
+          </a:prstGeom>
+          <a:solidFill>
+            <a:srgbClr val="2E7D32"/>
+          </a:solidFill>
+          <a:ln>
+            <a:noFill/>
+          </a:ln>
+        </p:spPr>
+        <p:txBody>
+          <a:bodyPr/>
+          <a:lstStyle/>
+          <a:p/>
+        </p:txBody>
+      </p:sp>
+      <p:sp>
+        <p:nvSpPr>
+          <p:cNvPr id="42" name="ct"/>
           <p:cNvSpPr txBox="1"/>
           <p:nvPr/>
         </p:nvSpPr>
         <p:spPr>
           <a:xfrm>
-            <a:off x="548640" y="1325880"/>
-            <a:ext cx="10149840" cy="4754880"/>
+            <a:off x="758952" y="1517904"/>
+            <a:ext cx="2898648" cy="1965960"/>
           </a:xfrm>
           <a:prstGeom prst="rect">
             <a:avLst/>
@@ -1231,183 +1290,944 @@
                 <a:spcPts val="0"/>
               </a:spcBef>
               <a:spcAft>
-                <a:spcPts val="300"/>
-              </a:spcAft>
-              <a:buNone/>
-            </a:pPr>
-            <a:r>
-              <a:rPr lang="en-US" sz="1600" b="1" dirty="0">
+                <a:spcPts val="160"/>
+              </a:spcAft>
+              <a:buNone/>
+            </a:pPr>
+            <a:r>
+              <a:rPr lang="en-US" sz="1300" b="1" dirty="0">
                 <a:solidFill>
                   <a:srgbClr val="2E7D32"/>
                 </a:solidFill>
                 <a:latin typeface="Calibri"/>
               </a:rPr>
-              <a:t>Hypothesis</a:t>
-            </a:r>
-          </a:p>
-          <a:p>
-            <a:pPr marL="292608" indent="-292608" algn="l">
-              <a:spcBef>
-                <a:spcPts val="0"/>
-              </a:spcBef>
-              <a:spcAft>
-                <a:spcPts val="500"/>
+              <a:t>Firmware (ESP32 / FreeRTOS)</a:t>
+            </a:r>
+          </a:p>
+          <a:p>
+            <a:pPr marL="237744" indent="-237744" algn="l">
+              <a:spcBef>
+                <a:spcPts val="0"/>
+              </a:spcBef>
+              <a:spcAft>
+                <a:spcPts val="120"/>
               </a:spcAft>
               <a:buFont typeface="Arial"/>
               <a:buChar char="•"/>
             </a:pPr>
             <a:r>
-              <a:rPr lang="en-US" sz="1500" dirty="0">
+              <a:rPr lang="en-US" sz="1100" dirty="0">
                 <a:solidFill>
                   <a:srgbClr val="1A2421"/>
                 </a:solidFill>
                 <a:latin typeface="Calibri"/>
               </a:rPr>
-              <a:t>Per-plant sensing + targeted dosing cuts fertilizer/chemical use sharply with no yield loss.</a:t>
-            </a:r>
-          </a:p>
-          <a:p>
-            <a:pPr marL="0" indent="0" algn="l">
-              <a:spcBef>
-                <a:spcPts val="0"/>
-              </a:spcBef>
-              <a:spcAft>
-                <a:spcPts val="300"/>
-              </a:spcAft>
-              <a:buNone/>
-            </a:pPr>
-            <a:r>
-              <a:rPr lang="en-US" sz="1600" b="1" dirty="0">
-                <a:solidFill>
-                  <a:srgbClr val="2E7D32"/>
-                </a:solidFill>
-                <a:latin typeface="Calibri"/>
-              </a:rPr>
-              <a:t>Progress - POC/MVP</a:t>
-            </a:r>
-          </a:p>
-          <a:p>
-            <a:pPr marL="292608" indent="-292608" algn="l">
-              <a:spcBef>
-                <a:spcPts val="0"/>
-              </a:spcBef>
-              <a:spcAft>
-                <a:spcPts val="500"/>
+              <a:t>Dual-core drive, NPK/RS485 sensing</a:t>
+            </a:r>
+          </a:p>
+          <a:p>
+            <a:pPr marL="237744" indent="-237744" algn="l">
+              <a:spcBef>
+                <a:spcPts val="0"/>
+              </a:spcBef>
+              <a:spcAft>
+                <a:spcPts val="120"/>
               </a:spcAft>
               <a:buFont typeface="Arial"/>
               <a:buChar char="•"/>
             </a:pPr>
             <a:r>
-              <a:rPr lang="en-US" sz="1500" dirty="0">
+              <a:rPr lang="en-US" sz="1100" dirty="0">
                 <a:solidFill>
                   <a:srgbClr val="1A2421"/>
                 </a:solidFill>
                 <a:latin typeface="Calibri"/>
               </a:rPr>
-              <a:t>Full software stack works: firmware, AI pipeline, navigation, dashboard, simulator, CI. 10 field risks solved in code.</a:t>
-            </a:r>
-          </a:p>
-          <a:p>
-            <a:pPr marL="0" indent="0" algn="l">
-              <a:spcBef>
-                <a:spcPts val="0"/>
-              </a:spcBef>
-              <a:spcAft>
-                <a:spcPts val="300"/>
-              </a:spcAft>
-              <a:buNone/>
-            </a:pPr>
-            <a:r>
-              <a:rPr lang="en-US" sz="1600" b="1" dirty="0">
-                <a:solidFill>
-                  <a:srgbClr val="2E7D32"/>
-                </a:solidFill>
-                <a:latin typeface="Calibri"/>
-              </a:rPr>
-              <a:t>Metrics we will prove in pilot</a:t>
-            </a:r>
-          </a:p>
-          <a:p>
-            <a:pPr marL="292608" indent="-292608" algn="l">
-              <a:spcBef>
-                <a:spcPts val="0"/>
-              </a:spcBef>
-              <a:spcAft>
-                <a:spcPts val="500"/>
+              <a:t>Dosing state machine</a:t>
+            </a:r>
+          </a:p>
+          <a:p>
+            <a:pPr marL="237744" indent="-237744" algn="l">
+              <a:spcBef>
+                <a:spcPts val="0"/>
+              </a:spcBef>
+              <a:spcAft>
+                <a:spcPts val="120"/>
               </a:spcAft>
               <a:buFont typeface="Arial"/>
               <a:buChar char="•"/>
             </a:pPr>
             <a:r>
-              <a:rPr lang="en-US" sz="1500" dirty="0">
+              <a:rPr lang="en-US" sz="1100" dirty="0">
                 <a:solidFill>
                   <a:srgbClr val="1A2421"/>
                 </a:solidFill>
                 <a:latin typeface="Calibri"/>
               </a:rPr>
-              <a:t>Fertilizer/pesticide reduction % vs hand broadcasting.</a:t>
-            </a:r>
-          </a:p>
-          <a:p>
-            <a:pPr marL="292608" indent="-292608" algn="l">
-              <a:spcBef>
-                <a:spcPts val="0"/>
-              </a:spcBef>
-              <a:spcAft>
-                <a:spcPts val="500"/>
+              <a:t>Secure MQTT + UART link</a:t>
+            </a:r>
+          </a:p>
+        </p:txBody>
+      </p:sp>
+      <p:sp>
+        <p:nvSpPr>
+          <p:cNvPr id="43" name="card"/>
+          <p:cNvSpPr/>
+          <p:nvPr/>
+        </p:nvSpPr>
+        <p:spPr>
+          <a:xfrm>
+            <a:off x="3977640" y="1371600"/>
+            <a:ext cx="3310128" cy="2240280"/>
+          </a:xfrm>
+          <a:prstGeom prst="roundRect">
+            <a:avLst>
+              <a:gd name="adj" fmla="val 8000"/>
+            </a:avLst>
+          </a:prstGeom>
+          <a:solidFill>
+            <a:srgbClr val="F3F8F1"/>
+          </a:solidFill>
+          <a:ln w="15875">
+            <a:solidFill>
+              <a:srgbClr val="1565C0"/>
+            </a:solidFill>
+          </a:ln>
+        </p:spPr>
+        <p:txBody>
+          <a:bodyPr/>
+          <a:lstStyle/>
+          <a:p/>
+        </p:txBody>
+      </p:sp>
+      <p:sp>
+        <p:nvSpPr>
+          <p:cNvPr id="44" name="tab"/>
+          <p:cNvSpPr/>
+          <p:nvPr/>
+        </p:nvSpPr>
+        <p:spPr>
+          <a:xfrm>
+            <a:off x="3977640" y="1371600"/>
+            <a:ext cx="109728" cy="2240280"/>
+          </a:xfrm>
+          <a:prstGeom prst="rect">
+            <a:avLst/>
+          </a:prstGeom>
+          <a:solidFill>
+            <a:srgbClr val="1565C0"/>
+          </a:solidFill>
+          <a:ln>
+            <a:noFill/>
+          </a:ln>
+        </p:spPr>
+        <p:txBody>
+          <a:bodyPr/>
+          <a:lstStyle/>
+          <a:p/>
+        </p:txBody>
+      </p:sp>
+      <p:sp>
+        <p:nvSpPr>
+          <p:cNvPr id="45" name="ct"/>
+          <p:cNvSpPr txBox="1"/>
+          <p:nvPr/>
+        </p:nvSpPr>
+        <p:spPr>
+          <a:xfrm>
+            <a:off x="4233672" y="1517904"/>
+            <a:ext cx="2898648" cy="1965960"/>
+          </a:xfrm>
+          <a:prstGeom prst="rect">
+            <a:avLst/>
+          </a:prstGeom>
+          <a:noFill/>
+        </p:spPr>
+        <p:txBody>
+          <a:bodyPr wrap="square" anchor="t" rtlCol="0">
+            <a:normAutofit/>
+          </a:bodyPr>
+          <a:lstStyle/>
+          <a:p>
+            <a:pPr marL="0" indent="0" algn="l">
+              <a:spcBef>
+                <a:spcPts val="0"/>
+              </a:spcBef>
+              <a:spcAft>
+                <a:spcPts val="160"/>
+              </a:spcAft>
+              <a:buNone/>
+            </a:pPr>
+            <a:r>
+              <a:rPr lang="en-US" sz="1300" b="1" dirty="0">
+                <a:solidFill>
+                  <a:srgbClr val="1565C0"/>
+                </a:solidFill>
+                <a:latin typeface="Calibri"/>
+              </a:rPr>
+              <a:t>AI Vision (Raspberry Pi)</a:t>
+            </a:r>
+          </a:p>
+          <a:p>
+            <a:pPr marL="237744" indent="-237744" algn="l">
+              <a:spcBef>
+                <a:spcPts val="0"/>
+              </a:spcBef>
+              <a:spcAft>
+                <a:spcPts val="120"/>
               </a:spcAft>
               <a:buFont typeface="Arial"/>
               <a:buChar char="•"/>
             </a:pPr>
             <a:r>
-              <a:rPr lang="en-US" sz="1500" dirty="0">
+              <a:rPr lang="en-US" sz="1100" dirty="0">
                 <a:solidFill>
                   <a:srgbClr val="1A2421"/>
                 </a:solidFill>
                 <a:latin typeface="Calibri"/>
               </a:rPr>
-              <a:t>Weed/disease detection accuracy (precision &amp; recall); dosing placement accuracy (cm).</a:t>
-            </a:r>
-          </a:p>
-          <a:p>
-            <a:pPr marL="292608" indent="-292608" algn="l">
-              <a:spcBef>
-                <a:spcPts val="0"/>
-              </a:spcBef>
-              <a:spcAft>
-                <a:spcPts val="500"/>
+              <a:t>YOLOv8n weed/disease/obstacle</a:t>
+            </a:r>
+          </a:p>
+          <a:p>
+            <a:pPr marL="237744" indent="-237744" algn="l">
+              <a:spcBef>
+                <a:spcPts val="0"/>
+              </a:spcBef>
+              <a:spcAft>
+                <a:spcPts val="120"/>
               </a:spcAft>
               <a:buFont typeface="Arial"/>
               <a:buChar char="•"/>
             </a:pPr>
             <a:r>
-              <a:rPr lang="en-US" sz="1500" dirty="0">
+              <a:rPr lang="en-US" sz="1100" dirty="0">
                 <a:solidFill>
                   <a:srgbClr val="1A2421"/>
                 </a:solidFill>
                 <a:latin typeface="Calibri"/>
               </a:rPr>
-              <a:t>Area covered per charge; cost saving per acre per season.</a:t>
-            </a:r>
-          </a:p>
-          <a:p>
-            <a:pPr marL="0" indent="0" algn="l">
-              <a:spcBef>
-                <a:spcPts val="0"/>
-              </a:spcBef>
-              <a:spcAft>
-                <a:spcPts val="0"/>
+              <a:t>Runs on Coral Edge TPU</a:t>
+            </a:r>
+          </a:p>
+          <a:p>
+            <a:pPr marL="237744" indent="-237744" algn="l">
+              <a:spcBef>
+                <a:spcPts val="0"/>
+              </a:spcBef>
+              <a:spcAft>
+                <a:spcPts val="120"/>
+              </a:spcAft>
+              <a:buFont typeface="Arial"/>
+              <a:buChar char="•"/>
+            </a:pPr>
+            <a:r>
+              <a:rPr lang="en-US" sz="1100" dirty="0">
+                <a:solidFill>
+                  <a:srgbClr val="1A2421"/>
+                </a:solidFill>
+                <a:latin typeface="Calibri"/>
+              </a:rPr>
+              <a:t>Training notebooks included</a:t>
+            </a:r>
+          </a:p>
+        </p:txBody>
+      </p:sp>
+      <p:sp>
+        <p:nvSpPr>
+          <p:cNvPr id="46" name="card"/>
+          <p:cNvSpPr/>
+          <p:nvPr/>
+        </p:nvSpPr>
+        <p:spPr>
+          <a:xfrm>
+            <a:off x="7452360" y="1371600"/>
+            <a:ext cx="3310128" cy="2240280"/>
+          </a:xfrm>
+          <a:prstGeom prst="roundRect">
+            <a:avLst>
+              <a:gd name="adj" fmla="val 8000"/>
+            </a:avLst>
+          </a:prstGeom>
+          <a:solidFill>
+            <a:srgbClr val="F3F8F1"/>
+          </a:solidFill>
+          <a:ln w="15875">
+            <a:solidFill>
+              <a:srgbClr val="6A1B9A"/>
+            </a:solidFill>
+          </a:ln>
+        </p:spPr>
+        <p:txBody>
+          <a:bodyPr/>
+          <a:lstStyle/>
+          <a:p/>
+        </p:txBody>
+      </p:sp>
+      <p:sp>
+        <p:nvSpPr>
+          <p:cNvPr id="47" name="tab"/>
+          <p:cNvSpPr/>
+          <p:nvPr/>
+        </p:nvSpPr>
+        <p:spPr>
+          <a:xfrm>
+            <a:off x="7452360" y="1371600"/>
+            <a:ext cx="109728" cy="2240280"/>
+          </a:xfrm>
+          <a:prstGeom prst="rect">
+            <a:avLst/>
+          </a:prstGeom>
+          <a:solidFill>
+            <a:srgbClr val="6A1B9A"/>
+          </a:solidFill>
+          <a:ln>
+            <a:noFill/>
+          </a:ln>
+        </p:spPr>
+        <p:txBody>
+          <a:bodyPr/>
+          <a:lstStyle/>
+          <a:p/>
+        </p:txBody>
+      </p:sp>
+      <p:sp>
+        <p:nvSpPr>
+          <p:cNvPr id="48" name="ct"/>
+          <p:cNvSpPr txBox="1"/>
+          <p:nvPr/>
+        </p:nvSpPr>
+        <p:spPr>
+          <a:xfrm>
+            <a:off x="7708392" y="1517904"/>
+            <a:ext cx="2898648" cy="1965960"/>
+          </a:xfrm>
+          <a:prstGeom prst="rect">
+            <a:avLst/>
+          </a:prstGeom>
+          <a:noFill/>
+        </p:spPr>
+        <p:txBody>
+          <a:bodyPr wrap="square" anchor="t" rtlCol="0">
+            <a:normAutofit/>
+          </a:bodyPr>
+          <a:lstStyle/>
+          <a:p>
+            <a:pPr marL="0" indent="0" algn="l">
+              <a:spcBef>
+                <a:spcPts val="0"/>
+              </a:spcBef>
+              <a:spcAft>
+                <a:spcPts val="160"/>
               </a:spcAft>
               <a:buNone/>
             </a:pPr>
             <a:r>
               <a:rPr lang="en-US" sz="1300" b="1" dirty="0">
                 <a:solidFill>
+                  <a:srgbClr val="6A1B9A"/>
+                </a:solidFill>
+                <a:latin typeface="Calibri"/>
+              </a:rPr>
+              <a:t>Navigation &amp; Systems</a:t>
+            </a:r>
+          </a:p>
+          <a:p>
+            <a:pPr marL="237744" indent="-237744" algn="l">
+              <a:spcBef>
+                <a:spcPts val="0"/>
+              </a:spcBef>
+              <a:spcAft>
+                <a:spcPts val="120"/>
+              </a:spcAft>
+              <a:buFont typeface="Arial"/>
+              <a:buChar char="•"/>
+            </a:pPr>
+            <a:r>
+              <a:rPr lang="en-US" sz="1100" dirty="0">
+                <a:solidFill>
+                  <a:srgbClr val="1A2421"/>
+                </a:solidFill>
+                <a:latin typeface="Calibri"/>
+              </a:rPr>
+              <a:t>EKF + GPS + vision geo-tag</a:t>
+            </a:r>
+          </a:p>
+          <a:p>
+            <a:pPr marL="237744" indent="-237744" algn="l">
+              <a:spcBef>
+                <a:spcPts val="0"/>
+              </a:spcBef>
+              <a:spcAft>
+                <a:spcPts val="120"/>
+              </a:spcAft>
+              <a:buFont typeface="Arial"/>
+              <a:buChar char="•"/>
+            </a:pPr>
+            <a:r>
+              <a:rPr lang="en-US" sz="1100" dirty="0">
+                <a:solidFill>
+                  <a:srgbClr val="1A2421"/>
+                </a:solidFill>
+                <a:latin typeface="Calibri"/>
+              </a:rPr>
+              <a:t>Snake-route path planner</a:t>
+            </a:r>
+          </a:p>
+          <a:p>
+            <a:pPr marL="237744" indent="-237744" algn="l">
+              <a:spcBef>
+                <a:spcPts val="0"/>
+              </a:spcBef>
+              <a:spcAft>
+                <a:spcPts val="120"/>
+              </a:spcAft>
+              <a:buFont typeface="Arial"/>
+              <a:buChar char="•"/>
+            </a:pPr>
+            <a:r>
+              <a:rPr lang="en-US" sz="1100" dirty="0">
+                <a:solidFill>
+                  <a:srgbClr val="1A2421"/>
+                </a:solidFill>
+                <a:latin typeface="Calibri"/>
+              </a:rPr>
+              <a:t>ROS2 nodes + full simulator</a:t>
+            </a:r>
+          </a:p>
+        </p:txBody>
+      </p:sp>
+      <p:sp>
+        <p:nvSpPr>
+          <p:cNvPr id="49" name="card"/>
+          <p:cNvSpPr/>
+          <p:nvPr/>
+        </p:nvSpPr>
+        <p:spPr>
+          <a:xfrm>
+            <a:off x="502920" y="3776472"/>
+            <a:ext cx="3310128" cy="2240280"/>
+          </a:xfrm>
+          <a:prstGeom prst="roundRect">
+            <a:avLst>
+              <a:gd name="adj" fmla="val 8000"/>
+            </a:avLst>
+          </a:prstGeom>
+          <a:solidFill>
+            <a:srgbClr val="F3F8F1"/>
+          </a:solidFill>
+          <a:ln w="15875">
+            <a:solidFill>
+              <a:srgbClr val="F9A825"/>
+            </a:solidFill>
+          </a:ln>
+        </p:spPr>
+        <p:txBody>
+          <a:bodyPr/>
+          <a:lstStyle/>
+          <a:p/>
+        </p:txBody>
+      </p:sp>
+      <p:sp>
+        <p:nvSpPr>
+          <p:cNvPr id="50" name="tab"/>
+          <p:cNvSpPr/>
+          <p:nvPr/>
+        </p:nvSpPr>
+        <p:spPr>
+          <a:xfrm>
+            <a:off x="502920" y="3776472"/>
+            <a:ext cx="109728" cy="2240280"/>
+          </a:xfrm>
+          <a:prstGeom prst="rect">
+            <a:avLst/>
+          </a:prstGeom>
+          <a:solidFill>
+            <a:srgbClr val="F9A825"/>
+          </a:solidFill>
+          <a:ln>
+            <a:noFill/>
+          </a:ln>
+        </p:spPr>
+        <p:txBody>
+          <a:bodyPr/>
+          <a:lstStyle/>
+          <a:p/>
+        </p:txBody>
+      </p:sp>
+      <p:sp>
+        <p:nvSpPr>
+          <p:cNvPr id="51" name="ct"/>
+          <p:cNvSpPr txBox="1"/>
+          <p:nvPr/>
+        </p:nvSpPr>
+        <p:spPr>
+          <a:xfrm>
+            <a:off x="758952" y="3922776"/>
+            <a:ext cx="2898648" cy="1965960"/>
+          </a:xfrm>
+          <a:prstGeom prst="rect">
+            <a:avLst/>
+          </a:prstGeom>
+          <a:noFill/>
+        </p:spPr>
+        <p:txBody>
+          <a:bodyPr wrap="square" anchor="t" rtlCol="0">
+            <a:normAutofit/>
+          </a:bodyPr>
+          <a:lstStyle/>
+          <a:p>
+            <a:pPr marL="0" indent="0" algn="l">
+              <a:spcBef>
+                <a:spcPts val="0"/>
+              </a:spcBef>
+              <a:spcAft>
+                <a:spcPts val="160"/>
+              </a:spcAft>
+              <a:buNone/>
+            </a:pPr>
+            <a:r>
+              <a:rPr lang="en-US" sz="1300" b="1" dirty="0">
+                <a:solidFill>
+                  <a:srgbClr val="F9A825"/>
+                </a:solidFill>
+                <a:latin typeface="Calibri"/>
+              </a:rPr>
+              <a:t>Software Tooling</a:t>
+            </a:r>
+          </a:p>
+          <a:p>
+            <a:pPr marL="237744" indent="-237744" algn="l">
+              <a:spcBef>
+                <a:spcPts val="0"/>
+              </a:spcBef>
+              <a:spcAft>
+                <a:spcPts val="120"/>
+              </a:spcAft>
+              <a:buFont typeface="Arial"/>
+              <a:buChar char="•"/>
+            </a:pPr>
+            <a:r>
+              <a:rPr lang="en-US" sz="1100" dirty="0">
+                <a:solidFill>
+                  <a:srgbClr val="1A2421"/>
+                </a:solidFill>
+                <a:latin typeface="Calibri"/>
+              </a:rPr>
+              <a:t>Live dashboard + Telegram alerts</a:t>
+            </a:r>
+          </a:p>
+          <a:p>
+            <a:pPr marL="237744" indent="-237744" algn="l">
+              <a:spcBef>
+                <a:spcPts val="0"/>
+              </a:spcBef>
+              <a:spcAft>
+                <a:spcPts val="120"/>
+              </a:spcAft>
+              <a:buFont typeface="Arial"/>
+              <a:buChar char="•"/>
+            </a:pPr>
+            <a:r>
+              <a:rPr lang="en-US" sz="1100" dirty="0">
+                <a:solidFill>
+                  <a:srgbClr val="1A2421"/>
+                </a:solidFill>
+                <a:latin typeface="Calibri"/>
+              </a:rPr>
+              <a:t>CI pipeline (automated build)</a:t>
+            </a:r>
+          </a:p>
+          <a:p>
+            <a:pPr marL="237744" indent="-237744" algn="l">
+              <a:spcBef>
+                <a:spcPts val="0"/>
+              </a:spcBef>
+              <a:spcAft>
+                <a:spcPts val="120"/>
+              </a:spcAft>
+              <a:buFont typeface="Arial"/>
+              <a:buChar char="•"/>
+            </a:pPr>
+            <a:r>
+              <a:rPr lang="en-US" sz="1100" dirty="0">
+                <a:solidFill>
+                  <a:srgbClr val="1A2421"/>
+                </a:solidFill>
+                <a:latin typeface="Calibri"/>
+              </a:rPr>
+              <a:t>Black-box data logging</a:t>
+            </a:r>
+          </a:p>
+        </p:txBody>
+      </p:sp>
+      <p:sp>
+        <p:nvSpPr>
+          <p:cNvPr id="52" name="card"/>
+          <p:cNvSpPr/>
+          <p:nvPr/>
+        </p:nvSpPr>
+        <p:spPr>
+          <a:xfrm>
+            <a:off x="3977640" y="3776472"/>
+            <a:ext cx="3310128" cy="2240280"/>
+          </a:xfrm>
+          <a:prstGeom prst="roundRect">
+            <a:avLst>
+              <a:gd name="adj" fmla="val 8000"/>
+            </a:avLst>
+          </a:prstGeom>
+          <a:solidFill>
+            <a:srgbClr val="F3F8F1"/>
+          </a:solidFill>
+          <a:ln w="15875">
+            <a:solidFill>
+              <a:srgbClr val="EF6C00"/>
+            </a:solidFill>
+          </a:ln>
+        </p:spPr>
+        <p:txBody>
+          <a:bodyPr/>
+          <a:lstStyle/>
+          <a:p/>
+        </p:txBody>
+      </p:sp>
+      <p:sp>
+        <p:nvSpPr>
+          <p:cNvPr id="53" name="tab"/>
+          <p:cNvSpPr/>
+          <p:nvPr/>
+        </p:nvSpPr>
+        <p:spPr>
+          <a:xfrm>
+            <a:off x="3977640" y="3776472"/>
+            <a:ext cx="109728" cy="2240280"/>
+          </a:xfrm>
+          <a:prstGeom prst="rect">
+            <a:avLst/>
+          </a:prstGeom>
+          <a:solidFill>
+            <a:srgbClr val="EF6C00"/>
+          </a:solidFill>
+          <a:ln>
+            <a:noFill/>
+          </a:ln>
+        </p:spPr>
+        <p:txBody>
+          <a:bodyPr/>
+          <a:lstStyle/>
+          <a:p/>
+        </p:txBody>
+      </p:sp>
+      <p:sp>
+        <p:nvSpPr>
+          <p:cNvPr id="54" name="ct"/>
+          <p:cNvSpPr txBox="1"/>
+          <p:nvPr/>
+        </p:nvSpPr>
+        <p:spPr>
+          <a:xfrm>
+            <a:off x="4233672" y="3922776"/>
+            <a:ext cx="2898648" cy="1965960"/>
+          </a:xfrm>
+          <a:prstGeom prst="rect">
+            <a:avLst/>
+          </a:prstGeom>
+          <a:noFill/>
+        </p:spPr>
+        <p:txBody>
+          <a:bodyPr wrap="square" anchor="t" rtlCol="0">
+            <a:normAutofit/>
+          </a:bodyPr>
+          <a:lstStyle/>
+          <a:p>
+            <a:pPr marL="0" indent="0" algn="l">
+              <a:spcBef>
+                <a:spcPts val="0"/>
+              </a:spcBef>
+              <a:spcAft>
+                <a:spcPts val="160"/>
+              </a:spcAft>
+              <a:buNone/>
+            </a:pPr>
+            <a:r>
+              <a:rPr lang="en-US" sz="1300" b="1" dirty="0">
+                <a:solidFill>
+                  <a:srgbClr val="EF6C00"/>
+                </a:solidFill>
+                <a:latin typeface="Calibri"/>
+              </a:rPr>
+              <a:t>Hardware Design</a:t>
+            </a:r>
+          </a:p>
+          <a:p>
+            <a:pPr marL="237744" indent="-237744" algn="l">
+              <a:spcBef>
+                <a:spcPts val="0"/>
+              </a:spcBef>
+              <a:spcAft>
+                <a:spcPts val="120"/>
+              </a:spcAft>
+              <a:buFont typeface="Arial"/>
+              <a:buChar char="•"/>
+            </a:pPr>
+            <a:r>
+              <a:rPr lang="en-US" sz="1100" dirty="0">
+                <a:solidFill>
+                  <a:srgbClr val="1A2421"/>
+                </a:solidFill>
+                <a:latin typeface="Calibri"/>
+              </a:rPr>
+              <a:t>Verified circuit + wiring v2</a:t>
+            </a:r>
+          </a:p>
+          <a:p>
+            <a:pPr marL="237744" indent="-237744" algn="l">
+              <a:spcBef>
+                <a:spcPts val="0"/>
+              </a:spcBef>
+              <a:spcAft>
+                <a:spcPts val="120"/>
+              </a:spcAft>
+              <a:buFont typeface="Arial"/>
+              <a:buChar char="•"/>
+            </a:pPr>
+            <a:r>
+              <a:rPr lang="en-US" sz="1100" dirty="0">
+                <a:solidFill>
+                  <a:srgbClr val="1A2421"/>
+                </a:solidFill>
+                <a:latin typeface="Calibri"/>
+              </a:rPr>
+              <a:t>110-part BOM, fully costed</a:t>
+            </a:r>
+          </a:p>
+          <a:p>
+            <a:pPr marL="237744" indent="-237744" algn="l">
+              <a:spcBef>
+                <a:spcPts val="0"/>
+              </a:spcBef>
+              <a:spcAft>
+                <a:spcPts val="120"/>
+              </a:spcAft>
+              <a:buFont typeface="Arial"/>
+              <a:buChar char="•"/>
+            </a:pPr>
+            <a:r>
+              <a:rPr lang="en-US" sz="1100" dirty="0">
+                <a:solidFill>
+                  <a:srgbClr val="1A2421"/>
+                </a:solidFill>
+                <a:latin typeface="Calibri"/>
+              </a:rPr>
+              <a:t>+15 gap-audit &amp; v2 upgrades</a:t>
+            </a:r>
+          </a:p>
+        </p:txBody>
+      </p:sp>
+      <p:sp>
+        <p:nvSpPr>
+          <p:cNvPr id="55" name="card"/>
+          <p:cNvSpPr/>
+          <p:nvPr/>
+        </p:nvSpPr>
+        <p:spPr>
+          <a:xfrm>
+            <a:off x="7452360" y="3776472"/>
+            <a:ext cx="3310128" cy="2240280"/>
+          </a:xfrm>
+          <a:prstGeom prst="roundRect">
+            <a:avLst>
+              <a:gd name="adj" fmla="val 8000"/>
+            </a:avLst>
+          </a:prstGeom>
+          <a:solidFill>
+            <a:srgbClr val="F3F8F1"/>
+          </a:solidFill>
+          <a:ln w="15875">
+            <a:solidFill>
+              <a:srgbClr val="2E7D32"/>
+            </a:solidFill>
+          </a:ln>
+        </p:spPr>
+        <p:txBody>
+          <a:bodyPr/>
+          <a:lstStyle/>
+          <a:p/>
+        </p:txBody>
+      </p:sp>
+      <p:sp>
+        <p:nvSpPr>
+          <p:cNvPr id="56" name="tab"/>
+          <p:cNvSpPr/>
+          <p:nvPr/>
+        </p:nvSpPr>
+        <p:spPr>
+          <a:xfrm>
+            <a:off x="7452360" y="3776472"/>
+            <a:ext cx="109728" cy="2240280"/>
+          </a:xfrm>
+          <a:prstGeom prst="rect">
+            <a:avLst/>
+          </a:prstGeom>
+          <a:solidFill>
+            <a:srgbClr val="2E7D32"/>
+          </a:solidFill>
+          <a:ln>
+            <a:noFill/>
+          </a:ln>
+        </p:spPr>
+        <p:txBody>
+          <a:bodyPr/>
+          <a:lstStyle/>
+          <a:p/>
+        </p:txBody>
+      </p:sp>
+      <p:sp>
+        <p:nvSpPr>
+          <p:cNvPr id="57" name="ct"/>
+          <p:cNvSpPr txBox="1"/>
+          <p:nvPr/>
+        </p:nvSpPr>
+        <p:spPr>
+          <a:xfrm>
+            <a:off x="7708392" y="3922776"/>
+            <a:ext cx="2898648" cy="1965960"/>
+          </a:xfrm>
+          <a:prstGeom prst="rect">
+            <a:avLst/>
+          </a:prstGeom>
+          <a:noFill/>
+        </p:spPr>
+        <p:txBody>
+          <a:bodyPr wrap="square" anchor="t" rtlCol="0">
+            <a:normAutofit/>
+          </a:bodyPr>
+          <a:lstStyle/>
+          <a:p>
+            <a:pPr marL="0" indent="0" algn="l">
+              <a:spcBef>
+                <a:spcPts val="0"/>
+              </a:spcBef>
+              <a:spcAft>
+                <a:spcPts val="160"/>
+              </a:spcAft>
+              <a:buNone/>
+            </a:pPr>
+            <a:r>
+              <a:rPr lang="en-US" sz="1300" b="1" dirty="0">
+                <a:solidFill>
                   <a:srgbClr val="2E7D32"/>
                 </a:solidFill>
                 <a:latin typeface="Calibri"/>
               </a:rPr>
-              <a:t>Targets to prove: 30-50% input reduction, &gt;85% detection accuracy.</a:t>
+              <a:t>Field Reliability</a:t>
+            </a:r>
+          </a:p>
+          <a:p>
+            <a:pPr marL="237744" indent="-237744" algn="l">
+              <a:spcBef>
+                <a:spcPts val="0"/>
+              </a:spcBef>
+              <a:spcAft>
+                <a:spcPts val="120"/>
+              </a:spcAft>
+              <a:buFont typeface="Arial"/>
+              <a:buChar char="•"/>
+            </a:pPr>
+            <a:r>
+              <a:rPr lang="en-US" sz="1100" dirty="0">
+                <a:solidFill>
+                  <a:srgbClr val="1A2421"/>
+                </a:solidFill>
+                <a:latin typeface="Calibri"/>
+              </a:rPr>
+              <a:t>10 real field risks engineered</a:t>
+            </a:r>
+          </a:p>
+          <a:p>
+            <a:pPr marL="237744" indent="-237744" algn="l">
+              <a:spcBef>
+                <a:spcPts val="0"/>
+              </a:spcBef>
+              <a:spcAft>
+                <a:spcPts val="120"/>
+              </a:spcAft>
+              <a:buFont typeface="Arial"/>
+              <a:buChar char="•"/>
+            </a:pPr>
+            <a:r>
+              <a:rPr lang="en-US" sz="1100" dirty="0">
+                <a:solidFill>
+                  <a:srgbClr val="1A2421"/>
+                </a:solidFill>
+                <a:latin typeface="Calibri"/>
+              </a:rPr>
+              <a:t>Heat/battery, stall, comms-loss</a:t>
+            </a:r>
+          </a:p>
+          <a:p>
+            <a:pPr marL="237744" indent="-237744" algn="l">
+              <a:spcBef>
+                <a:spcPts val="0"/>
+              </a:spcBef>
+              <a:spcAft>
+                <a:spcPts val="120"/>
+              </a:spcAft>
+              <a:buFont typeface="Arial"/>
+              <a:buChar char="•"/>
+            </a:pPr>
+            <a:r>
+              <a:rPr lang="en-US" sz="1100" dirty="0">
+                <a:solidFill>
+                  <a:srgbClr val="1A2421"/>
+                </a:solidFill>
+                <a:latin typeface="Calibri"/>
+              </a:rPr>
+              <a:t>Dust/dew sealing &amp; fail-safes</a:t>
+            </a:r>
+          </a:p>
+        </p:txBody>
+      </p:sp>
+      <p:sp>
+        <p:nvSpPr>
+          <p:cNvPr id="58" name="note"/>
+          <p:cNvSpPr txBox="1"/>
+          <p:nvPr/>
+        </p:nvSpPr>
+        <p:spPr>
+          <a:xfrm>
+            <a:off x="502920" y="5989320"/>
+            <a:ext cx="10058400" cy="320040"/>
+          </a:xfrm>
+          <a:prstGeom prst="rect">
+            <a:avLst/>
+          </a:prstGeom>
+          <a:noFill/>
+        </p:spPr>
+        <p:txBody>
+          <a:bodyPr wrap="square" anchor="t" rtlCol="0">
+            <a:normAutofit/>
+          </a:bodyPr>
+          <a:lstStyle/>
+          <a:p>
+            <a:pPr marL="0" indent="0" algn="l">
+              <a:spcBef>
+                <a:spcPts val="0"/>
+              </a:spcBef>
+              <a:spcAft>
+                <a:spcPts val="600"/>
+              </a:spcAft>
+              <a:buNone/>
+            </a:pPr>
+            <a:r>
+              <a:rPr lang="en-US" sz="1100" i="1" dirty="0">
+                <a:solidFill>
+                  <a:srgbClr val="5B6B63"/>
+                </a:solidFill>
+                <a:latin typeface="Calibri"/>
+              </a:rPr>
+              <a:t>Built end-to-end by our 4-member team - software validated in simulation; hardware integration is the next step.</a:t>
             </a:r>
           </a:p>
         </p:txBody>
@@ -1537,7 +2357,7 @@
                 </a:solidFill>
                 <a:latin typeface="Calibri"/>
               </a:rPr>
-              <a:t>Execution &amp; Business Plan</a:t>
+              <a:t>PoC Hypothesis &amp; Metrics</a:t>
             </a:r>
           </a:p>
         </p:txBody>
@@ -1580,14 +2400,14 @@
                 </a:solidFill>
                 <a:latin typeface="Calibri"/>
               </a:rPr>
-              <a:t>AgriRover  -  IITB-Groww INV.ENT Program</a:t>
-            </a:r>
-          </a:p>
-        </p:txBody>
-      </p:sp>
-      <p:sp>
-        <p:nvSpPr>
-          <p:cNvPr id="30" name="body"/>
+              <a:t>AgriRover  -  IITB-Groww INV.ENT  -  Track A  -  Team of 4</a:t>
+            </a:r>
+          </a:p>
+        </p:txBody>
+      </p:sp>
+      <p:sp>
+        <p:nvSpPr>
+          <p:cNvPr id="30" name="b"/>
           <p:cNvSpPr txBox="1"/>
           <p:nvPr/>
         </p:nvSpPr>
@@ -1612,7 +2432,7 @@
                 <a:spcPts val="0"/>
               </a:spcBef>
               <a:spcAft>
-                <a:spcPts val="300"/>
+                <a:spcPts val="240"/>
               </a:spcAft>
               <a:buNone/>
             </a:pPr>
@@ -1623,7 +2443,7 @@
                 </a:solidFill>
                 <a:latin typeface="Calibri"/>
               </a:rPr>
-              <a:t>Next milestones</a:t>
+              <a:t>Hypothesis</a:t>
             </a:r>
           </a:p>
           <a:p>
@@ -1632,7 +2452,7 @@
                 <a:spcPts val="0"/>
               </a:spcBef>
               <a:spcAft>
-                <a:spcPts val="500"/>
+                <a:spcPts val="420"/>
               </a:spcAft>
               <a:buFont typeface="Arial"/>
               <a:buChar char="•"/>
@@ -1644,7 +2464,27 @@
                 </a:solidFill>
                 <a:latin typeface="Calibri"/>
               </a:rPr>
-              <a:t>Build: assemble hardware prototype (BTS7960 drive, NPK probe, pan/tilt sprayer, LiFePO4) - ~3 months.</a:t>
+              <a:t>Per-plant sensing + targeted dosing cuts fertilizer/chemical use sharply with no yield loss.</a:t>
+            </a:r>
+          </a:p>
+          <a:p>
+            <a:pPr marL="0" indent="0" algn="l">
+              <a:spcBef>
+                <a:spcPts val="0"/>
+              </a:spcBef>
+              <a:spcAft>
+                <a:spcPts val="240"/>
+              </a:spcAft>
+              <a:buNone/>
+            </a:pPr>
+            <a:r>
+              <a:rPr lang="en-US" sz="1600" b="1" dirty="0">
+                <a:solidFill>
+                  <a:srgbClr val="2E7D32"/>
+                </a:solidFill>
+                <a:latin typeface="Calibri"/>
+              </a:rPr>
+              <a:t>Metrics we will prove in pilot</a:t>
             </a:r>
           </a:p>
           <a:p>
@@ -1653,7 +2493,7 @@
                 <a:spcPts val="0"/>
               </a:spcBef>
               <a:spcAft>
-                <a:spcPts val="500"/>
+                <a:spcPts val="420"/>
               </a:spcAft>
               <a:buFont typeface="Arial"/>
               <a:buChar char="•"/>
@@ -1665,7 +2505,7 @@
                 </a:solidFill>
                 <a:latin typeface="Calibri"/>
               </a:rPr>
-              <a:t>Test: pilot on 5-10 small farms; measure input savings, accuracy and uptime.</a:t>
+              <a:t>Fertilizer/pesticide reduction % vs hand broadcasting.</a:t>
             </a:r>
           </a:p>
           <a:p>
@@ -1674,7 +2514,7 @@
                 <a:spcPts val="0"/>
               </a:spcBef>
               <a:spcAft>
-                <a:spcPts val="500"/>
+                <a:spcPts val="420"/>
               </a:spcAft>
               <a:buFont typeface="Arial"/>
               <a:buChar char="•"/>
@@ -1686,27 +2526,7 @@
                 </a:solidFill>
                 <a:latin typeface="Calibri"/>
               </a:rPr>
-              <a:t>Iterate: refine dosing + AI from field data; harden for dust and 40-45C heat.</a:t>
-            </a:r>
-          </a:p>
-          <a:p>
-            <a:pPr marL="0" indent="0" algn="l">
-              <a:spcBef>
-                <a:spcPts val="0"/>
-              </a:spcBef>
-              <a:spcAft>
-                <a:spcPts val="300"/>
-              </a:spcAft>
-              <a:buNone/>
-            </a:pPr>
-            <a:r>
-              <a:rPr lang="en-US" sz="1600" b="1" dirty="0">
-                <a:solidFill>
-                  <a:srgbClr val="2E7D32"/>
-                </a:solidFill>
-                <a:latin typeface="Calibri"/>
-              </a:rPr>
-              <a:t>Competitors</a:t>
+              <a:t>Weed/disease detection accuracy (precision &amp; recall); dosing placement accuracy (cm).</a:t>
             </a:r>
           </a:p>
           <a:p>
@@ -1715,7 +2535,7 @@
                 <a:spcPts val="0"/>
               </a:spcBef>
               <a:spcAft>
-                <a:spcPts val="500"/>
+                <a:spcPts val="420"/>
               </a:spcAft>
               <a:buFont typeface="Arial"/>
               <a:buChar char="•"/>
@@ -1727,48 +2547,27 @@
                 </a:solidFill>
                 <a:latin typeface="Calibri"/>
               </a:rPr>
-              <a:t>Big precision-ag (tractors, large drones) = costly, large-farm. Manual labour/dealers; slow soil labs. Our edge: affordable, autonomous, small-farm, per-plant.</a:t>
-            </a:r>
-          </a:p>
-          <a:p>
-            <a:pPr marL="0" indent="0" algn="l">
-              <a:spcBef>
-                <a:spcPts val="0"/>
-              </a:spcBef>
-              <a:spcAft>
-                <a:spcPts val="300"/>
-              </a:spcAft>
-              <a:buNone/>
-            </a:pPr>
-            <a:r>
-              <a:rPr lang="en-US" sz="1600" b="1" dirty="0">
+              <a:t>Area covered per charge; cost saving per acre per season.</a:t>
+            </a:r>
+          </a:p>
+          <a:p>
+            <a:pPr marL="0" indent="0" algn="l">
+              <a:spcBef>
+                <a:spcPts val="0"/>
+              </a:spcBef>
+              <a:spcAft>
+                <a:spcPts val="0"/>
+              </a:spcAft>
+              <a:buNone/>
+            </a:pPr>
+            <a:r>
+              <a:rPr lang="en-US" sz="1400" b="1" dirty="0">
                 <a:solidFill>
                   <a:srgbClr val="2E7D32"/>
                 </a:solidFill>
                 <a:latin typeface="Calibri"/>
               </a:rPr>
-              <a:t>Pricing (indicative)</a:t>
-            </a:r>
-          </a:p>
-          <a:p>
-            <a:pPr marL="292608" indent="-292608" algn="l">
-              <a:spcBef>
-                <a:spcPts val="0"/>
-              </a:spcBef>
-              <a:spcAft>
-                <a:spcPts val="500"/>
-              </a:spcAft>
-              <a:buFont typeface="Arial"/>
-              <a:buChar char="•"/>
-            </a:pPr>
-            <a:r>
-              <a:rPr lang="en-US" sz="1500" dirty="0">
-                <a:solidFill>
-                  <a:srgbClr val="1A2421"/>
-                </a:solidFill>
-                <a:latin typeface="Calibri"/>
-              </a:rPr>
-              <a:t>Rover sale + service, or Rover-as-a-Service via FPOs/co-ops at a per-acre fee.</a:t>
+              <a:t>Targets to prove: 30-50% input reduction, &gt;85% detection accuracy.</a:t>
             </a:r>
           </a:p>
         </p:txBody>
@@ -1898,7 +2697,7 @@
                 </a:solidFill>
                 <a:latin typeface="Calibri"/>
               </a:rPr>
-              <a:t>Team, Budget &amp; Impact</a:t>
+              <a:t>Execution &amp; Business Plan</a:t>
             </a:r>
           </a:p>
         </p:txBody>
@@ -1941,14 +2740,14 @@
                 </a:solidFill>
                 <a:latin typeface="Calibri"/>
               </a:rPr>
-              <a:t>AgriRover  -  IITB-Groww INV.ENT Program</a:t>
-            </a:r>
-          </a:p>
-        </p:txBody>
-      </p:sp>
-      <p:sp>
-        <p:nvSpPr>
-          <p:cNvPr id="30" name="body"/>
+              <a:t>AgriRover  -  IITB-Groww INV.ENT  -  Track A  -  Team of 4</a:t>
+            </a:r>
+          </a:p>
+        </p:txBody>
+      </p:sp>
+      <p:sp>
+        <p:nvSpPr>
+          <p:cNvPr id="30" name="b"/>
           <p:cNvSpPr txBox="1"/>
           <p:nvPr/>
         </p:nvSpPr>
@@ -1973,7 +2772,7 @@
                 <a:spcPts val="0"/>
               </a:spcBef>
               <a:spcAft>
-                <a:spcPts val="300"/>
+                <a:spcPts val="240"/>
               </a:spcAft>
               <a:buNone/>
             </a:pPr>
@@ -1984,7 +2783,7 @@
                 </a:solidFill>
                 <a:latin typeface="Calibri"/>
               </a:rPr>
-              <a:t>Team (fill with your real team)</a:t>
+              <a:t>Next milestones</a:t>
             </a:r>
           </a:p>
           <a:p>
@@ -1993,7 +2792,7 @@
                 <a:spcPts val="0"/>
               </a:spcBef>
               <a:spcAft>
-                <a:spcPts val="500"/>
+                <a:spcPts val="420"/>
               </a:spcAft>
               <a:buFont typeface="Arial"/>
               <a:buChar char="•"/>
@@ -2005,27 +2804,7 @@
                 </a:solidFill>
                 <a:latin typeface="Calibri"/>
               </a:rPr>
-              <a:t>Embedded/robotics, AI/ML, agronomy advisor, operations.</a:t>
-            </a:r>
-          </a:p>
-          <a:p>
-            <a:pPr marL="0" indent="0" algn="l">
-              <a:spcBef>
-                <a:spcPts val="0"/>
-              </a:spcBef>
-              <a:spcAft>
-                <a:spcPts val="300"/>
-              </a:spcAft>
-              <a:buNone/>
-            </a:pPr>
-            <a:r>
-              <a:rPr lang="en-US" sz="1600" b="1" dirty="0">
-                <a:solidFill>
-                  <a:srgbClr val="2E7D32"/>
-                </a:solidFill>
-                <a:latin typeface="Calibri"/>
-              </a:rPr>
-              <a:t>Why us</a:t>
+              <a:t>Build: assemble hardware prototype (BTS7960 drive, NPK probe, pan/tilt sprayer, LiFePO4) - ~3 months.</a:t>
             </a:r>
           </a:p>
           <a:p>
@@ -2034,7 +2813,7 @@
                 <a:spcPts val="0"/>
               </a:spcBef>
               <a:spcAft>
-                <a:spcPts val="500"/>
+                <a:spcPts val="420"/>
               </a:spcAft>
               <a:buFont typeface="Arial"/>
               <a:buChar char="•"/>
@@ -2046,27 +2825,7 @@
                 </a:solidFill>
                 <a:latin typeface="Calibri"/>
               </a:rPr>
-              <a:t>Built the full software stack + detailed hardware design (firmware, AI, navigation, 110-part BOM).</a:t>
-            </a:r>
-          </a:p>
-          <a:p>
-            <a:pPr marL="0" indent="0" algn="l">
-              <a:spcBef>
-                <a:spcPts val="0"/>
-              </a:spcBef>
-              <a:spcAft>
-                <a:spcPts val="300"/>
-              </a:spcAft>
-              <a:buNone/>
-            </a:pPr>
-            <a:r>
-              <a:rPr lang="en-US" sz="1600" b="1" dirty="0">
-                <a:solidFill>
-                  <a:srgbClr val="2E7D32"/>
-                </a:solidFill>
-                <a:latin typeface="Calibri"/>
-              </a:rPr>
-              <a:t>Use of funds &amp; output</a:t>
+              <a:t>Test: pilot on 5-10 small farms; measure input savings, accuracy and uptime.</a:t>
             </a:r>
           </a:p>
           <a:p>
@@ -2075,7 +2834,7 @@
                 <a:spcPts val="0"/>
               </a:spcBef>
               <a:spcAft>
-                <a:spcPts val="500"/>
+                <a:spcPts val="420"/>
               </a:spcAft>
               <a:buFont typeface="Arial"/>
               <a:buChar char="•"/>
@@ -2087,16 +2846,16 @@
                 </a:solidFill>
                 <a:latin typeface="Calibri"/>
               </a:rPr>
-              <a:t>Prototype hardware/BOM, sensors + compute, field pilots, agronomy validation -&gt; a field-tested rover + pilot data on input savings.</a:t>
-            </a:r>
-          </a:p>
-          <a:p>
-            <a:pPr marL="0" indent="0" algn="l">
-              <a:spcBef>
-                <a:spcPts val="0"/>
-              </a:spcBef>
-              <a:spcAft>
-                <a:spcPts val="300"/>
+              <a:t>Iterate: refine dosing + AI from field data; harden for dust and 40-45C heat.</a:t>
+            </a:r>
+          </a:p>
+          <a:p>
+            <a:pPr marL="0" indent="0" algn="l">
+              <a:spcBef>
+                <a:spcPts val="0"/>
+              </a:spcBef>
+              <a:spcAft>
+                <a:spcPts val="240"/>
               </a:spcAft>
               <a:buNone/>
             </a:pPr>
@@ -2107,7 +2866,7 @@
                 </a:solidFill>
                 <a:latin typeface="Calibri"/>
               </a:rPr>
-              <a:t>Long-term vision &amp; impact</a:t>
+              <a:t>Competitors &amp; edge</a:t>
             </a:r>
           </a:p>
           <a:p>
@@ -2116,7 +2875,7 @@
                 <a:spcPts val="0"/>
               </a:spcBef>
               <a:spcAft>
-                <a:spcPts val="500"/>
+                <a:spcPts val="420"/>
               </a:spcAft>
               <a:buFont typeface="Arial"/>
               <a:buChar char="•"/>
@@ -2128,7 +2887,48 @@
                 </a:solidFill>
                 <a:latin typeface="Calibri"/>
               </a:rPr>
-              <a:t>Affordable precision farming for every smallholder: lower input cost, less runoff, healthier soil, higher net income.</a:t>
+              <a:t>Big precision-ag (tractors, large drones) = costly, large-farm. Manual labour/dealers; slow soil labs. Our edge: affordable, autonomous, small-farm, per-plant.</a:t>
+            </a:r>
+          </a:p>
+          <a:p>
+            <a:pPr marL="0" indent="0" algn="l">
+              <a:spcBef>
+                <a:spcPts val="0"/>
+              </a:spcBef>
+              <a:spcAft>
+                <a:spcPts val="240"/>
+              </a:spcAft>
+              <a:buNone/>
+            </a:pPr>
+            <a:r>
+              <a:rPr lang="en-US" sz="1600" b="1" dirty="0">
+                <a:solidFill>
+                  <a:srgbClr val="2E7D32"/>
+                </a:solidFill>
+                <a:latin typeface="Calibri"/>
+              </a:rPr>
+              <a:t>Pricing (indicative)</a:t>
+            </a:r>
+          </a:p>
+          <a:p>
+            <a:pPr marL="292608" indent="-292608" algn="l">
+              <a:spcBef>
+                <a:spcPts val="0"/>
+              </a:spcBef>
+              <a:spcAft>
+                <a:spcPts val="420"/>
+              </a:spcAft>
+              <a:buFont typeface="Arial"/>
+              <a:buChar char="•"/>
+            </a:pPr>
+            <a:r>
+              <a:rPr lang="en-US" sz="1500" dirty="0">
+                <a:solidFill>
+                  <a:srgbClr val="1A2421"/>
+                </a:solidFill>
+                <a:latin typeface="Calibri"/>
+              </a:rPr>
+              <a:t>Rover sale + service, or Rover-as-a-Service via FPOs/co-ops at a per-acre fee.</a:t>
             </a:r>
           </a:p>
         </p:txBody>
@@ -2258,7 +3058,7 @@
                 </a:solidFill>
                 <a:latin typeface="Calibri"/>
               </a:rPr>
-              <a:t>Budget Sheet</a:t>
+              <a:t>Team of 4 &amp; Impact</a:t>
             </a:r>
           </a:p>
         </p:txBody>
@@ -2301,20 +3101,803 @@
                 </a:solidFill>
                 <a:latin typeface="Calibri"/>
               </a:rPr>
-              <a:t>AgriRover  -  IITB-Groww INV.ENT Program</a:t>
+              <a:t>AgriRover  -  IITB-Groww INV.ENT  -  Track A  -  Team of 4</a:t>
+            </a:r>
+          </a:p>
+        </p:txBody>
+      </p:sp>
+      <p:sp>
+        <p:nvSpPr>
+          <p:cNvPr id="50" name="m"/>
+          <p:cNvSpPr/>
+          <p:nvPr/>
+        </p:nvSpPr>
+        <p:spPr>
+          <a:xfrm>
+            <a:off x="502920" y="1371600"/>
+            <a:ext cx="5074920" cy="914400"/>
+          </a:xfrm>
+          <a:prstGeom prst="roundRect">
+            <a:avLst>
+              <a:gd name="adj" fmla="val 8000"/>
+            </a:avLst>
+          </a:prstGeom>
+          <a:solidFill>
+            <a:srgbClr val="F3F8F1"/>
+          </a:solidFill>
+          <a:ln w="14000">
+            <a:solidFill>
+              <a:srgbClr val="2E7D32"/>
+            </a:solidFill>
+          </a:ln>
+        </p:spPr>
+        <p:txBody>
+          <a:bodyPr/>
+          <a:lstStyle/>
+          <a:p/>
+        </p:txBody>
+      </p:sp>
+      <p:sp>
+        <p:nvSpPr>
+          <p:cNvPr id="51" name="mt"/>
+          <p:cNvSpPr/>
+          <p:nvPr/>
+        </p:nvSpPr>
+        <p:spPr>
+          <a:xfrm>
+            <a:off x="502920" y="1371600"/>
+            <a:ext cx="91440" cy="914400"/>
+          </a:xfrm>
+          <a:prstGeom prst="rect">
+            <a:avLst/>
+          </a:prstGeom>
+          <a:solidFill>
+            <a:srgbClr val="2E7D32"/>
+          </a:solidFill>
+          <a:ln>
+            <a:noFill/>
+          </a:ln>
+        </p:spPr>
+        <p:txBody>
+          <a:bodyPr/>
+          <a:lstStyle/>
+          <a:p/>
+        </p:txBody>
+      </p:sp>
+      <p:sp>
+        <p:nvSpPr>
+          <p:cNvPr id="52" name="mc"/>
+          <p:cNvSpPr txBox="1"/>
+          <p:nvPr/>
+        </p:nvSpPr>
+        <p:spPr>
+          <a:xfrm>
+            <a:off x="722376" y="1463040"/>
+            <a:ext cx="4709160" cy="777240"/>
+          </a:xfrm>
+          <a:prstGeom prst="rect">
+            <a:avLst/>
+          </a:prstGeom>
+          <a:noFill/>
+        </p:spPr>
+        <p:txBody>
+          <a:bodyPr wrap="square" anchor="ctr" rtlCol="0">
+            <a:normAutofit/>
+          </a:bodyPr>
+          <a:lstStyle/>
+          <a:p>
+            <a:pPr marL="0" indent="0" algn="l">
+              <a:spcBef>
+                <a:spcPts val="0"/>
+              </a:spcBef>
+              <a:spcAft>
+                <a:spcPts val="80"/>
+              </a:spcAft>
+              <a:buNone/>
+            </a:pPr>
+            <a:r>
+              <a:rPr lang="en-US" sz="1300" b="1" dirty="0">
+                <a:solidFill>
+                  <a:srgbClr val="2E7D32"/>
+                </a:solidFill>
+                <a:latin typeface="Calibri"/>
+              </a:rPr>
+              <a:t>[Name 1] - Embedded &amp; Firmware</a:t>
+            </a:r>
+          </a:p>
+          <a:p>
+            <a:pPr marL="0" indent="0" algn="l">
+              <a:spcBef>
+                <a:spcPts val="0"/>
+              </a:spcBef>
+              <a:spcAft>
+                <a:spcPts val="0"/>
+              </a:spcAft>
+              <a:buNone/>
+            </a:pPr>
+            <a:r>
+              <a:rPr lang="en-US" sz="1050" dirty="0">
+                <a:solidFill>
+                  <a:srgbClr val="1A2421"/>
+                </a:solidFill>
+                <a:latin typeface="Calibri"/>
+              </a:rPr>
+              <a:t>ESP32/FreeRTOS, drive, sensing, dosing</a:t>
+            </a:r>
+          </a:p>
+        </p:txBody>
+      </p:sp>
+      <p:sp>
+        <p:nvSpPr>
+          <p:cNvPr id="53" name="m"/>
+          <p:cNvSpPr/>
+          <p:nvPr/>
+        </p:nvSpPr>
+        <p:spPr>
+          <a:xfrm>
+            <a:off x="5806440" y="1371600"/>
+            <a:ext cx="5074920" cy="914400"/>
+          </a:xfrm>
+          <a:prstGeom prst="roundRect">
+            <a:avLst>
+              <a:gd name="adj" fmla="val 8000"/>
+            </a:avLst>
+          </a:prstGeom>
+          <a:solidFill>
+            <a:srgbClr val="F3F8F1"/>
+          </a:solidFill>
+          <a:ln w="14000">
+            <a:solidFill>
+              <a:srgbClr val="1565C0"/>
+            </a:solidFill>
+          </a:ln>
+        </p:spPr>
+        <p:txBody>
+          <a:bodyPr/>
+          <a:lstStyle/>
+          <a:p/>
+        </p:txBody>
+      </p:sp>
+      <p:sp>
+        <p:nvSpPr>
+          <p:cNvPr id="54" name="mt"/>
+          <p:cNvSpPr/>
+          <p:nvPr/>
+        </p:nvSpPr>
+        <p:spPr>
+          <a:xfrm>
+            <a:off x="5806440" y="1371600"/>
+            <a:ext cx="91440" cy="914400"/>
+          </a:xfrm>
+          <a:prstGeom prst="rect">
+            <a:avLst/>
+          </a:prstGeom>
+          <a:solidFill>
+            <a:srgbClr val="1565C0"/>
+          </a:solidFill>
+          <a:ln>
+            <a:noFill/>
+          </a:ln>
+        </p:spPr>
+        <p:txBody>
+          <a:bodyPr/>
+          <a:lstStyle/>
+          <a:p/>
+        </p:txBody>
+      </p:sp>
+      <p:sp>
+        <p:nvSpPr>
+          <p:cNvPr id="55" name="mc"/>
+          <p:cNvSpPr txBox="1"/>
+          <p:nvPr/>
+        </p:nvSpPr>
+        <p:spPr>
+          <a:xfrm>
+            <a:off x="6025896" y="1463040"/>
+            <a:ext cx="4709160" cy="777240"/>
+          </a:xfrm>
+          <a:prstGeom prst="rect">
+            <a:avLst/>
+          </a:prstGeom>
+          <a:noFill/>
+        </p:spPr>
+        <p:txBody>
+          <a:bodyPr wrap="square" anchor="ctr" rtlCol="0">
+            <a:normAutofit/>
+          </a:bodyPr>
+          <a:lstStyle/>
+          <a:p>
+            <a:pPr marL="0" indent="0" algn="l">
+              <a:spcBef>
+                <a:spcPts val="0"/>
+              </a:spcBef>
+              <a:spcAft>
+                <a:spcPts val="80"/>
+              </a:spcAft>
+              <a:buNone/>
+            </a:pPr>
+            <a:r>
+              <a:rPr lang="en-US" sz="1300" b="1" dirty="0">
+                <a:solidFill>
+                  <a:srgbClr val="1565C0"/>
+                </a:solidFill>
+                <a:latin typeface="Calibri"/>
+              </a:rPr>
+              <a:t>[Name 2] - AI &amp; Vision</a:t>
+            </a:r>
+          </a:p>
+          <a:p>
+            <a:pPr marL="0" indent="0" algn="l">
+              <a:spcBef>
+                <a:spcPts val="0"/>
+              </a:spcBef>
+              <a:spcAft>
+                <a:spcPts val="0"/>
+              </a:spcAft>
+              <a:buNone/>
+            </a:pPr>
+            <a:r>
+              <a:rPr lang="en-US" sz="1050" dirty="0">
+                <a:solidFill>
+                  <a:srgbClr val="1A2421"/>
+                </a:solidFill>
+                <a:latin typeface="Calibri"/>
+              </a:rPr>
+              <a:t>YOLOv8n, Coral TPU, disease/weed/obstacle</a:t>
+            </a:r>
+          </a:p>
+        </p:txBody>
+      </p:sp>
+      <p:sp>
+        <p:nvSpPr>
+          <p:cNvPr id="56" name="m"/>
+          <p:cNvSpPr/>
+          <p:nvPr/>
+        </p:nvSpPr>
+        <p:spPr>
+          <a:xfrm>
+            <a:off x="502920" y="2423160"/>
+            <a:ext cx="5074920" cy="914400"/>
+          </a:xfrm>
+          <a:prstGeom prst="roundRect">
+            <a:avLst>
+              <a:gd name="adj" fmla="val 8000"/>
+            </a:avLst>
+          </a:prstGeom>
+          <a:solidFill>
+            <a:srgbClr val="F3F8F1"/>
+          </a:solidFill>
+          <a:ln w="14000">
+            <a:solidFill>
+              <a:srgbClr val="6A1B9A"/>
+            </a:solidFill>
+          </a:ln>
+        </p:spPr>
+        <p:txBody>
+          <a:bodyPr/>
+          <a:lstStyle/>
+          <a:p/>
+        </p:txBody>
+      </p:sp>
+      <p:sp>
+        <p:nvSpPr>
+          <p:cNvPr id="57" name="mt"/>
+          <p:cNvSpPr/>
+          <p:nvPr/>
+        </p:nvSpPr>
+        <p:spPr>
+          <a:xfrm>
+            <a:off x="502920" y="2423160"/>
+            <a:ext cx="91440" cy="914400"/>
+          </a:xfrm>
+          <a:prstGeom prst="rect">
+            <a:avLst/>
+          </a:prstGeom>
+          <a:solidFill>
+            <a:srgbClr val="6A1B9A"/>
+          </a:solidFill>
+          <a:ln>
+            <a:noFill/>
+          </a:ln>
+        </p:spPr>
+        <p:txBody>
+          <a:bodyPr/>
+          <a:lstStyle/>
+          <a:p/>
+        </p:txBody>
+      </p:sp>
+      <p:sp>
+        <p:nvSpPr>
+          <p:cNvPr id="58" name="mc"/>
+          <p:cNvSpPr txBox="1"/>
+          <p:nvPr/>
+        </p:nvSpPr>
+        <p:spPr>
+          <a:xfrm>
+            <a:off x="722376" y="2514600"/>
+            <a:ext cx="4709160" cy="777240"/>
+          </a:xfrm>
+          <a:prstGeom prst="rect">
+            <a:avLst/>
+          </a:prstGeom>
+          <a:noFill/>
+        </p:spPr>
+        <p:txBody>
+          <a:bodyPr wrap="square" anchor="ctr" rtlCol="0">
+            <a:normAutofit/>
+          </a:bodyPr>
+          <a:lstStyle/>
+          <a:p>
+            <a:pPr marL="0" indent="0" algn="l">
+              <a:spcBef>
+                <a:spcPts val="0"/>
+              </a:spcBef>
+              <a:spcAft>
+                <a:spcPts val="80"/>
+              </a:spcAft>
+              <a:buNone/>
+            </a:pPr>
+            <a:r>
+              <a:rPr lang="en-US" sz="1300" b="1" dirty="0">
+                <a:solidFill>
+                  <a:srgbClr val="6A1B9A"/>
+                </a:solidFill>
+                <a:latin typeface="Calibri"/>
+              </a:rPr>
+              <a:t>[Name 3] - Navigation &amp; Systems</a:t>
+            </a:r>
+          </a:p>
+          <a:p>
+            <a:pPr marL="0" indent="0" algn="l">
+              <a:spcBef>
+                <a:spcPts val="0"/>
+              </a:spcBef>
+              <a:spcAft>
+                <a:spcPts val="0"/>
+              </a:spcAft>
+              <a:buNone/>
+            </a:pPr>
+            <a:r>
+              <a:rPr lang="en-US" sz="1050" dirty="0">
+                <a:solidFill>
+                  <a:srgbClr val="1A2421"/>
+                </a:solidFill>
+                <a:latin typeface="Calibri"/>
+              </a:rPr>
+              <a:t>EKF, GPS, ROS2, simulation</a:t>
+            </a:r>
+          </a:p>
+        </p:txBody>
+      </p:sp>
+      <p:sp>
+        <p:nvSpPr>
+          <p:cNvPr id="59" name="m"/>
+          <p:cNvSpPr/>
+          <p:nvPr/>
+        </p:nvSpPr>
+        <p:spPr>
+          <a:xfrm>
+            <a:off x="5806440" y="2423160"/>
+            <a:ext cx="5074920" cy="914400"/>
+          </a:xfrm>
+          <a:prstGeom prst="roundRect">
+            <a:avLst>
+              <a:gd name="adj" fmla="val 8000"/>
+            </a:avLst>
+          </a:prstGeom>
+          <a:solidFill>
+            <a:srgbClr val="F3F8F1"/>
+          </a:solidFill>
+          <a:ln w="14000">
+            <a:solidFill>
+              <a:srgbClr val="EF6C00"/>
+            </a:solidFill>
+          </a:ln>
+        </p:spPr>
+        <p:txBody>
+          <a:bodyPr/>
+          <a:lstStyle/>
+          <a:p/>
+        </p:txBody>
+      </p:sp>
+      <p:sp>
+        <p:nvSpPr>
+          <p:cNvPr id="60" name="mt"/>
+          <p:cNvSpPr/>
+          <p:nvPr/>
+        </p:nvSpPr>
+        <p:spPr>
+          <a:xfrm>
+            <a:off x="5806440" y="2423160"/>
+            <a:ext cx="91440" cy="914400"/>
+          </a:xfrm>
+          <a:prstGeom prst="rect">
+            <a:avLst/>
+          </a:prstGeom>
+          <a:solidFill>
+            <a:srgbClr val="EF6C00"/>
+          </a:solidFill>
+          <a:ln>
+            <a:noFill/>
+          </a:ln>
+        </p:spPr>
+        <p:txBody>
+          <a:bodyPr/>
+          <a:lstStyle/>
+          <a:p/>
+        </p:txBody>
+      </p:sp>
+      <p:sp>
+        <p:nvSpPr>
+          <p:cNvPr id="61" name="mc"/>
+          <p:cNvSpPr txBox="1"/>
+          <p:nvPr/>
+        </p:nvSpPr>
+        <p:spPr>
+          <a:xfrm>
+            <a:off x="6025896" y="2514600"/>
+            <a:ext cx="4709160" cy="777240"/>
+          </a:xfrm>
+          <a:prstGeom prst="rect">
+            <a:avLst/>
+          </a:prstGeom>
+          <a:noFill/>
+        </p:spPr>
+        <p:txBody>
+          <a:bodyPr wrap="square" anchor="ctr" rtlCol="0">
+            <a:normAutofit/>
+          </a:bodyPr>
+          <a:lstStyle/>
+          <a:p>
+            <a:pPr marL="0" indent="0" algn="l">
+              <a:spcBef>
+                <a:spcPts val="0"/>
+              </a:spcBef>
+              <a:spcAft>
+                <a:spcPts val="80"/>
+              </a:spcAft>
+              <a:buNone/>
+            </a:pPr>
+            <a:r>
+              <a:rPr lang="en-US" sz="1300" b="1" dirty="0">
+                <a:solidFill>
+                  <a:srgbClr val="EF6C00"/>
+                </a:solidFill>
+                <a:latin typeface="Calibri"/>
+              </a:rPr>
+              <a:t>[Name 4] - Hardware &amp; Integration</a:t>
+            </a:r>
+          </a:p>
+          <a:p>
+            <a:pPr marL="0" indent="0" algn="l">
+              <a:spcBef>
+                <a:spcPts val="0"/>
+              </a:spcBef>
+              <a:spcAft>
+                <a:spcPts val="0"/>
+              </a:spcAft>
+              <a:buNone/>
+            </a:pPr>
+            <a:r>
+              <a:rPr lang="en-US" sz="1050" dirty="0">
+                <a:solidFill>
+                  <a:srgbClr val="1A2421"/>
+                </a:solidFill>
+                <a:latin typeface="Calibri"/>
+              </a:rPr>
+              <a:t>Circuit design, 110-part BOM, dashboard</a:t>
+            </a:r>
+          </a:p>
+        </p:txBody>
+      </p:sp>
+      <p:sp>
+        <p:nvSpPr>
+          <p:cNvPr id="62" name="imp"/>
+          <p:cNvSpPr txBox="1"/>
+          <p:nvPr/>
+        </p:nvSpPr>
+        <p:spPr>
+          <a:xfrm>
+            <a:off x="502920" y="3703320"/>
+            <a:ext cx="10241280" cy="2468880"/>
+          </a:xfrm>
+          <a:prstGeom prst="rect">
+            <a:avLst/>
+          </a:prstGeom>
+          <a:noFill/>
+        </p:spPr>
+        <p:txBody>
+          <a:bodyPr wrap="square" anchor="t" rtlCol="0">
+            <a:normAutofit/>
+          </a:bodyPr>
+          <a:lstStyle/>
+          <a:p>
+            <a:pPr marL="0" indent="0" algn="l">
+              <a:spcBef>
+                <a:spcPts val="0"/>
+              </a:spcBef>
+              <a:spcAft>
+                <a:spcPts val="240"/>
+              </a:spcAft>
+              <a:buNone/>
+            </a:pPr>
+            <a:r>
+              <a:rPr lang="en-US" sz="1600" b="1" dirty="0">
+                <a:solidFill>
+                  <a:srgbClr val="2E7D32"/>
+                </a:solidFill>
+                <a:latin typeface="Calibri"/>
+              </a:rPr>
+              <a:t>Why us</a:t>
+            </a:r>
+          </a:p>
+          <a:p>
+            <a:pPr marL="292608" indent="-292608" algn="l">
+              <a:spcBef>
+                <a:spcPts val="0"/>
+              </a:spcBef>
+              <a:spcAft>
+                <a:spcPts val="420"/>
+              </a:spcAft>
+              <a:buFont typeface="Arial"/>
+              <a:buChar char="•"/>
+            </a:pPr>
+            <a:r>
+              <a:rPr lang="en-US" sz="1500" dirty="0">
+                <a:solidFill>
+                  <a:srgbClr val="1A2421"/>
+                </a:solidFill>
+                <a:latin typeface="Calibri"/>
+              </a:rPr>
+              <a:t>4-member team that has already built the full software stack + a fully costed hardware design - end to end.</a:t>
+            </a:r>
+          </a:p>
+          <a:p>
+            <a:pPr marL="0" indent="0" algn="l">
+              <a:spcBef>
+                <a:spcPts val="0"/>
+              </a:spcBef>
+              <a:spcAft>
+                <a:spcPts val="240"/>
+              </a:spcAft>
+              <a:buNone/>
+            </a:pPr>
+            <a:r>
+              <a:rPr lang="en-US" sz="1600" b="1" dirty="0">
+                <a:solidFill>
+                  <a:srgbClr val="2E7D32"/>
+                </a:solidFill>
+                <a:latin typeface="Calibri"/>
+              </a:rPr>
+              <a:t>Impact</a:t>
+            </a:r>
+          </a:p>
+          <a:p>
+            <a:pPr marL="292608" indent="-292608" algn="l">
+              <a:spcBef>
+                <a:spcPts val="0"/>
+              </a:spcBef>
+              <a:spcAft>
+                <a:spcPts val="420"/>
+              </a:spcAft>
+              <a:buFont typeface="Arial"/>
+              <a:buChar char="•"/>
+            </a:pPr>
+            <a:r>
+              <a:rPr lang="en-US" sz="1500" dirty="0">
+                <a:solidFill>
+                  <a:srgbClr val="1A2421"/>
+                </a:solidFill>
+                <a:latin typeface="Calibri"/>
+              </a:rPr>
+              <a:t>Lower input cost for small farmers, less fertilizer/pesticide runoff, healthier soil and higher net income.</a:t>
+            </a:r>
+          </a:p>
+          <a:p>
+            <a:pPr marL="292608" indent="-292608" algn="l">
+              <a:spcBef>
+                <a:spcPts val="0"/>
+              </a:spcBef>
+              <a:spcAft>
+                <a:spcPts val="420"/>
+              </a:spcAft>
+              <a:buFont typeface="Arial"/>
+              <a:buChar char="•"/>
+            </a:pPr>
+            <a:r>
+              <a:rPr lang="en-US" sz="1500" dirty="0">
+                <a:solidFill>
+                  <a:srgbClr val="1A2421"/>
+                </a:solidFill>
+                <a:latin typeface="Calibri"/>
+              </a:rPr>
+              <a:t>Long-term: affordable precision farming for every smallholder; shared rover fleets via FPOs.</a:t>
+            </a:r>
+          </a:p>
+        </p:txBody>
+      </p:sp>
+    </p:spTree>
+  </p:cSld>
+  <p:clrMapOvr>
+    <a:masterClrMapping/>
+  </p:clrMapOvr>
+</p:sld>
+</file>
+
+<file path=ppt/slides/slide8.xml><?xml version="1.0" encoding="utf-8"?>
+<p:sld xmlns:a="http://schemas.openxmlformats.org/drawingml/2006/main" xmlns:r="http://schemas.openxmlformats.org/officeDocument/2006/relationships" xmlns:p="http://schemas.openxmlformats.org/presentationml/2006/main">
+  <p:cSld>
+    <p:bg>
+      <p:bgPr>
+        <a:solidFill>
+          <a:srgbClr val="FFFFFF"/>
+        </a:solidFill>
+        <a:effectLst/>
+      </p:bgPr>
+    </p:bg>
+    <p:spTree>
+      <p:nvGrpSpPr>
+        <p:cNvPr id="1" name=""/>
+        <p:cNvGrpSpPr/>
+        <p:nvPr/>
+      </p:nvGrpSpPr>
+      <p:grpSpPr>
+        <a:xfrm>
+          <a:off x="0" y="0"/>
+          <a:ext cx="0" cy="0"/>
+          <a:chOff x="0" y="0"/>
+          <a:chExt cx="0" cy="0"/>
+        </a:xfrm>
+      </p:grpSpPr>
+      <p:sp>
+        <p:nvSpPr>
+          <p:cNvPr id="10" name="band"/>
+          <p:cNvSpPr/>
+          <p:nvPr/>
+        </p:nvSpPr>
+        <p:spPr>
+          <a:xfrm>
+            <a:off x="0" y="0"/>
+            <a:ext cx="12192000" cy="1051560"/>
+          </a:xfrm>
+          <a:prstGeom prst="rect">
+            <a:avLst/>
+          </a:prstGeom>
+          <a:solidFill>
+            <a:srgbClr val="2E7D32"/>
+          </a:solidFill>
+          <a:ln>
+            <a:noFill/>
+          </a:ln>
+        </p:spPr>
+        <p:txBody>
+          <a:bodyPr/>
+          <a:lstStyle/>
+          <a:p/>
+        </p:txBody>
+      </p:sp>
+      <p:sp>
+        <p:nvSpPr>
+          <p:cNvPr id="11" name="accent"/>
+          <p:cNvSpPr/>
+          <p:nvPr/>
+        </p:nvSpPr>
+        <p:spPr>
+          <a:xfrm>
+            <a:off x="0" y="1051560"/>
+            <a:ext cx="12192000" cy="54864"/>
+          </a:xfrm>
+          <a:prstGeom prst="rect">
+            <a:avLst/>
+          </a:prstGeom>
+          <a:solidFill>
+            <a:srgbClr val="F9A825"/>
+          </a:solidFill>
+          <a:ln>
+            <a:noFill/>
+          </a:ln>
+        </p:spPr>
+        <p:txBody>
+          <a:bodyPr/>
+          <a:lstStyle/>
+          <a:p/>
+        </p:txBody>
+      </p:sp>
+      <p:sp>
+        <p:nvSpPr>
+          <p:cNvPr id="12" name="title"/>
+          <p:cNvSpPr txBox="1"/>
+          <p:nvPr/>
+        </p:nvSpPr>
+        <p:spPr>
+          <a:xfrm>
+            <a:off x="548640" y="146304"/>
+            <a:ext cx="10058400" cy="777240"/>
+          </a:xfrm>
+          <a:prstGeom prst="rect">
+            <a:avLst/>
+          </a:prstGeom>
+          <a:noFill/>
+        </p:spPr>
+        <p:txBody>
+          <a:bodyPr wrap="square" anchor="ctr" rtlCol="0">
+            <a:normAutofit/>
+          </a:bodyPr>
+          <a:lstStyle/>
+          <a:p>
+            <a:pPr marL="0" indent="0" algn="l">
+              <a:spcBef>
+                <a:spcPts val="0"/>
+              </a:spcBef>
+              <a:spcAft>
+                <a:spcPts val="600"/>
+              </a:spcAft>
+              <a:buNone/>
+            </a:pPr>
+            <a:r>
+              <a:rPr lang="en-US" sz="2800" b="1" dirty="0">
+                <a:solidFill>
+                  <a:srgbClr val="FFFFFF"/>
+                </a:solidFill>
+                <a:latin typeface="Calibri"/>
+              </a:rPr>
+              <a:t>Budget Sheet  (costed BOM)</a:t>
+            </a:r>
+          </a:p>
+        </p:txBody>
+      </p:sp>
+      <p:sp>
+        <p:nvSpPr>
+          <p:cNvPr id="13" name="foot"/>
+          <p:cNvSpPr txBox="1"/>
+          <p:nvPr/>
+        </p:nvSpPr>
+        <p:spPr>
+          <a:xfrm>
+            <a:off x="548640" y="6355080"/>
+            <a:ext cx="10058400" cy="365760"/>
+          </a:xfrm>
+          <a:prstGeom prst="rect">
+            <a:avLst/>
+          </a:prstGeom>
+          <a:noFill/>
+        </p:spPr>
+        <p:txBody>
+          <a:bodyPr wrap="square" anchor="t" rtlCol="0">
+            <a:normAutofit/>
+          </a:bodyPr>
+          <a:lstStyle/>
+          <a:p>
+            <a:pPr marL="0" indent="0" algn="l">
+              <a:spcBef>
+                <a:spcPts val="0"/>
+              </a:spcBef>
+              <a:spcAft>
+                <a:spcPts val="600"/>
+              </a:spcAft>
+              <a:buNone/>
+            </a:pPr>
+            <a:r>
+              <a:rPr lang="en-US" sz="1000" dirty="0">
+                <a:solidFill>
+                  <a:srgbClr val="5B6B63"/>
+                </a:solidFill>
+                <a:latin typeface="Calibri"/>
+              </a:rPr>
+              <a:t>AgriRover  -  IITB-Groww INV.ENT  -  Track A  -  Team of 4</a:t>
             </a:r>
           </a:p>
         </p:txBody>
       </p:sp>
       <p:graphicFrame>
         <p:nvGraphicFramePr>
-          <p:cNvPr id="40" name="Budget"/>
+          <p:cNvPr id="70" name="tbl"/>
           <p:cNvGraphicFramePr/>
           <p:nvPr/>
         </p:nvGraphicFramePr>
         <p:xfrm>
-          <a:off x="548640" y="1371600"/>
-          <a:ext cx="9966960" cy="4389120"/>
+          <a:off x="502920" y="1325880"/>
+          <a:ext cx="5669280" cy="4183380"/>
         </p:xfrm>
         <a:graphic>
           <a:graphicData uri="http://schemas.openxmlformats.org/drawingml/2006/table">
@@ -2323,11 +3906,10 @@
                 <a:tableStyleId>{5C22544A-7EE6-4342-B048-85BDC9FD1C3A}</a:tableStyleId>
               </a:tblPr>
               <a:tblGrid>
-                <a:gridCol w="4023360"/>
-                <a:gridCol w="4206240"/>
-                <a:gridCol w="1737360"/>
+                <a:gridCol w="3977640"/>
+                <a:gridCol w="1691640"/>
               </a:tblGrid>
-              <a:tr h="457200">
+              <a:tr h="278892">
                 <a:tc>
                   <a:txBody>
                     <a:bodyPr/>
@@ -2335,40 +3917,17 @@
                     <a:p>
                       <a:pPr algn="l"/>
                       <a:r>
-                        <a:rPr lang="en-US" sz="1250" b="1" dirty="0">
+                        <a:rPr lang="en-US" sz="1100" b="1" dirty="0">
                           <a:solidFill>
                             <a:srgbClr val="FFFFFF"/>
                           </a:solidFill>
                           <a:latin typeface="Calibri"/>
                         </a:rPr>
-                        <a:t>Item</a:t>
+                        <a:t>Section</a:t>
                       </a:r>
                     </a:p>
                   </a:txBody>
-                  <a:tcPr marL="73152" marR="73152" marT="36576" marB="36576" anchor="ctr">
-                    <a:solidFill>
-                      <a:srgbClr val="2E7D32"/>
-                    </a:solidFill>
-                  </a:tcPr>
-                </a:tc>
-                <a:tc>
-                  <a:txBody>
-                    <a:bodyPr/>
-                    <a:lstStyle/>
-                    <a:p>
-                      <a:pPr algn="l"/>
-                      <a:r>
-                        <a:rPr lang="en-US" sz="1250" b="1" dirty="0">
-                          <a:solidFill>
-                            <a:srgbClr val="FFFFFF"/>
-                          </a:solidFill>
-                          <a:latin typeface="Calibri"/>
-                        </a:rPr>
-                        <a:t>Purpose</a:t>
-                      </a:r>
-                    </a:p>
-                  </a:txBody>
-                  <a:tcPr marL="73152" marR="73152" marT="36576" marB="36576" anchor="ctr">
+                  <a:tcPr marL="64008" marR="64008" marT="18288" marB="18288" anchor="ctr">
                     <a:solidFill>
                       <a:srgbClr val="2E7D32"/>
                     </a:solidFill>
@@ -2381,7 +3940,7 @@
                     <a:p>
                       <a:pPr algn="r"/>
                       <a:r>
-                        <a:rPr lang="en-US" sz="1250" b="1" dirty="0">
+                        <a:rPr lang="en-US" sz="1100" b="1" dirty="0">
                           <a:solidFill>
                             <a:srgbClr val="FFFFFF"/>
                           </a:solidFill>
@@ -2391,14 +3950,14 @@
                       </a:r>
                     </a:p>
                   </a:txBody>
-                  <a:tcPr marL="73152" marR="73152" marT="36576" marB="36576" anchor="ctr">
+                  <a:tcPr marL="64008" marR="64008" marT="18288" marB="18288" anchor="ctr">
                     <a:solidFill>
                       <a:srgbClr val="2E7D32"/>
                     </a:solidFill>
                   </a:tcPr>
                 </a:tc>
               </a:tr>
-              <a:tr h="457200">
+              <a:tr h="278892">
                 <a:tc>
                   <a:txBody>
                     <a:bodyPr/>
@@ -2406,40 +3965,17 @@
                     <a:p>
                       <a:pPr algn="l"/>
                       <a:r>
-                        <a:rPr lang="en-US" sz="1200" dirty="0">
+                        <a:rPr lang="en-US" sz="1050" dirty="0">
                           <a:solidFill>
                             <a:srgbClr val="1A2421"/>
                           </a:solidFill>
                           <a:latin typeface="Calibri"/>
                         </a:rPr>
-                        <a:t>Chassis, motors &amp; BTS7960 drivers</a:t>
+                        <a:t>1. Brain &amp; Compute</a:t>
                       </a:r>
                     </a:p>
                   </a:txBody>
-                  <a:tcPr marL="73152" marR="73152" marT="36576" marB="36576" anchor="ctr">
-                    <a:solidFill>
-                      <a:srgbClr val="F3F8F1"/>
-                    </a:solidFill>
-                  </a:tcPr>
-                </a:tc>
-                <a:tc>
-                  <a:txBody>
-                    <a:bodyPr/>
-                    <a:lstStyle/>
-                    <a:p>
-                      <a:pPr algn="l"/>
-                      <a:r>
-                        <a:rPr lang="en-US" sz="1200" dirty="0">
-                          <a:solidFill>
-                            <a:srgbClr val="1A2421"/>
-                          </a:solidFill>
-                          <a:latin typeface="Calibri"/>
-                        </a:rPr>
-                        <a:t>Mobility on field</a:t>
-                      </a:r>
-                    </a:p>
-                  </a:txBody>
-                  <a:tcPr marL="73152" marR="73152" marT="36576" marB="36576" anchor="ctr">
+                  <a:tcPr marL="64008" marR="64008" marT="18288" marB="18288" anchor="ctr">
                     <a:solidFill>
                       <a:srgbClr val="F3F8F1"/>
                     </a:solidFill>
@@ -2452,24 +3988,24 @@
                     <a:p>
                       <a:pPr algn="r"/>
                       <a:r>
-                        <a:rPr lang="en-US" sz="1200" dirty="0">
+                        <a:rPr lang="en-US" sz="1050" dirty="0">
                           <a:solidFill>
                             <a:srgbClr val="1A2421"/>
                           </a:solidFill>
                           <a:latin typeface="Calibri"/>
                         </a:rPr>
-                        <a:t>9,000</a:t>
+                        <a:t>5,880 - 8,150</a:t>
                       </a:r>
                     </a:p>
                   </a:txBody>
-                  <a:tcPr marL="73152" marR="73152" marT="36576" marB="36576" anchor="ctr">
+                  <a:tcPr marL="64008" marR="64008" marT="18288" marB="18288" anchor="ctr">
                     <a:solidFill>
                       <a:srgbClr val="F3F8F1"/>
                     </a:solidFill>
                   </a:tcPr>
                 </a:tc>
               </a:tr>
-              <a:tr h="457200">
+              <a:tr h="278892">
                 <a:tc>
                   <a:txBody>
                     <a:bodyPr/>
@@ -2477,40 +4013,17 @@
                     <a:p>
                       <a:pPr algn="l"/>
                       <a:r>
-                        <a:rPr lang="en-US" sz="1200" dirty="0">
+                        <a:rPr lang="en-US" sz="1050" dirty="0">
                           <a:solidFill>
                             <a:srgbClr val="1A2421"/>
                           </a:solidFill>
                           <a:latin typeface="Calibri"/>
                         </a:rPr>
-                        <a:t>Raspberry Pi 4 + camera</a:t>
+                        <a:t>2. Power</a:t>
                       </a:r>
                     </a:p>
                   </a:txBody>
-                  <a:tcPr marL="73152" marR="73152" marT="36576" marB="36576" anchor="ctr">
-                    <a:solidFill>
-                      <a:srgbClr val="FFFFFF"/>
-                    </a:solidFill>
-                  </a:tcPr>
-                </a:tc>
-                <a:tc>
-                  <a:txBody>
-                    <a:bodyPr/>
-                    <a:lstStyle/>
-                    <a:p>
-                      <a:pPr algn="l"/>
-                      <a:r>
-                        <a:rPr lang="en-US" sz="1200" dirty="0">
-                          <a:solidFill>
-                            <a:srgbClr val="1A2421"/>
-                          </a:solidFill>
-                          <a:latin typeface="Calibri"/>
-                        </a:rPr>
-                        <a:t>On-board AI inference</a:t>
-                      </a:r>
-                    </a:p>
-                  </a:txBody>
-                  <a:tcPr marL="73152" marR="73152" marT="36576" marB="36576" anchor="ctr">
+                  <a:tcPr marL="64008" marR="64008" marT="18288" marB="18288" anchor="ctr">
                     <a:solidFill>
                       <a:srgbClr val="FFFFFF"/>
                     </a:solidFill>
@@ -2523,24 +4036,24 @@
                     <a:p>
                       <a:pPr algn="r"/>
                       <a:r>
-                        <a:rPr lang="en-US" sz="1200" dirty="0">
+                        <a:rPr lang="en-US" sz="1050" dirty="0">
                           <a:solidFill>
                             <a:srgbClr val="1A2421"/>
                           </a:solidFill>
                           <a:latin typeface="Calibri"/>
                         </a:rPr>
-                        <a:t>8,000</a:t>
+                        <a:t>2,350 - 4,040</a:t>
                       </a:r>
                     </a:p>
                   </a:txBody>
-                  <a:tcPr marL="73152" marR="73152" marT="36576" marB="36576" anchor="ctr">
+                  <a:tcPr marL="64008" marR="64008" marT="18288" marB="18288" anchor="ctr">
                     <a:solidFill>
                       <a:srgbClr val="FFFFFF"/>
                     </a:solidFill>
                   </a:tcPr>
                 </a:tc>
               </a:tr>
-              <a:tr h="457200">
+              <a:tr h="278892">
                 <a:tc>
                   <a:txBody>
                     <a:bodyPr/>
@@ -2548,40 +4061,17 @@
                     <a:p>
                       <a:pPr algn="l"/>
                       <a:r>
-                        <a:rPr lang="en-US" sz="1200" dirty="0">
+                        <a:rPr lang="en-US" sz="1050" dirty="0">
                           <a:solidFill>
                             <a:srgbClr val="1A2421"/>
                           </a:solidFill>
                           <a:latin typeface="Calibri"/>
                         </a:rPr>
-                        <a:t>NPK probe, moisture/TDS, GPS, IMU</a:t>
+                        <a:t>3. Motor &amp; Drive</a:t>
                       </a:r>
                     </a:p>
                   </a:txBody>
-                  <a:tcPr marL="73152" marR="73152" marT="36576" marB="36576" anchor="ctr">
-                    <a:solidFill>
-                      <a:srgbClr val="F3F8F1"/>
-                    </a:solidFill>
-                  </a:tcPr>
-                </a:tc>
-                <a:tc>
-                  <a:txBody>
-                    <a:bodyPr/>
-                    <a:lstStyle/>
-                    <a:p>
-                      <a:pPr algn="l"/>
-                      <a:r>
-                        <a:rPr lang="en-US" sz="1200" dirty="0">
-                          <a:solidFill>
-                            <a:srgbClr val="1A2421"/>
-                          </a:solidFill>
-                          <a:latin typeface="Calibri"/>
-                        </a:rPr>
-                        <a:t>Soil + navigation sensing</a:t>
-                      </a:r>
-                    </a:p>
-                  </a:txBody>
-                  <a:tcPr marL="73152" marR="73152" marT="36576" marB="36576" anchor="ctr">
+                  <a:tcPr marL="64008" marR="64008" marT="18288" marB="18288" anchor="ctr">
                     <a:solidFill>
                       <a:srgbClr val="F3F8F1"/>
                     </a:solidFill>
@@ -2594,24 +4084,24 @@
                     <a:p>
                       <a:pPr algn="r"/>
                       <a:r>
-                        <a:rPr lang="en-US" sz="1200" dirty="0">
+                        <a:rPr lang="en-US" sz="1050" dirty="0">
                           <a:solidFill>
                             <a:srgbClr val="1A2421"/>
                           </a:solidFill>
                           <a:latin typeface="Calibri"/>
                         </a:rPr>
-                        <a:t>9,000</a:t>
+                        <a:t>1,740 - 3,400</a:t>
                       </a:r>
                     </a:p>
                   </a:txBody>
-                  <a:tcPr marL="73152" marR="73152" marT="36576" marB="36576" anchor="ctr">
+                  <a:tcPr marL="64008" marR="64008" marT="18288" marB="18288" anchor="ctr">
                     <a:solidFill>
                       <a:srgbClr val="F3F8F1"/>
                     </a:solidFill>
                   </a:tcPr>
                 </a:tc>
               </a:tr>
-              <a:tr h="457200">
+              <a:tr h="278892">
                 <a:tc>
                   <a:txBody>
                     <a:bodyPr/>
@@ -2619,40 +4109,17 @@
                     <a:p>
                       <a:pPr algn="l"/>
                       <a:r>
-                        <a:rPr lang="en-US" sz="1200" dirty="0">
+                        <a:rPr lang="en-US" sz="1050" dirty="0">
                           <a:solidFill>
                             <a:srgbClr val="1A2421"/>
                           </a:solidFill>
                           <a:latin typeface="Calibri"/>
                         </a:rPr>
-                        <a:t>LiFePO4 battery + power/thermal</a:t>
+                        <a:t>4. Sensing (ESP32)</a:t>
                       </a:r>
                     </a:p>
                   </a:txBody>
-                  <a:tcPr marL="73152" marR="73152" marT="36576" marB="36576" anchor="ctr">
-                    <a:solidFill>
-                      <a:srgbClr val="FFFFFF"/>
-                    </a:solidFill>
-                  </a:tcPr>
-                </a:tc>
-                <a:tc>
-                  <a:txBody>
-                    <a:bodyPr/>
-                    <a:lstStyle/>
-                    <a:p>
-                      <a:pPr algn="l"/>
-                      <a:r>
-                        <a:rPr lang="en-US" sz="1200" dirty="0">
-                          <a:solidFill>
-                            <a:srgbClr val="1A2421"/>
-                          </a:solidFill>
-                          <a:latin typeface="Calibri"/>
-                        </a:rPr>
-                        <a:t>Safe field power</a:t>
-                      </a:r>
-                    </a:p>
-                  </a:txBody>
-                  <a:tcPr marL="73152" marR="73152" marT="36576" marB="36576" anchor="ctr">
+                  <a:tcPr marL="64008" marR="64008" marT="18288" marB="18288" anchor="ctr">
                     <a:solidFill>
                       <a:srgbClr val="FFFFFF"/>
                     </a:solidFill>
@@ -2665,24 +4132,24 @@
                     <a:p>
                       <a:pPr algn="r"/>
                       <a:r>
-                        <a:rPr lang="en-US" sz="1200" dirty="0">
+                        <a:rPr lang="en-US" sz="1050" dirty="0">
                           <a:solidFill>
                             <a:srgbClr val="1A2421"/>
                           </a:solidFill>
                           <a:latin typeface="Calibri"/>
                         </a:rPr>
-                        <a:t>6,000</a:t>
+                        <a:t>3,740 - 8,080</a:t>
                       </a:r>
                     </a:p>
                   </a:txBody>
-                  <a:tcPr marL="73152" marR="73152" marT="36576" marB="36576" anchor="ctr">
+                  <a:tcPr marL="64008" marR="64008" marT="18288" marB="18288" anchor="ctr">
                     <a:solidFill>
                       <a:srgbClr val="FFFFFF"/>
                     </a:solidFill>
                   </a:tcPr>
                 </a:tc>
               </a:tr>
-              <a:tr h="457200">
+              <a:tr h="278892">
                 <a:tc>
                   <a:txBody>
                     <a:bodyPr/>
@@ -2690,40 +4157,17 @@
                     <a:p>
                       <a:pPr algn="l"/>
                       <a:r>
-                        <a:rPr lang="en-US" sz="1200" dirty="0">
+                        <a:rPr lang="en-US" sz="1050" dirty="0">
                           <a:solidFill>
                             <a:srgbClr val="1A2421"/>
                           </a:solidFill>
                           <a:latin typeface="Calibri"/>
                         </a:rPr>
-                        <a:t>Pumps, pan/tilt sprayer, tank, actuator</a:t>
+                        <a:t>5. AI Sensing (Pi)</a:t>
                       </a:r>
                     </a:p>
                   </a:txBody>
-                  <a:tcPr marL="73152" marR="73152" marT="36576" marB="36576" anchor="ctr">
-                    <a:solidFill>
-                      <a:srgbClr val="F3F8F1"/>
-                    </a:solidFill>
-                  </a:tcPr>
-                </a:tc>
-                <a:tc>
-                  <a:txBody>
-                    <a:bodyPr/>
-                    <a:lstStyle/>
-                    <a:p>
-                      <a:pPr algn="l"/>
-                      <a:r>
-                        <a:rPr lang="en-US" sz="1200" dirty="0">
-                          <a:solidFill>
-                            <a:srgbClr val="1A2421"/>
-                          </a:solidFill>
-                          <a:latin typeface="Calibri"/>
-                        </a:rPr>
-                        <a:t>Targeted micro-dosing</a:t>
-                      </a:r>
-                    </a:p>
-                  </a:txBody>
-                  <a:tcPr marL="73152" marR="73152" marT="36576" marB="36576" anchor="ctr">
+                  <a:tcPr marL="64008" marR="64008" marT="18288" marB="18288" anchor="ctr">
                     <a:solidFill>
                       <a:srgbClr val="F3F8F1"/>
                     </a:solidFill>
@@ -2736,24 +4180,24 @@
                     <a:p>
                       <a:pPr algn="r"/>
                       <a:r>
-                        <a:rPr lang="en-US" sz="1200" dirty="0">
+                        <a:rPr lang="en-US" sz="1050" dirty="0">
                           <a:solidFill>
                             <a:srgbClr val="1A2421"/>
                           </a:solidFill>
                           <a:latin typeface="Calibri"/>
                         </a:rPr>
-                        <a:t>7,000</a:t>
+                        <a:t>4,680 - 7,100</a:t>
                       </a:r>
                     </a:p>
                   </a:txBody>
-                  <a:tcPr marL="73152" marR="73152" marT="36576" marB="36576" anchor="ctr">
+                  <a:tcPr marL="64008" marR="64008" marT="18288" marB="18288" anchor="ctr">
                     <a:solidFill>
                       <a:srgbClr val="F3F8F1"/>
                     </a:solidFill>
                   </a:tcPr>
                 </a:tc>
               </a:tr>
-              <a:tr h="457200">
+              <a:tr h="278892">
                 <a:tc>
                   <a:txBody>
                     <a:bodyPr/>
@@ -2761,40 +4205,17 @@
                     <a:p>
                       <a:pPr algn="l"/>
                       <a:r>
-                        <a:rPr lang="en-US" sz="1200" dirty="0">
+                        <a:rPr lang="en-US" sz="1050" dirty="0">
                           <a:solidFill>
                             <a:srgbClr val="1A2421"/>
                           </a:solidFill>
                           <a:latin typeface="Calibri"/>
                         </a:rPr>
-                        <a:t>Enclosure, wiring, field testing</a:t>
+                        <a:t>6. Actuation</a:t>
                       </a:r>
                     </a:p>
                   </a:txBody>
-                  <a:tcPr marL="73152" marR="73152" marT="36576" marB="36576" anchor="ctr">
-                    <a:solidFill>
-                      <a:srgbClr val="FFFFFF"/>
-                    </a:solidFill>
-                  </a:tcPr>
-                </a:tc>
-                <a:tc>
-                  <a:txBody>
-                    <a:bodyPr/>
-                    <a:lstStyle/>
-                    <a:p>
-                      <a:pPr algn="l"/>
-                      <a:r>
-                        <a:rPr lang="en-US" sz="1200" dirty="0">
-                          <a:solidFill>
-                            <a:srgbClr val="1A2421"/>
-                          </a:solidFill>
-                          <a:latin typeface="Calibri"/>
-                        </a:rPr>
-                        <a:t>Assembly &amp; pilot</a:t>
-                      </a:r>
-                    </a:p>
-                  </a:txBody>
-                  <a:tcPr marL="73152" marR="73152" marT="36576" marB="36576" anchor="ctr">
+                  <a:tcPr marL="64008" marR="64008" marT="18288" marB="18288" anchor="ctr">
                     <a:solidFill>
                       <a:srgbClr val="FFFFFF"/>
                     </a:solidFill>
@@ -2807,24 +4228,24 @@
                     <a:p>
                       <a:pPr algn="r"/>
                       <a:r>
-                        <a:rPr lang="en-US" sz="1200" dirty="0">
+                        <a:rPr lang="en-US" sz="1050" dirty="0">
                           <a:solidFill>
                             <a:srgbClr val="1A2421"/>
                           </a:solidFill>
                           <a:latin typeface="Calibri"/>
                         </a:rPr>
-                        <a:t>5,000</a:t>
+                        <a:t>1,560 - 3,030</a:t>
                       </a:r>
                     </a:p>
                   </a:txBody>
-                  <a:tcPr marL="73152" marR="73152" marT="36576" marB="36576" anchor="ctr">
+                  <a:tcPr marL="64008" marR="64008" marT="18288" marB="18288" anchor="ctr">
                     <a:solidFill>
                       <a:srgbClr val="FFFFFF"/>
                     </a:solidFill>
                   </a:tcPr>
                 </a:tc>
               </a:tr>
-              <a:tr h="457200">
+              <a:tr h="278892">
                 <a:tc>
                   <a:txBody>
                     <a:bodyPr/>
@@ -2832,40 +4253,17 @@
                     <a:p>
                       <a:pPr algn="l"/>
                       <a:r>
-                        <a:rPr lang="en-US" sz="1200" dirty="0">
+                        <a:rPr lang="en-US" sz="1050" dirty="0">
                           <a:solidFill>
                             <a:srgbClr val="1A2421"/>
                           </a:solidFill>
                           <a:latin typeface="Calibri"/>
                         </a:rPr>
-                        <a:t>Contingency</a:t>
+                        <a:t>7. Communication</a:t>
                       </a:r>
                     </a:p>
                   </a:txBody>
-                  <a:tcPr marL="73152" marR="73152" marT="36576" marB="36576" anchor="ctr">
-                    <a:solidFill>
-                      <a:srgbClr val="F3F8F1"/>
-                    </a:solidFill>
-                  </a:tcPr>
-                </a:tc>
-                <a:tc>
-                  <a:txBody>
-                    <a:bodyPr/>
-                    <a:lstStyle/>
-                    <a:p>
-                      <a:pPr algn="l"/>
-                      <a:r>
-                        <a:rPr lang="en-US" sz="1200" dirty="0">
-                          <a:solidFill>
-                            <a:srgbClr val="1A2421"/>
-                          </a:solidFill>
-                          <a:latin typeface="Calibri"/>
-                        </a:rPr>
-                        <a:t>Risk buffer</a:t>
-                      </a:r>
-                    </a:p>
-                  </a:txBody>
-                  <a:tcPr marL="73152" marR="73152" marT="36576" marB="36576" anchor="ctr">
+                  <a:tcPr marL="64008" marR="64008" marT="18288" marB="18288" anchor="ctr">
                     <a:solidFill>
                       <a:srgbClr val="F3F8F1"/>
                     </a:solidFill>
@@ -2878,24 +4276,24 @@
                     <a:p>
                       <a:pPr algn="r"/>
                       <a:r>
-                        <a:rPr lang="en-US" sz="1200" dirty="0">
+                        <a:rPr lang="en-US" sz="1050" dirty="0">
                           <a:solidFill>
                             <a:srgbClr val="1A2421"/>
                           </a:solidFill>
                           <a:latin typeface="Calibri"/>
                         </a:rPr>
-                        <a:t>3,000</a:t>
+                        <a:t>500 - 1,000</a:t>
                       </a:r>
                     </a:p>
                   </a:txBody>
-                  <a:tcPr marL="73152" marR="73152" marT="36576" marB="36576" anchor="ctr">
+                  <a:tcPr marL="64008" marR="64008" marT="18288" marB="18288" anchor="ctr">
                     <a:solidFill>
                       <a:srgbClr val="F3F8F1"/>
                     </a:solidFill>
                   </a:tcPr>
                 </a:tc>
               </a:tr>
-              <a:tr h="457200">
+              <a:tr h="278892">
                 <a:tc>
                   <a:txBody>
                     <a:bodyPr/>
@@ -2903,19 +4301,19 @@
                     <a:p>
                       <a:pPr algn="l"/>
                       <a:r>
-                        <a:rPr lang="en-US" sz="1200" b="1" dirty="0">
+                        <a:rPr lang="en-US" sz="1050" dirty="0">
                           <a:solidFill>
-                            <a:srgbClr val="FFFFFF"/>
+                            <a:srgbClr val="1A2421"/>
                           </a:solidFill>
                           <a:latin typeface="Calibri"/>
                         </a:rPr>
-                        <a:t>TOTAL</a:t>
+                        <a:t>8. Interface</a:t>
                       </a:r>
                     </a:p>
                   </a:txBody>
-                  <a:tcPr marL="73152" marR="73152" marT="36576" marB="36576" anchor="ctr">
+                  <a:tcPr marL="64008" marR="64008" marT="18288" marB="18288" anchor="ctr">
                     <a:solidFill>
-                      <a:srgbClr val="14532D"/>
+                      <a:srgbClr val="FFFFFF"/>
                     </a:solidFill>
                   </a:tcPr>
                 </a:tc>
@@ -2924,19 +4322,284 @@
                     <a:bodyPr/>
                     <a:lstStyle/>
                     <a:p>
+                      <a:pPr algn="r"/>
+                      <a:r>
+                        <a:rPr lang="en-US" sz="1050" dirty="0">
+                          <a:solidFill>
+                            <a:srgbClr val="1A2421"/>
+                          </a:solidFill>
+                          <a:latin typeface="Calibri"/>
+                        </a:rPr>
+                        <a:t>480 - 870</a:t>
+                      </a:r>
+                    </a:p>
+                  </a:txBody>
+                  <a:tcPr marL="64008" marR="64008" marT="18288" marB="18288" anchor="ctr">
+                    <a:solidFill>
+                      <a:srgbClr val="FFFFFF"/>
+                    </a:solidFill>
+                  </a:tcPr>
+                </a:tc>
+              </a:tr>
+              <a:tr h="278892">
+                <a:tc>
+                  <a:txBody>
+                    <a:bodyPr/>
+                    <a:lstStyle/>
+                    <a:p>
                       <a:pPr algn="l"/>
                       <a:r>
-                        <a:rPr lang="en-US" sz="1200" b="1" dirty="0">
+                        <a:rPr lang="en-US" sz="1050" dirty="0">
+                          <a:solidFill>
+                            <a:srgbClr val="1A2421"/>
+                          </a:solidFill>
+                          <a:latin typeface="Calibri"/>
+                        </a:rPr>
+                        <a:t>9. Passives &amp; wiring</a:t>
+                      </a:r>
+                    </a:p>
+                  </a:txBody>
+                  <a:tcPr marL="64008" marR="64008" marT="18288" marB="18288" anchor="ctr">
+                    <a:solidFill>
+                      <a:srgbClr val="F3F8F1"/>
+                    </a:solidFill>
+                  </a:tcPr>
+                </a:tc>
+                <a:tc>
+                  <a:txBody>
+                    <a:bodyPr/>
+                    <a:lstStyle/>
+                    <a:p>
+                      <a:pPr algn="r"/>
+                      <a:r>
+                        <a:rPr lang="en-US" sz="1050" dirty="0">
+                          <a:solidFill>
+                            <a:srgbClr val="1A2421"/>
+                          </a:solidFill>
+                          <a:latin typeface="Calibri"/>
+                        </a:rPr>
+                        <a:t>790 - 1,530</a:t>
+                      </a:r>
+                    </a:p>
+                  </a:txBody>
+                  <a:tcPr marL="64008" marR="64008" marT="18288" marB="18288" anchor="ctr">
+                    <a:solidFill>
+                      <a:srgbClr val="F3F8F1"/>
+                    </a:solidFill>
+                  </a:tcPr>
+                </a:tc>
+              </a:tr>
+              <a:tr h="278892">
+                <a:tc>
+                  <a:txBody>
+                    <a:bodyPr/>
+                    <a:lstStyle/>
+                    <a:p>
+                      <a:pPr algn="l"/>
+                      <a:r>
+                        <a:rPr lang="en-US" sz="1050" dirty="0">
+                          <a:solidFill>
+                            <a:srgbClr val="1A2421"/>
+                          </a:solidFill>
+                          <a:latin typeface="Calibri"/>
+                        </a:rPr>
+                        <a:t>10. Chassis</a:t>
+                      </a:r>
+                    </a:p>
+                  </a:txBody>
+                  <a:tcPr marL="64008" marR="64008" marT="18288" marB="18288" anchor="ctr">
+                    <a:solidFill>
+                      <a:srgbClr val="FFFFFF"/>
+                    </a:solidFill>
+                  </a:tcPr>
+                </a:tc>
+                <a:tc>
+                  <a:txBody>
+                    <a:bodyPr/>
+                    <a:lstStyle/>
+                    <a:p>
+                      <a:pPr algn="r"/>
+                      <a:r>
+                        <a:rPr lang="en-US" sz="1050" dirty="0">
+                          <a:solidFill>
+                            <a:srgbClr val="1A2421"/>
+                          </a:solidFill>
+                          <a:latin typeface="Calibri"/>
+                        </a:rPr>
+                        <a:t>1,420 - 2,600</a:t>
+                      </a:r>
+                    </a:p>
+                  </a:txBody>
+                  <a:tcPr marL="64008" marR="64008" marT="18288" marB="18288" anchor="ctr">
+                    <a:solidFill>
+                      <a:srgbClr val="FFFFFF"/>
+                    </a:solidFill>
+                  </a:tcPr>
+                </a:tc>
+              </a:tr>
+              <a:tr h="278892">
+                <a:tc>
+                  <a:txBody>
+                    <a:bodyPr/>
+                    <a:lstStyle/>
+                    <a:p>
+                      <a:pPr algn="l"/>
+                      <a:r>
+                        <a:rPr lang="en-US" sz="1050" dirty="0">
+                          <a:solidFill>
+                            <a:srgbClr val="1A2421"/>
+                          </a:solidFill>
+                          <a:latin typeface="Calibri"/>
+                        </a:rPr>
+                        <a:t>11. Safety / Thermal</a:t>
+                      </a:r>
+                    </a:p>
+                  </a:txBody>
+                  <a:tcPr marL="64008" marR="64008" marT="18288" marB="18288" anchor="ctr">
+                    <a:solidFill>
+                      <a:srgbClr val="F3F8F1"/>
+                    </a:solidFill>
+                  </a:tcPr>
+                </a:tc>
+                <a:tc>
+                  <a:txBody>
+                    <a:bodyPr/>
+                    <a:lstStyle/>
+                    <a:p>
+                      <a:pPr algn="r"/>
+                      <a:r>
+                        <a:rPr lang="en-US" sz="1050" dirty="0">
+                          <a:solidFill>
+                            <a:srgbClr val="1A2421"/>
+                          </a:solidFill>
+                          <a:latin typeface="Calibri"/>
+                        </a:rPr>
+                        <a:t>2,070 - 3,880</a:t>
+                      </a:r>
+                    </a:p>
+                  </a:txBody>
+                  <a:tcPr marL="64008" marR="64008" marT="18288" marB="18288" anchor="ctr">
+                    <a:solidFill>
+                      <a:srgbClr val="F3F8F1"/>
+                    </a:solidFill>
+                  </a:tcPr>
+                </a:tc>
+              </a:tr>
+              <a:tr h="278892">
+                <a:tc>
+                  <a:txBody>
+                    <a:bodyPr/>
+                    <a:lstStyle/>
+                    <a:p>
+                      <a:pPr algn="l"/>
+                      <a:r>
+                        <a:rPr lang="en-US" sz="1050" dirty="0">
+                          <a:solidFill>
+                            <a:srgbClr val="1A2421"/>
+                          </a:solidFill>
+                          <a:latin typeface="Calibri"/>
+                        </a:rPr>
+                        <a:t>12. v2 Upgrade parts</a:t>
+                      </a:r>
+                    </a:p>
+                  </a:txBody>
+                  <a:tcPr marL="64008" marR="64008" marT="18288" marB="18288" anchor="ctr">
+                    <a:solidFill>
+                      <a:srgbClr val="FFFFFF"/>
+                    </a:solidFill>
+                  </a:tcPr>
+                </a:tc>
+                <a:tc>
+                  <a:txBody>
+                    <a:bodyPr/>
+                    <a:lstStyle/>
+                    <a:p>
+                      <a:pPr algn="r"/>
+                      <a:r>
+                        <a:rPr lang="en-US" sz="1050" dirty="0">
+                          <a:solidFill>
+                            <a:srgbClr val="1A2421"/>
+                          </a:solidFill>
+                          <a:latin typeface="Calibri"/>
+                        </a:rPr>
+                        <a:t>740 - 1,510</a:t>
+                      </a:r>
+                    </a:p>
+                  </a:txBody>
+                  <a:tcPr marL="64008" marR="64008" marT="18288" marB="18288" anchor="ctr">
+                    <a:solidFill>
+                      <a:srgbClr val="FFFFFF"/>
+                    </a:solidFill>
+                  </a:tcPr>
+                </a:tc>
+              </a:tr>
+              <a:tr h="278892">
+                <a:tc>
+                  <a:txBody>
+                    <a:bodyPr/>
+                    <a:lstStyle/>
+                    <a:p>
+                      <a:pPr algn="l"/>
+                      <a:r>
+                        <a:rPr lang="en-US" sz="1050" dirty="0">
+                          <a:solidFill>
+                            <a:srgbClr val="1A2421"/>
+                          </a:solidFill>
+                          <a:latin typeface="Calibri"/>
+                        </a:rPr>
+                        <a:t>13. Tools (one-time)</a:t>
+                      </a:r>
+                    </a:p>
+                  </a:txBody>
+                  <a:tcPr marL="64008" marR="64008" marT="18288" marB="18288" anchor="ctr">
+                    <a:solidFill>
+                      <a:srgbClr val="F3F8F1"/>
+                    </a:solidFill>
+                  </a:tcPr>
+                </a:tc>
+                <a:tc>
+                  <a:txBody>
+                    <a:bodyPr/>
+                    <a:lstStyle/>
+                    <a:p>
+                      <a:pPr algn="r"/>
+                      <a:r>
+                        <a:rPr lang="en-US" sz="1050" dirty="0">
+                          <a:solidFill>
+                            <a:srgbClr val="1A2421"/>
+                          </a:solidFill>
+                          <a:latin typeface="Calibri"/>
+                        </a:rPr>
+                        <a:t>1,410 - 2,760</a:t>
+                      </a:r>
+                    </a:p>
+                  </a:txBody>
+                  <a:tcPr marL="64008" marR="64008" marT="18288" marB="18288" anchor="ctr">
+                    <a:solidFill>
+                      <a:srgbClr val="F3F8F1"/>
+                    </a:solidFill>
+                  </a:tcPr>
+                </a:tc>
+              </a:tr>
+              <a:tr h="278892">
+                <a:tc>
+                  <a:txBody>
+                    <a:bodyPr/>
+                    <a:lstStyle/>
+                    <a:p>
+                      <a:pPr algn="l"/>
+                      <a:r>
+                        <a:rPr lang="en-US" sz="1150" b="1" dirty="0">
                           <a:solidFill>
                             <a:srgbClr val="FFFFFF"/>
                           </a:solidFill>
                           <a:latin typeface="Calibri"/>
                         </a:rPr>
-                        <a:t/>
+                        <a:t>TOTAL (Full AI build)</a:t>
                       </a:r>
                     </a:p>
                   </a:txBody>
-                  <a:tcPr marL="73152" marR="73152" marT="36576" marB="36576" anchor="ctr">
+                  <a:tcPr marL="64008" marR="64008" marT="18288" marB="18288" anchor="ctr">
                     <a:solidFill>
                       <a:srgbClr val="14532D"/>
                     </a:solidFill>
@@ -2949,17 +4612,17 @@
                     <a:p>
                       <a:pPr algn="r"/>
                       <a:r>
-                        <a:rPr lang="en-US" sz="1300" b="1" dirty="0">
+                        <a:rPr lang="en-US" sz="1150" b="1" dirty="0">
                           <a:solidFill>
                             <a:srgbClr val="FFFFFF"/>
                           </a:solidFill>
                           <a:latin typeface="Calibri"/>
                         </a:rPr>
-                        <a:t>47,000</a:t>
+                        <a:t>27,360 - 47,950</a:t>
                       </a:r>
                     </a:p>
                   </a:txBody>
-                  <a:tcPr marL="73152" marR="73152" marT="36576" marB="36576" anchor="ctr">
+                  <a:tcPr marL="64008" marR="64008" marT="18288" marB="18288" anchor="ctr">
                     <a:solidFill>
                       <a:srgbClr val="14532D"/>
                     </a:solidFill>
@@ -2972,14 +4635,45 @@
       </p:graphicFrame>
       <p:sp>
         <p:nvSpPr>
-          <p:cNvPr id="41" name="note"/>
+          <p:cNvPr id="80" name="tier"/>
+          <p:cNvSpPr/>
+          <p:nvPr/>
+        </p:nvSpPr>
+        <p:spPr>
+          <a:xfrm>
+            <a:off x="6537960" y="1371600"/>
+            <a:ext cx="4160520" cy="3246120"/>
+          </a:xfrm>
+          <a:prstGeom prst="roundRect">
+            <a:avLst>
+              <a:gd name="adj" fmla="val 8000"/>
+            </a:avLst>
+          </a:prstGeom>
+          <a:solidFill>
+            <a:srgbClr val="E7F1E4"/>
+          </a:solidFill>
+          <a:ln w="14000">
+            <a:solidFill>
+              <a:srgbClr val="2E7D32"/>
+            </a:solidFill>
+          </a:ln>
+        </p:spPr>
+        <p:txBody>
+          <a:bodyPr/>
+          <a:lstStyle/>
+          <a:p/>
+        </p:txBody>
+      </p:sp>
+      <p:sp>
+        <p:nvSpPr>
+          <p:cNvPr id="81" name="tiertx"/>
           <p:cNvSpPr txBox="1"/>
           <p:nvPr/>
         </p:nvSpPr>
         <p:spPr>
           <a:xfrm>
-            <a:off x="548640" y="5897880"/>
-            <a:ext cx="9966960" cy="365760"/>
+            <a:off x="6766560" y="1554480"/>
+            <a:ext cx="3749040" cy="2926080"/>
           </a:xfrm>
           <a:prstGeom prst="rect">
             <a:avLst/>
@@ -2997,18 +4691,201 @@
                 <a:spcPts val="0"/>
               </a:spcBef>
               <a:spcAft>
-                <a:spcPts val="600"/>
-              </a:spcAft>
-              <a:buNone/>
-            </a:pPr>
-            <a:r>
-              <a:rPr lang="en-US" sz="1100" i="1" dirty="0">
+                <a:spcPts val="200"/>
+              </a:spcAft>
+              <a:buNone/>
+            </a:pPr>
+            <a:r>
+              <a:rPr lang="en-US" sz="1500" b="1" dirty="0">
+                <a:solidFill>
+                  <a:srgbClr val="2E7D32"/>
+                </a:solidFill>
+                <a:latin typeface="Calibri"/>
+              </a:rPr>
+              <a:t>Build tiers</a:t>
+            </a:r>
+          </a:p>
+          <a:p>
+            <a:pPr marL="0" indent="0" algn="l">
+              <a:spcBef>
+                <a:spcPts val="0"/>
+              </a:spcBef>
+              <a:spcAft>
+                <a:spcPts val="80"/>
+              </a:spcAft>
+              <a:buNone/>
+            </a:pPr>
+            <a:r>
+              <a:rPr lang="en-US" sz="1150" b="1" dirty="0">
+                <a:solidFill>
+                  <a:srgbClr val="1A2421"/>
+                </a:solidFill>
+                <a:latin typeface="Calibri"/>
+              </a:rPr>
+              <a:t>Core only (demo): Rs 8,000 - 14,000</a:t>
+            </a:r>
+          </a:p>
+          <a:p>
+            <a:pPr marL="0" indent="0" algn="l">
+              <a:spcBef>
+                <a:spcPts val="0"/>
+              </a:spcBef>
+              <a:spcAft>
+                <a:spcPts val="260"/>
+              </a:spcAft>
+              <a:buNone/>
+            </a:pPr>
+            <a:r>
+              <a:rPr lang="en-US" sz="1000" dirty="0">
                 <a:solidFill>
                   <a:srgbClr val="5B6B63"/>
                 </a:solidFill>
                 <a:latin typeface="Calibri"/>
               </a:rPr>
-              <a:t>Indicative component budget - total capped at Rs 47,000.</a:t>
+              <a:t>ESP32 + moisture + NPK + relay dosing + power/drive.</a:t>
+            </a:r>
+          </a:p>
+          <a:p>
+            <a:pPr marL="0" indent="0" algn="l">
+              <a:spcBef>
+                <a:spcPts val="0"/>
+              </a:spcBef>
+              <a:spcAft>
+                <a:spcPts val="80"/>
+              </a:spcAft>
+              <a:buNone/>
+            </a:pPr>
+            <a:r>
+              <a:rPr lang="en-US" sz="1150" b="1" dirty="0">
+                <a:solidFill>
+                  <a:srgbClr val="1A2421"/>
+                </a:solidFill>
+                <a:latin typeface="Calibri"/>
+              </a:rPr>
+              <a:t>Core + Navigation: Rs 12,000 - 20,000</a:t>
+            </a:r>
+          </a:p>
+          <a:p>
+            <a:pPr marL="0" indent="0" algn="l">
+              <a:spcBef>
+                <a:spcPts val="0"/>
+              </a:spcBef>
+              <a:spcAft>
+                <a:spcPts val="260"/>
+              </a:spcAft>
+              <a:buNone/>
+            </a:pPr>
+            <a:r>
+              <a:rPr lang="en-US" sz="1000" dirty="0">
+                <a:solidFill>
+                  <a:srgbClr val="5B6B63"/>
+                </a:solidFill>
+                <a:latin typeface="Calibri"/>
+              </a:rPr>
+              <a:t>Adds GPS, encoders, INA219, OLED, safety.</a:t>
+            </a:r>
+          </a:p>
+          <a:p>
+            <a:pPr marL="0" indent="0" algn="l">
+              <a:spcBef>
+                <a:spcPts val="0"/>
+              </a:spcBef>
+              <a:spcAft>
+                <a:spcPts val="80"/>
+              </a:spcAft>
+              <a:buNone/>
+            </a:pPr>
+            <a:r>
+              <a:rPr lang="en-US" sz="1150" b="1" dirty="0">
+                <a:solidFill>
+                  <a:srgbClr val="14532D"/>
+                </a:solidFill>
+                <a:latin typeface="Calibri"/>
+              </a:rPr>
+              <a:t>Full AI build: Rs 27,000 - 48,000</a:t>
+            </a:r>
+          </a:p>
+          <a:p>
+            <a:pPr marL="0" indent="0" algn="l">
+              <a:spcBef>
+                <a:spcPts val="0"/>
+              </a:spcBef>
+              <a:spcAft>
+                <a:spcPts val="0"/>
+              </a:spcAft>
+              <a:buNone/>
+            </a:pPr>
+            <a:r>
+              <a:rPr lang="en-US" sz="1000" dirty="0">
+                <a:solidFill>
+                  <a:srgbClr val="5B6B63"/>
+                </a:solidFill>
+                <a:latin typeface="Calibri"/>
+              </a:rPr>
+              <a:t>Everything in this sheet (within the Rs 47K cap).</a:t>
+            </a:r>
+          </a:p>
+        </p:txBody>
+      </p:sp>
+      <p:sp>
+        <p:nvSpPr>
+          <p:cNvPr id="82" name="bn"/>
+          <p:cNvSpPr txBox="1"/>
+          <p:nvPr/>
+        </p:nvSpPr>
+        <p:spPr>
+          <a:xfrm>
+            <a:off x="6537960" y="4800600"/>
+            <a:ext cx="4160520" cy="1371600"/>
+          </a:xfrm>
+          <a:prstGeom prst="rect">
+            <a:avLst/>
+          </a:prstGeom>
+          <a:noFill/>
+        </p:spPr>
+        <p:txBody>
+          <a:bodyPr wrap="square" anchor="t" rtlCol="0">
+            <a:normAutofit/>
+          </a:bodyPr>
+          <a:lstStyle/>
+          <a:p>
+            <a:pPr marL="0" indent="0" algn="l">
+              <a:spcBef>
+                <a:spcPts val="0"/>
+              </a:spcBef>
+              <a:spcAft>
+                <a:spcPts val="120"/>
+              </a:spcAft>
+              <a:buNone/>
+            </a:pPr>
+            <a:r>
+              <a:rPr lang="en-US" sz="1000" i="1" dirty="0">
+                <a:solidFill>
+                  <a:srgbClr val="5B6B63"/>
+                </a:solidFill>
+                <a:latin typeface="Calibri"/>
+              </a:rPr>
+              <a:t>Indicative India prices - verify before ordering.</a:t>
+            </a:r>
+          </a:p>
+          <a:p>
+            <a:pPr marL="0" indent="0" algn="l">
+              <a:spcBef>
+                <a:spcPts val="0"/>
+              </a:spcBef>
+              <a:spcAft>
+                <a:spcPts val="0"/>
+              </a:spcAft>
+              <a:buNone/>
+            </a:pPr>
+            <a:r>
+              <a:rPr lang="en-US" sz="1000" i="1" dirty="0">
+                <a:solidFill>
+                  <a:srgbClr val="5B6B63"/>
+                </a:solidFill>
+                <a:latin typeface="Calibri"/>
+              </a:rPr>
+              <a:t>Software is free. 'Printed' parts are PETG, not bought.</a:t>
             </a:r>
           </a:p>
         </p:txBody>
@@ -3087,23 +4964,20 @@
         </a:solidFill>
       </a:fillStyleLst>
       <a:lnStyleLst>
-        <a:ln w="6350" cap="flat" cmpd="sng" algn="ctr">
+        <a:ln w="6350">
           <a:solidFill>
             <a:schemeClr val="phClr"/>
           </a:solidFill>
-          <a:prstDash val="solid"/>
         </a:ln>
-        <a:ln w="12700" cap="flat" cmpd="sng" algn="ctr">
+        <a:ln w="12700">
           <a:solidFill>
             <a:schemeClr val="phClr"/>
           </a:solidFill>
-          <a:prstDash val="solid"/>
         </a:ln>
-        <a:ln w="19050" cap="flat" cmpd="sng" algn="ctr">
+        <a:ln w="19050">
           <a:solidFill>
             <a:schemeClr val="phClr"/>
           </a:solidFill>
-          <a:prstDash val="solid"/>
         </a:ln>
       </a:lnStyleLst>
       <a:effectStyleLst>

</xml_diff>

<commit_message>
Add real team (Hitanshu, Vivek, Shreyash, Pritish - IIT Bombay); names + dept only
</commit_message>
<xml_diff>
--- a/AgriRover_Pitch.pptx
+++ b/AgriRover_Pitch.pptx
@@ -324,7 +324,7 @@
                 </a:solidFill>
                 <a:latin typeface="Calibri"/>
               </a:rPr>
-              <a:t>IITB-Groww INV.ENT  -  Track A      |      A 4-member student team      |      Team: [Your names]</a:t>
+              <a:t>IITB-Groww INV.ENT  -  Track A    |    Team (IIT Bombay): Hitanshu Kapadiya, Vivek Gupta, Shreyash Wagh, Pritish Nandy</a:t>
             </a:r>
           </a:p>
         </p:txBody>
@@ -3202,7 +3202,7 @@
                 </a:solidFill>
                 <a:latin typeface="Calibri"/>
               </a:rPr>
-              <a:t>[Name 1] - Embedded &amp; Firmware</a:t>
+              <a:t>Hitanshu Kapadiya</a:t>
             </a:r>
           </a:p>
           <a:p>
@@ -3222,7 +3222,7 @@
                 </a:solidFill>
                 <a:latin typeface="Calibri"/>
               </a:rPr>
-              <a:t>ESP32/FreeRTOS, drive, sensing, dosing</a:t>
+              <a:t>Mechanical Engineering, IIT Bombay</a:t>
             </a:r>
           </a:p>
         </p:txBody>
@@ -3323,7 +3323,7 @@
                 </a:solidFill>
                 <a:latin typeface="Calibri"/>
               </a:rPr>
-              <a:t>[Name 2] - AI &amp; Vision</a:t>
+              <a:t>Vivek Gupta</a:t>
             </a:r>
           </a:p>
           <a:p>
@@ -3343,7 +3343,7 @@
                 </a:solidFill>
                 <a:latin typeface="Calibri"/>
               </a:rPr>
-              <a:t>YOLOv8n, Coral TPU, disease/weed/obstacle</a:t>
+              <a:t>Mechanical Engineering, IIT Bombay</a:t>
             </a:r>
           </a:p>
         </p:txBody>
@@ -3444,7 +3444,7 @@
                 </a:solidFill>
                 <a:latin typeface="Calibri"/>
               </a:rPr>
-              <a:t>[Name 3] - Navigation &amp; Systems</a:t>
+              <a:t>Shreyash Wagh</a:t>
             </a:r>
           </a:p>
           <a:p>
@@ -3464,7 +3464,7 @@
                 </a:solidFill>
                 <a:latin typeface="Calibri"/>
               </a:rPr>
-              <a:t>EKF, GPS, ROS2, simulation</a:t>
+              <a:t>Mechanical Engineering, IIT Bombay</a:t>
             </a:r>
           </a:p>
         </p:txBody>
@@ -3565,7 +3565,7 @@
                 </a:solidFill>
                 <a:latin typeface="Calibri"/>
               </a:rPr>
-              <a:t>[Name 4] - Hardware &amp; Integration</a:t>
+              <a:t>Pritish Nandy</a:t>
             </a:r>
           </a:p>
           <a:p>
@@ -3585,7 +3585,7 @@
                 </a:solidFill>
                 <a:latin typeface="Calibri"/>
               </a:rPr>
-              <a:t>Circuit design, 110-part BOM, dashboard</a:t>
+              <a:t>Aerospace Engineering, IIT Bombay</a:t>
             </a:r>
           </a:p>
         </p:txBody>
@@ -3649,7 +3649,7 @@
                 </a:solidFill>
                 <a:latin typeface="Calibri"/>
               </a:rPr>
-              <a:t>4-member team that has already built the full software stack + a fully costed hardware design - end to end.</a:t>
+              <a:t>An IIT Bombay team of 4 that built the full software stack, circuit design and complete mechanical fabrication - end to end.</a:t>
             </a:r>
           </a:p>
           <a:p>

</xml_diff>

<commit_message>
Add 'Why AgriRover? (vs alternatives)' competitive matrix slide
</commit_message>
<xml_diff>
--- a/AgriRover_Pitch.pptx
+++ b/AgriRover_Pitch.pptx
@@ -13,6 +13,7 @@
     <p:sldId id="261" r:id="rId7"/>
     <p:sldId id="262" r:id="rId8"/>
     <p:sldId id="263" r:id="rId9"/>
+    <p:sldId id="264" r:id="rId10"/>
   </p:sldIdLst>
   <p:sldSz cx="12192000" cy="6858000"/>
   <p:notesSz cx="6858000" cy="9144000"/>
@@ -166,7 +167,7 @@
         <p:spPr>
           <a:xfrm>
             <a:off x="731520" y="1554480"/>
-            <a:ext cx="9692640" cy="1280160"/>
+            <a:ext cx="10607040" cy="1280160"/>
           </a:xfrm>
           <a:prstGeom prst="rect">
             <a:avLst/>
@@ -209,7 +210,7 @@
         <p:spPr>
           <a:xfrm>
             <a:off x="777240" y="2788920"/>
-            <a:ext cx="9692640" cy="914400"/>
+            <a:ext cx="10607040" cy="914400"/>
           </a:xfrm>
           <a:prstGeom prst="rect">
             <a:avLst/>
@@ -252,7 +253,7 @@
         <p:spPr>
           <a:xfrm>
             <a:off x="777240" y="4434840"/>
-            <a:ext cx="9692640" cy="1097280"/>
+            <a:ext cx="10607040" cy="1097280"/>
           </a:xfrm>
           <a:prstGeom prst="rect">
             <a:avLst/>
@@ -294,8 +295,8 @@
         </p:nvSpPr>
         <p:spPr>
           <a:xfrm>
-            <a:off x="777240" y="5623560"/>
-            <a:ext cx="9692640" cy="548640"/>
+            <a:off x="777240" y="5577840"/>
+            <a:ext cx="10607040" cy="640080"/>
           </a:xfrm>
           <a:prstGeom prst="rect">
             <a:avLst/>
@@ -318,7 +319,7 @@
               <a:buNone/>
             </a:pPr>
             <a:r>
-              <a:rPr lang="en-US" sz="1300" b="1" dirty="0">
+              <a:rPr lang="en-US" sz="1250" b="1" dirty="0">
                 <a:solidFill>
                   <a:srgbClr val="66BB6A"/>
                 </a:solidFill>
@@ -425,7 +426,7 @@
         <p:spPr>
           <a:xfrm>
             <a:off x="548640" y="146304"/>
-            <a:ext cx="10058400" cy="777240"/>
+            <a:ext cx="10972800" cy="777240"/>
           </a:xfrm>
           <a:prstGeom prst="rect">
             <a:avLst/>
@@ -468,7 +469,7 @@
         <p:spPr>
           <a:xfrm>
             <a:off x="548640" y="6355080"/>
-            <a:ext cx="10058400" cy="365760"/>
+            <a:ext cx="10972800" cy="365760"/>
           </a:xfrm>
           <a:prstGeom prst="rect">
             <a:avLst/>
@@ -497,7 +498,7 @@
                 </a:solidFill>
                 <a:latin typeface="Calibri"/>
               </a:rPr>
-              <a:t>AgriRover  -  IITB-Groww INV.ENT  -  Track A  -  Team of 4</a:t>
+              <a:t>AgriRover  -  IITB-Groww INV.ENT  -  Track A  -  Team of 4 (IIT Bombay)</a:t>
             </a:r>
           </a:p>
         </p:txBody>
@@ -511,7 +512,7 @@
         <p:spPr>
           <a:xfrm>
             <a:off x="548640" y="1325880"/>
-            <a:ext cx="10149840" cy="4754880"/>
+            <a:ext cx="10698480" cy="4754880"/>
           </a:xfrm>
           <a:prstGeom prst="rect">
             <a:avLst/>
@@ -766,7 +767,7 @@
         <p:spPr>
           <a:xfrm>
             <a:off x="548640" y="146304"/>
-            <a:ext cx="10058400" cy="777240"/>
+            <a:ext cx="10972800" cy="777240"/>
           </a:xfrm>
           <a:prstGeom prst="rect">
             <a:avLst/>
@@ -809,7 +810,7 @@
         <p:spPr>
           <a:xfrm>
             <a:off x="548640" y="6355080"/>
-            <a:ext cx="10058400" cy="365760"/>
+            <a:ext cx="10972800" cy="365760"/>
           </a:xfrm>
           <a:prstGeom prst="rect">
             <a:avLst/>
@@ -838,7 +839,7 @@
                 </a:solidFill>
                 <a:latin typeface="Calibri"/>
               </a:rPr>
-              <a:t>AgriRover  -  IITB-Groww INV.ENT  -  Track A  -  Team of 4</a:t>
+              <a:t>AgriRover  -  IITB-Groww INV.ENT  -  Track A  -  Team of 4 (IIT Bombay)</a:t>
             </a:r>
           </a:p>
         </p:txBody>
@@ -852,7 +853,7 @@
         <p:spPr>
           <a:xfrm>
             <a:off x="548640" y="1325880"/>
-            <a:ext cx="10149840" cy="4754880"/>
+            <a:ext cx="10698480" cy="4754880"/>
           </a:xfrm>
           <a:prstGeom prst="rect">
             <a:avLst/>
@@ -1128,7 +1129,7 @@
         <p:spPr>
           <a:xfrm>
             <a:off x="548640" y="146304"/>
-            <a:ext cx="10058400" cy="777240"/>
+            <a:ext cx="10972800" cy="777240"/>
           </a:xfrm>
           <a:prstGeom prst="rect">
             <a:avLst/>
@@ -1157,7 +1158,7 @@
                 </a:solidFill>
                 <a:latin typeface="Calibri"/>
               </a:rPr>
-              <a:t>What We've Built  (POC/MVP)</a:t>
+              <a:t>Why AgriRover?  (vs alternatives)</a:t>
             </a:r>
           </a:p>
         </p:txBody>
@@ -1171,7 +1172,7 @@
         <p:spPr>
           <a:xfrm>
             <a:off x="548640" y="6355080"/>
-            <a:ext cx="10058400" cy="365760"/>
+            <a:ext cx="10972800" cy="365760"/>
           </a:xfrm>
           <a:prstGeom prst="rect">
             <a:avLst/>
@@ -1200,79 +1201,867 @@
                 </a:solidFill>
                 <a:latin typeface="Calibri"/>
               </a:rPr>
-              <a:t>AgriRover  -  IITB-Groww INV.ENT  -  Track A  -  Team of 4</a:t>
-            </a:r>
-          </a:p>
-        </p:txBody>
-      </p:sp>
-      <p:sp>
-        <p:nvSpPr>
-          <p:cNvPr id="40" name="card"/>
-          <p:cNvSpPr/>
-          <p:nvPr/>
-        </p:nvSpPr>
-        <p:spPr>
-          <a:xfrm>
-            <a:off x="502920" y="1371600"/>
-            <a:ext cx="3310128" cy="2240280"/>
-          </a:xfrm>
-          <a:prstGeom prst="roundRect">
-            <a:avLst>
-              <a:gd name="adj" fmla="val 8000"/>
-            </a:avLst>
-          </a:prstGeom>
-          <a:solidFill>
-            <a:srgbClr val="F3F8F1"/>
-          </a:solidFill>
-          <a:ln w="15875">
-            <a:solidFill>
-              <a:srgbClr val="2E7D32"/>
-            </a:solidFill>
-          </a:ln>
-        </p:spPr>
-        <p:txBody>
-          <a:bodyPr/>
-          <a:lstStyle/>
-          <a:p/>
-        </p:txBody>
-      </p:sp>
-      <p:sp>
-        <p:nvSpPr>
-          <p:cNvPr id="41" name="tab"/>
-          <p:cNvSpPr/>
-          <p:nvPr/>
-        </p:nvSpPr>
-        <p:spPr>
-          <a:xfrm>
-            <a:off x="502920" y="1371600"/>
-            <a:ext cx="109728" cy="2240280"/>
-          </a:xfrm>
-          <a:prstGeom prst="rect">
-            <a:avLst/>
-          </a:prstGeom>
-          <a:solidFill>
-            <a:srgbClr val="2E7D32"/>
-          </a:solidFill>
-          <a:ln>
-            <a:noFill/>
-          </a:ln>
-        </p:spPr>
-        <p:txBody>
-          <a:bodyPr/>
-          <a:lstStyle/>
-          <a:p/>
-        </p:txBody>
-      </p:sp>
-      <p:sp>
-        <p:nvSpPr>
-          <p:cNvPr id="42" name="ct"/>
+              <a:t>AgriRover  -  IITB-Groww INV.ENT  -  Track A  -  Team of 4 (IIT Bombay)</a:t>
+            </a:r>
+          </a:p>
+        </p:txBody>
+      </p:sp>
+      <p:graphicFrame>
+        <p:nvGraphicFramePr>
+          <p:cNvPr id="40" name="tbl"/>
+          <p:cNvGraphicFramePr/>
+          <p:nvPr/>
+        </p:nvGraphicFramePr>
+        <p:xfrm>
+          <a:off x="457200" y="1371600"/>
+          <a:ext cx="11155680" cy="3968496"/>
+        </p:xfrm>
+        <a:graphic>
+          <a:graphicData uri="http://schemas.openxmlformats.org/drawingml/2006/table">
+            <a:tbl>
+              <a:tblPr firstRow="1">
+                <a:tableStyleId>{5C22544A-7EE6-4342-B048-85BDC9FD1C3A}</a:tableStyleId>
+              </a:tblPr>
+              <a:tblGrid>
+                <a:gridCol w="3200400"/>
+                <a:gridCol w="2103120"/>
+                <a:gridCol w="2057400"/>
+                <a:gridCol w="1828800"/>
+                <a:gridCol w="1965960"/>
+              </a:tblGrid>
+              <a:tr h="566928">
+                <a:tc>
+                  <a:txBody>
+                    <a:bodyPr/>
+                    <a:lstStyle/>
+                    <a:p>
+                      <a:pPr algn="l"/>
+                      <a:r>
+                        <a:rPr lang="en-US" sz="1100" b="1" dirty="0">
+                          <a:solidFill>
+                            <a:srgbClr val="FFFFFF"/>
+                          </a:solidFill>
+                          <a:latin typeface="Calibri"/>
+                        </a:rPr>
+                        <a:t>Capability</a:t>
+                      </a:r>
+                    </a:p>
+                  </a:txBody>
+                  <a:tcPr marL="64008" marR="64008" marT="18288" marB="18288" anchor="ctr">
+                    <a:solidFill>
+                      <a:srgbClr val="37474F"/>
+                    </a:solidFill>
+                  </a:tcPr>
+                </a:tc>
+                <a:tc>
+                  <a:txBody>
+                    <a:bodyPr/>
+                    <a:lstStyle/>
+                    <a:p>
+                      <a:pPr algn="ctr"/>
+                      <a:r>
+                        <a:rPr lang="en-US" sz="1150" b="1" dirty="0">
+                          <a:solidFill>
+                            <a:srgbClr val="FFFFFF"/>
+                          </a:solidFill>
+                          <a:latin typeface="Calibri"/>
+                        </a:rPr>
+                        <a:t>AgriRover</a:t>
+                      </a:r>
+                    </a:p>
+                  </a:txBody>
+                  <a:tcPr marL="64008" marR="64008" marT="18288" marB="18288" anchor="ctr">
+                    <a:solidFill>
+                      <a:srgbClr val="14532D"/>
+                    </a:solidFill>
+                  </a:tcPr>
+                </a:tc>
+                <a:tc>
+                  <a:txBody>
+                    <a:bodyPr/>
+                    <a:lstStyle/>
+                    <a:p>
+                      <a:pPr algn="ctr"/>
+                      <a:r>
+                        <a:rPr lang="en-US" sz="1000" b="1" dirty="0">
+                          <a:solidFill>
+                            <a:srgbClr val="FFFFFF"/>
+                          </a:solidFill>
+                          <a:latin typeface="Calibri"/>
+                        </a:rPr>
+                        <a:t>Big precision-ag (tractors)</a:t>
+                      </a:r>
+                    </a:p>
+                  </a:txBody>
+                  <a:tcPr marL="64008" marR="64008" marT="18288" marB="18288" anchor="ctr">
+                    <a:solidFill>
+                      <a:srgbClr val="37474F"/>
+                    </a:solidFill>
+                  </a:tcPr>
+                </a:tc>
+                <a:tc>
+                  <a:txBody>
+                    <a:bodyPr/>
+                    <a:lstStyle/>
+                    <a:p>
+                      <a:pPr algn="ctr"/>
+                      <a:r>
+                        <a:rPr lang="en-US" sz="1000" b="1" dirty="0">
+                          <a:solidFill>
+                            <a:srgbClr val="FFFFFF"/>
+                          </a:solidFill>
+                          <a:latin typeface="Calibri"/>
+                        </a:rPr>
+                        <a:t>Agri spray drones</a:t>
+                      </a:r>
+                    </a:p>
+                  </a:txBody>
+                  <a:tcPr marL="64008" marR="64008" marT="18288" marB="18288" anchor="ctr">
+                    <a:solidFill>
+                      <a:srgbClr val="37474F"/>
+                    </a:solidFill>
+                  </a:tcPr>
+                </a:tc>
+                <a:tc>
+                  <a:txBody>
+                    <a:bodyPr/>
+                    <a:lstStyle/>
+                    <a:p>
+                      <a:pPr algn="ctr"/>
+                      <a:r>
+                        <a:rPr lang="en-US" sz="1000" b="1" dirty="0">
+                          <a:solidFill>
+                            <a:srgbClr val="FFFFFF"/>
+                          </a:solidFill>
+                          <a:latin typeface="Calibri"/>
+                        </a:rPr>
+                        <a:t>Manual + dealer / lab</a:t>
+                      </a:r>
+                    </a:p>
+                  </a:txBody>
+                  <a:tcPr marL="64008" marR="64008" marT="18288" marB="18288" anchor="ctr">
+                    <a:solidFill>
+                      <a:srgbClr val="37474F"/>
+                    </a:solidFill>
+                  </a:tcPr>
+                </a:tc>
+              </a:tr>
+              <a:tr h="566928">
+                <a:tc>
+                  <a:txBody>
+                    <a:bodyPr/>
+                    <a:lstStyle/>
+                    <a:p>
+                      <a:pPr algn="l"/>
+                      <a:r>
+                        <a:rPr lang="en-US" sz="1100" b="1" dirty="0">
+                          <a:solidFill>
+                            <a:srgbClr val="1A2421"/>
+                          </a:solidFill>
+                          <a:latin typeface="Calibri"/>
+                        </a:rPr>
+                        <a:t>Affordable for small (&lt;2 ha) farms</a:t>
+                      </a:r>
+                    </a:p>
+                  </a:txBody>
+                  <a:tcPr marL="64008" marR="64008" marT="18288" marB="18288" anchor="ctr">
+                    <a:solidFill>
+                      <a:srgbClr val="E7F1E4"/>
+                    </a:solidFill>
+                  </a:tcPr>
+                </a:tc>
+                <a:tc>
+                  <a:txBody>
+                    <a:bodyPr/>
+                    <a:lstStyle/>
+                    <a:p>
+                      <a:pPr algn="ctr"/>
+                      <a:r>
+                        <a:rPr lang="en-US" sz="1050" b="1" dirty="0">
+                          <a:solidFill>
+                            <a:srgbClr val="2E7D32"/>
+                          </a:solidFill>
+                          <a:latin typeface="Calibri"/>
+                        </a:rPr>
+                        <a:t>Yes</a:t>
+                      </a:r>
+                    </a:p>
+                  </a:txBody>
+                  <a:tcPr marL="64008" marR="64008" marT="18288" marB="18288" anchor="ctr">
+                    <a:solidFill>
+                      <a:srgbClr val="DDEFD3"/>
+                    </a:solidFill>
+                  </a:tcPr>
+                </a:tc>
+                <a:tc>
+                  <a:txBody>
+                    <a:bodyPr/>
+                    <a:lstStyle/>
+                    <a:p>
+                      <a:pPr algn="ctr"/>
+                      <a:r>
+                        <a:rPr lang="en-US" sz="1050" b="1" dirty="0">
+                          <a:solidFill>
+                            <a:srgbClr val="C62828"/>
+                          </a:solidFill>
+                          <a:latin typeface="Calibri"/>
+                        </a:rPr>
+                        <a:t>No</a:t>
+                      </a:r>
+                    </a:p>
+                  </a:txBody>
+                  <a:tcPr marL="64008" marR="64008" marT="18288" marB="18288" anchor="ctr">
+                    <a:solidFill>
+                      <a:srgbClr val="FFFFFF"/>
+                    </a:solidFill>
+                  </a:tcPr>
+                </a:tc>
+                <a:tc>
+                  <a:txBody>
+                    <a:bodyPr/>
+                    <a:lstStyle/>
+                    <a:p>
+                      <a:pPr algn="ctr"/>
+                      <a:r>
+                        <a:rPr lang="en-US" sz="1050" b="1" dirty="0">
+                          <a:solidFill>
+                            <a:srgbClr val="B26A00"/>
+                          </a:solidFill>
+                          <a:latin typeface="Calibri"/>
+                        </a:rPr>
+                        <a:t>Partly</a:t>
+                      </a:r>
+                    </a:p>
+                  </a:txBody>
+                  <a:tcPr marL="64008" marR="64008" marT="18288" marB="18288" anchor="ctr">
+                    <a:solidFill>
+                      <a:srgbClr val="FFFFFF"/>
+                    </a:solidFill>
+                  </a:tcPr>
+                </a:tc>
+                <a:tc>
+                  <a:txBody>
+                    <a:bodyPr/>
+                    <a:lstStyle/>
+                    <a:p>
+                      <a:pPr algn="ctr"/>
+                      <a:r>
+                        <a:rPr lang="en-US" sz="1050" b="1" dirty="0">
+                          <a:solidFill>
+                            <a:srgbClr val="2E7D32"/>
+                          </a:solidFill>
+                          <a:latin typeface="Calibri"/>
+                        </a:rPr>
+                        <a:t>Yes*</a:t>
+                      </a:r>
+                    </a:p>
+                  </a:txBody>
+                  <a:tcPr marL="64008" marR="64008" marT="18288" marB="18288" anchor="ctr">
+                    <a:solidFill>
+                      <a:srgbClr val="DDEFD3"/>
+                    </a:solidFill>
+                  </a:tcPr>
+                </a:tc>
+              </a:tr>
+              <a:tr h="566928">
+                <a:tc>
+                  <a:txBody>
+                    <a:bodyPr/>
+                    <a:lstStyle/>
+                    <a:p>
+                      <a:pPr algn="l"/>
+                      <a:r>
+                        <a:rPr lang="en-US" sz="1100" b="1" dirty="0">
+                          <a:solidFill>
+                            <a:srgbClr val="1A2421"/>
+                          </a:solidFill>
+                          <a:latin typeface="Calibri"/>
+                        </a:rPr>
+                        <a:t>Instant on-board soil NPK sensing</a:t>
+                      </a:r>
+                    </a:p>
+                  </a:txBody>
+                  <a:tcPr marL="64008" marR="64008" marT="18288" marB="18288" anchor="ctr">
+                    <a:solidFill>
+                      <a:srgbClr val="E7F1E4"/>
+                    </a:solidFill>
+                  </a:tcPr>
+                </a:tc>
+                <a:tc>
+                  <a:txBody>
+                    <a:bodyPr/>
+                    <a:lstStyle/>
+                    <a:p>
+                      <a:pPr algn="ctr"/>
+                      <a:r>
+                        <a:rPr lang="en-US" sz="1050" b="1" dirty="0">
+                          <a:solidFill>
+                            <a:srgbClr val="2E7D32"/>
+                          </a:solidFill>
+                          <a:latin typeface="Calibri"/>
+                        </a:rPr>
+                        <a:t>Yes</a:t>
+                      </a:r>
+                    </a:p>
+                  </a:txBody>
+                  <a:tcPr marL="64008" marR="64008" marT="18288" marB="18288" anchor="ctr">
+                    <a:solidFill>
+                      <a:srgbClr val="DDEFD3"/>
+                    </a:solidFill>
+                  </a:tcPr>
+                </a:tc>
+                <a:tc>
+                  <a:txBody>
+                    <a:bodyPr/>
+                    <a:lstStyle/>
+                    <a:p>
+                      <a:pPr algn="ctr"/>
+                      <a:r>
+                        <a:rPr lang="en-US" sz="1050" b="1" dirty="0">
+                          <a:solidFill>
+                            <a:srgbClr val="C62828"/>
+                          </a:solidFill>
+                          <a:latin typeface="Calibri"/>
+                        </a:rPr>
+                        <a:t>No</a:t>
+                      </a:r>
+                    </a:p>
+                  </a:txBody>
+                  <a:tcPr marL="64008" marR="64008" marT="18288" marB="18288" anchor="ctr">
+                    <a:solidFill>
+                      <a:srgbClr val="FFFFFF"/>
+                    </a:solidFill>
+                  </a:tcPr>
+                </a:tc>
+                <a:tc>
+                  <a:txBody>
+                    <a:bodyPr/>
+                    <a:lstStyle/>
+                    <a:p>
+                      <a:pPr algn="ctr"/>
+                      <a:r>
+                        <a:rPr lang="en-US" sz="1050" b="1" dirty="0">
+                          <a:solidFill>
+                            <a:srgbClr val="C62828"/>
+                          </a:solidFill>
+                          <a:latin typeface="Calibri"/>
+                        </a:rPr>
+                        <a:t>No</a:t>
+                      </a:r>
+                    </a:p>
+                  </a:txBody>
+                  <a:tcPr marL="64008" marR="64008" marT="18288" marB="18288" anchor="ctr">
+                    <a:solidFill>
+                      <a:srgbClr val="FFFFFF"/>
+                    </a:solidFill>
+                  </a:tcPr>
+                </a:tc>
+                <a:tc>
+                  <a:txBody>
+                    <a:bodyPr/>
+                    <a:lstStyle/>
+                    <a:p>
+                      <a:pPr algn="ctr"/>
+                      <a:r>
+                        <a:rPr lang="en-US" sz="1050" b="1" dirty="0">
+                          <a:solidFill>
+                            <a:srgbClr val="B26A00"/>
+                          </a:solidFill>
+                          <a:latin typeface="Calibri"/>
+                        </a:rPr>
+                        <a:t>Lab, 2-3 wks</a:t>
+                      </a:r>
+                    </a:p>
+                  </a:txBody>
+                  <a:tcPr marL="64008" marR="64008" marT="18288" marB="18288" anchor="ctr">
+                    <a:solidFill>
+                      <a:srgbClr val="FFFFFF"/>
+                    </a:solidFill>
+                  </a:tcPr>
+                </a:tc>
+              </a:tr>
+              <a:tr h="566928">
+                <a:tc>
+                  <a:txBody>
+                    <a:bodyPr/>
+                    <a:lstStyle/>
+                    <a:p>
+                      <a:pPr algn="l"/>
+                      <a:r>
+                        <a:rPr lang="en-US" sz="1100" b="1" dirty="0">
+                          <a:solidFill>
+                            <a:srgbClr val="1A2421"/>
+                          </a:solidFill>
+                          <a:latin typeface="Calibri"/>
+                        </a:rPr>
+                        <a:t>Per-plant targeted micro-dosing</a:t>
+                      </a:r>
+                    </a:p>
+                  </a:txBody>
+                  <a:tcPr marL="64008" marR="64008" marT="18288" marB="18288" anchor="ctr">
+                    <a:solidFill>
+                      <a:srgbClr val="E7F1E4"/>
+                    </a:solidFill>
+                  </a:tcPr>
+                </a:tc>
+                <a:tc>
+                  <a:txBody>
+                    <a:bodyPr/>
+                    <a:lstStyle/>
+                    <a:p>
+                      <a:pPr algn="ctr"/>
+                      <a:r>
+                        <a:rPr lang="en-US" sz="1050" b="1" dirty="0">
+                          <a:solidFill>
+                            <a:srgbClr val="2E7D32"/>
+                          </a:solidFill>
+                          <a:latin typeface="Calibri"/>
+                        </a:rPr>
+                        <a:t>Yes</a:t>
+                      </a:r>
+                    </a:p>
+                  </a:txBody>
+                  <a:tcPr marL="64008" marR="64008" marT="18288" marB="18288" anchor="ctr">
+                    <a:solidFill>
+                      <a:srgbClr val="DDEFD3"/>
+                    </a:solidFill>
+                  </a:tcPr>
+                </a:tc>
+                <a:tc>
+                  <a:txBody>
+                    <a:bodyPr/>
+                    <a:lstStyle/>
+                    <a:p>
+                      <a:pPr algn="ctr"/>
+                      <a:r>
+                        <a:rPr lang="en-US" sz="1050" b="1" dirty="0">
+                          <a:solidFill>
+                            <a:srgbClr val="C62828"/>
+                          </a:solidFill>
+                          <a:latin typeface="Calibri"/>
+                        </a:rPr>
+                        <a:t>Broadcast</a:t>
+                      </a:r>
+                    </a:p>
+                  </a:txBody>
+                  <a:tcPr marL="64008" marR="64008" marT="18288" marB="18288" anchor="ctr">
+                    <a:solidFill>
+                      <a:srgbClr val="FFFFFF"/>
+                    </a:solidFill>
+                  </a:tcPr>
+                </a:tc>
+                <a:tc>
+                  <a:txBody>
+                    <a:bodyPr/>
+                    <a:lstStyle/>
+                    <a:p>
+                      <a:pPr algn="ctr"/>
+                      <a:r>
+                        <a:rPr lang="en-US" sz="1050" b="1" dirty="0">
+                          <a:solidFill>
+                            <a:srgbClr val="B26A00"/>
+                          </a:solidFill>
+                          <a:latin typeface="Calibri"/>
+                        </a:rPr>
+                        <a:t>Limited</a:t>
+                      </a:r>
+                    </a:p>
+                  </a:txBody>
+                  <a:tcPr marL="64008" marR="64008" marT="18288" marB="18288" anchor="ctr">
+                    <a:solidFill>
+                      <a:srgbClr val="FFFFFF"/>
+                    </a:solidFill>
+                  </a:tcPr>
+                </a:tc>
+                <a:tc>
+                  <a:txBody>
+                    <a:bodyPr/>
+                    <a:lstStyle/>
+                    <a:p>
+                      <a:pPr algn="ctr"/>
+                      <a:r>
+                        <a:rPr lang="en-US" sz="1050" b="1" dirty="0">
+                          <a:solidFill>
+                            <a:srgbClr val="C62828"/>
+                          </a:solidFill>
+                          <a:latin typeface="Calibri"/>
+                        </a:rPr>
+                        <a:t>No</a:t>
+                      </a:r>
+                    </a:p>
+                  </a:txBody>
+                  <a:tcPr marL="64008" marR="64008" marT="18288" marB="18288" anchor="ctr">
+                    <a:solidFill>
+                      <a:srgbClr val="FFFFFF"/>
+                    </a:solidFill>
+                  </a:tcPr>
+                </a:tc>
+              </a:tr>
+              <a:tr h="566928">
+                <a:tc>
+                  <a:txBody>
+                    <a:bodyPr/>
+                    <a:lstStyle/>
+                    <a:p>
+                      <a:pPr algn="l"/>
+                      <a:r>
+                        <a:rPr lang="en-US" sz="1100" b="1" dirty="0">
+                          <a:solidFill>
+                            <a:srgbClr val="1A2421"/>
+                          </a:solidFill>
+                          <a:latin typeface="Calibri"/>
+                        </a:rPr>
+                        <a:t>AI weed &amp; disease detection</a:t>
+                      </a:r>
+                    </a:p>
+                  </a:txBody>
+                  <a:tcPr marL="64008" marR="64008" marT="18288" marB="18288" anchor="ctr">
+                    <a:solidFill>
+                      <a:srgbClr val="E7F1E4"/>
+                    </a:solidFill>
+                  </a:tcPr>
+                </a:tc>
+                <a:tc>
+                  <a:txBody>
+                    <a:bodyPr/>
+                    <a:lstStyle/>
+                    <a:p>
+                      <a:pPr algn="ctr"/>
+                      <a:r>
+                        <a:rPr lang="en-US" sz="1050" b="1" dirty="0">
+                          <a:solidFill>
+                            <a:srgbClr val="2E7D32"/>
+                          </a:solidFill>
+                          <a:latin typeface="Calibri"/>
+                        </a:rPr>
+                        <a:t>Yes</a:t>
+                      </a:r>
+                    </a:p>
+                  </a:txBody>
+                  <a:tcPr marL="64008" marR="64008" marT="18288" marB="18288" anchor="ctr">
+                    <a:solidFill>
+                      <a:srgbClr val="DDEFD3"/>
+                    </a:solidFill>
+                  </a:tcPr>
+                </a:tc>
+                <a:tc>
+                  <a:txBody>
+                    <a:bodyPr/>
+                    <a:lstStyle/>
+                    <a:p>
+                      <a:pPr algn="ctr"/>
+                      <a:r>
+                        <a:rPr lang="en-US" sz="1050" b="1" dirty="0">
+                          <a:solidFill>
+                            <a:srgbClr val="B26A00"/>
+                          </a:solidFill>
+                          <a:latin typeface="Calibri"/>
+                        </a:rPr>
+                        <a:t>Some</a:t>
+                      </a:r>
+                    </a:p>
+                  </a:txBody>
+                  <a:tcPr marL="64008" marR="64008" marT="18288" marB="18288" anchor="ctr">
+                    <a:solidFill>
+                      <a:srgbClr val="FFFFFF"/>
+                    </a:solidFill>
+                  </a:tcPr>
+                </a:tc>
+                <a:tc>
+                  <a:txBody>
+                    <a:bodyPr/>
+                    <a:lstStyle/>
+                    <a:p>
+                      <a:pPr algn="ctr"/>
+                      <a:r>
+                        <a:rPr lang="en-US" sz="1050" b="1" dirty="0">
+                          <a:solidFill>
+                            <a:srgbClr val="B26A00"/>
+                          </a:solidFill>
+                          <a:latin typeface="Calibri"/>
+                        </a:rPr>
+                        <a:t>Some</a:t>
+                      </a:r>
+                    </a:p>
+                  </a:txBody>
+                  <a:tcPr marL="64008" marR="64008" marT="18288" marB="18288" anchor="ctr">
+                    <a:solidFill>
+                      <a:srgbClr val="FFFFFF"/>
+                    </a:solidFill>
+                  </a:tcPr>
+                </a:tc>
+                <a:tc>
+                  <a:txBody>
+                    <a:bodyPr/>
+                    <a:lstStyle/>
+                    <a:p>
+                      <a:pPr algn="ctr"/>
+                      <a:r>
+                        <a:rPr lang="en-US" sz="1050" b="1" dirty="0">
+                          <a:solidFill>
+                            <a:srgbClr val="C62828"/>
+                          </a:solidFill>
+                          <a:latin typeface="Calibri"/>
+                        </a:rPr>
+                        <a:t>No</a:t>
+                      </a:r>
+                    </a:p>
+                  </a:txBody>
+                  <a:tcPr marL="64008" marR="64008" marT="18288" marB="18288" anchor="ctr">
+                    <a:solidFill>
+                      <a:srgbClr val="FFFFFF"/>
+                    </a:solidFill>
+                  </a:tcPr>
+                </a:tc>
+              </a:tr>
+              <a:tr h="566928">
+                <a:tc>
+                  <a:txBody>
+                    <a:bodyPr/>
+                    <a:lstStyle/>
+                    <a:p>
+                      <a:pPr algn="l"/>
+                      <a:r>
+                        <a:rPr lang="en-US" sz="1100" b="1" dirty="0">
+                          <a:solidFill>
+                            <a:srgbClr val="1A2421"/>
+                          </a:solidFill>
+                          <a:latin typeface="Calibri"/>
+                        </a:rPr>
+                        <a:t>Fully autonomous ground robot</a:t>
+                      </a:r>
+                    </a:p>
+                  </a:txBody>
+                  <a:tcPr marL="64008" marR="64008" marT="18288" marB="18288" anchor="ctr">
+                    <a:solidFill>
+                      <a:srgbClr val="E7F1E4"/>
+                    </a:solidFill>
+                  </a:tcPr>
+                </a:tc>
+                <a:tc>
+                  <a:txBody>
+                    <a:bodyPr/>
+                    <a:lstStyle/>
+                    <a:p>
+                      <a:pPr algn="ctr"/>
+                      <a:r>
+                        <a:rPr lang="en-US" sz="1050" b="1" dirty="0">
+                          <a:solidFill>
+                            <a:srgbClr val="2E7D32"/>
+                          </a:solidFill>
+                          <a:latin typeface="Calibri"/>
+                        </a:rPr>
+                        <a:t>Yes</a:t>
+                      </a:r>
+                    </a:p>
+                  </a:txBody>
+                  <a:tcPr marL="64008" marR="64008" marT="18288" marB="18288" anchor="ctr">
+                    <a:solidFill>
+                      <a:srgbClr val="DDEFD3"/>
+                    </a:solidFill>
+                  </a:tcPr>
+                </a:tc>
+                <a:tc>
+                  <a:txBody>
+                    <a:bodyPr/>
+                    <a:lstStyle/>
+                    <a:p>
+                      <a:pPr algn="ctr"/>
+                      <a:r>
+                        <a:rPr lang="en-US" sz="1050" b="1" dirty="0">
+                          <a:solidFill>
+                            <a:srgbClr val="B26A00"/>
+                          </a:solidFill>
+                          <a:latin typeface="Calibri"/>
+                        </a:rPr>
+                        <a:t>Operator</a:t>
+                      </a:r>
+                    </a:p>
+                  </a:txBody>
+                  <a:tcPr marL="64008" marR="64008" marT="18288" marB="18288" anchor="ctr">
+                    <a:solidFill>
+                      <a:srgbClr val="FFFFFF"/>
+                    </a:solidFill>
+                  </a:tcPr>
+                </a:tc>
+                <a:tc>
+                  <a:txBody>
+                    <a:bodyPr/>
+                    <a:lstStyle/>
+                    <a:p>
+                      <a:pPr algn="ctr"/>
+                      <a:r>
+                        <a:rPr lang="en-US" sz="1050" b="1" dirty="0">
+                          <a:solidFill>
+                            <a:srgbClr val="B26A00"/>
+                          </a:solidFill>
+                          <a:latin typeface="Calibri"/>
+                        </a:rPr>
+                        <a:t>Pilot-flown</a:t>
+                      </a:r>
+                    </a:p>
+                  </a:txBody>
+                  <a:tcPr marL="64008" marR="64008" marT="18288" marB="18288" anchor="ctr">
+                    <a:solidFill>
+                      <a:srgbClr val="FFFFFF"/>
+                    </a:solidFill>
+                  </a:tcPr>
+                </a:tc>
+                <a:tc>
+                  <a:txBody>
+                    <a:bodyPr/>
+                    <a:lstStyle/>
+                    <a:p>
+                      <a:pPr algn="ctr"/>
+                      <a:r>
+                        <a:rPr lang="en-US" sz="1050" b="1" dirty="0">
+                          <a:solidFill>
+                            <a:srgbClr val="C62828"/>
+                          </a:solidFill>
+                          <a:latin typeface="Calibri"/>
+                        </a:rPr>
+                        <a:t>Manual</a:t>
+                      </a:r>
+                    </a:p>
+                  </a:txBody>
+                  <a:tcPr marL="64008" marR="64008" marT="18288" marB="18288" anchor="ctr">
+                    <a:solidFill>
+                      <a:srgbClr val="FFFFFF"/>
+                    </a:solidFill>
+                  </a:tcPr>
+                </a:tc>
+              </a:tr>
+              <a:tr h="566928">
+                <a:tc>
+                  <a:txBody>
+                    <a:bodyPr/>
+                    <a:lstStyle/>
+                    <a:p>
+                      <a:pPr algn="l"/>
+                      <a:r>
+                        <a:rPr lang="en-US" sz="1100" b="1" dirty="0">
+                          <a:solidFill>
+                            <a:srgbClr val="1A2421"/>
+                          </a:solidFill>
+                          <a:latin typeface="Calibri"/>
+                        </a:rPr>
+                        <a:t>Indicative cost</a:t>
+                      </a:r>
+                    </a:p>
+                  </a:txBody>
+                  <a:tcPr marL="64008" marR="64008" marT="18288" marB="18288" anchor="ctr">
+                    <a:solidFill>
+                      <a:srgbClr val="E7F1E4"/>
+                    </a:solidFill>
+                  </a:tcPr>
+                </a:tc>
+                <a:tc>
+                  <a:txBody>
+                    <a:bodyPr/>
+                    <a:lstStyle/>
+                    <a:p>
+                      <a:pPr algn="ctr"/>
+                      <a:r>
+                        <a:rPr lang="en-US" sz="1050" b="1" dirty="0">
+                          <a:solidFill>
+                            <a:srgbClr val="2E7D32"/>
+                          </a:solidFill>
+                          <a:latin typeface="Calibri"/>
+                        </a:rPr>
+                        <a:t>Rs 30-48K</a:t>
+                      </a:r>
+                    </a:p>
+                  </a:txBody>
+                  <a:tcPr marL="64008" marR="64008" marT="18288" marB="18288" anchor="ctr">
+                    <a:solidFill>
+                      <a:srgbClr val="DDEFD3"/>
+                    </a:solidFill>
+                  </a:tcPr>
+                </a:tc>
+                <a:tc>
+                  <a:txBody>
+                    <a:bodyPr/>
+                    <a:lstStyle/>
+                    <a:p>
+                      <a:pPr algn="ctr"/>
+                      <a:r>
+                        <a:rPr lang="en-US" sz="1050" b="1" dirty="0">
+                          <a:solidFill>
+                            <a:srgbClr val="C62828"/>
+                          </a:solidFill>
+                          <a:latin typeface="Calibri"/>
+                        </a:rPr>
+                        <a:t>Lakhs+</a:t>
+                      </a:r>
+                    </a:p>
+                  </a:txBody>
+                  <a:tcPr marL="64008" marR="64008" marT="18288" marB="18288" anchor="ctr">
+                    <a:solidFill>
+                      <a:srgbClr val="FFFFFF"/>
+                    </a:solidFill>
+                  </a:tcPr>
+                </a:tc>
+                <a:tc>
+                  <a:txBody>
+                    <a:bodyPr/>
+                    <a:lstStyle/>
+                    <a:p>
+                      <a:pPr algn="ctr"/>
+                      <a:r>
+                        <a:rPr lang="en-US" sz="1050" b="1" dirty="0">
+                          <a:solidFill>
+                            <a:srgbClr val="B26A00"/>
+                          </a:solidFill>
+                          <a:latin typeface="Calibri"/>
+                        </a:rPr>
+                        <a:t>Rs 50K-5L+</a:t>
+                      </a:r>
+                    </a:p>
+                  </a:txBody>
+                  <a:tcPr marL="64008" marR="64008" marT="18288" marB="18288" anchor="ctr">
+                    <a:solidFill>
+                      <a:srgbClr val="FFFFFF"/>
+                    </a:solidFill>
+                  </a:tcPr>
+                </a:tc>
+                <a:tc>
+                  <a:txBody>
+                    <a:bodyPr/>
+                    <a:lstStyle/>
+                    <a:p>
+                      <a:pPr algn="ctr"/>
+                      <a:r>
+                        <a:rPr lang="en-US" sz="1050" b="1" dirty="0">
+                          <a:solidFill>
+                            <a:srgbClr val="B26A00"/>
+                          </a:solidFill>
+                          <a:latin typeface="Calibri"/>
+                        </a:rPr>
+                        <a:t>Recurring labour</a:t>
+                      </a:r>
+                    </a:p>
+                  </a:txBody>
+                  <a:tcPr marL="64008" marR="64008" marT="18288" marB="18288" anchor="ctr">
+                    <a:solidFill>
+                      <a:srgbClr val="FFFFFF"/>
+                    </a:solidFill>
+                  </a:tcPr>
+                </a:tc>
+              </a:tr>
+            </a:tbl>
+          </a:graphicData>
+        </a:graphic>
+      </p:graphicFrame>
+      <p:sp>
+        <p:nvSpPr>
+          <p:cNvPr id="41" name="edge"/>
           <p:cNvSpPr txBox="1"/>
           <p:nvPr/>
         </p:nvSpPr>
         <p:spPr>
           <a:xfrm>
-            <a:off x="758952" y="1517904"/>
-            <a:ext cx="2898648" cy="1965960"/>
+            <a:off x="457200" y="5532120"/>
+            <a:ext cx="11155680" cy="411480"/>
           </a:xfrm>
           <a:prstGeom prst="rect">
             <a:avLst/>
@@ -1285,158 +2074,37 @@
           </a:bodyPr>
           <a:lstStyle/>
           <a:p>
-            <a:pPr marL="0" indent="0" algn="l">
-              <a:spcBef>
-                <a:spcPts val="0"/>
-              </a:spcBef>
-              <a:spcAft>
-                <a:spcPts val="160"/>
+            <a:pPr marL="0" indent="0" algn="ctr">
+              <a:spcBef>
+                <a:spcPts val="0"/>
+              </a:spcBef>
+              <a:spcAft>
+                <a:spcPts val="600"/>
               </a:spcAft>
               <a:buNone/>
             </a:pPr>
             <a:r>
               <a:rPr lang="en-US" sz="1300" b="1" dirty="0">
                 <a:solidFill>
-                  <a:srgbClr val="2E7D32"/>
-                </a:solidFill>
-                <a:latin typeface="Calibri"/>
-              </a:rPr>
-              <a:t>Firmware (ESP32 / FreeRTOS)</a:t>
-            </a:r>
-          </a:p>
-          <a:p>
-            <a:pPr marL="237744" indent="-237744" algn="l">
-              <a:spcBef>
-                <a:spcPts val="0"/>
-              </a:spcBef>
-              <a:spcAft>
-                <a:spcPts val="120"/>
-              </a:spcAft>
-              <a:buFont typeface="Arial"/>
-              <a:buChar char="•"/>
-            </a:pPr>
-            <a:r>
-              <a:rPr lang="en-US" sz="1100" dirty="0">
-                <a:solidFill>
-                  <a:srgbClr val="1A2421"/>
-                </a:solidFill>
-                <a:latin typeface="Calibri"/>
-              </a:rPr>
-              <a:t>Dual-core drive, NPK/RS485 sensing</a:t>
-            </a:r>
-          </a:p>
-          <a:p>
-            <a:pPr marL="237744" indent="-237744" algn="l">
-              <a:spcBef>
-                <a:spcPts val="0"/>
-              </a:spcBef>
-              <a:spcAft>
-                <a:spcPts val="120"/>
-              </a:spcAft>
-              <a:buFont typeface="Arial"/>
-              <a:buChar char="•"/>
-            </a:pPr>
-            <a:r>
-              <a:rPr lang="en-US" sz="1100" dirty="0">
-                <a:solidFill>
-                  <a:srgbClr val="1A2421"/>
-                </a:solidFill>
-                <a:latin typeface="Calibri"/>
-              </a:rPr>
-              <a:t>Dosing state machine</a:t>
-            </a:r>
-          </a:p>
-          <a:p>
-            <a:pPr marL="237744" indent="-237744" algn="l">
-              <a:spcBef>
-                <a:spcPts val="0"/>
-              </a:spcBef>
-              <a:spcAft>
-                <a:spcPts val="120"/>
-              </a:spcAft>
-              <a:buFont typeface="Arial"/>
-              <a:buChar char="•"/>
-            </a:pPr>
-            <a:r>
-              <a:rPr lang="en-US" sz="1100" dirty="0">
-                <a:solidFill>
-                  <a:srgbClr val="1A2421"/>
-                </a:solidFill>
-                <a:latin typeface="Calibri"/>
-              </a:rPr>
-              <a:t>Secure MQTT + UART link</a:t>
-            </a:r>
-          </a:p>
-        </p:txBody>
-      </p:sp>
-      <p:sp>
-        <p:nvSpPr>
-          <p:cNvPr id="43" name="card"/>
-          <p:cNvSpPr/>
-          <p:nvPr/>
-        </p:nvSpPr>
-        <p:spPr>
-          <a:xfrm>
-            <a:off x="3977640" y="1371600"/>
-            <a:ext cx="3310128" cy="2240280"/>
-          </a:xfrm>
-          <a:prstGeom prst="roundRect">
-            <a:avLst>
-              <a:gd name="adj" fmla="val 8000"/>
-            </a:avLst>
-          </a:prstGeom>
-          <a:solidFill>
-            <a:srgbClr val="F3F8F1"/>
-          </a:solidFill>
-          <a:ln w="15875">
-            <a:solidFill>
-              <a:srgbClr val="1565C0"/>
-            </a:solidFill>
-          </a:ln>
-        </p:spPr>
-        <p:txBody>
-          <a:bodyPr/>
-          <a:lstStyle/>
-          <a:p/>
-        </p:txBody>
-      </p:sp>
-      <p:sp>
-        <p:nvSpPr>
-          <p:cNvPr id="44" name="tab"/>
-          <p:cNvSpPr/>
-          <p:nvPr/>
-        </p:nvSpPr>
-        <p:spPr>
-          <a:xfrm>
-            <a:off x="3977640" y="1371600"/>
-            <a:ext cx="109728" cy="2240280"/>
-          </a:xfrm>
-          <a:prstGeom prst="rect">
-            <a:avLst/>
-          </a:prstGeom>
-          <a:solidFill>
-            <a:srgbClr val="1565C0"/>
-          </a:solidFill>
-          <a:ln>
-            <a:noFill/>
-          </a:ln>
-        </p:spPr>
-        <p:txBody>
-          <a:bodyPr/>
-          <a:lstStyle/>
-          <a:p/>
-        </p:txBody>
-      </p:sp>
-      <p:sp>
-        <p:nvSpPr>
-          <p:cNvPr id="45" name="ct"/>
+                  <a:srgbClr val="14532D"/>
+                </a:solidFill>
+                <a:latin typeface="Calibri"/>
+              </a:rPr>
+              <a:t>Our edge: the only affordable, autonomous, per-plant solution purpose-built for India's small farms.</a:t>
+            </a:r>
+          </a:p>
+        </p:txBody>
+      </p:sp>
+      <p:sp>
+        <p:nvSpPr>
+          <p:cNvPr id="42" name="fn"/>
           <p:cNvSpPr txBox="1"/>
           <p:nvPr/>
         </p:nvSpPr>
         <p:spPr>
           <a:xfrm>
-            <a:off x="4233672" y="1517904"/>
-            <a:ext cx="2898648" cy="1965960"/>
+            <a:off x="457200" y="5943600"/>
+            <a:ext cx="11155680" cy="365760"/>
           </a:xfrm>
           <a:prstGeom prst="rect">
             <a:avLst/>
@@ -1454,780 +2122,18 @@
                 <a:spcPts val="0"/>
               </a:spcBef>
               <a:spcAft>
-                <a:spcPts val="160"/>
+                <a:spcPts val="600"/>
               </a:spcAft>
               <a:buNone/>
             </a:pPr>
             <a:r>
-              <a:rPr lang="en-US" sz="1300" b="1" dirty="0">
-                <a:solidFill>
-                  <a:srgbClr val="1565C0"/>
-                </a:solidFill>
-                <a:latin typeface="Calibri"/>
-              </a:rPr>
-              <a:t>AI Vision (Raspberry Pi)</a:t>
-            </a:r>
-          </a:p>
-          <a:p>
-            <a:pPr marL="237744" indent="-237744" algn="l">
-              <a:spcBef>
-                <a:spcPts val="0"/>
-              </a:spcBef>
-              <a:spcAft>
-                <a:spcPts val="120"/>
-              </a:spcAft>
-              <a:buFont typeface="Arial"/>
-              <a:buChar char="•"/>
-            </a:pPr>
-            <a:r>
-              <a:rPr lang="en-US" sz="1100" dirty="0">
-                <a:solidFill>
-                  <a:srgbClr val="1A2421"/>
-                </a:solidFill>
-                <a:latin typeface="Calibri"/>
-              </a:rPr>
-              <a:t>YOLOv8n weed/disease/obstacle</a:t>
-            </a:r>
-          </a:p>
-          <a:p>
-            <a:pPr marL="237744" indent="-237744" algn="l">
-              <a:spcBef>
-                <a:spcPts val="0"/>
-              </a:spcBef>
-              <a:spcAft>
-                <a:spcPts val="120"/>
-              </a:spcAft>
-              <a:buFont typeface="Arial"/>
-              <a:buChar char="•"/>
-            </a:pPr>
-            <a:r>
-              <a:rPr lang="en-US" sz="1100" dirty="0">
-                <a:solidFill>
-                  <a:srgbClr val="1A2421"/>
-                </a:solidFill>
-                <a:latin typeface="Calibri"/>
-              </a:rPr>
-              <a:t>Runs on Coral Edge TPU</a:t>
-            </a:r>
-          </a:p>
-          <a:p>
-            <a:pPr marL="237744" indent="-237744" algn="l">
-              <a:spcBef>
-                <a:spcPts val="0"/>
-              </a:spcBef>
-              <a:spcAft>
-                <a:spcPts val="120"/>
-              </a:spcAft>
-              <a:buFont typeface="Arial"/>
-              <a:buChar char="•"/>
-            </a:pPr>
-            <a:r>
-              <a:rPr lang="en-US" sz="1100" dirty="0">
-                <a:solidFill>
-                  <a:srgbClr val="1A2421"/>
-                </a:solidFill>
-                <a:latin typeface="Calibri"/>
-              </a:rPr>
-              <a:t>Training notebooks included</a:t>
-            </a:r>
-          </a:p>
-        </p:txBody>
-      </p:sp>
-      <p:sp>
-        <p:nvSpPr>
-          <p:cNvPr id="46" name="card"/>
-          <p:cNvSpPr/>
-          <p:nvPr/>
-        </p:nvSpPr>
-        <p:spPr>
-          <a:xfrm>
-            <a:off x="7452360" y="1371600"/>
-            <a:ext cx="3310128" cy="2240280"/>
-          </a:xfrm>
-          <a:prstGeom prst="roundRect">
-            <a:avLst>
-              <a:gd name="adj" fmla="val 8000"/>
-            </a:avLst>
-          </a:prstGeom>
-          <a:solidFill>
-            <a:srgbClr val="F3F8F1"/>
-          </a:solidFill>
-          <a:ln w="15875">
-            <a:solidFill>
-              <a:srgbClr val="6A1B9A"/>
-            </a:solidFill>
-          </a:ln>
-        </p:spPr>
-        <p:txBody>
-          <a:bodyPr/>
-          <a:lstStyle/>
-          <a:p/>
-        </p:txBody>
-      </p:sp>
-      <p:sp>
-        <p:nvSpPr>
-          <p:cNvPr id="47" name="tab"/>
-          <p:cNvSpPr/>
-          <p:nvPr/>
-        </p:nvSpPr>
-        <p:spPr>
-          <a:xfrm>
-            <a:off x="7452360" y="1371600"/>
-            <a:ext cx="109728" cy="2240280"/>
-          </a:xfrm>
-          <a:prstGeom prst="rect">
-            <a:avLst/>
-          </a:prstGeom>
-          <a:solidFill>
-            <a:srgbClr val="6A1B9A"/>
-          </a:solidFill>
-          <a:ln>
-            <a:noFill/>
-          </a:ln>
-        </p:spPr>
-        <p:txBody>
-          <a:bodyPr/>
-          <a:lstStyle/>
-          <a:p/>
-        </p:txBody>
-      </p:sp>
-      <p:sp>
-        <p:nvSpPr>
-          <p:cNvPr id="48" name="ct"/>
-          <p:cNvSpPr txBox="1"/>
-          <p:nvPr/>
-        </p:nvSpPr>
-        <p:spPr>
-          <a:xfrm>
-            <a:off x="7708392" y="1517904"/>
-            <a:ext cx="2898648" cy="1965960"/>
-          </a:xfrm>
-          <a:prstGeom prst="rect">
-            <a:avLst/>
-          </a:prstGeom>
-          <a:noFill/>
-        </p:spPr>
-        <p:txBody>
-          <a:bodyPr wrap="square" anchor="t" rtlCol="0">
-            <a:normAutofit/>
-          </a:bodyPr>
-          <a:lstStyle/>
-          <a:p>
-            <a:pPr marL="0" indent="0" algn="l">
-              <a:spcBef>
-                <a:spcPts val="0"/>
-              </a:spcBef>
-              <a:spcAft>
-                <a:spcPts val="160"/>
-              </a:spcAft>
-              <a:buNone/>
-            </a:pPr>
-            <a:r>
-              <a:rPr lang="en-US" sz="1300" b="1" dirty="0">
-                <a:solidFill>
-                  <a:srgbClr val="6A1B9A"/>
-                </a:solidFill>
-                <a:latin typeface="Calibri"/>
-              </a:rPr>
-              <a:t>Navigation &amp; Systems</a:t>
-            </a:r>
-          </a:p>
-          <a:p>
-            <a:pPr marL="237744" indent="-237744" algn="l">
-              <a:spcBef>
-                <a:spcPts val="0"/>
-              </a:spcBef>
-              <a:spcAft>
-                <a:spcPts val="120"/>
-              </a:spcAft>
-              <a:buFont typeface="Arial"/>
-              <a:buChar char="•"/>
-            </a:pPr>
-            <a:r>
-              <a:rPr lang="en-US" sz="1100" dirty="0">
-                <a:solidFill>
-                  <a:srgbClr val="1A2421"/>
-                </a:solidFill>
-                <a:latin typeface="Calibri"/>
-              </a:rPr>
-              <a:t>EKF + GPS + vision geo-tag</a:t>
-            </a:r>
-          </a:p>
-          <a:p>
-            <a:pPr marL="237744" indent="-237744" algn="l">
-              <a:spcBef>
-                <a:spcPts val="0"/>
-              </a:spcBef>
-              <a:spcAft>
-                <a:spcPts val="120"/>
-              </a:spcAft>
-              <a:buFont typeface="Arial"/>
-              <a:buChar char="•"/>
-            </a:pPr>
-            <a:r>
-              <a:rPr lang="en-US" sz="1100" dirty="0">
-                <a:solidFill>
-                  <a:srgbClr val="1A2421"/>
-                </a:solidFill>
-                <a:latin typeface="Calibri"/>
-              </a:rPr>
-              <a:t>Snake-route path planner</a:t>
-            </a:r>
-          </a:p>
-          <a:p>
-            <a:pPr marL="237744" indent="-237744" algn="l">
-              <a:spcBef>
-                <a:spcPts val="0"/>
-              </a:spcBef>
-              <a:spcAft>
-                <a:spcPts val="120"/>
-              </a:spcAft>
-              <a:buFont typeface="Arial"/>
-              <a:buChar char="•"/>
-            </a:pPr>
-            <a:r>
-              <a:rPr lang="en-US" sz="1100" dirty="0">
-                <a:solidFill>
-                  <a:srgbClr val="1A2421"/>
-                </a:solidFill>
-                <a:latin typeface="Calibri"/>
-              </a:rPr>
-              <a:t>ROS2 nodes + full simulator</a:t>
-            </a:r>
-          </a:p>
-        </p:txBody>
-      </p:sp>
-      <p:sp>
-        <p:nvSpPr>
-          <p:cNvPr id="49" name="card"/>
-          <p:cNvSpPr/>
-          <p:nvPr/>
-        </p:nvSpPr>
-        <p:spPr>
-          <a:xfrm>
-            <a:off x="502920" y="3776472"/>
-            <a:ext cx="3310128" cy="2240280"/>
-          </a:xfrm>
-          <a:prstGeom prst="roundRect">
-            <a:avLst>
-              <a:gd name="adj" fmla="val 8000"/>
-            </a:avLst>
-          </a:prstGeom>
-          <a:solidFill>
-            <a:srgbClr val="F3F8F1"/>
-          </a:solidFill>
-          <a:ln w="15875">
-            <a:solidFill>
-              <a:srgbClr val="F9A825"/>
-            </a:solidFill>
-          </a:ln>
-        </p:spPr>
-        <p:txBody>
-          <a:bodyPr/>
-          <a:lstStyle/>
-          <a:p/>
-        </p:txBody>
-      </p:sp>
-      <p:sp>
-        <p:nvSpPr>
-          <p:cNvPr id="50" name="tab"/>
-          <p:cNvSpPr/>
-          <p:nvPr/>
-        </p:nvSpPr>
-        <p:spPr>
-          <a:xfrm>
-            <a:off x="502920" y="3776472"/>
-            <a:ext cx="109728" cy="2240280"/>
-          </a:xfrm>
-          <a:prstGeom prst="rect">
-            <a:avLst/>
-          </a:prstGeom>
-          <a:solidFill>
-            <a:srgbClr val="F9A825"/>
-          </a:solidFill>
-          <a:ln>
-            <a:noFill/>
-          </a:ln>
-        </p:spPr>
-        <p:txBody>
-          <a:bodyPr/>
-          <a:lstStyle/>
-          <a:p/>
-        </p:txBody>
-      </p:sp>
-      <p:sp>
-        <p:nvSpPr>
-          <p:cNvPr id="51" name="ct"/>
-          <p:cNvSpPr txBox="1"/>
-          <p:nvPr/>
-        </p:nvSpPr>
-        <p:spPr>
-          <a:xfrm>
-            <a:off x="758952" y="3922776"/>
-            <a:ext cx="2898648" cy="1965960"/>
-          </a:xfrm>
-          <a:prstGeom prst="rect">
-            <a:avLst/>
-          </a:prstGeom>
-          <a:noFill/>
-        </p:spPr>
-        <p:txBody>
-          <a:bodyPr wrap="square" anchor="t" rtlCol="0">
-            <a:normAutofit/>
-          </a:bodyPr>
-          <a:lstStyle/>
-          <a:p>
-            <a:pPr marL="0" indent="0" algn="l">
-              <a:spcBef>
-                <a:spcPts val="0"/>
-              </a:spcBef>
-              <a:spcAft>
-                <a:spcPts val="160"/>
-              </a:spcAft>
-              <a:buNone/>
-            </a:pPr>
-            <a:r>
-              <a:rPr lang="en-US" sz="1300" b="1" dirty="0">
-                <a:solidFill>
-                  <a:srgbClr val="F9A825"/>
-                </a:solidFill>
-                <a:latin typeface="Calibri"/>
-              </a:rPr>
-              <a:t>Software Tooling</a:t>
-            </a:r>
-          </a:p>
-          <a:p>
-            <a:pPr marL="237744" indent="-237744" algn="l">
-              <a:spcBef>
-                <a:spcPts val="0"/>
-              </a:spcBef>
-              <a:spcAft>
-                <a:spcPts val="120"/>
-              </a:spcAft>
-              <a:buFont typeface="Arial"/>
-              <a:buChar char="•"/>
-            </a:pPr>
-            <a:r>
-              <a:rPr lang="en-US" sz="1100" dirty="0">
-                <a:solidFill>
-                  <a:srgbClr val="1A2421"/>
-                </a:solidFill>
-                <a:latin typeface="Calibri"/>
-              </a:rPr>
-              <a:t>Live dashboard + Telegram alerts</a:t>
-            </a:r>
-          </a:p>
-          <a:p>
-            <a:pPr marL="237744" indent="-237744" algn="l">
-              <a:spcBef>
-                <a:spcPts val="0"/>
-              </a:spcBef>
-              <a:spcAft>
-                <a:spcPts val="120"/>
-              </a:spcAft>
-              <a:buFont typeface="Arial"/>
-              <a:buChar char="•"/>
-            </a:pPr>
-            <a:r>
-              <a:rPr lang="en-US" sz="1100" dirty="0">
-                <a:solidFill>
-                  <a:srgbClr val="1A2421"/>
-                </a:solidFill>
-                <a:latin typeface="Calibri"/>
-              </a:rPr>
-              <a:t>CI pipeline (automated build)</a:t>
-            </a:r>
-          </a:p>
-          <a:p>
-            <a:pPr marL="237744" indent="-237744" algn="l">
-              <a:spcBef>
-                <a:spcPts val="0"/>
-              </a:spcBef>
-              <a:spcAft>
-                <a:spcPts val="120"/>
-              </a:spcAft>
-              <a:buFont typeface="Arial"/>
-              <a:buChar char="•"/>
-            </a:pPr>
-            <a:r>
-              <a:rPr lang="en-US" sz="1100" dirty="0">
-                <a:solidFill>
-                  <a:srgbClr val="1A2421"/>
-                </a:solidFill>
-                <a:latin typeface="Calibri"/>
-              </a:rPr>
-              <a:t>Black-box data logging</a:t>
-            </a:r>
-          </a:p>
-        </p:txBody>
-      </p:sp>
-      <p:sp>
-        <p:nvSpPr>
-          <p:cNvPr id="52" name="card"/>
-          <p:cNvSpPr/>
-          <p:nvPr/>
-        </p:nvSpPr>
-        <p:spPr>
-          <a:xfrm>
-            <a:off x="3977640" y="3776472"/>
-            <a:ext cx="3310128" cy="2240280"/>
-          </a:xfrm>
-          <a:prstGeom prst="roundRect">
-            <a:avLst>
-              <a:gd name="adj" fmla="val 8000"/>
-            </a:avLst>
-          </a:prstGeom>
-          <a:solidFill>
-            <a:srgbClr val="F3F8F1"/>
-          </a:solidFill>
-          <a:ln w="15875">
-            <a:solidFill>
-              <a:srgbClr val="EF6C00"/>
-            </a:solidFill>
-          </a:ln>
-        </p:spPr>
-        <p:txBody>
-          <a:bodyPr/>
-          <a:lstStyle/>
-          <a:p/>
-        </p:txBody>
-      </p:sp>
-      <p:sp>
-        <p:nvSpPr>
-          <p:cNvPr id="53" name="tab"/>
-          <p:cNvSpPr/>
-          <p:nvPr/>
-        </p:nvSpPr>
-        <p:spPr>
-          <a:xfrm>
-            <a:off x="3977640" y="3776472"/>
-            <a:ext cx="109728" cy="2240280"/>
-          </a:xfrm>
-          <a:prstGeom prst="rect">
-            <a:avLst/>
-          </a:prstGeom>
-          <a:solidFill>
-            <a:srgbClr val="EF6C00"/>
-          </a:solidFill>
-          <a:ln>
-            <a:noFill/>
-          </a:ln>
-        </p:spPr>
-        <p:txBody>
-          <a:bodyPr/>
-          <a:lstStyle/>
-          <a:p/>
-        </p:txBody>
-      </p:sp>
-      <p:sp>
-        <p:nvSpPr>
-          <p:cNvPr id="54" name="ct"/>
-          <p:cNvSpPr txBox="1"/>
-          <p:nvPr/>
-        </p:nvSpPr>
-        <p:spPr>
-          <a:xfrm>
-            <a:off x="4233672" y="3922776"/>
-            <a:ext cx="2898648" cy="1965960"/>
-          </a:xfrm>
-          <a:prstGeom prst="rect">
-            <a:avLst/>
-          </a:prstGeom>
-          <a:noFill/>
-        </p:spPr>
-        <p:txBody>
-          <a:bodyPr wrap="square" anchor="t" rtlCol="0">
-            <a:normAutofit/>
-          </a:bodyPr>
-          <a:lstStyle/>
-          <a:p>
-            <a:pPr marL="0" indent="0" algn="l">
-              <a:spcBef>
-                <a:spcPts val="0"/>
-              </a:spcBef>
-              <a:spcAft>
-                <a:spcPts val="160"/>
-              </a:spcAft>
-              <a:buNone/>
-            </a:pPr>
-            <a:r>
-              <a:rPr lang="en-US" sz="1300" b="1" dirty="0">
-                <a:solidFill>
-                  <a:srgbClr val="EF6C00"/>
-                </a:solidFill>
-                <a:latin typeface="Calibri"/>
-              </a:rPr>
-              <a:t>Hardware Design</a:t>
-            </a:r>
-          </a:p>
-          <a:p>
-            <a:pPr marL="237744" indent="-237744" algn="l">
-              <a:spcBef>
-                <a:spcPts val="0"/>
-              </a:spcBef>
-              <a:spcAft>
-                <a:spcPts val="120"/>
-              </a:spcAft>
-              <a:buFont typeface="Arial"/>
-              <a:buChar char="•"/>
-            </a:pPr>
-            <a:r>
-              <a:rPr lang="en-US" sz="1100" dirty="0">
-                <a:solidFill>
-                  <a:srgbClr val="1A2421"/>
-                </a:solidFill>
-                <a:latin typeface="Calibri"/>
-              </a:rPr>
-              <a:t>Verified circuit + wiring v2</a:t>
-            </a:r>
-          </a:p>
-          <a:p>
-            <a:pPr marL="237744" indent="-237744" algn="l">
-              <a:spcBef>
-                <a:spcPts val="0"/>
-              </a:spcBef>
-              <a:spcAft>
-                <a:spcPts val="120"/>
-              </a:spcAft>
-              <a:buFont typeface="Arial"/>
-              <a:buChar char="•"/>
-            </a:pPr>
-            <a:r>
-              <a:rPr lang="en-US" sz="1100" dirty="0">
-                <a:solidFill>
-                  <a:srgbClr val="1A2421"/>
-                </a:solidFill>
-                <a:latin typeface="Calibri"/>
-              </a:rPr>
-              <a:t>110-part BOM, fully costed</a:t>
-            </a:r>
-          </a:p>
-          <a:p>
-            <a:pPr marL="237744" indent="-237744" algn="l">
-              <a:spcBef>
-                <a:spcPts val="0"/>
-              </a:spcBef>
-              <a:spcAft>
-                <a:spcPts val="120"/>
-              </a:spcAft>
-              <a:buFont typeface="Arial"/>
-              <a:buChar char="•"/>
-            </a:pPr>
-            <a:r>
-              <a:rPr lang="en-US" sz="1100" dirty="0">
-                <a:solidFill>
-                  <a:srgbClr val="1A2421"/>
-                </a:solidFill>
-                <a:latin typeface="Calibri"/>
-              </a:rPr>
-              <a:t>+15 gap-audit &amp; v2 upgrades</a:t>
-            </a:r>
-          </a:p>
-        </p:txBody>
-      </p:sp>
-      <p:sp>
-        <p:nvSpPr>
-          <p:cNvPr id="55" name="card"/>
-          <p:cNvSpPr/>
-          <p:nvPr/>
-        </p:nvSpPr>
-        <p:spPr>
-          <a:xfrm>
-            <a:off x="7452360" y="3776472"/>
-            <a:ext cx="3310128" cy="2240280"/>
-          </a:xfrm>
-          <a:prstGeom prst="roundRect">
-            <a:avLst>
-              <a:gd name="adj" fmla="val 8000"/>
-            </a:avLst>
-          </a:prstGeom>
-          <a:solidFill>
-            <a:srgbClr val="F3F8F1"/>
-          </a:solidFill>
-          <a:ln w="15875">
-            <a:solidFill>
-              <a:srgbClr val="2E7D32"/>
-            </a:solidFill>
-          </a:ln>
-        </p:spPr>
-        <p:txBody>
-          <a:bodyPr/>
-          <a:lstStyle/>
-          <a:p/>
-        </p:txBody>
-      </p:sp>
-      <p:sp>
-        <p:nvSpPr>
-          <p:cNvPr id="56" name="tab"/>
-          <p:cNvSpPr/>
-          <p:nvPr/>
-        </p:nvSpPr>
-        <p:spPr>
-          <a:xfrm>
-            <a:off x="7452360" y="3776472"/>
-            <a:ext cx="109728" cy="2240280"/>
-          </a:xfrm>
-          <a:prstGeom prst="rect">
-            <a:avLst/>
-          </a:prstGeom>
-          <a:solidFill>
-            <a:srgbClr val="2E7D32"/>
-          </a:solidFill>
-          <a:ln>
-            <a:noFill/>
-          </a:ln>
-        </p:spPr>
-        <p:txBody>
-          <a:bodyPr/>
-          <a:lstStyle/>
-          <a:p/>
-        </p:txBody>
-      </p:sp>
-      <p:sp>
-        <p:nvSpPr>
-          <p:cNvPr id="57" name="ct"/>
-          <p:cNvSpPr txBox="1"/>
-          <p:nvPr/>
-        </p:nvSpPr>
-        <p:spPr>
-          <a:xfrm>
-            <a:off x="7708392" y="3922776"/>
-            <a:ext cx="2898648" cy="1965960"/>
-          </a:xfrm>
-          <a:prstGeom prst="rect">
-            <a:avLst/>
-          </a:prstGeom>
-          <a:noFill/>
-        </p:spPr>
-        <p:txBody>
-          <a:bodyPr wrap="square" anchor="t" rtlCol="0">
-            <a:normAutofit/>
-          </a:bodyPr>
-          <a:lstStyle/>
-          <a:p>
-            <a:pPr marL="0" indent="0" algn="l">
-              <a:spcBef>
-                <a:spcPts val="0"/>
-              </a:spcBef>
-              <a:spcAft>
-                <a:spcPts val="160"/>
-              </a:spcAft>
-              <a:buNone/>
-            </a:pPr>
-            <a:r>
-              <a:rPr lang="en-US" sz="1300" b="1" dirty="0">
-                <a:solidFill>
-                  <a:srgbClr val="2E7D32"/>
-                </a:solidFill>
-                <a:latin typeface="Calibri"/>
-              </a:rPr>
-              <a:t>Field Reliability</a:t>
-            </a:r>
-          </a:p>
-          <a:p>
-            <a:pPr marL="237744" indent="-237744" algn="l">
-              <a:spcBef>
-                <a:spcPts val="0"/>
-              </a:spcBef>
-              <a:spcAft>
-                <a:spcPts val="120"/>
-              </a:spcAft>
-              <a:buFont typeface="Arial"/>
-              <a:buChar char="•"/>
-            </a:pPr>
-            <a:r>
-              <a:rPr lang="en-US" sz="1100" dirty="0">
-                <a:solidFill>
-                  <a:srgbClr val="1A2421"/>
-                </a:solidFill>
-                <a:latin typeface="Calibri"/>
-              </a:rPr>
-              <a:t>10 real field risks engineered</a:t>
-            </a:r>
-          </a:p>
-          <a:p>
-            <a:pPr marL="237744" indent="-237744" algn="l">
-              <a:spcBef>
-                <a:spcPts val="0"/>
-              </a:spcBef>
-              <a:spcAft>
-                <a:spcPts val="120"/>
-              </a:spcAft>
-              <a:buFont typeface="Arial"/>
-              <a:buChar char="•"/>
-            </a:pPr>
-            <a:r>
-              <a:rPr lang="en-US" sz="1100" dirty="0">
-                <a:solidFill>
-                  <a:srgbClr val="1A2421"/>
-                </a:solidFill>
-                <a:latin typeface="Calibri"/>
-              </a:rPr>
-              <a:t>Heat/battery, stall, comms-loss</a:t>
-            </a:r>
-          </a:p>
-          <a:p>
-            <a:pPr marL="237744" indent="-237744" algn="l">
-              <a:spcBef>
-                <a:spcPts val="0"/>
-              </a:spcBef>
-              <a:spcAft>
-                <a:spcPts val="120"/>
-              </a:spcAft>
-              <a:buFont typeface="Arial"/>
-              <a:buChar char="•"/>
-            </a:pPr>
-            <a:r>
-              <a:rPr lang="en-US" sz="1100" dirty="0">
-                <a:solidFill>
-                  <a:srgbClr val="1A2421"/>
-                </a:solidFill>
-                <a:latin typeface="Calibri"/>
-              </a:rPr>
-              <a:t>Dust/dew sealing &amp; fail-safes</a:t>
-            </a:r>
-          </a:p>
-        </p:txBody>
-      </p:sp>
-      <p:sp>
-        <p:nvSpPr>
-          <p:cNvPr id="58" name="note"/>
-          <p:cNvSpPr txBox="1"/>
-          <p:nvPr/>
-        </p:nvSpPr>
-        <p:spPr>
-          <a:xfrm>
-            <a:off x="502920" y="5989320"/>
-            <a:ext cx="10058400" cy="320040"/>
-          </a:xfrm>
-          <a:prstGeom prst="rect">
-            <a:avLst/>
-          </a:prstGeom>
-          <a:noFill/>
-        </p:spPr>
-        <p:txBody>
-          <a:bodyPr wrap="square" anchor="t" rtlCol="0">
-            <a:normAutofit/>
-          </a:bodyPr>
-          <a:lstStyle/>
-          <a:p>
-            <a:pPr marL="0" indent="0" algn="l">
-              <a:spcBef>
-                <a:spcPts val="0"/>
-              </a:spcBef>
-              <a:spcAft>
-                <a:spcPts val="600"/>
-              </a:spcAft>
-              <a:buNone/>
-            </a:pPr>
-            <a:r>
-              <a:rPr lang="en-US" sz="1100" i="1" dirty="0">
+              <a:rPr lang="en-US" sz="1000" i="1" dirty="0">
                 <a:solidFill>
                   <a:srgbClr val="5B6B63"/>
                 </a:solidFill>
                 <a:latin typeface="Calibri"/>
               </a:rPr>
-              <a:t>Built end-to-end by our 4-member team - software validated in simulation; hardware integration is the next step.</a:t>
+              <a:t>*Manual labour is cheap per use but recurring; AgriRover is a one-time low-cost asset that also senses soil and acts per plant.</a:t>
             </a:r>
           </a:p>
         </p:txBody>
@@ -2328,7 +2234,7 @@
         <p:spPr>
           <a:xfrm>
             <a:off x="548640" y="146304"/>
-            <a:ext cx="10058400" cy="777240"/>
+            <a:ext cx="10972800" cy="777240"/>
           </a:xfrm>
           <a:prstGeom prst="rect">
             <a:avLst/>
@@ -2357,7 +2263,7 @@
                 </a:solidFill>
                 <a:latin typeface="Calibri"/>
               </a:rPr>
-              <a:t>PoC Hypothesis &amp; Metrics</a:t>
+              <a:t>What We've Built  (POC/MVP)</a:t>
             </a:r>
           </a:p>
         </p:txBody>
@@ -2371,7 +2277,7 @@
         <p:spPr>
           <a:xfrm>
             <a:off x="548640" y="6355080"/>
-            <a:ext cx="10058400" cy="365760"/>
+            <a:ext cx="10972800" cy="365760"/>
           </a:xfrm>
           <a:prstGeom prst="rect">
             <a:avLst/>
@@ -2400,21 +2306,79 @@
                 </a:solidFill>
                 <a:latin typeface="Calibri"/>
               </a:rPr>
-              <a:t>AgriRover  -  IITB-Groww INV.ENT  -  Track A  -  Team of 4</a:t>
-            </a:r>
-          </a:p>
-        </p:txBody>
-      </p:sp>
-      <p:sp>
-        <p:nvSpPr>
-          <p:cNvPr id="30" name="b"/>
+              <a:t>AgriRover  -  IITB-Groww INV.ENT  -  Track A  -  Team of 4 (IIT Bombay)</a:t>
+            </a:r>
+          </a:p>
+        </p:txBody>
+      </p:sp>
+      <p:sp>
+        <p:nvSpPr>
+          <p:cNvPr id="50" name="card"/>
+          <p:cNvSpPr/>
+          <p:nvPr/>
+        </p:nvSpPr>
+        <p:spPr>
+          <a:xfrm>
+            <a:off x="502920" y="1371600"/>
+            <a:ext cx="3310128" cy="2240280"/>
+          </a:xfrm>
+          <a:prstGeom prst="roundRect">
+            <a:avLst>
+              <a:gd name="adj" fmla="val 8000"/>
+            </a:avLst>
+          </a:prstGeom>
+          <a:solidFill>
+            <a:srgbClr val="F3F8F1"/>
+          </a:solidFill>
+          <a:ln w="15875">
+            <a:solidFill>
+              <a:srgbClr val="2E7D32"/>
+            </a:solidFill>
+          </a:ln>
+        </p:spPr>
+        <p:txBody>
+          <a:bodyPr/>
+          <a:lstStyle/>
+          <a:p/>
+        </p:txBody>
+      </p:sp>
+      <p:sp>
+        <p:nvSpPr>
+          <p:cNvPr id="51" name="tab"/>
+          <p:cNvSpPr/>
+          <p:nvPr/>
+        </p:nvSpPr>
+        <p:spPr>
+          <a:xfrm>
+            <a:off x="502920" y="1371600"/>
+            <a:ext cx="109728" cy="2240280"/>
+          </a:xfrm>
+          <a:prstGeom prst="rect">
+            <a:avLst/>
+          </a:prstGeom>
+          <a:solidFill>
+            <a:srgbClr val="2E7D32"/>
+          </a:solidFill>
+          <a:ln>
+            <a:noFill/>
+          </a:ln>
+        </p:spPr>
+        <p:txBody>
+          <a:bodyPr/>
+          <a:lstStyle/>
+          <a:p/>
+        </p:txBody>
+      </p:sp>
+      <p:sp>
+        <p:nvSpPr>
+          <p:cNvPr id="52" name="ct"/>
           <p:cNvSpPr txBox="1"/>
           <p:nvPr/>
         </p:nvSpPr>
         <p:spPr>
           <a:xfrm>
-            <a:off x="548640" y="1325880"/>
-            <a:ext cx="10149840" cy="4754880"/>
+            <a:off x="758952" y="1517904"/>
+            <a:ext cx="2898648" cy="1965960"/>
           </a:xfrm>
           <a:prstGeom prst="rect">
             <a:avLst/>
@@ -2432,142 +2396,944 @@
                 <a:spcPts val="0"/>
               </a:spcBef>
               <a:spcAft>
-                <a:spcPts val="240"/>
+                <a:spcPts val="160"/>
               </a:spcAft>
               <a:buNone/>
             </a:pPr>
             <a:r>
-              <a:rPr lang="en-US" sz="1600" b="1" dirty="0">
+              <a:rPr lang="en-US" sz="1300" b="1" dirty="0">
                 <a:solidFill>
                   <a:srgbClr val="2E7D32"/>
                 </a:solidFill>
                 <a:latin typeface="Calibri"/>
               </a:rPr>
-              <a:t>Hypothesis</a:t>
-            </a:r>
-          </a:p>
-          <a:p>
-            <a:pPr marL="292608" indent="-292608" algn="l">
-              <a:spcBef>
-                <a:spcPts val="0"/>
-              </a:spcBef>
-              <a:spcAft>
-                <a:spcPts val="420"/>
+              <a:t>Firmware (ESP32 / FreeRTOS)</a:t>
+            </a:r>
+          </a:p>
+          <a:p>
+            <a:pPr marL="237744" indent="-237744" algn="l">
+              <a:spcBef>
+                <a:spcPts val="0"/>
+              </a:spcBef>
+              <a:spcAft>
+                <a:spcPts val="120"/>
               </a:spcAft>
               <a:buFont typeface="Arial"/>
               <a:buChar char="•"/>
             </a:pPr>
             <a:r>
-              <a:rPr lang="en-US" sz="1500" dirty="0">
+              <a:rPr lang="en-US" sz="1100" dirty="0">
                 <a:solidFill>
                   <a:srgbClr val="1A2421"/>
                 </a:solidFill>
                 <a:latin typeface="Calibri"/>
               </a:rPr>
-              <a:t>Per-plant sensing + targeted dosing cuts fertilizer/chemical use sharply with no yield loss.</a:t>
-            </a:r>
-          </a:p>
-          <a:p>
-            <a:pPr marL="0" indent="0" algn="l">
-              <a:spcBef>
-                <a:spcPts val="0"/>
-              </a:spcBef>
-              <a:spcAft>
-                <a:spcPts val="240"/>
-              </a:spcAft>
-              <a:buNone/>
-            </a:pPr>
-            <a:r>
-              <a:rPr lang="en-US" sz="1600" b="1" dirty="0">
-                <a:solidFill>
-                  <a:srgbClr val="2E7D32"/>
-                </a:solidFill>
-                <a:latin typeface="Calibri"/>
-              </a:rPr>
-              <a:t>Metrics we will prove in pilot</a:t>
-            </a:r>
-          </a:p>
-          <a:p>
-            <a:pPr marL="292608" indent="-292608" algn="l">
-              <a:spcBef>
-                <a:spcPts val="0"/>
-              </a:spcBef>
-              <a:spcAft>
-                <a:spcPts val="420"/>
+              <a:t>Dual-core drive, NPK/RS485 sensing</a:t>
+            </a:r>
+          </a:p>
+          <a:p>
+            <a:pPr marL="237744" indent="-237744" algn="l">
+              <a:spcBef>
+                <a:spcPts val="0"/>
+              </a:spcBef>
+              <a:spcAft>
+                <a:spcPts val="120"/>
               </a:spcAft>
               <a:buFont typeface="Arial"/>
               <a:buChar char="•"/>
             </a:pPr>
             <a:r>
-              <a:rPr lang="en-US" sz="1500" dirty="0">
+              <a:rPr lang="en-US" sz="1100" dirty="0">
                 <a:solidFill>
                   <a:srgbClr val="1A2421"/>
                 </a:solidFill>
                 <a:latin typeface="Calibri"/>
               </a:rPr>
-              <a:t>Fertilizer/pesticide reduction % vs hand broadcasting.</a:t>
-            </a:r>
-          </a:p>
-          <a:p>
-            <a:pPr marL="292608" indent="-292608" algn="l">
-              <a:spcBef>
-                <a:spcPts val="0"/>
-              </a:spcBef>
-              <a:spcAft>
-                <a:spcPts val="420"/>
+              <a:t>Dosing state machine</a:t>
+            </a:r>
+          </a:p>
+          <a:p>
+            <a:pPr marL="237744" indent="-237744" algn="l">
+              <a:spcBef>
+                <a:spcPts val="0"/>
+              </a:spcBef>
+              <a:spcAft>
+                <a:spcPts val="120"/>
               </a:spcAft>
               <a:buFont typeface="Arial"/>
               <a:buChar char="•"/>
             </a:pPr>
             <a:r>
-              <a:rPr lang="en-US" sz="1500" dirty="0">
+              <a:rPr lang="en-US" sz="1100" dirty="0">
                 <a:solidFill>
                   <a:srgbClr val="1A2421"/>
                 </a:solidFill>
                 <a:latin typeface="Calibri"/>
               </a:rPr>
-              <a:t>Weed/disease detection accuracy (precision &amp; recall); dosing placement accuracy (cm).</a:t>
-            </a:r>
-          </a:p>
-          <a:p>
-            <a:pPr marL="292608" indent="-292608" algn="l">
-              <a:spcBef>
-                <a:spcPts val="0"/>
-              </a:spcBef>
-              <a:spcAft>
-                <a:spcPts val="420"/>
+              <a:t>Secure MQTT + UART link</a:t>
+            </a:r>
+          </a:p>
+        </p:txBody>
+      </p:sp>
+      <p:sp>
+        <p:nvSpPr>
+          <p:cNvPr id="53" name="card"/>
+          <p:cNvSpPr/>
+          <p:nvPr/>
+        </p:nvSpPr>
+        <p:spPr>
+          <a:xfrm>
+            <a:off x="3977640" y="1371600"/>
+            <a:ext cx="3310128" cy="2240280"/>
+          </a:xfrm>
+          <a:prstGeom prst="roundRect">
+            <a:avLst>
+              <a:gd name="adj" fmla="val 8000"/>
+            </a:avLst>
+          </a:prstGeom>
+          <a:solidFill>
+            <a:srgbClr val="F3F8F1"/>
+          </a:solidFill>
+          <a:ln w="15875">
+            <a:solidFill>
+              <a:srgbClr val="1565C0"/>
+            </a:solidFill>
+          </a:ln>
+        </p:spPr>
+        <p:txBody>
+          <a:bodyPr/>
+          <a:lstStyle/>
+          <a:p/>
+        </p:txBody>
+      </p:sp>
+      <p:sp>
+        <p:nvSpPr>
+          <p:cNvPr id="54" name="tab"/>
+          <p:cNvSpPr/>
+          <p:nvPr/>
+        </p:nvSpPr>
+        <p:spPr>
+          <a:xfrm>
+            <a:off x="3977640" y="1371600"/>
+            <a:ext cx="109728" cy="2240280"/>
+          </a:xfrm>
+          <a:prstGeom prst="rect">
+            <a:avLst/>
+          </a:prstGeom>
+          <a:solidFill>
+            <a:srgbClr val="1565C0"/>
+          </a:solidFill>
+          <a:ln>
+            <a:noFill/>
+          </a:ln>
+        </p:spPr>
+        <p:txBody>
+          <a:bodyPr/>
+          <a:lstStyle/>
+          <a:p/>
+        </p:txBody>
+      </p:sp>
+      <p:sp>
+        <p:nvSpPr>
+          <p:cNvPr id="55" name="ct"/>
+          <p:cNvSpPr txBox="1"/>
+          <p:nvPr/>
+        </p:nvSpPr>
+        <p:spPr>
+          <a:xfrm>
+            <a:off x="4233672" y="1517904"/>
+            <a:ext cx="2898648" cy="1965960"/>
+          </a:xfrm>
+          <a:prstGeom prst="rect">
+            <a:avLst/>
+          </a:prstGeom>
+          <a:noFill/>
+        </p:spPr>
+        <p:txBody>
+          <a:bodyPr wrap="square" anchor="t" rtlCol="0">
+            <a:normAutofit/>
+          </a:bodyPr>
+          <a:lstStyle/>
+          <a:p>
+            <a:pPr marL="0" indent="0" algn="l">
+              <a:spcBef>
+                <a:spcPts val="0"/>
+              </a:spcBef>
+              <a:spcAft>
+                <a:spcPts val="160"/>
+              </a:spcAft>
+              <a:buNone/>
+            </a:pPr>
+            <a:r>
+              <a:rPr lang="en-US" sz="1300" b="1" dirty="0">
+                <a:solidFill>
+                  <a:srgbClr val="1565C0"/>
+                </a:solidFill>
+                <a:latin typeface="Calibri"/>
+              </a:rPr>
+              <a:t>AI Vision (Raspberry Pi)</a:t>
+            </a:r>
+          </a:p>
+          <a:p>
+            <a:pPr marL="237744" indent="-237744" algn="l">
+              <a:spcBef>
+                <a:spcPts val="0"/>
+              </a:spcBef>
+              <a:spcAft>
+                <a:spcPts val="120"/>
               </a:spcAft>
               <a:buFont typeface="Arial"/>
               <a:buChar char="•"/>
             </a:pPr>
             <a:r>
-              <a:rPr lang="en-US" sz="1500" dirty="0">
+              <a:rPr lang="en-US" sz="1100" dirty="0">
                 <a:solidFill>
                   <a:srgbClr val="1A2421"/>
                 </a:solidFill>
                 <a:latin typeface="Calibri"/>
               </a:rPr>
-              <a:t>Area covered per charge; cost saving per acre per season.</a:t>
-            </a:r>
-          </a:p>
+              <a:t>YOLOv8n weed/disease/obstacle</a:t>
+            </a:r>
+          </a:p>
+          <a:p>
+            <a:pPr marL="237744" indent="-237744" algn="l">
+              <a:spcBef>
+                <a:spcPts val="0"/>
+              </a:spcBef>
+              <a:spcAft>
+                <a:spcPts val="120"/>
+              </a:spcAft>
+              <a:buFont typeface="Arial"/>
+              <a:buChar char="•"/>
+            </a:pPr>
+            <a:r>
+              <a:rPr lang="en-US" sz="1100" dirty="0">
+                <a:solidFill>
+                  <a:srgbClr val="1A2421"/>
+                </a:solidFill>
+                <a:latin typeface="Calibri"/>
+              </a:rPr>
+              <a:t>Runs on Coral Edge TPU</a:t>
+            </a:r>
+          </a:p>
+          <a:p>
+            <a:pPr marL="237744" indent="-237744" algn="l">
+              <a:spcBef>
+                <a:spcPts val="0"/>
+              </a:spcBef>
+              <a:spcAft>
+                <a:spcPts val="120"/>
+              </a:spcAft>
+              <a:buFont typeface="Arial"/>
+              <a:buChar char="•"/>
+            </a:pPr>
+            <a:r>
+              <a:rPr lang="en-US" sz="1100" dirty="0">
+                <a:solidFill>
+                  <a:srgbClr val="1A2421"/>
+                </a:solidFill>
+                <a:latin typeface="Calibri"/>
+              </a:rPr>
+              <a:t>Training notebooks included</a:t>
+            </a:r>
+          </a:p>
+        </p:txBody>
+      </p:sp>
+      <p:sp>
+        <p:nvSpPr>
+          <p:cNvPr id="56" name="card"/>
+          <p:cNvSpPr/>
+          <p:nvPr/>
+        </p:nvSpPr>
+        <p:spPr>
+          <a:xfrm>
+            <a:off x="7452360" y="1371600"/>
+            <a:ext cx="3310128" cy="2240280"/>
+          </a:xfrm>
+          <a:prstGeom prst="roundRect">
+            <a:avLst>
+              <a:gd name="adj" fmla="val 8000"/>
+            </a:avLst>
+          </a:prstGeom>
+          <a:solidFill>
+            <a:srgbClr val="F3F8F1"/>
+          </a:solidFill>
+          <a:ln w="15875">
+            <a:solidFill>
+              <a:srgbClr val="6A1B9A"/>
+            </a:solidFill>
+          </a:ln>
+        </p:spPr>
+        <p:txBody>
+          <a:bodyPr/>
+          <a:lstStyle/>
+          <a:p/>
+        </p:txBody>
+      </p:sp>
+      <p:sp>
+        <p:nvSpPr>
+          <p:cNvPr id="57" name="tab"/>
+          <p:cNvSpPr/>
+          <p:nvPr/>
+        </p:nvSpPr>
+        <p:spPr>
+          <a:xfrm>
+            <a:off x="7452360" y="1371600"/>
+            <a:ext cx="109728" cy="2240280"/>
+          </a:xfrm>
+          <a:prstGeom prst="rect">
+            <a:avLst/>
+          </a:prstGeom>
+          <a:solidFill>
+            <a:srgbClr val="6A1B9A"/>
+          </a:solidFill>
+          <a:ln>
+            <a:noFill/>
+          </a:ln>
+        </p:spPr>
+        <p:txBody>
+          <a:bodyPr/>
+          <a:lstStyle/>
+          <a:p/>
+        </p:txBody>
+      </p:sp>
+      <p:sp>
+        <p:nvSpPr>
+          <p:cNvPr id="58" name="ct"/>
+          <p:cNvSpPr txBox="1"/>
+          <p:nvPr/>
+        </p:nvSpPr>
+        <p:spPr>
+          <a:xfrm>
+            <a:off x="7708392" y="1517904"/>
+            <a:ext cx="2898648" cy="1965960"/>
+          </a:xfrm>
+          <a:prstGeom prst="rect">
+            <a:avLst/>
+          </a:prstGeom>
+          <a:noFill/>
+        </p:spPr>
+        <p:txBody>
+          <a:bodyPr wrap="square" anchor="t" rtlCol="0">
+            <a:normAutofit/>
+          </a:bodyPr>
+          <a:lstStyle/>
           <a:p>
             <a:pPr marL="0" indent="0" algn="l">
               <a:spcBef>
                 <a:spcPts val="0"/>
               </a:spcBef>
               <a:spcAft>
-                <a:spcPts val="0"/>
+                <a:spcPts val="160"/>
               </a:spcAft>
               <a:buNone/>
             </a:pPr>
             <a:r>
-              <a:rPr lang="en-US" sz="1400" b="1" dirty="0">
+              <a:rPr lang="en-US" sz="1300" b="1" dirty="0">
+                <a:solidFill>
+                  <a:srgbClr val="6A1B9A"/>
+                </a:solidFill>
+                <a:latin typeface="Calibri"/>
+              </a:rPr>
+              <a:t>Navigation &amp; Systems</a:t>
+            </a:r>
+          </a:p>
+          <a:p>
+            <a:pPr marL="237744" indent="-237744" algn="l">
+              <a:spcBef>
+                <a:spcPts val="0"/>
+              </a:spcBef>
+              <a:spcAft>
+                <a:spcPts val="120"/>
+              </a:spcAft>
+              <a:buFont typeface="Arial"/>
+              <a:buChar char="•"/>
+            </a:pPr>
+            <a:r>
+              <a:rPr lang="en-US" sz="1100" dirty="0">
+                <a:solidFill>
+                  <a:srgbClr val="1A2421"/>
+                </a:solidFill>
+                <a:latin typeface="Calibri"/>
+              </a:rPr>
+              <a:t>EKF + GPS + vision geo-tag</a:t>
+            </a:r>
+          </a:p>
+          <a:p>
+            <a:pPr marL="237744" indent="-237744" algn="l">
+              <a:spcBef>
+                <a:spcPts val="0"/>
+              </a:spcBef>
+              <a:spcAft>
+                <a:spcPts val="120"/>
+              </a:spcAft>
+              <a:buFont typeface="Arial"/>
+              <a:buChar char="•"/>
+            </a:pPr>
+            <a:r>
+              <a:rPr lang="en-US" sz="1100" dirty="0">
+                <a:solidFill>
+                  <a:srgbClr val="1A2421"/>
+                </a:solidFill>
+                <a:latin typeface="Calibri"/>
+              </a:rPr>
+              <a:t>Snake-route path planner</a:t>
+            </a:r>
+          </a:p>
+          <a:p>
+            <a:pPr marL="237744" indent="-237744" algn="l">
+              <a:spcBef>
+                <a:spcPts val="0"/>
+              </a:spcBef>
+              <a:spcAft>
+                <a:spcPts val="120"/>
+              </a:spcAft>
+              <a:buFont typeface="Arial"/>
+              <a:buChar char="•"/>
+            </a:pPr>
+            <a:r>
+              <a:rPr lang="en-US" sz="1100" dirty="0">
+                <a:solidFill>
+                  <a:srgbClr val="1A2421"/>
+                </a:solidFill>
+                <a:latin typeface="Calibri"/>
+              </a:rPr>
+              <a:t>ROS2 nodes + full simulator</a:t>
+            </a:r>
+          </a:p>
+        </p:txBody>
+      </p:sp>
+      <p:sp>
+        <p:nvSpPr>
+          <p:cNvPr id="59" name="card"/>
+          <p:cNvSpPr/>
+          <p:nvPr/>
+        </p:nvSpPr>
+        <p:spPr>
+          <a:xfrm>
+            <a:off x="502920" y="3776472"/>
+            <a:ext cx="3310128" cy="2240280"/>
+          </a:xfrm>
+          <a:prstGeom prst="roundRect">
+            <a:avLst>
+              <a:gd name="adj" fmla="val 8000"/>
+            </a:avLst>
+          </a:prstGeom>
+          <a:solidFill>
+            <a:srgbClr val="F3F8F1"/>
+          </a:solidFill>
+          <a:ln w="15875">
+            <a:solidFill>
+              <a:srgbClr val="F9A825"/>
+            </a:solidFill>
+          </a:ln>
+        </p:spPr>
+        <p:txBody>
+          <a:bodyPr/>
+          <a:lstStyle/>
+          <a:p/>
+        </p:txBody>
+      </p:sp>
+      <p:sp>
+        <p:nvSpPr>
+          <p:cNvPr id="60" name="tab"/>
+          <p:cNvSpPr/>
+          <p:nvPr/>
+        </p:nvSpPr>
+        <p:spPr>
+          <a:xfrm>
+            <a:off x="502920" y="3776472"/>
+            <a:ext cx="109728" cy="2240280"/>
+          </a:xfrm>
+          <a:prstGeom prst="rect">
+            <a:avLst/>
+          </a:prstGeom>
+          <a:solidFill>
+            <a:srgbClr val="F9A825"/>
+          </a:solidFill>
+          <a:ln>
+            <a:noFill/>
+          </a:ln>
+        </p:spPr>
+        <p:txBody>
+          <a:bodyPr/>
+          <a:lstStyle/>
+          <a:p/>
+        </p:txBody>
+      </p:sp>
+      <p:sp>
+        <p:nvSpPr>
+          <p:cNvPr id="61" name="ct"/>
+          <p:cNvSpPr txBox="1"/>
+          <p:nvPr/>
+        </p:nvSpPr>
+        <p:spPr>
+          <a:xfrm>
+            <a:off x="758952" y="3922776"/>
+            <a:ext cx="2898648" cy="1965960"/>
+          </a:xfrm>
+          <a:prstGeom prst="rect">
+            <a:avLst/>
+          </a:prstGeom>
+          <a:noFill/>
+        </p:spPr>
+        <p:txBody>
+          <a:bodyPr wrap="square" anchor="t" rtlCol="0">
+            <a:normAutofit/>
+          </a:bodyPr>
+          <a:lstStyle/>
+          <a:p>
+            <a:pPr marL="0" indent="0" algn="l">
+              <a:spcBef>
+                <a:spcPts val="0"/>
+              </a:spcBef>
+              <a:spcAft>
+                <a:spcPts val="160"/>
+              </a:spcAft>
+              <a:buNone/>
+            </a:pPr>
+            <a:r>
+              <a:rPr lang="en-US" sz="1300" b="1" dirty="0">
+                <a:solidFill>
+                  <a:srgbClr val="F9A825"/>
+                </a:solidFill>
+                <a:latin typeface="Calibri"/>
+              </a:rPr>
+              <a:t>Software Tooling</a:t>
+            </a:r>
+          </a:p>
+          <a:p>
+            <a:pPr marL="237744" indent="-237744" algn="l">
+              <a:spcBef>
+                <a:spcPts val="0"/>
+              </a:spcBef>
+              <a:spcAft>
+                <a:spcPts val="120"/>
+              </a:spcAft>
+              <a:buFont typeface="Arial"/>
+              <a:buChar char="•"/>
+            </a:pPr>
+            <a:r>
+              <a:rPr lang="en-US" sz="1100" dirty="0">
+                <a:solidFill>
+                  <a:srgbClr val="1A2421"/>
+                </a:solidFill>
+                <a:latin typeface="Calibri"/>
+              </a:rPr>
+              <a:t>Live dashboard + Telegram alerts</a:t>
+            </a:r>
+          </a:p>
+          <a:p>
+            <a:pPr marL="237744" indent="-237744" algn="l">
+              <a:spcBef>
+                <a:spcPts val="0"/>
+              </a:spcBef>
+              <a:spcAft>
+                <a:spcPts val="120"/>
+              </a:spcAft>
+              <a:buFont typeface="Arial"/>
+              <a:buChar char="•"/>
+            </a:pPr>
+            <a:r>
+              <a:rPr lang="en-US" sz="1100" dirty="0">
+                <a:solidFill>
+                  <a:srgbClr val="1A2421"/>
+                </a:solidFill>
+                <a:latin typeface="Calibri"/>
+              </a:rPr>
+              <a:t>CI pipeline (automated build)</a:t>
+            </a:r>
+          </a:p>
+          <a:p>
+            <a:pPr marL="237744" indent="-237744" algn="l">
+              <a:spcBef>
+                <a:spcPts val="0"/>
+              </a:spcBef>
+              <a:spcAft>
+                <a:spcPts val="120"/>
+              </a:spcAft>
+              <a:buFont typeface="Arial"/>
+              <a:buChar char="•"/>
+            </a:pPr>
+            <a:r>
+              <a:rPr lang="en-US" sz="1100" dirty="0">
+                <a:solidFill>
+                  <a:srgbClr val="1A2421"/>
+                </a:solidFill>
+                <a:latin typeface="Calibri"/>
+              </a:rPr>
+              <a:t>Black-box data logging</a:t>
+            </a:r>
+          </a:p>
+        </p:txBody>
+      </p:sp>
+      <p:sp>
+        <p:nvSpPr>
+          <p:cNvPr id="62" name="card"/>
+          <p:cNvSpPr/>
+          <p:nvPr/>
+        </p:nvSpPr>
+        <p:spPr>
+          <a:xfrm>
+            <a:off x="3977640" y="3776472"/>
+            <a:ext cx="3310128" cy="2240280"/>
+          </a:xfrm>
+          <a:prstGeom prst="roundRect">
+            <a:avLst>
+              <a:gd name="adj" fmla="val 8000"/>
+            </a:avLst>
+          </a:prstGeom>
+          <a:solidFill>
+            <a:srgbClr val="F3F8F1"/>
+          </a:solidFill>
+          <a:ln w="15875">
+            <a:solidFill>
+              <a:srgbClr val="EF6C00"/>
+            </a:solidFill>
+          </a:ln>
+        </p:spPr>
+        <p:txBody>
+          <a:bodyPr/>
+          <a:lstStyle/>
+          <a:p/>
+        </p:txBody>
+      </p:sp>
+      <p:sp>
+        <p:nvSpPr>
+          <p:cNvPr id="63" name="tab"/>
+          <p:cNvSpPr/>
+          <p:nvPr/>
+        </p:nvSpPr>
+        <p:spPr>
+          <a:xfrm>
+            <a:off x="3977640" y="3776472"/>
+            <a:ext cx="109728" cy="2240280"/>
+          </a:xfrm>
+          <a:prstGeom prst="rect">
+            <a:avLst/>
+          </a:prstGeom>
+          <a:solidFill>
+            <a:srgbClr val="EF6C00"/>
+          </a:solidFill>
+          <a:ln>
+            <a:noFill/>
+          </a:ln>
+        </p:spPr>
+        <p:txBody>
+          <a:bodyPr/>
+          <a:lstStyle/>
+          <a:p/>
+        </p:txBody>
+      </p:sp>
+      <p:sp>
+        <p:nvSpPr>
+          <p:cNvPr id="64" name="ct"/>
+          <p:cNvSpPr txBox="1"/>
+          <p:nvPr/>
+        </p:nvSpPr>
+        <p:spPr>
+          <a:xfrm>
+            <a:off x="4233672" y="3922776"/>
+            <a:ext cx="2898648" cy="1965960"/>
+          </a:xfrm>
+          <a:prstGeom prst="rect">
+            <a:avLst/>
+          </a:prstGeom>
+          <a:noFill/>
+        </p:spPr>
+        <p:txBody>
+          <a:bodyPr wrap="square" anchor="t" rtlCol="0">
+            <a:normAutofit/>
+          </a:bodyPr>
+          <a:lstStyle/>
+          <a:p>
+            <a:pPr marL="0" indent="0" algn="l">
+              <a:spcBef>
+                <a:spcPts val="0"/>
+              </a:spcBef>
+              <a:spcAft>
+                <a:spcPts val="160"/>
+              </a:spcAft>
+              <a:buNone/>
+            </a:pPr>
+            <a:r>
+              <a:rPr lang="en-US" sz="1300" b="1" dirty="0">
+                <a:solidFill>
+                  <a:srgbClr val="EF6C00"/>
+                </a:solidFill>
+                <a:latin typeface="Calibri"/>
+              </a:rPr>
+              <a:t>Hardware Design</a:t>
+            </a:r>
+          </a:p>
+          <a:p>
+            <a:pPr marL="237744" indent="-237744" algn="l">
+              <a:spcBef>
+                <a:spcPts val="0"/>
+              </a:spcBef>
+              <a:spcAft>
+                <a:spcPts val="120"/>
+              </a:spcAft>
+              <a:buFont typeface="Arial"/>
+              <a:buChar char="•"/>
+            </a:pPr>
+            <a:r>
+              <a:rPr lang="en-US" sz="1100" dirty="0">
+                <a:solidFill>
+                  <a:srgbClr val="1A2421"/>
+                </a:solidFill>
+                <a:latin typeface="Calibri"/>
+              </a:rPr>
+              <a:t>Verified circuit + wiring v2</a:t>
+            </a:r>
+          </a:p>
+          <a:p>
+            <a:pPr marL="237744" indent="-237744" algn="l">
+              <a:spcBef>
+                <a:spcPts val="0"/>
+              </a:spcBef>
+              <a:spcAft>
+                <a:spcPts val="120"/>
+              </a:spcAft>
+              <a:buFont typeface="Arial"/>
+              <a:buChar char="•"/>
+            </a:pPr>
+            <a:r>
+              <a:rPr lang="en-US" sz="1100" dirty="0">
+                <a:solidFill>
+                  <a:srgbClr val="1A2421"/>
+                </a:solidFill>
+                <a:latin typeface="Calibri"/>
+              </a:rPr>
+              <a:t>110-part BOM, fully costed</a:t>
+            </a:r>
+          </a:p>
+          <a:p>
+            <a:pPr marL="237744" indent="-237744" algn="l">
+              <a:spcBef>
+                <a:spcPts val="0"/>
+              </a:spcBef>
+              <a:spcAft>
+                <a:spcPts val="120"/>
+              </a:spcAft>
+              <a:buFont typeface="Arial"/>
+              <a:buChar char="•"/>
+            </a:pPr>
+            <a:r>
+              <a:rPr lang="en-US" sz="1100" dirty="0">
+                <a:solidFill>
+                  <a:srgbClr val="1A2421"/>
+                </a:solidFill>
+                <a:latin typeface="Calibri"/>
+              </a:rPr>
+              <a:t>+15 gap-audit &amp; v2 upgrades</a:t>
+            </a:r>
+          </a:p>
+        </p:txBody>
+      </p:sp>
+      <p:sp>
+        <p:nvSpPr>
+          <p:cNvPr id="65" name="card"/>
+          <p:cNvSpPr/>
+          <p:nvPr/>
+        </p:nvSpPr>
+        <p:spPr>
+          <a:xfrm>
+            <a:off x="7452360" y="3776472"/>
+            <a:ext cx="3310128" cy="2240280"/>
+          </a:xfrm>
+          <a:prstGeom prst="roundRect">
+            <a:avLst>
+              <a:gd name="adj" fmla="val 8000"/>
+            </a:avLst>
+          </a:prstGeom>
+          <a:solidFill>
+            <a:srgbClr val="F3F8F1"/>
+          </a:solidFill>
+          <a:ln w="15875">
+            <a:solidFill>
+              <a:srgbClr val="2E7D32"/>
+            </a:solidFill>
+          </a:ln>
+        </p:spPr>
+        <p:txBody>
+          <a:bodyPr/>
+          <a:lstStyle/>
+          <a:p/>
+        </p:txBody>
+      </p:sp>
+      <p:sp>
+        <p:nvSpPr>
+          <p:cNvPr id="66" name="tab"/>
+          <p:cNvSpPr/>
+          <p:nvPr/>
+        </p:nvSpPr>
+        <p:spPr>
+          <a:xfrm>
+            <a:off x="7452360" y="3776472"/>
+            <a:ext cx="109728" cy="2240280"/>
+          </a:xfrm>
+          <a:prstGeom prst="rect">
+            <a:avLst/>
+          </a:prstGeom>
+          <a:solidFill>
+            <a:srgbClr val="2E7D32"/>
+          </a:solidFill>
+          <a:ln>
+            <a:noFill/>
+          </a:ln>
+        </p:spPr>
+        <p:txBody>
+          <a:bodyPr/>
+          <a:lstStyle/>
+          <a:p/>
+        </p:txBody>
+      </p:sp>
+      <p:sp>
+        <p:nvSpPr>
+          <p:cNvPr id="67" name="ct"/>
+          <p:cNvSpPr txBox="1"/>
+          <p:nvPr/>
+        </p:nvSpPr>
+        <p:spPr>
+          <a:xfrm>
+            <a:off x="7708392" y="3922776"/>
+            <a:ext cx="2898648" cy="1965960"/>
+          </a:xfrm>
+          <a:prstGeom prst="rect">
+            <a:avLst/>
+          </a:prstGeom>
+          <a:noFill/>
+        </p:spPr>
+        <p:txBody>
+          <a:bodyPr wrap="square" anchor="t" rtlCol="0">
+            <a:normAutofit/>
+          </a:bodyPr>
+          <a:lstStyle/>
+          <a:p>
+            <a:pPr marL="0" indent="0" algn="l">
+              <a:spcBef>
+                <a:spcPts val="0"/>
+              </a:spcBef>
+              <a:spcAft>
+                <a:spcPts val="160"/>
+              </a:spcAft>
+              <a:buNone/>
+            </a:pPr>
+            <a:r>
+              <a:rPr lang="en-US" sz="1300" b="1" dirty="0">
                 <a:solidFill>
                   <a:srgbClr val="2E7D32"/>
                 </a:solidFill>
                 <a:latin typeface="Calibri"/>
               </a:rPr>
-              <a:t>Targets to prove: 30-50% input reduction, &gt;85% detection accuracy.</a:t>
+              <a:t>Field Reliability</a:t>
+            </a:r>
+          </a:p>
+          <a:p>
+            <a:pPr marL="237744" indent="-237744" algn="l">
+              <a:spcBef>
+                <a:spcPts val="0"/>
+              </a:spcBef>
+              <a:spcAft>
+                <a:spcPts val="120"/>
+              </a:spcAft>
+              <a:buFont typeface="Arial"/>
+              <a:buChar char="•"/>
+            </a:pPr>
+            <a:r>
+              <a:rPr lang="en-US" sz="1100" dirty="0">
+                <a:solidFill>
+                  <a:srgbClr val="1A2421"/>
+                </a:solidFill>
+                <a:latin typeface="Calibri"/>
+              </a:rPr>
+              <a:t>10 real field risks engineered</a:t>
+            </a:r>
+          </a:p>
+          <a:p>
+            <a:pPr marL="237744" indent="-237744" algn="l">
+              <a:spcBef>
+                <a:spcPts val="0"/>
+              </a:spcBef>
+              <a:spcAft>
+                <a:spcPts val="120"/>
+              </a:spcAft>
+              <a:buFont typeface="Arial"/>
+              <a:buChar char="•"/>
+            </a:pPr>
+            <a:r>
+              <a:rPr lang="en-US" sz="1100" dirty="0">
+                <a:solidFill>
+                  <a:srgbClr val="1A2421"/>
+                </a:solidFill>
+                <a:latin typeface="Calibri"/>
+              </a:rPr>
+              <a:t>Heat/battery, stall, comms-loss</a:t>
+            </a:r>
+          </a:p>
+          <a:p>
+            <a:pPr marL="237744" indent="-237744" algn="l">
+              <a:spcBef>
+                <a:spcPts val="0"/>
+              </a:spcBef>
+              <a:spcAft>
+                <a:spcPts val="120"/>
+              </a:spcAft>
+              <a:buFont typeface="Arial"/>
+              <a:buChar char="•"/>
+            </a:pPr>
+            <a:r>
+              <a:rPr lang="en-US" sz="1100" dirty="0">
+                <a:solidFill>
+                  <a:srgbClr val="1A2421"/>
+                </a:solidFill>
+                <a:latin typeface="Calibri"/>
+              </a:rPr>
+              <a:t>Dust/dew sealing &amp; fail-safes</a:t>
+            </a:r>
+          </a:p>
+        </p:txBody>
+      </p:sp>
+      <p:sp>
+        <p:nvSpPr>
+          <p:cNvPr id="68" name="note"/>
+          <p:cNvSpPr txBox="1"/>
+          <p:nvPr/>
+        </p:nvSpPr>
+        <p:spPr>
+          <a:xfrm>
+            <a:off x="502920" y="5989320"/>
+            <a:ext cx="10515600" cy="320040"/>
+          </a:xfrm>
+          <a:prstGeom prst="rect">
+            <a:avLst/>
+          </a:prstGeom>
+          <a:noFill/>
+        </p:spPr>
+        <p:txBody>
+          <a:bodyPr wrap="square" anchor="t" rtlCol="0">
+            <a:normAutofit/>
+          </a:bodyPr>
+          <a:lstStyle/>
+          <a:p>
+            <a:pPr marL="0" indent="0" algn="l">
+              <a:spcBef>
+                <a:spcPts val="0"/>
+              </a:spcBef>
+              <a:spcAft>
+                <a:spcPts val="600"/>
+              </a:spcAft>
+              <a:buNone/>
+            </a:pPr>
+            <a:r>
+              <a:rPr lang="en-US" sz="1100" i="1" dirty="0">
+                <a:solidFill>
+                  <a:srgbClr val="5B6B63"/>
+                </a:solidFill>
+                <a:latin typeface="Calibri"/>
+              </a:rPr>
+              <a:t>Built end-to-end by our 4-member team - software validated in simulation; hardware integration is the next step.</a:t>
             </a:r>
           </a:p>
         </p:txBody>
@@ -2668,7 +3434,7 @@
         <p:spPr>
           <a:xfrm>
             <a:off x="548640" y="146304"/>
-            <a:ext cx="10058400" cy="777240"/>
+            <a:ext cx="10972800" cy="777240"/>
           </a:xfrm>
           <a:prstGeom prst="rect">
             <a:avLst/>
@@ -2697,7 +3463,7 @@
                 </a:solidFill>
                 <a:latin typeface="Calibri"/>
               </a:rPr>
-              <a:t>Execution &amp; Business Plan</a:t>
+              <a:t>PoC Hypothesis &amp; Metrics</a:t>
             </a:r>
           </a:p>
         </p:txBody>
@@ -2711,7 +3477,7 @@
         <p:spPr>
           <a:xfrm>
             <a:off x="548640" y="6355080"/>
-            <a:ext cx="10058400" cy="365760"/>
+            <a:ext cx="10972800" cy="365760"/>
           </a:xfrm>
           <a:prstGeom prst="rect">
             <a:avLst/>
@@ -2740,7 +3506,7 @@
                 </a:solidFill>
                 <a:latin typeface="Calibri"/>
               </a:rPr>
-              <a:t>AgriRover  -  IITB-Groww INV.ENT  -  Track A  -  Team of 4</a:t>
+              <a:t>AgriRover  -  IITB-Groww INV.ENT  -  Track A  -  Team of 4 (IIT Bombay)</a:t>
             </a:r>
           </a:p>
         </p:txBody>
@@ -2754,7 +3520,7 @@
         <p:spPr>
           <a:xfrm>
             <a:off x="548640" y="1325880"/>
-            <a:ext cx="10149840" cy="4754880"/>
+            <a:ext cx="10698480" cy="4754880"/>
           </a:xfrm>
           <a:prstGeom prst="rect">
             <a:avLst/>
@@ -2783,7 +3549,7 @@
                 </a:solidFill>
                 <a:latin typeface="Calibri"/>
               </a:rPr>
-              <a:t>Next milestones</a:t>
+              <a:t>Hypothesis</a:t>
             </a:r>
           </a:p>
           <a:p>
@@ -2804,7 +3570,27 @@
                 </a:solidFill>
                 <a:latin typeface="Calibri"/>
               </a:rPr>
-              <a:t>Build: assemble hardware prototype (BTS7960 drive, NPK probe, pan/tilt sprayer, LiFePO4) - ~3 months.</a:t>
+              <a:t>Per-plant sensing + targeted dosing cuts fertilizer/chemical use sharply with no yield loss.</a:t>
+            </a:r>
+          </a:p>
+          <a:p>
+            <a:pPr marL="0" indent="0" algn="l">
+              <a:spcBef>
+                <a:spcPts val="0"/>
+              </a:spcBef>
+              <a:spcAft>
+                <a:spcPts val="240"/>
+              </a:spcAft>
+              <a:buNone/>
+            </a:pPr>
+            <a:r>
+              <a:rPr lang="en-US" sz="1600" b="1" dirty="0">
+                <a:solidFill>
+                  <a:srgbClr val="2E7D32"/>
+                </a:solidFill>
+                <a:latin typeface="Calibri"/>
+              </a:rPr>
+              <a:t>Metrics we will prove in pilot</a:t>
             </a:r>
           </a:p>
           <a:p>
@@ -2825,7 +3611,7 @@
                 </a:solidFill>
                 <a:latin typeface="Calibri"/>
               </a:rPr>
-              <a:t>Test: pilot on 5-10 small farms; measure input savings, accuracy and uptime.</a:t>
+              <a:t>Fertilizer/pesticide reduction % vs hand broadcasting.</a:t>
             </a:r>
           </a:p>
           <a:p>
@@ -2846,27 +3632,7 @@
                 </a:solidFill>
                 <a:latin typeface="Calibri"/>
               </a:rPr>
-              <a:t>Iterate: refine dosing + AI from field data; harden for dust and 40-45C heat.</a:t>
-            </a:r>
-          </a:p>
-          <a:p>
-            <a:pPr marL="0" indent="0" algn="l">
-              <a:spcBef>
-                <a:spcPts val="0"/>
-              </a:spcBef>
-              <a:spcAft>
-                <a:spcPts val="240"/>
-              </a:spcAft>
-              <a:buNone/>
-            </a:pPr>
-            <a:r>
-              <a:rPr lang="en-US" sz="1600" b="1" dirty="0">
-                <a:solidFill>
-                  <a:srgbClr val="2E7D32"/>
-                </a:solidFill>
-                <a:latin typeface="Calibri"/>
-              </a:rPr>
-              <a:t>Competitors &amp; edge</a:t>
+              <a:t>Weed/disease detection accuracy (precision &amp; recall); dosing placement accuracy (cm).</a:t>
             </a:r>
           </a:p>
           <a:p>
@@ -2887,7 +3653,7 @@
                 </a:solidFill>
                 <a:latin typeface="Calibri"/>
               </a:rPr>
-              <a:t>Big precision-ag (tractors, large drones) = costly, large-farm. Manual labour/dealers; slow soil labs. Our edge: affordable, autonomous, small-farm, per-plant.</a:t>
+              <a:t>Area covered per charge; cost saving per acre per season.</a:t>
             </a:r>
           </a:p>
           <a:p>
@@ -2896,39 +3662,18 @@
                 <a:spcPts val="0"/>
               </a:spcBef>
               <a:spcAft>
-                <a:spcPts val="240"/>
+                <a:spcPts val="0"/>
               </a:spcAft>
               <a:buNone/>
             </a:pPr>
             <a:r>
-              <a:rPr lang="en-US" sz="1600" b="1" dirty="0">
+              <a:rPr lang="en-US" sz="1400" b="1" dirty="0">
                 <a:solidFill>
                   <a:srgbClr val="2E7D32"/>
                 </a:solidFill>
                 <a:latin typeface="Calibri"/>
               </a:rPr>
-              <a:t>Pricing (indicative)</a:t>
-            </a:r>
-          </a:p>
-          <a:p>
-            <a:pPr marL="292608" indent="-292608" algn="l">
-              <a:spcBef>
-                <a:spcPts val="0"/>
-              </a:spcBef>
-              <a:spcAft>
-                <a:spcPts val="420"/>
-              </a:spcAft>
-              <a:buFont typeface="Arial"/>
-              <a:buChar char="•"/>
-            </a:pPr>
-            <a:r>
-              <a:rPr lang="en-US" sz="1500" dirty="0">
-                <a:solidFill>
-                  <a:srgbClr val="1A2421"/>
-                </a:solidFill>
-                <a:latin typeface="Calibri"/>
-              </a:rPr>
-              <a:t>Rover sale + service, or Rover-as-a-Service via FPOs/co-ops at a per-acre fee.</a:t>
+              <a:t>Targets to prove: 30-50% input reduction, &gt;85% detection accuracy.</a:t>
             </a:r>
           </a:p>
         </p:txBody>
@@ -3029,7 +3774,7 @@
         <p:spPr>
           <a:xfrm>
             <a:off x="548640" y="146304"/>
-            <a:ext cx="10058400" cy="777240"/>
+            <a:ext cx="10972800" cy="777240"/>
           </a:xfrm>
           <a:prstGeom prst="rect">
             <a:avLst/>
@@ -3058,7 +3803,7 @@
                 </a:solidFill>
                 <a:latin typeface="Calibri"/>
               </a:rPr>
-              <a:t>Team of 4 &amp; Impact</a:t>
+              <a:t>Execution &amp; Business Plan</a:t>
             </a:r>
           </a:p>
         </p:txBody>
@@ -3072,7 +3817,7 @@
         <p:spPr>
           <a:xfrm>
             <a:off x="548640" y="6355080"/>
-            <a:ext cx="10058400" cy="365760"/>
+            <a:ext cx="10972800" cy="365760"/>
           </a:xfrm>
           <a:prstGeom prst="rect">
             <a:avLst/>
@@ -3101,505 +3846,21 @@
                 </a:solidFill>
                 <a:latin typeface="Calibri"/>
               </a:rPr>
-              <a:t>AgriRover  -  IITB-Groww INV.ENT  -  Track A  -  Team of 4</a:t>
-            </a:r>
-          </a:p>
-        </p:txBody>
-      </p:sp>
-      <p:sp>
-        <p:nvSpPr>
-          <p:cNvPr id="50" name="m"/>
-          <p:cNvSpPr/>
-          <p:nvPr/>
-        </p:nvSpPr>
-        <p:spPr>
-          <a:xfrm>
-            <a:off x="502920" y="1371600"/>
-            <a:ext cx="5074920" cy="914400"/>
-          </a:xfrm>
-          <a:prstGeom prst="roundRect">
-            <a:avLst>
-              <a:gd name="adj" fmla="val 8000"/>
-            </a:avLst>
-          </a:prstGeom>
-          <a:solidFill>
-            <a:srgbClr val="F3F8F1"/>
-          </a:solidFill>
-          <a:ln w="14000">
-            <a:solidFill>
-              <a:srgbClr val="2E7D32"/>
-            </a:solidFill>
-          </a:ln>
-        </p:spPr>
-        <p:txBody>
-          <a:bodyPr/>
-          <a:lstStyle/>
-          <a:p/>
-        </p:txBody>
-      </p:sp>
-      <p:sp>
-        <p:nvSpPr>
-          <p:cNvPr id="51" name="mt"/>
-          <p:cNvSpPr/>
-          <p:nvPr/>
-        </p:nvSpPr>
-        <p:spPr>
-          <a:xfrm>
-            <a:off x="502920" y="1371600"/>
-            <a:ext cx="91440" cy="914400"/>
-          </a:xfrm>
-          <a:prstGeom prst="rect">
-            <a:avLst/>
-          </a:prstGeom>
-          <a:solidFill>
-            <a:srgbClr val="2E7D32"/>
-          </a:solidFill>
-          <a:ln>
-            <a:noFill/>
-          </a:ln>
-        </p:spPr>
-        <p:txBody>
-          <a:bodyPr/>
-          <a:lstStyle/>
-          <a:p/>
-        </p:txBody>
-      </p:sp>
-      <p:sp>
-        <p:nvSpPr>
-          <p:cNvPr id="52" name="mc"/>
+              <a:t>AgriRover  -  IITB-Groww INV.ENT  -  Track A  -  Team of 4 (IIT Bombay)</a:t>
+            </a:r>
+          </a:p>
+        </p:txBody>
+      </p:sp>
+      <p:sp>
+        <p:nvSpPr>
+          <p:cNvPr id="30" name="b"/>
           <p:cNvSpPr txBox="1"/>
           <p:nvPr/>
         </p:nvSpPr>
         <p:spPr>
           <a:xfrm>
-            <a:off x="722376" y="1463040"/>
-            <a:ext cx="4709160" cy="777240"/>
-          </a:xfrm>
-          <a:prstGeom prst="rect">
-            <a:avLst/>
-          </a:prstGeom>
-          <a:noFill/>
-        </p:spPr>
-        <p:txBody>
-          <a:bodyPr wrap="square" anchor="ctr" rtlCol="0">
-            <a:normAutofit/>
-          </a:bodyPr>
-          <a:lstStyle/>
-          <a:p>
-            <a:pPr marL="0" indent="0" algn="l">
-              <a:spcBef>
-                <a:spcPts val="0"/>
-              </a:spcBef>
-              <a:spcAft>
-                <a:spcPts val="80"/>
-              </a:spcAft>
-              <a:buNone/>
-            </a:pPr>
-            <a:r>
-              <a:rPr lang="en-US" sz="1300" b="1" dirty="0">
-                <a:solidFill>
-                  <a:srgbClr val="2E7D32"/>
-                </a:solidFill>
-                <a:latin typeface="Calibri"/>
-              </a:rPr>
-              <a:t>Hitanshu Kapadiya</a:t>
-            </a:r>
-          </a:p>
-          <a:p>
-            <a:pPr marL="0" indent="0" algn="l">
-              <a:spcBef>
-                <a:spcPts val="0"/>
-              </a:spcBef>
-              <a:spcAft>
-                <a:spcPts val="0"/>
-              </a:spcAft>
-              <a:buNone/>
-            </a:pPr>
-            <a:r>
-              <a:rPr lang="en-US" sz="1050" dirty="0">
-                <a:solidFill>
-                  <a:srgbClr val="1A2421"/>
-                </a:solidFill>
-                <a:latin typeface="Calibri"/>
-              </a:rPr>
-              <a:t>Mechanical Engineering, IIT Bombay</a:t>
-            </a:r>
-          </a:p>
-        </p:txBody>
-      </p:sp>
-      <p:sp>
-        <p:nvSpPr>
-          <p:cNvPr id="53" name="m"/>
-          <p:cNvSpPr/>
-          <p:nvPr/>
-        </p:nvSpPr>
-        <p:spPr>
-          <a:xfrm>
-            <a:off x="5806440" y="1371600"/>
-            <a:ext cx="5074920" cy="914400"/>
-          </a:xfrm>
-          <a:prstGeom prst="roundRect">
-            <a:avLst>
-              <a:gd name="adj" fmla="val 8000"/>
-            </a:avLst>
-          </a:prstGeom>
-          <a:solidFill>
-            <a:srgbClr val="F3F8F1"/>
-          </a:solidFill>
-          <a:ln w="14000">
-            <a:solidFill>
-              <a:srgbClr val="1565C0"/>
-            </a:solidFill>
-          </a:ln>
-        </p:spPr>
-        <p:txBody>
-          <a:bodyPr/>
-          <a:lstStyle/>
-          <a:p/>
-        </p:txBody>
-      </p:sp>
-      <p:sp>
-        <p:nvSpPr>
-          <p:cNvPr id="54" name="mt"/>
-          <p:cNvSpPr/>
-          <p:nvPr/>
-        </p:nvSpPr>
-        <p:spPr>
-          <a:xfrm>
-            <a:off x="5806440" y="1371600"/>
-            <a:ext cx="91440" cy="914400"/>
-          </a:xfrm>
-          <a:prstGeom prst="rect">
-            <a:avLst/>
-          </a:prstGeom>
-          <a:solidFill>
-            <a:srgbClr val="1565C0"/>
-          </a:solidFill>
-          <a:ln>
-            <a:noFill/>
-          </a:ln>
-        </p:spPr>
-        <p:txBody>
-          <a:bodyPr/>
-          <a:lstStyle/>
-          <a:p/>
-        </p:txBody>
-      </p:sp>
-      <p:sp>
-        <p:nvSpPr>
-          <p:cNvPr id="55" name="mc"/>
-          <p:cNvSpPr txBox="1"/>
-          <p:nvPr/>
-        </p:nvSpPr>
-        <p:spPr>
-          <a:xfrm>
-            <a:off x="6025896" y="1463040"/>
-            <a:ext cx="4709160" cy="777240"/>
-          </a:xfrm>
-          <a:prstGeom prst="rect">
-            <a:avLst/>
-          </a:prstGeom>
-          <a:noFill/>
-        </p:spPr>
-        <p:txBody>
-          <a:bodyPr wrap="square" anchor="ctr" rtlCol="0">
-            <a:normAutofit/>
-          </a:bodyPr>
-          <a:lstStyle/>
-          <a:p>
-            <a:pPr marL="0" indent="0" algn="l">
-              <a:spcBef>
-                <a:spcPts val="0"/>
-              </a:spcBef>
-              <a:spcAft>
-                <a:spcPts val="80"/>
-              </a:spcAft>
-              <a:buNone/>
-            </a:pPr>
-            <a:r>
-              <a:rPr lang="en-US" sz="1300" b="1" dirty="0">
-                <a:solidFill>
-                  <a:srgbClr val="1565C0"/>
-                </a:solidFill>
-                <a:latin typeface="Calibri"/>
-              </a:rPr>
-              <a:t>Vivek Gupta</a:t>
-            </a:r>
-          </a:p>
-          <a:p>
-            <a:pPr marL="0" indent="0" algn="l">
-              <a:spcBef>
-                <a:spcPts val="0"/>
-              </a:spcBef>
-              <a:spcAft>
-                <a:spcPts val="0"/>
-              </a:spcAft>
-              <a:buNone/>
-            </a:pPr>
-            <a:r>
-              <a:rPr lang="en-US" sz="1050" dirty="0">
-                <a:solidFill>
-                  <a:srgbClr val="1A2421"/>
-                </a:solidFill>
-                <a:latin typeface="Calibri"/>
-              </a:rPr>
-              <a:t>Mechanical Engineering, IIT Bombay</a:t>
-            </a:r>
-          </a:p>
-        </p:txBody>
-      </p:sp>
-      <p:sp>
-        <p:nvSpPr>
-          <p:cNvPr id="56" name="m"/>
-          <p:cNvSpPr/>
-          <p:nvPr/>
-        </p:nvSpPr>
-        <p:spPr>
-          <a:xfrm>
-            <a:off x="502920" y="2423160"/>
-            <a:ext cx="5074920" cy="914400"/>
-          </a:xfrm>
-          <a:prstGeom prst="roundRect">
-            <a:avLst>
-              <a:gd name="adj" fmla="val 8000"/>
-            </a:avLst>
-          </a:prstGeom>
-          <a:solidFill>
-            <a:srgbClr val="F3F8F1"/>
-          </a:solidFill>
-          <a:ln w="14000">
-            <a:solidFill>
-              <a:srgbClr val="6A1B9A"/>
-            </a:solidFill>
-          </a:ln>
-        </p:spPr>
-        <p:txBody>
-          <a:bodyPr/>
-          <a:lstStyle/>
-          <a:p/>
-        </p:txBody>
-      </p:sp>
-      <p:sp>
-        <p:nvSpPr>
-          <p:cNvPr id="57" name="mt"/>
-          <p:cNvSpPr/>
-          <p:nvPr/>
-        </p:nvSpPr>
-        <p:spPr>
-          <a:xfrm>
-            <a:off x="502920" y="2423160"/>
-            <a:ext cx="91440" cy="914400"/>
-          </a:xfrm>
-          <a:prstGeom prst="rect">
-            <a:avLst/>
-          </a:prstGeom>
-          <a:solidFill>
-            <a:srgbClr val="6A1B9A"/>
-          </a:solidFill>
-          <a:ln>
-            <a:noFill/>
-          </a:ln>
-        </p:spPr>
-        <p:txBody>
-          <a:bodyPr/>
-          <a:lstStyle/>
-          <a:p/>
-        </p:txBody>
-      </p:sp>
-      <p:sp>
-        <p:nvSpPr>
-          <p:cNvPr id="58" name="mc"/>
-          <p:cNvSpPr txBox="1"/>
-          <p:nvPr/>
-        </p:nvSpPr>
-        <p:spPr>
-          <a:xfrm>
-            <a:off x="722376" y="2514600"/>
-            <a:ext cx="4709160" cy="777240"/>
-          </a:xfrm>
-          <a:prstGeom prst="rect">
-            <a:avLst/>
-          </a:prstGeom>
-          <a:noFill/>
-        </p:spPr>
-        <p:txBody>
-          <a:bodyPr wrap="square" anchor="ctr" rtlCol="0">
-            <a:normAutofit/>
-          </a:bodyPr>
-          <a:lstStyle/>
-          <a:p>
-            <a:pPr marL="0" indent="0" algn="l">
-              <a:spcBef>
-                <a:spcPts val="0"/>
-              </a:spcBef>
-              <a:spcAft>
-                <a:spcPts val="80"/>
-              </a:spcAft>
-              <a:buNone/>
-            </a:pPr>
-            <a:r>
-              <a:rPr lang="en-US" sz="1300" b="1" dirty="0">
-                <a:solidFill>
-                  <a:srgbClr val="6A1B9A"/>
-                </a:solidFill>
-                <a:latin typeface="Calibri"/>
-              </a:rPr>
-              <a:t>Shreyash Wagh</a:t>
-            </a:r>
-          </a:p>
-          <a:p>
-            <a:pPr marL="0" indent="0" algn="l">
-              <a:spcBef>
-                <a:spcPts val="0"/>
-              </a:spcBef>
-              <a:spcAft>
-                <a:spcPts val="0"/>
-              </a:spcAft>
-              <a:buNone/>
-            </a:pPr>
-            <a:r>
-              <a:rPr lang="en-US" sz="1050" dirty="0">
-                <a:solidFill>
-                  <a:srgbClr val="1A2421"/>
-                </a:solidFill>
-                <a:latin typeface="Calibri"/>
-              </a:rPr>
-              <a:t>Mechanical Engineering, IIT Bombay</a:t>
-            </a:r>
-          </a:p>
-        </p:txBody>
-      </p:sp>
-      <p:sp>
-        <p:nvSpPr>
-          <p:cNvPr id="59" name="m"/>
-          <p:cNvSpPr/>
-          <p:nvPr/>
-        </p:nvSpPr>
-        <p:spPr>
-          <a:xfrm>
-            <a:off x="5806440" y="2423160"/>
-            <a:ext cx="5074920" cy="914400"/>
-          </a:xfrm>
-          <a:prstGeom prst="roundRect">
-            <a:avLst>
-              <a:gd name="adj" fmla="val 8000"/>
-            </a:avLst>
-          </a:prstGeom>
-          <a:solidFill>
-            <a:srgbClr val="F3F8F1"/>
-          </a:solidFill>
-          <a:ln w="14000">
-            <a:solidFill>
-              <a:srgbClr val="EF6C00"/>
-            </a:solidFill>
-          </a:ln>
-        </p:spPr>
-        <p:txBody>
-          <a:bodyPr/>
-          <a:lstStyle/>
-          <a:p/>
-        </p:txBody>
-      </p:sp>
-      <p:sp>
-        <p:nvSpPr>
-          <p:cNvPr id="60" name="mt"/>
-          <p:cNvSpPr/>
-          <p:nvPr/>
-        </p:nvSpPr>
-        <p:spPr>
-          <a:xfrm>
-            <a:off x="5806440" y="2423160"/>
-            <a:ext cx="91440" cy="914400"/>
-          </a:xfrm>
-          <a:prstGeom prst="rect">
-            <a:avLst/>
-          </a:prstGeom>
-          <a:solidFill>
-            <a:srgbClr val="EF6C00"/>
-          </a:solidFill>
-          <a:ln>
-            <a:noFill/>
-          </a:ln>
-        </p:spPr>
-        <p:txBody>
-          <a:bodyPr/>
-          <a:lstStyle/>
-          <a:p/>
-        </p:txBody>
-      </p:sp>
-      <p:sp>
-        <p:nvSpPr>
-          <p:cNvPr id="61" name="mc"/>
-          <p:cNvSpPr txBox="1"/>
-          <p:nvPr/>
-        </p:nvSpPr>
-        <p:spPr>
-          <a:xfrm>
-            <a:off x="6025896" y="2514600"/>
-            <a:ext cx="4709160" cy="777240"/>
-          </a:xfrm>
-          <a:prstGeom prst="rect">
-            <a:avLst/>
-          </a:prstGeom>
-          <a:noFill/>
-        </p:spPr>
-        <p:txBody>
-          <a:bodyPr wrap="square" anchor="ctr" rtlCol="0">
-            <a:normAutofit/>
-          </a:bodyPr>
-          <a:lstStyle/>
-          <a:p>
-            <a:pPr marL="0" indent="0" algn="l">
-              <a:spcBef>
-                <a:spcPts val="0"/>
-              </a:spcBef>
-              <a:spcAft>
-                <a:spcPts val="80"/>
-              </a:spcAft>
-              <a:buNone/>
-            </a:pPr>
-            <a:r>
-              <a:rPr lang="en-US" sz="1300" b="1" dirty="0">
-                <a:solidFill>
-                  <a:srgbClr val="EF6C00"/>
-                </a:solidFill>
-                <a:latin typeface="Calibri"/>
-              </a:rPr>
-              <a:t>Pritish Nandy</a:t>
-            </a:r>
-          </a:p>
-          <a:p>
-            <a:pPr marL="0" indent="0" algn="l">
-              <a:spcBef>
-                <a:spcPts val="0"/>
-              </a:spcBef>
-              <a:spcAft>
-                <a:spcPts val="0"/>
-              </a:spcAft>
-              <a:buNone/>
-            </a:pPr>
-            <a:r>
-              <a:rPr lang="en-US" sz="1050" dirty="0">
-                <a:solidFill>
-                  <a:srgbClr val="1A2421"/>
-                </a:solidFill>
-                <a:latin typeface="Calibri"/>
-              </a:rPr>
-              <a:t>Aerospace Engineering, IIT Bombay</a:t>
-            </a:r>
-          </a:p>
-        </p:txBody>
-      </p:sp>
-      <p:sp>
-        <p:nvSpPr>
-          <p:cNvPr id="62" name="imp"/>
-          <p:cNvSpPr txBox="1"/>
-          <p:nvPr/>
-        </p:nvSpPr>
-        <p:spPr>
-          <a:xfrm>
-            <a:off x="502920" y="3703320"/>
-            <a:ext cx="10241280" cy="2468880"/>
+            <a:off x="548640" y="1325880"/>
+            <a:ext cx="10698480" cy="4754880"/>
           </a:xfrm>
           <a:prstGeom prst="rect">
             <a:avLst/>
@@ -3628,7 +3889,7 @@
                 </a:solidFill>
                 <a:latin typeface="Calibri"/>
               </a:rPr>
-              <a:t>Why us</a:t>
+              <a:t>Next milestones</a:t>
             </a:r>
           </a:p>
           <a:p>
@@ -3649,27 +3910,7 @@
                 </a:solidFill>
                 <a:latin typeface="Calibri"/>
               </a:rPr>
-              <a:t>An IIT Bombay team of 4 that built the full software stack, circuit design and complete mechanical fabrication - end to end.</a:t>
-            </a:r>
-          </a:p>
-          <a:p>
-            <a:pPr marL="0" indent="0" algn="l">
-              <a:spcBef>
-                <a:spcPts val="0"/>
-              </a:spcBef>
-              <a:spcAft>
-                <a:spcPts val="240"/>
-              </a:spcAft>
-              <a:buNone/>
-            </a:pPr>
-            <a:r>
-              <a:rPr lang="en-US" sz="1600" b="1" dirty="0">
-                <a:solidFill>
-                  <a:srgbClr val="2E7D32"/>
-                </a:solidFill>
-                <a:latin typeface="Calibri"/>
-              </a:rPr>
-              <a:t>Impact</a:t>
+              <a:t>Build: assemble hardware prototype (BTS7960 drive, NPK probe, pan/tilt sprayer, LiFePO4) - ~3 months.</a:t>
             </a:r>
           </a:p>
           <a:p>
@@ -3690,7 +3931,7 @@
                 </a:solidFill>
                 <a:latin typeface="Calibri"/>
               </a:rPr>
-              <a:t>Lower input cost for small farmers, less fertilizer/pesticide runoff, healthier soil and higher net income.</a:t>
+              <a:t>Test: pilot on 5-10 small farms; measure input savings, accuracy and uptime.</a:t>
             </a:r>
           </a:p>
           <a:p>
@@ -3711,7 +3952,48 @@
                 </a:solidFill>
                 <a:latin typeface="Calibri"/>
               </a:rPr>
-              <a:t>Long-term: affordable precision farming for every smallholder; shared rover fleets via FPOs.</a:t>
+              <a:t>Iterate: refine dosing + AI from field data; harden for dust and 40-45C heat.</a:t>
+            </a:r>
+          </a:p>
+          <a:p>
+            <a:pPr marL="0" indent="0" algn="l">
+              <a:spcBef>
+                <a:spcPts val="0"/>
+              </a:spcBef>
+              <a:spcAft>
+                <a:spcPts val="240"/>
+              </a:spcAft>
+              <a:buNone/>
+            </a:pPr>
+            <a:r>
+              <a:rPr lang="en-US" sz="1600" b="1" dirty="0">
+                <a:solidFill>
+                  <a:srgbClr val="2E7D32"/>
+                </a:solidFill>
+                <a:latin typeface="Calibri"/>
+              </a:rPr>
+              <a:t>Pricing (indicative)</a:t>
+            </a:r>
+          </a:p>
+          <a:p>
+            <a:pPr marL="292608" indent="-292608" algn="l">
+              <a:spcBef>
+                <a:spcPts val="0"/>
+              </a:spcBef>
+              <a:spcAft>
+                <a:spcPts val="420"/>
+              </a:spcAft>
+              <a:buFont typeface="Arial"/>
+              <a:buChar char="•"/>
+            </a:pPr>
+            <a:r>
+              <a:rPr lang="en-US" sz="1500" dirty="0">
+                <a:solidFill>
+                  <a:srgbClr val="1A2421"/>
+                </a:solidFill>
+                <a:latin typeface="Calibri"/>
+              </a:rPr>
+              <a:t>Rover sale + service, or Rover-as-a-Service via FPOs/co-ops at a per-acre fee.</a:t>
             </a:r>
           </a:p>
         </p:txBody>
@@ -3812,7 +4094,7 @@
         <p:spPr>
           <a:xfrm>
             <a:off x="548640" y="146304"/>
-            <a:ext cx="10058400" cy="777240"/>
+            <a:ext cx="10972800" cy="777240"/>
           </a:xfrm>
           <a:prstGeom prst="rect">
             <a:avLst/>
@@ -3841,7 +4123,7 @@
                 </a:solidFill>
                 <a:latin typeface="Calibri"/>
               </a:rPr>
-              <a:t>Budget Sheet  (costed BOM)</a:t>
+              <a:t>Team of 4 &amp; Impact</a:t>
             </a:r>
           </a:p>
         </p:txBody>
@@ -3855,7 +4137,7 @@
         <p:spPr>
           <a:xfrm>
             <a:off x="548640" y="6355080"/>
-            <a:ext cx="10058400" cy="365760"/>
+            <a:ext cx="10972800" cy="365760"/>
           </a:xfrm>
           <a:prstGeom prst="rect">
             <a:avLst/>
@@ -3884,7 +4166,790 @@
                 </a:solidFill>
                 <a:latin typeface="Calibri"/>
               </a:rPr>
-              <a:t>AgriRover  -  IITB-Groww INV.ENT  -  Track A  -  Team of 4</a:t>
+              <a:t>AgriRover  -  IITB-Groww INV.ENT  -  Track A  -  Team of 4 (IIT Bombay)</a:t>
+            </a:r>
+          </a:p>
+        </p:txBody>
+      </p:sp>
+      <p:sp>
+        <p:nvSpPr>
+          <p:cNvPr id="60" name="m"/>
+          <p:cNvSpPr/>
+          <p:nvPr/>
+        </p:nvSpPr>
+        <p:spPr>
+          <a:xfrm>
+            <a:off x="502920" y="1371600"/>
+            <a:ext cx="5074920" cy="914400"/>
+          </a:xfrm>
+          <a:prstGeom prst="roundRect">
+            <a:avLst>
+              <a:gd name="adj" fmla="val 8000"/>
+            </a:avLst>
+          </a:prstGeom>
+          <a:solidFill>
+            <a:srgbClr val="F3F8F1"/>
+          </a:solidFill>
+          <a:ln w="14000">
+            <a:solidFill>
+              <a:srgbClr val="2E7D32"/>
+            </a:solidFill>
+          </a:ln>
+        </p:spPr>
+        <p:txBody>
+          <a:bodyPr/>
+          <a:lstStyle/>
+          <a:p/>
+        </p:txBody>
+      </p:sp>
+      <p:sp>
+        <p:nvSpPr>
+          <p:cNvPr id="61" name="mt"/>
+          <p:cNvSpPr/>
+          <p:nvPr/>
+        </p:nvSpPr>
+        <p:spPr>
+          <a:xfrm>
+            <a:off x="502920" y="1371600"/>
+            <a:ext cx="91440" cy="914400"/>
+          </a:xfrm>
+          <a:prstGeom prst="rect">
+            <a:avLst/>
+          </a:prstGeom>
+          <a:solidFill>
+            <a:srgbClr val="2E7D32"/>
+          </a:solidFill>
+          <a:ln>
+            <a:noFill/>
+          </a:ln>
+        </p:spPr>
+        <p:txBody>
+          <a:bodyPr/>
+          <a:lstStyle/>
+          <a:p/>
+        </p:txBody>
+      </p:sp>
+      <p:sp>
+        <p:nvSpPr>
+          <p:cNvPr id="62" name="mc"/>
+          <p:cNvSpPr txBox="1"/>
+          <p:nvPr/>
+        </p:nvSpPr>
+        <p:spPr>
+          <a:xfrm>
+            <a:off x="722376" y="1463040"/>
+            <a:ext cx="4709160" cy="777240"/>
+          </a:xfrm>
+          <a:prstGeom prst="rect">
+            <a:avLst/>
+          </a:prstGeom>
+          <a:noFill/>
+        </p:spPr>
+        <p:txBody>
+          <a:bodyPr wrap="square" anchor="ctr" rtlCol="0">
+            <a:normAutofit/>
+          </a:bodyPr>
+          <a:lstStyle/>
+          <a:p>
+            <a:pPr marL="0" indent="0" algn="l">
+              <a:spcBef>
+                <a:spcPts val="0"/>
+              </a:spcBef>
+              <a:spcAft>
+                <a:spcPts val="80"/>
+              </a:spcAft>
+              <a:buNone/>
+            </a:pPr>
+            <a:r>
+              <a:rPr lang="en-US" sz="1400" b="1" dirty="0">
+                <a:solidFill>
+                  <a:srgbClr val="2E7D32"/>
+                </a:solidFill>
+                <a:latin typeface="Calibri"/>
+              </a:rPr>
+              <a:t>Hitanshu Kapadiya</a:t>
+            </a:r>
+          </a:p>
+          <a:p>
+            <a:pPr marL="0" indent="0" algn="l">
+              <a:spcBef>
+                <a:spcPts val="0"/>
+              </a:spcBef>
+              <a:spcAft>
+                <a:spcPts val="0"/>
+              </a:spcAft>
+              <a:buNone/>
+            </a:pPr>
+            <a:r>
+              <a:rPr lang="en-US" sz="1100" dirty="0">
+                <a:solidFill>
+                  <a:srgbClr val="1A2421"/>
+                </a:solidFill>
+                <a:latin typeface="Calibri"/>
+              </a:rPr>
+              <a:t>Mechanical Engineering, IIT Bombay</a:t>
+            </a:r>
+          </a:p>
+        </p:txBody>
+      </p:sp>
+      <p:sp>
+        <p:nvSpPr>
+          <p:cNvPr id="63" name="m"/>
+          <p:cNvSpPr/>
+          <p:nvPr/>
+        </p:nvSpPr>
+        <p:spPr>
+          <a:xfrm>
+            <a:off x="5806440" y="1371600"/>
+            <a:ext cx="5074920" cy="914400"/>
+          </a:xfrm>
+          <a:prstGeom prst="roundRect">
+            <a:avLst>
+              <a:gd name="adj" fmla="val 8000"/>
+            </a:avLst>
+          </a:prstGeom>
+          <a:solidFill>
+            <a:srgbClr val="F3F8F1"/>
+          </a:solidFill>
+          <a:ln w="14000">
+            <a:solidFill>
+              <a:srgbClr val="1565C0"/>
+            </a:solidFill>
+          </a:ln>
+        </p:spPr>
+        <p:txBody>
+          <a:bodyPr/>
+          <a:lstStyle/>
+          <a:p/>
+        </p:txBody>
+      </p:sp>
+      <p:sp>
+        <p:nvSpPr>
+          <p:cNvPr id="64" name="mt"/>
+          <p:cNvSpPr/>
+          <p:nvPr/>
+        </p:nvSpPr>
+        <p:spPr>
+          <a:xfrm>
+            <a:off x="5806440" y="1371600"/>
+            <a:ext cx="91440" cy="914400"/>
+          </a:xfrm>
+          <a:prstGeom prst="rect">
+            <a:avLst/>
+          </a:prstGeom>
+          <a:solidFill>
+            <a:srgbClr val="1565C0"/>
+          </a:solidFill>
+          <a:ln>
+            <a:noFill/>
+          </a:ln>
+        </p:spPr>
+        <p:txBody>
+          <a:bodyPr/>
+          <a:lstStyle/>
+          <a:p/>
+        </p:txBody>
+      </p:sp>
+      <p:sp>
+        <p:nvSpPr>
+          <p:cNvPr id="65" name="mc"/>
+          <p:cNvSpPr txBox="1"/>
+          <p:nvPr/>
+        </p:nvSpPr>
+        <p:spPr>
+          <a:xfrm>
+            <a:off x="6025896" y="1463040"/>
+            <a:ext cx="4709160" cy="777240"/>
+          </a:xfrm>
+          <a:prstGeom prst="rect">
+            <a:avLst/>
+          </a:prstGeom>
+          <a:noFill/>
+        </p:spPr>
+        <p:txBody>
+          <a:bodyPr wrap="square" anchor="ctr" rtlCol="0">
+            <a:normAutofit/>
+          </a:bodyPr>
+          <a:lstStyle/>
+          <a:p>
+            <a:pPr marL="0" indent="0" algn="l">
+              <a:spcBef>
+                <a:spcPts val="0"/>
+              </a:spcBef>
+              <a:spcAft>
+                <a:spcPts val="80"/>
+              </a:spcAft>
+              <a:buNone/>
+            </a:pPr>
+            <a:r>
+              <a:rPr lang="en-US" sz="1400" b="1" dirty="0">
+                <a:solidFill>
+                  <a:srgbClr val="1565C0"/>
+                </a:solidFill>
+                <a:latin typeface="Calibri"/>
+              </a:rPr>
+              <a:t>Vivek Gupta</a:t>
+            </a:r>
+          </a:p>
+          <a:p>
+            <a:pPr marL="0" indent="0" algn="l">
+              <a:spcBef>
+                <a:spcPts val="0"/>
+              </a:spcBef>
+              <a:spcAft>
+                <a:spcPts val="0"/>
+              </a:spcAft>
+              <a:buNone/>
+            </a:pPr>
+            <a:r>
+              <a:rPr lang="en-US" sz="1100" dirty="0">
+                <a:solidFill>
+                  <a:srgbClr val="1A2421"/>
+                </a:solidFill>
+                <a:latin typeface="Calibri"/>
+              </a:rPr>
+              <a:t>Mechanical Engineering, IIT Bombay</a:t>
+            </a:r>
+          </a:p>
+        </p:txBody>
+      </p:sp>
+      <p:sp>
+        <p:nvSpPr>
+          <p:cNvPr id="66" name="m"/>
+          <p:cNvSpPr/>
+          <p:nvPr/>
+        </p:nvSpPr>
+        <p:spPr>
+          <a:xfrm>
+            <a:off x="502920" y="2423160"/>
+            <a:ext cx="5074920" cy="914400"/>
+          </a:xfrm>
+          <a:prstGeom prst="roundRect">
+            <a:avLst>
+              <a:gd name="adj" fmla="val 8000"/>
+            </a:avLst>
+          </a:prstGeom>
+          <a:solidFill>
+            <a:srgbClr val="F3F8F1"/>
+          </a:solidFill>
+          <a:ln w="14000">
+            <a:solidFill>
+              <a:srgbClr val="6A1B9A"/>
+            </a:solidFill>
+          </a:ln>
+        </p:spPr>
+        <p:txBody>
+          <a:bodyPr/>
+          <a:lstStyle/>
+          <a:p/>
+        </p:txBody>
+      </p:sp>
+      <p:sp>
+        <p:nvSpPr>
+          <p:cNvPr id="67" name="mt"/>
+          <p:cNvSpPr/>
+          <p:nvPr/>
+        </p:nvSpPr>
+        <p:spPr>
+          <a:xfrm>
+            <a:off x="502920" y="2423160"/>
+            <a:ext cx="91440" cy="914400"/>
+          </a:xfrm>
+          <a:prstGeom prst="rect">
+            <a:avLst/>
+          </a:prstGeom>
+          <a:solidFill>
+            <a:srgbClr val="6A1B9A"/>
+          </a:solidFill>
+          <a:ln>
+            <a:noFill/>
+          </a:ln>
+        </p:spPr>
+        <p:txBody>
+          <a:bodyPr/>
+          <a:lstStyle/>
+          <a:p/>
+        </p:txBody>
+      </p:sp>
+      <p:sp>
+        <p:nvSpPr>
+          <p:cNvPr id="68" name="mc"/>
+          <p:cNvSpPr txBox="1"/>
+          <p:nvPr/>
+        </p:nvSpPr>
+        <p:spPr>
+          <a:xfrm>
+            <a:off x="722376" y="2514600"/>
+            <a:ext cx="4709160" cy="777240"/>
+          </a:xfrm>
+          <a:prstGeom prst="rect">
+            <a:avLst/>
+          </a:prstGeom>
+          <a:noFill/>
+        </p:spPr>
+        <p:txBody>
+          <a:bodyPr wrap="square" anchor="ctr" rtlCol="0">
+            <a:normAutofit/>
+          </a:bodyPr>
+          <a:lstStyle/>
+          <a:p>
+            <a:pPr marL="0" indent="0" algn="l">
+              <a:spcBef>
+                <a:spcPts val="0"/>
+              </a:spcBef>
+              <a:spcAft>
+                <a:spcPts val="80"/>
+              </a:spcAft>
+              <a:buNone/>
+            </a:pPr>
+            <a:r>
+              <a:rPr lang="en-US" sz="1400" b="1" dirty="0">
+                <a:solidFill>
+                  <a:srgbClr val="6A1B9A"/>
+                </a:solidFill>
+                <a:latin typeface="Calibri"/>
+              </a:rPr>
+              <a:t>Shreyash Wagh</a:t>
+            </a:r>
+          </a:p>
+          <a:p>
+            <a:pPr marL="0" indent="0" algn="l">
+              <a:spcBef>
+                <a:spcPts val="0"/>
+              </a:spcBef>
+              <a:spcAft>
+                <a:spcPts val="0"/>
+              </a:spcAft>
+              <a:buNone/>
+            </a:pPr>
+            <a:r>
+              <a:rPr lang="en-US" sz="1100" dirty="0">
+                <a:solidFill>
+                  <a:srgbClr val="1A2421"/>
+                </a:solidFill>
+                <a:latin typeface="Calibri"/>
+              </a:rPr>
+              <a:t>Mechanical Engineering, IIT Bombay</a:t>
+            </a:r>
+          </a:p>
+        </p:txBody>
+      </p:sp>
+      <p:sp>
+        <p:nvSpPr>
+          <p:cNvPr id="69" name="m"/>
+          <p:cNvSpPr/>
+          <p:nvPr/>
+        </p:nvSpPr>
+        <p:spPr>
+          <a:xfrm>
+            <a:off x="5806440" y="2423160"/>
+            <a:ext cx="5074920" cy="914400"/>
+          </a:xfrm>
+          <a:prstGeom prst="roundRect">
+            <a:avLst>
+              <a:gd name="adj" fmla="val 8000"/>
+            </a:avLst>
+          </a:prstGeom>
+          <a:solidFill>
+            <a:srgbClr val="F3F8F1"/>
+          </a:solidFill>
+          <a:ln w="14000">
+            <a:solidFill>
+              <a:srgbClr val="EF6C00"/>
+            </a:solidFill>
+          </a:ln>
+        </p:spPr>
+        <p:txBody>
+          <a:bodyPr/>
+          <a:lstStyle/>
+          <a:p/>
+        </p:txBody>
+      </p:sp>
+      <p:sp>
+        <p:nvSpPr>
+          <p:cNvPr id="70" name="mt"/>
+          <p:cNvSpPr/>
+          <p:nvPr/>
+        </p:nvSpPr>
+        <p:spPr>
+          <a:xfrm>
+            <a:off x="5806440" y="2423160"/>
+            <a:ext cx="91440" cy="914400"/>
+          </a:xfrm>
+          <a:prstGeom prst="rect">
+            <a:avLst/>
+          </a:prstGeom>
+          <a:solidFill>
+            <a:srgbClr val="EF6C00"/>
+          </a:solidFill>
+          <a:ln>
+            <a:noFill/>
+          </a:ln>
+        </p:spPr>
+        <p:txBody>
+          <a:bodyPr/>
+          <a:lstStyle/>
+          <a:p/>
+        </p:txBody>
+      </p:sp>
+      <p:sp>
+        <p:nvSpPr>
+          <p:cNvPr id="71" name="mc"/>
+          <p:cNvSpPr txBox="1"/>
+          <p:nvPr/>
+        </p:nvSpPr>
+        <p:spPr>
+          <a:xfrm>
+            <a:off x="6025896" y="2514600"/>
+            <a:ext cx="4709160" cy="777240"/>
+          </a:xfrm>
+          <a:prstGeom prst="rect">
+            <a:avLst/>
+          </a:prstGeom>
+          <a:noFill/>
+        </p:spPr>
+        <p:txBody>
+          <a:bodyPr wrap="square" anchor="ctr" rtlCol="0">
+            <a:normAutofit/>
+          </a:bodyPr>
+          <a:lstStyle/>
+          <a:p>
+            <a:pPr marL="0" indent="0" algn="l">
+              <a:spcBef>
+                <a:spcPts val="0"/>
+              </a:spcBef>
+              <a:spcAft>
+                <a:spcPts val="80"/>
+              </a:spcAft>
+              <a:buNone/>
+            </a:pPr>
+            <a:r>
+              <a:rPr lang="en-US" sz="1400" b="1" dirty="0">
+                <a:solidFill>
+                  <a:srgbClr val="EF6C00"/>
+                </a:solidFill>
+                <a:latin typeface="Calibri"/>
+              </a:rPr>
+              <a:t>Pritish Nandy</a:t>
+            </a:r>
+          </a:p>
+          <a:p>
+            <a:pPr marL="0" indent="0" algn="l">
+              <a:spcBef>
+                <a:spcPts val="0"/>
+              </a:spcBef>
+              <a:spcAft>
+                <a:spcPts val="0"/>
+              </a:spcAft>
+              <a:buNone/>
+            </a:pPr>
+            <a:r>
+              <a:rPr lang="en-US" sz="1100" dirty="0">
+                <a:solidFill>
+                  <a:srgbClr val="1A2421"/>
+                </a:solidFill>
+                <a:latin typeface="Calibri"/>
+              </a:rPr>
+              <a:t>Aerospace Engineering, IIT Bombay</a:t>
+            </a:r>
+          </a:p>
+        </p:txBody>
+      </p:sp>
+      <p:sp>
+        <p:nvSpPr>
+          <p:cNvPr id="72" name="imp"/>
+          <p:cNvSpPr txBox="1"/>
+          <p:nvPr/>
+        </p:nvSpPr>
+        <p:spPr>
+          <a:xfrm>
+            <a:off x="502920" y="3703320"/>
+            <a:ext cx="10698480" cy="2468880"/>
+          </a:xfrm>
+          <a:prstGeom prst="rect">
+            <a:avLst/>
+          </a:prstGeom>
+          <a:noFill/>
+        </p:spPr>
+        <p:txBody>
+          <a:bodyPr wrap="square" anchor="t" rtlCol="0">
+            <a:normAutofit/>
+          </a:bodyPr>
+          <a:lstStyle/>
+          <a:p>
+            <a:pPr marL="0" indent="0" algn="l">
+              <a:spcBef>
+                <a:spcPts val="0"/>
+              </a:spcBef>
+              <a:spcAft>
+                <a:spcPts val="240"/>
+              </a:spcAft>
+              <a:buNone/>
+            </a:pPr>
+            <a:r>
+              <a:rPr lang="en-US" sz="1600" b="1" dirty="0">
+                <a:solidFill>
+                  <a:srgbClr val="2E7D32"/>
+                </a:solidFill>
+                <a:latin typeface="Calibri"/>
+              </a:rPr>
+              <a:t>Why us</a:t>
+            </a:r>
+          </a:p>
+          <a:p>
+            <a:pPr marL="292608" indent="-292608" algn="l">
+              <a:spcBef>
+                <a:spcPts val="0"/>
+              </a:spcBef>
+              <a:spcAft>
+                <a:spcPts val="420"/>
+              </a:spcAft>
+              <a:buFont typeface="Arial"/>
+              <a:buChar char="•"/>
+            </a:pPr>
+            <a:r>
+              <a:rPr lang="en-US" sz="1500" dirty="0">
+                <a:solidFill>
+                  <a:srgbClr val="1A2421"/>
+                </a:solidFill>
+                <a:latin typeface="Calibri"/>
+              </a:rPr>
+              <a:t>An IIT Bombay team of 4 that built the full software stack, circuit design and complete mechanical fabrication - end to end.</a:t>
+            </a:r>
+          </a:p>
+          <a:p>
+            <a:pPr marL="0" indent="0" algn="l">
+              <a:spcBef>
+                <a:spcPts val="0"/>
+              </a:spcBef>
+              <a:spcAft>
+                <a:spcPts val="240"/>
+              </a:spcAft>
+              <a:buNone/>
+            </a:pPr>
+            <a:r>
+              <a:rPr lang="en-US" sz="1600" b="1" dirty="0">
+                <a:solidFill>
+                  <a:srgbClr val="2E7D32"/>
+                </a:solidFill>
+                <a:latin typeface="Calibri"/>
+              </a:rPr>
+              <a:t>Impact</a:t>
+            </a:r>
+          </a:p>
+          <a:p>
+            <a:pPr marL="292608" indent="-292608" algn="l">
+              <a:spcBef>
+                <a:spcPts val="0"/>
+              </a:spcBef>
+              <a:spcAft>
+                <a:spcPts val="420"/>
+              </a:spcAft>
+              <a:buFont typeface="Arial"/>
+              <a:buChar char="•"/>
+            </a:pPr>
+            <a:r>
+              <a:rPr lang="en-US" sz="1500" dirty="0">
+                <a:solidFill>
+                  <a:srgbClr val="1A2421"/>
+                </a:solidFill>
+                <a:latin typeface="Calibri"/>
+              </a:rPr>
+              <a:t>Lower input cost for small farmers, less fertilizer/pesticide runoff, healthier soil and higher net income.</a:t>
+            </a:r>
+          </a:p>
+          <a:p>
+            <a:pPr marL="292608" indent="-292608" algn="l">
+              <a:spcBef>
+                <a:spcPts val="0"/>
+              </a:spcBef>
+              <a:spcAft>
+                <a:spcPts val="420"/>
+              </a:spcAft>
+              <a:buFont typeface="Arial"/>
+              <a:buChar char="•"/>
+            </a:pPr>
+            <a:r>
+              <a:rPr lang="en-US" sz="1500" dirty="0">
+                <a:solidFill>
+                  <a:srgbClr val="1A2421"/>
+                </a:solidFill>
+                <a:latin typeface="Calibri"/>
+              </a:rPr>
+              <a:t>Long-term: affordable precision farming for every smallholder; shared rover fleets via FPOs.</a:t>
+            </a:r>
+          </a:p>
+        </p:txBody>
+      </p:sp>
+    </p:spTree>
+  </p:cSld>
+  <p:clrMapOvr>
+    <a:masterClrMapping/>
+  </p:clrMapOvr>
+</p:sld>
+</file>
+
+<file path=ppt/slides/slide9.xml><?xml version="1.0" encoding="utf-8"?>
+<p:sld xmlns:a="http://schemas.openxmlformats.org/drawingml/2006/main" xmlns:r="http://schemas.openxmlformats.org/officeDocument/2006/relationships" xmlns:p="http://schemas.openxmlformats.org/presentationml/2006/main">
+  <p:cSld>
+    <p:bg>
+      <p:bgPr>
+        <a:solidFill>
+          <a:srgbClr val="FFFFFF"/>
+        </a:solidFill>
+        <a:effectLst/>
+      </p:bgPr>
+    </p:bg>
+    <p:spTree>
+      <p:nvGrpSpPr>
+        <p:cNvPr id="1" name=""/>
+        <p:cNvGrpSpPr/>
+        <p:nvPr/>
+      </p:nvGrpSpPr>
+      <p:grpSpPr>
+        <a:xfrm>
+          <a:off x="0" y="0"/>
+          <a:ext cx="0" cy="0"/>
+          <a:chOff x="0" y="0"/>
+          <a:chExt cx="0" cy="0"/>
+        </a:xfrm>
+      </p:grpSpPr>
+      <p:sp>
+        <p:nvSpPr>
+          <p:cNvPr id="10" name="band"/>
+          <p:cNvSpPr/>
+          <p:nvPr/>
+        </p:nvSpPr>
+        <p:spPr>
+          <a:xfrm>
+            <a:off x="0" y="0"/>
+            <a:ext cx="12192000" cy="1051560"/>
+          </a:xfrm>
+          <a:prstGeom prst="rect">
+            <a:avLst/>
+          </a:prstGeom>
+          <a:solidFill>
+            <a:srgbClr val="2E7D32"/>
+          </a:solidFill>
+          <a:ln>
+            <a:noFill/>
+          </a:ln>
+        </p:spPr>
+        <p:txBody>
+          <a:bodyPr/>
+          <a:lstStyle/>
+          <a:p/>
+        </p:txBody>
+      </p:sp>
+      <p:sp>
+        <p:nvSpPr>
+          <p:cNvPr id="11" name="accent"/>
+          <p:cNvSpPr/>
+          <p:nvPr/>
+        </p:nvSpPr>
+        <p:spPr>
+          <a:xfrm>
+            <a:off x="0" y="1051560"/>
+            <a:ext cx="12192000" cy="54864"/>
+          </a:xfrm>
+          <a:prstGeom prst="rect">
+            <a:avLst/>
+          </a:prstGeom>
+          <a:solidFill>
+            <a:srgbClr val="F9A825"/>
+          </a:solidFill>
+          <a:ln>
+            <a:noFill/>
+          </a:ln>
+        </p:spPr>
+        <p:txBody>
+          <a:bodyPr/>
+          <a:lstStyle/>
+          <a:p/>
+        </p:txBody>
+      </p:sp>
+      <p:sp>
+        <p:nvSpPr>
+          <p:cNvPr id="12" name="title"/>
+          <p:cNvSpPr txBox="1"/>
+          <p:nvPr/>
+        </p:nvSpPr>
+        <p:spPr>
+          <a:xfrm>
+            <a:off x="548640" y="146304"/>
+            <a:ext cx="10972800" cy="777240"/>
+          </a:xfrm>
+          <a:prstGeom prst="rect">
+            <a:avLst/>
+          </a:prstGeom>
+          <a:noFill/>
+        </p:spPr>
+        <p:txBody>
+          <a:bodyPr wrap="square" anchor="ctr" rtlCol="0">
+            <a:normAutofit/>
+          </a:bodyPr>
+          <a:lstStyle/>
+          <a:p>
+            <a:pPr marL="0" indent="0" algn="l">
+              <a:spcBef>
+                <a:spcPts val="0"/>
+              </a:spcBef>
+              <a:spcAft>
+                <a:spcPts val="600"/>
+              </a:spcAft>
+              <a:buNone/>
+            </a:pPr>
+            <a:r>
+              <a:rPr lang="en-US" sz="2800" b="1" dirty="0">
+                <a:solidFill>
+                  <a:srgbClr val="FFFFFF"/>
+                </a:solidFill>
+                <a:latin typeface="Calibri"/>
+              </a:rPr>
+              <a:t>Budget Sheet  (costed BOM)</a:t>
+            </a:r>
+          </a:p>
+        </p:txBody>
+      </p:sp>
+      <p:sp>
+        <p:nvSpPr>
+          <p:cNvPr id="13" name="foot"/>
+          <p:cNvSpPr txBox="1"/>
+          <p:nvPr/>
+        </p:nvSpPr>
+        <p:spPr>
+          <a:xfrm>
+            <a:off x="548640" y="6355080"/>
+            <a:ext cx="10972800" cy="365760"/>
+          </a:xfrm>
+          <a:prstGeom prst="rect">
+            <a:avLst/>
+          </a:prstGeom>
+          <a:noFill/>
+        </p:spPr>
+        <p:txBody>
+          <a:bodyPr wrap="square" anchor="t" rtlCol="0">
+            <a:normAutofit/>
+          </a:bodyPr>
+          <a:lstStyle/>
+          <a:p>
+            <a:pPr marL="0" indent="0" algn="l">
+              <a:spcBef>
+                <a:spcPts val="0"/>
+              </a:spcBef>
+              <a:spcAft>
+                <a:spcPts val="600"/>
+              </a:spcAft>
+              <a:buNone/>
+            </a:pPr>
+            <a:r>
+              <a:rPr lang="en-US" sz="1000" dirty="0">
+                <a:solidFill>
+                  <a:srgbClr val="5B6B63"/>
+                </a:solidFill>
+                <a:latin typeface="Calibri"/>
+              </a:rPr>
+              <a:t>AgriRover  -  IITB-Groww INV.ENT  -  Track A  -  Team of 4 (IIT Bombay)</a:t>
             </a:r>
           </a:p>
         </p:txBody>
@@ -4642,7 +5707,7 @@
         <p:spPr>
           <a:xfrm>
             <a:off x="6537960" y="1371600"/>
-            <a:ext cx="4160520" cy="3246120"/>
+            <a:ext cx="4526280" cy="3246120"/>
           </a:xfrm>
           <a:prstGeom prst="roundRect">
             <a:avLst>
@@ -4673,7 +5738,7 @@
         <p:spPr>
           <a:xfrm>
             <a:off x="6766560" y="1554480"/>
-            <a:ext cx="3749040" cy="2926080"/>
+            <a:ext cx="4114800" cy="2926080"/>
           </a:xfrm>
           <a:prstGeom prst="rect">
             <a:avLst/>
@@ -4836,7 +5901,7 @@
         <p:spPr>
           <a:xfrm>
             <a:off x="6537960" y="4800600"/>
-            <a:ext cx="4160520" cy="1371600"/>
+            <a:ext cx="4526280" cy="1371600"/>
           </a:xfrm>
           <a:prstGeom prst="rect">
             <a:avLst/>

</xml_diff>

<commit_message>
Add 'Projected Impact & Scale (Simulation)' slide with bar charts + KPI bars
</commit_message>
<xml_diff>
--- a/AgriRover_Pitch.pptx
+++ b/AgriRover_Pitch.pptx
@@ -16,6 +16,7 @@
     <p:sldId id="264" r:id="rId10"/>
     <p:sldId id="265" r:id="rId11"/>
     <p:sldId id="266" r:id="rId12"/>
+    <p:sldId id="267" r:id="rId13"/>
   </p:sldIdLst>
   <p:sldSz cx="12192000" cy="6858000"/>
   <p:notesSz cx="6858000" cy="9144000"/>
@@ -457,7 +458,7 @@
                 </a:solidFill>
                 <a:latin typeface="Calibri"/>
               </a:rPr>
-              <a:t>Team of 4 &amp; Impact</a:t>
+              <a:t>Execution &amp; Next Milestones</a:t>
             </a:r>
           </a:p>
         </p:txBody>
@@ -507,498 +508,14 @@
       </p:sp>
       <p:sp>
         <p:nvSpPr>
-          <p:cNvPr id="60" name="m"/>
-          <p:cNvSpPr/>
-          <p:nvPr/>
-        </p:nvSpPr>
-        <p:spPr>
-          <a:xfrm>
-            <a:off x="502920" y="1371600"/>
-            <a:ext cx="5074920" cy="914400"/>
-          </a:xfrm>
-          <a:prstGeom prst="roundRect">
-            <a:avLst>
-              <a:gd name="adj" fmla="val 8000"/>
-            </a:avLst>
-          </a:prstGeom>
-          <a:solidFill>
-            <a:srgbClr val="F3F8F1"/>
-          </a:solidFill>
-          <a:ln w="14000">
-            <a:solidFill>
-              <a:srgbClr val="2E7D32"/>
-            </a:solidFill>
-          </a:ln>
-        </p:spPr>
-        <p:txBody>
-          <a:bodyPr/>
-          <a:lstStyle/>
-          <a:p/>
-        </p:txBody>
-      </p:sp>
-      <p:sp>
-        <p:nvSpPr>
-          <p:cNvPr id="61" name="mt"/>
-          <p:cNvSpPr/>
-          <p:nvPr/>
-        </p:nvSpPr>
-        <p:spPr>
-          <a:xfrm>
-            <a:off x="502920" y="1371600"/>
-            <a:ext cx="91440" cy="914400"/>
-          </a:xfrm>
-          <a:prstGeom prst="rect">
-            <a:avLst/>
-          </a:prstGeom>
-          <a:solidFill>
-            <a:srgbClr val="2E7D32"/>
-          </a:solidFill>
-          <a:ln>
-            <a:noFill/>
-          </a:ln>
-        </p:spPr>
-        <p:txBody>
-          <a:bodyPr/>
-          <a:lstStyle/>
-          <a:p/>
-        </p:txBody>
-      </p:sp>
-      <p:sp>
-        <p:nvSpPr>
-          <p:cNvPr id="62" name="mc"/>
+          <p:cNvPr id="30" name="b"/>
           <p:cNvSpPr txBox="1"/>
           <p:nvPr/>
         </p:nvSpPr>
         <p:spPr>
           <a:xfrm>
-            <a:off x="722376" y="1463040"/>
-            <a:ext cx="4709160" cy="777240"/>
-          </a:xfrm>
-          <a:prstGeom prst="rect">
-            <a:avLst/>
-          </a:prstGeom>
-          <a:noFill/>
-        </p:spPr>
-        <p:txBody>
-          <a:bodyPr wrap="square" anchor="ctr" rtlCol="0">
-            <a:normAutofit/>
-          </a:bodyPr>
-          <a:lstStyle/>
-          <a:p>
-            <a:pPr marL="0" indent="0" algn="l">
-              <a:spcBef>
-                <a:spcPts val="0"/>
-              </a:spcBef>
-              <a:spcAft>
-                <a:spcPts val="80"/>
-              </a:spcAft>
-              <a:buNone/>
-            </a:pPr>
-            <a:r>
-              <a:rPr lang="en-US" sz="1400" b="1" dirty="0">
-                <a:solidFill>
-                  <a:srgbClr val="2E7D32"/>
-                </a:solidFill>
-                <a:latin typeface="Calibri"/>
-              </a:rPr>
-              <a:t>Hitanshu Kapadiya</a:t>
-            </a:r>
-          </a:p>
-          <a:p>
-            <a:pPr marL="0" indent="0" algn="l">
-              <a:spcBef>
-                <a:spcPts val="0"/>
-              </a:spcBef>
-              <a:spcAft>
-                <a:spcPts val="0"/>
-              </a:spcAft>
-              <a:buNone/>
-            </a:pPr>
-            <a:r>
-              <a:rPr lang="en-US" sz="1100" dirty="0">
-                <a:solidFill>
-                  <a:srgbClr val="1A2421"/>
-                </a:solidFill>
-                <a:latin typeface="Calibri"/>
-              </a:rPr>
-              <a:t>Mechanical Engineering, IIT Bombay</a:t>
-            </a:r>
-          </a:p>
-        </p:txBody>
-      </p:sp>
-      <p:sp>
-        <p:nvSpPr>
-          <p:cNvPr id="63" name="m"/>
-          <p:cNvSpPr/>
-          <p:nvPr/>
-        </p:nvSpPr>
-        <p:spPr>
-          <a:xfrm>
-            <a:off x="5806440" y="1371600"/>
-            <a:ext cx="5074920" cy="914400"/>
-          </a:xfrm>
-          <a:prstGeom prst="roundRect">
-            <a:avLst>
-              <a:gd name="adj" fmla="val 8000"/>
-            </a:avLst>
-          </a:prstGeom>
-          <a:solidFill>
-            <a:srgbClr val="F3F8F1"/>
-          </a:solidFill>
-          <a:ln w="14000">
-            <a:solidFill>
-              <a:srgbClr val="1565C0"/>
-            </a:solidFill>
-          </a:ln>
-        </p:spPr>
-        <p:txBody>
-          <a:bodyPr/>
-          <a:lstStyle/>
-          <a:p/>
-        </p:txBody>
-      </p:sp>
-      <p:sp>
-        <p:nvSpPr>
-          <p:cNvPr id="64" name="mt"/>
-          <p:cNvSpPr/>
-          <p:nvPr/>
-        </p:nvSpPr>
-        <p:spPr>
-          <a:xfrm>
-            <a:off x="5806440" y="1371600"/>
-            <a:ext cx="91440" cy="914400"/>
-          </a:xfrm>
-          <a:prstGeom prst="rect">
-            <a:avLst/>
-          </a:prstGeom>
-          <a:solidFill>
-            <a:srgbClr val="1565C0"/>
-          </a:solidFill>
-          <a:ln>
-            <a:noFill/>
-          </a:ln>
-        </p:spPr>
-        <p:txBody>
-          <a:bodyPr/>
-          <a:lstStyle/>
-          <a:p/>
-        </p:txBody>
-      </p:sp>
-      <p:sp>
-        <p:nvSpPr>
-          <p:cNvPr id="65" name="mc"/>
-          <p:cNvSpPr txBox="1"/>
-          <p:nvPr/>
-        </p:nvSpPr>
-        <p:spPr>
-          <a:xfrm>
-            <a:off x="6025896" y="1463040"/>
-            <a:ext cx="4709160" cy="777240"/>
-          </a:xfrm>
-          <a:prstGeom prst="rect">
-            <a:avLst/>
-          </a:prstGeom>
-          <a:noFill/>
-        </p:spPr>
-        <p:txBody>
-          <a:bodyPr wrap="square" anchor="ctr" rtlCol="0">
-            <a:normAutofit/>
-          </a:bodyPr>
-          <a:lstStyle/>
-          <a:p>
-            <a:pPr marL="0" indent="0" algn="l">
-              <a:spcBef>
-                <a:spcPts val="0"/>
-              </a:spcBef>
-              <a:spcAft>
-                <a:spcPts val="80"/>
-              </a:spcAft>
-              <a:buNone/>
-            </a:pPr>
-            <a:r>
-              <a:rPr lang="en-US" sz="1400" b="1" dirty="0">
-                <a:solidFill>
-                  <a:srgbClr val="1565C0"/>
-                </a:solidFill>
-                <a:latin typeface="Calibri"/>
-              </a:rPr>
-              <a:t>Vivek Gupta</a:t>
-            </a:r>
-          </a:p>
-          <a:p>
-            <a:pPr marL="0" indent="0" algn="l">
-              <a:spcBef>
-                <a:spcPts val="0"/>
-              </a:spcBef>
-              <a:spcAft>
-                <a:spcPts val="0"/>
-              </a:spcAft>
-              <a:buNone/>
-            </a:pPr>
-            <a:r>
-              <a:rPr lang="en-US" sz="1100" dirty="0">
-                <a:solidFill>
-                  <a:srgbClr val="1A2421"/>
-                </a:solidFill>
-                <a:latin typeface="Calibri"/>
-              </a:rPr>
-              <a:t>Mechanical Engineering, IIT Bombay</a:t>
-            </a:r>
-          </a:p>
-        </p:txBody>
-      </p:sp>
-      <p:sp>
-        <p:nvSpPr>
-          <p:cNvPr id="66" name="m"/>
-          <p:cNvSpPr/>
-          <p:nvPr/>
-        </p:nvSpPr>
-        <p:spPr>
-          <a:xfrm>
-            <a:off x="502920" y="2423160"/>
-            <a:ext cx="5074920" cy="914400"/>
-          </a:xfrm>
-          <a:prstGeom prst="roundRect">
-            <a:avLst>
-              <a:gd name="adj" fmla="val 8000"/>
-            </a:avLst>
-          </a:prstGeom>
-          <a:solidFill>
-            <a:srgbClr val="F3F8F1"/>
-          </a:solidFill>
-          <a:ln w="14000">
-            <a:solidFill>
-              <a:srgbClr val="6A1B9A"/>
-            </a:solidFill>
-          </a:ln>
-        </p:spPr>
-        <p:txBody>
-          <a:bodyPr/>
-          <a:lstStyle/>
-          <a:p/>
-        </p:txBody>
-      </p:sp>
-      <p:sp>
-        <p:nvSpPr>
-          <p:cNvPr id="67" name="mt"/>
-          <p:cNvSpPr/>
-          <p:nvPr/>
-        </p:nvSpPr>
-        <p:spPr>
-          <a:xfrm>
-            <a:off x="502920" y="2423160"/>
-            <a:ext cx="91440" cy="914400"/>
-          </a:xfrm>
-          <a:prstGeom prst="rect">
-            <a:avLst/>
-          </a:prstGeom>
-          <a:solidFill>
-            <a:srgbClr val="6A1B9A"/>
-          </a:solidFill>
-          <a:ln>
-            <a:noFill/>
-          </a:ln>
-        </p:spPr>
-        <p:txBody>
-          <a:bodyPr/>
-          <a:lstStyle/>
-          <a:p/>
-        </p:txBody>
-      </p:sp>
-      <p:sp>
-        <p:nvSpPr>
-          <p:cNvPr id="68" name="mc"/>
-          <p:cNvSpPr txBox="1"/>
-          <p:nvPr/>
-        </p:nvSpPr>
-        <p:spPr>
-          <a:xfrm>
-            <a:off x="722376" y="2514600"/>
-            <a:ext cx="4709160" cy="777240"/>
-          </a:xfrm>
-          <a:prstGeom prst="rect">
-            <a:avLst/>
-          </a:prstGeom>
-          <a:noFill/>
-        </p:spPr>
-        <p:txBody>
-          <a:bodyPr wrap="square" anchor="ctr" rtlCol="0">
-            <a:normAutofit/>
-          </a:bodyPr>
-          <a:lstStyle/>
-          <a:p>
-            <a:pPr marL="0" indent="0" algn="l">
-              <a:spcBef>
-                <a:spcPts val="0"/>
-              </a:spcBef>
-              <a:spcAft>
-                <a:spcPts val="80"/>
-              </a:spcAft>
-              <a:buNone/>
-            </a:pPr>
-            <a:r>
-              <a:rPr lang="en-US" sz="1400" b="1" dirty="0">
-                <a:solidFill>
-                  <a:srgbClr val="6A1B9A"/>
-                </a:solidFill>
-                <a:latin typeface="Calibri"/>
-              </a:rPr>
-              <a:t>Shreyash Wagh</a:t>
-            </a:r>
-          </a:p>
-          <a:p>
-            <a:pPr marL="0" indent="0" algn="l">
-              <a:spcBef>
-                <a:spcPts val="0"/>
-              </a:spcBef>
-              <a:spcAft>
-                <a:spcPts val="0"/>
-              </a:spcAft>
-              <a:buNone/>
-            </a:pPr>
-            <a:r>
-              <a:rPr lang="en-US" sz="1100" dirty="0">
-                <a:solidFill>
-                  <a:srgbClr val="1A2421"/>
-                </a:solidFill>
-                <a:latin typeface="Calibri"/>
-              </a:rPr>
-              <a:t>Mechanical Engineering, IIT Bombay</a:t>
-            </a:r>
-          </a:p>
-        </p:txBody>
-      </p:sp>
-      <p:sp>
-        <p:nvSpPr>
-          <p:cNvPr id="69" name="m"/>
-          <p:cNvSpPr/>
-          <p:nvPr/>
-        </p:nvSpPr>
-        <p:spPr>
-          <a:xfrm>
-            <a:off x="5806440" y="2423160"/>
-            <a:ext cx="5074920" cy="914400"/>
-          </a:xfrm>
-          <a:prstGeom prst="roundRect">
-            <a:avLst>
-              <a:gd name="adj" fmla="val 8000"/>
-            </a:avLst>
-          </a:prstGeom>
-          <a:solidFill>
-            <a:srgbClr val="F3F8F1"/>
-          </a:solidFill>
-          <a:ln w="14000">
-            <a:solidFill>
-              <a:srgbClr val="EF6C00"/>
-            </a:solidFill>
-          </a:ln>
-        </p:spPr>
-        <p:txBody>
-          <a:bodyPr/>
-          <a:lstStyle/>
-          <a:p/>
-        </p:txBody>
-      </p:sp>
-      <p:sp>
-        <p:nvSpPr>
-          <p:cNvPr id="70" name="mt"/>
-          <p:cNvSpPr/>
-          <p:nvPr/>
-        </p:nvSpPr>
-        <p:spPr>
-          <a:xfrm>
-            <a:off x="5806440" y="2423160"/>
-            <a:ext cx="91440" cy="914400"/>
-          </a:xfrm>
-          <a:prstGeom prst="rect">
-            <a:avLst/>
-          </a:prstGeom>
-          <a:solidFill>
-            <a:srgbClr val="EF6C00"/>
-          </a:solidFill>
-          <a:ln>
-            <a:noFill/>
-          </a:ln>
-        </p:spPr>
-        <p:txBody>
-          <a:bodyPr/>
-          <a:lstStyle/>
-          <a:p/>
-        </p:txBody>
-      </p:sp>
-      <p:sp>
-        <p:nvSpPr>
-          <p:cNvPr id="71" name="mc"/>
-          <p:cNvSpPr txBox="1"/>
-          <p:nvPr/>
-        </p:nvSpPr>
-        <p:spPr>
-          <a:xfrm>
-            <a:off x="6025896" y="2514600"/>
-            <a:ext cx="4709160" cy="777240"/>
-          </a:xfrm>
-          <a:prstGeom prst="rect">
-            <a:avLst/>
-          </a:prstGeom>
-          <a:noFill/>
-        </p:spPr>
-        <p:txBody>
-          <a:bodyPr wrap="square" anchor="ctr" rtlCol="0">
-            <a:normAutofit/>
-          </a:bodyPr>
-          <a:lstStyle/>
-          <a:p>
-            <a:pPr marL="0" indent="0" algn="l">
-              <a:spcBef>
-                <a:spcPts val="0"/>
-              </a:spcBef>
-              <a:spcAft>
-                <a:spcPts val="80"/>
-              </a:spcAft>
-              <a:buNone/>
-            </a:pPr>
-            <a:r>
-              <a:rPr lang="en-US" sz="1400" b="1" dirty="0">
-                <a:solidFill>
-                  <a:srgbClr val="EF6C00"/>
-                </a:solidFill>
-                <a:latin typeface="Calibri"/>
-              </a:rPr>
-              <a:t>Pritish Nandy</a:t>
-            </a:r>
-          </a:p>
-          <a:p>
-            <a:pPr marL="0" indent="0" algn="l">
-              <a:spcBef>
-                <a:spcPts val="0"/>
-              </a:spcBef>
-              <a:spcAft>
-                <a:spcPts val="0"/>
-              </a:spcAft>
-              <a:buNone/>
-            </a:pPr>
-            <a:r>
-              <a:rPr lang="en-US" sz="1100" dirty="0">
-                <a:solidFill>
-                  <a:srgbClr val="1A2421"/>
-                </a:solidFill>
-                <a:latin typeface="Calibri"/>
-              </a:rPr>
-              <a:t>Aerospace Engineering, IIT Bombay</a:t>
-            </a:r>
-          </a:p>
-        </p:txBody>
-      </p:sp>
-      <p:sp>
-        <p:nvSpPr>
-          <p:cNvPr id="72" name="imp"/>
-          <p:cNvSpPr txBox="1"/>
-          <p:nvPr/>
-        </p:nvSpPr>
-        <p:spPr>
-          <a:xfrm>
-            <a:off x="502920" y="3703320"/>
-            <a:ext cx="10698480" cy="2468880"/>
+            <a:off x="548640" y="1325880"/>
+            <a:ext cx="10698480" cy="4754880"/>
           </a:xfrm>
           <a:prstGeom prst="rect">
             <a:avLst/>
@@ -1027,7 +544,7 @@
                 </a:solidFill>
                 <a:latin typeface="Calibri"/>
               </a:rPr>
-              <a:t>Why us</a:t>
+              <a:t>Next milestones</a:t>
             </a:r>
           </a:p>
           <a:p>
@@ -1048,27 +565,7 @@
                 </a:solidFill>
                 <a:latin typeface="Calibri"/>
               </a:rPr>
-              <a:t>An IIT Bombay team of 4 that built the full software stack, circuit design and complete mechanical fabrication - end to end.</a:t>
-            </a:r>
-          </a:p>
-          <a:p>
-            <a:pPr marL="0" indent="0" algn="l">
-              <a:spcBef>
-                <a:spcPts val="0"/>
-              </a:spcBef>
-              <a:spcAft>
-                <a:spcPts val="220"/>
-              </a:spcAft>
-              <a:buNone/>
-            </a:pPr>
-            <a:r>
-              <a:rPr lang="en-US" sz="1600" b="1" dirty="0">
-                <a:solidFill>
-                  <a:srgbClr val="2E7D32"/>
-                </a:solidFill>
-                <a:latin typeface="Calibri"/>
-              </a:rPr>
-              <a:t>Impact</a:t>
+              <a:t>Build: assemble hardware prototype (BTS7960 drive, NPK probe, pan/tilt sprayer, LiFePO4) - ~3 months.</a:t>
             </a:r>
           </a:p>
           <a:p>
@@ -1089,7 +586,7 @@
                 </a:solidFill>
                 <a:latin typeface="Calibri"/>
               </a:rPr>
-              <a:t>Lower input cost for small farmers, less fertilizer/pesticide runoff, healthier soil and higher net income.</a:t>
+              <a:t>Test: pilot on 5-10 small farms; measure input savings, accuracy and uptime.</a:t>
             </a:r>
           </a:p>
           <a:p>
@@ -1110,7 +607,69 @@
                 </a:solidFill>
                 <a:latin typeface="Calibri"/>
               </a:rPr>
-              <a:t>Long-term: affordable precision farming for every smallholder; shared rover fleets via FPOs.</a:t>
+              <a:t>Iterate: refine dosing + AI from field data; harden for dust and 40-45C heat.</a:t>
+            </a:r>
+          </a:p>
+          <a:p>
+            <a:pPr marL="0" indent="0" algn="l">
+              <a:spcBef>
+                <a:spcPts val="0"/>
+              </a:spcBef>
+              <a:spcAft>
+                <a:spcPts val="220"/>
+              </a:spcAft>
+              <a:buNone/>
+            </a:pPr>
+            <a:r>
+              <a:rPr lang="en-US" sz="1600" b="1" dirty="0">
+                <a:solidFill>
+                  <a:srgbClr val="2E7D32"/>
+                </a:solidFill>
+                <a:latin typeface="Calibri"/>
+              </a:rPr>
+              <a:t>Go-to-market</a:t>
+            </a:r>
+          </a:p>
+          <a:p>
+            <a:pPr marL="292608" indent="-292608" algn="l">
+              <a:spcBef>
+                <a:spcPts val="0"/>
+              </a:spcBef>
+              <a:spcAft>
+                <a:spcPts val="380"/>
+              </a:spcAft>
+              <a:buFont typeface="Arial"/>
+              <a:buChar char="•"/>
+            </a:pPr>
+            <a:r>
+              <a:rPr lang="en-US" sz="1500" dirty="0">
+                <a:solidFill>
+                  <a:srgbClr val="1A2421"/>
+                </a:solidFill>
+                <a:latin typeface="Calibri"/>
+              </a:rPr>
+              <a:t>Pilot with a local FPO / Custom Hiring Centre; use SMAM/AIF support to lower farmer cost.</a:t>
+            </a:r>
+          </a:p>
+          <a:p>
+            <a:pPr marL="292608" indent="-292608" algn="l">
+              <a:spcBef>
+                <a:spcPts val="0"/>
+              </a:spcBef>
+              <a:spcAft>
+                <a:spcPts val="380"/>
+              </a:spcAft>
+              <a:buFont typeface="Arial"/>
+              <a:buChar char="•"/>
+            </a:pPr>
+            <a:r>
+              <a:rPr lang="en-US" sz="1500" dirty="0">
+                <a:solidFill>
+                  <a:srgbClr val="1A2421"/>
+                </a:solidFill>
+                <a:latin typeface="Calibri"/>
+              </a:rPr>
+              <a:t>Expand from sale to Rover-as-a-Service + data subscription.</a:t>
             </a:r>
           </a:p>
         </p:txBody>
@@ -1124,6 +683,789 @@
 </file>
 
 <file path=ppt/slides/slide11.xml><?xml version="1.0" encoding="utf-8"?>
+<p:sld xmlns:a="http://schemas.openxmlformats.org/drawingml/2006/main" xmlns:r="http://schemas.openxmlformats.org/officeDocument/2006/relationships" xmlns:p="http://schemas.openxmlformats.org/presentationml/2006/main">
+  <p:cSld>
+    <p:bg>
+      <p:bgPr>
+        <a:solidFill>
+          <a:srgbClr val="FFFFFF"/>
+        </a:solidFill>
+        <a:effectLst/>
+      </p:bgPr>
+    </p:bg>
+    <p:spTree>
+      <p:nvGrpSpPr>
+        <p:cNvPr id="1" name=""/>
+        <p:cNvGrpSpPr/>
+        <p:nvPr/>
+      </p:nvGrpSpPr>
+      <p:grpSpPr>
+        <a:xfrm>
+          <a:off x="0" y="0"/>
+          <a:ext cx="0" cy="0"/>
+          <a:chOff x="0" y="0"/>
+          <a:chExt cx="0" cy="0"/>
+        </a:xfrm>
+      </p:grpSpPr>
+      <p:sp>
+        <p:nvSpPr>
+          <p:cNvPr id="10" name="band"/>
+          <p:cNvSpPr/>
+          <p:nvPr/>
+        </p:nvSpPr>
+        <p:spPr>
+          <a:xfrm>
+            <a:off x="0" y="0"/>
+            <a:ext cx="12192000" cy="1051560"/>
+          </a:xfrm>
+          <a:prstGeom prst="rect">
+            <a:avLst/>
+          </a:prstGeom>
+          <a:solidFill>
+            <a:srgbClr val="2E7D32"/>
+          </a:solidFill>
+          <a:ln>
+            <a:noFill/>
+          </a:ln>
+        </p:spPr>
+        <p:txBody>
+          <a:bodyPr/>
+          <a:lstStyle/>
+          <a:p/>
+        </p:txBody>
+      </p:sp>
+      <p:sp>
+        <p:nvSpPr>
+          <p:cNvPr id="11" name="accent"/>
+          <p:cNvSpPr/>
+          <p:nvPr/>
+        </p:nvSpPr>
+        <p:spPr>
+          <a:xfrm>
+            <a:off x="0" y="1051560"/>
+            <a:ext cx="12192000" cy="54864"/>
+          </a:xfrm>
+          <a:prstGeom prst="rect">
+            <a:avLst/>
+          </a:prstGeom>
+          <a:solidFill>
+            <a:srgbClr val="F9A825"/>
+          </a:solidFill>
+          <a:ln>
+            <a:noFill/>
+          </a:ln>
+        </p:spPr>
+        <p:txBody>
+          <a:bodyPr/>
+          <a:lstStyle/>
+          <a:p/>
+        </p:txBody>
+      </p:sp>
+      <p:sp>
+        <p:nvSpPr>
+          <p:cNvPr id="12" name="title"/>
+          <p:cNvSpPr txBox="1"/>
+          <p:nvPr/>
+        </p:nvSpPr>
+        <p:spPr>
+          <a:xfrm>
+            <a:off x="548640" y="146304"/>
+            <a:ext cx="10972800" cy="777240"/>
+          </a:xfrm>
+          <a:prstGeom prst="rect">
+            <a:avLst/>
+          </a:prstGeom>
+          <a:noFill/>
+        </p:spPr>
+        <p:txBody>
+          <a:bodyPr wrap="square" anchor="ctr" rtlCol="0">
+            <a:normAutofit/>
+          </a:bodyPr>
+          <a:lstStyle/>
+          <a:p>
+            <a:pPr marL="0" indent="0" algn="l">
+              <a:spcBef>
+                <a:spcPts val="0"/>
+              </a:spcBef>
+              <a:spcAft>
+                <a:spcPts val="600"/>
+              </a:spcAft>
+              <a:buNone/>
+            </a:pPr>
+            <a:r>
+              <a:rPr lang="en-US" sz="2700" b="1" dirty="0">
+                <a:solidFill>
+                  <a:srgbClr val="FFFFFF"/>
+                </a:solidFill>
+                <a:latin typeface="Calibri"/>
+              </a:rPr>
+              <a:t>Team of 4 &amp; Impact</a:t>
+            </a:r>
+          </a:p>
+        </p:txBody>
+      </p:sp>
+      <p:sp>
+        <p:nvSpPr>
+          <p:cNvPr id="13" name="foot"/>
+          <p:cNvSpPr txBox="1"/>
+          <p:nvPr/>
+        </p:nvSpPr>
+        <p:spPr>
+          <a:xfrm>
+            <a:off x="548640" y="6364224"/>
+            <a:ext cx="10972800" cy="365760"/>
+          </a:xfrm>
+          <a:prstGeom prst="rect">
+            <a:avLst/>
+          </a:prstGeom>
+          <a:noFill/>
+        </p:spPr>
+        <p:txBody>
+          <a:bodyPr wrap="square" anchor="t" rtlCol="0">
+            <a:normAutofit/>
+          </a:bodyPr>
+          <a:lstStyle/>
+          <a:p>
+            <a:pPr marL="0" indent="0" algn="l">
+              <a:spcBef>
+                <a:spcPts val="0"/>
+              </a:spcBef>
+              <a:spcAft>
+                <a:spcPts val="600"/>
+              </a:spcAft>
+              <a:buNone/>
+            </a:pPr>
+            <a:r>
+              <a:rPr lang="en-US" sz="1000" dirty="0">
+                <a:solidFill>
+                  <a:srgbClr val="5B6B63"/>
+                </a:solidFill>
+                <a:latin typeface="Calibri"/>
+              </a:rPr>
+              <a:t>AgriRover  -  IITB-Groww INV.ENT  -  Track A  -  Team of 4 (IIT Bombay)</a:t>
+            </a:r>
+          </a:p>
+        </p:txBody>
+      </p:sp>
+      <p:sp>
+        <p:nvSpPr>
+          <p:cNvPr id="60" name="m"/>
+          <p:cNvSpPr/>
+          <p:nvPr/>
+        </p:nvSpPr>
+        <p:spPr>
+          <a:xfrm>
+            <a:off x="502920" y="1371600"/>
+            <a:ext cx="5074920" cy="914400"/>
+          </a:xfrm>
+          <a:prstGeom prst="roundRect">
+            <a:avLst>
+              <a:gd name="adj" fmla="val 8000"/>
+            </a:avLst>
+          </a:prstGeom>
+          <a:solidFill>
+            <a:srgbClr val="F3F8F1"/>
+          </a:solidFill>
+          <a:ln w="14000">
+            <a:solidFill>
+              <a:srgbClr val="2E7D32"/>
+            </a:solidFill>
+          </a:ln>
+        </p:spPr>
+        <p:txBody>
+          <a:bodyPr/>
+          <a:lstStyle/>
+          <a:p/>
+        </p:txBody>
+      </p:sp>
+      <p:sp>
+        <p:nvSpPr>
+          <p:cNvPr id="61" name="mt"/>
+          <p:cNvSpPr/>
+          <p:nvPr/>
+        </p:nvSpPr>
+        <p:spPr>
+          <a:xfrm>
+            <a:off x="502920" y="1371600"/>
+            <a:ext cx="91440" cy="914400"/>
+          </a:xfrm>
+          <a:prstGeom prst="rect">
+            <a:avLst/>
+          </a:prstGeom>
+          <a:solidFill>
+            <a:srgbClr val="2E7D32"/>
+          </a:solidFill>
+          <a:ln>
+            <a:noFill/>
+          </a:ln>
+        </p:spPr>
+        <p:txBody>
+          <a:bodyPr/>
+          <a:lstStyle/>
+          <a:p/>
+        </p:txBody>
+      </p:sp>
+      <p:sp>
+        <p:nvSpPr>
+          <p:cNvPr id="62" name="mc"/>
+          <p:cNvSpPr txBox="1"/>
+          <p:nvPr/>
+        </p:nvSpPr>
+        <p:spPr>
+          <a:xfrm>
+            <a:off x="722376" y="1463040"/>
+            <a:ext cx="4709160" cy="777240"/>
+          </a:xfrm>
+          <a:prstGeom prst="rect">
+            <a:avLst/>
+          </a:prstGeom>
+          <a:noFill/>
+        </p:spPr>
+        <p:txBody>
+          <a:bodyPr wrap="square" anchor="ctr" rtlCol="0">
+            <a:normAutofit/>
+          </a:bodyPr>
+          <a:lstStyle/>
+          <a:p>
+            <a:pPr marL="0" indent="0" algn="l">
+              <a:spcBef>
+                <a:spcPts val="0"/>
+              </a:spcBef>
+              <a:spcAft>
+                <a:spcPts val="80"/>
+              </a:spcAft>
+              <a:buNone/>
+            </a:pPr>
+            <a:r>
+              <a:rPr lang="en-US" sz="1400" b="1" dirty="0">
+                <a:solidFill>
+                  <a:srgbClr val="2E7D32"/>
+                </a:solidFill>
+                <a:latin typeface="Calibri"/>
+              </a:rPr>
+              <a:t>Hitanshu Kapadiya</a:t>
+            </a:r>
+          </a:p>
+          <a:p>
+            <a:pPr marL="0" indent="0" algn="l">
+              <a:spcBef>
+                <a:spcPts val="0"/>
+              </a:spcBef>
+              <a:spcAft>
+                <a:spcPts val="0"/>
+              </a:spcAft>
+              <a:buNone/>
+            </a:pPr>
+            <a:r>
+              <a:rPr lang="en-US" sz="1100" dirty="0">
+                <a:solidFill>
+                  <a:srgbClr val="1A2421"/>
+                </a:solidFill>
+                <a:latin typeface="Calibri"/>
+              </a:rPr>
+              <a:t>Mechanical Engineering, IIT Bombay</a:t>
+            </a:r>
+          </a:p>
+        </p:txBody>
+      </p:sp>
+      <p:sp>
+        <p:nvSpPr>
+          <p:cNvPr id="63" name="m"/>
+          <p:cNvSpPr/>
+          <p:nvPr/>
+        </p:nvSpPr>
+        <p:spPr>
+          <a:xfrm>
+            <a:off x="5806440" y="1371600"/>
+            <a:ext cx="5074920" cy="914400"/>
+          </a:xfrm>
+          <a:prstGeom prst="roundRect">
+            <a:avLst>
+              <a:gd name="adj" fmla="val 8000"/>
+            </a:avLst>
+          </a:prstGeom>
+          <a:solidFill>
+            <a:srgbClr val="F3F8F1"/>
+          </a:solidFill>
+          <a:ln w="14000">
+            <a:solidFill>
+              <a:srgbClr val="1565C0"/>
+            </a:solidFill>
+          </a:ln>
+        </p:spPr>
+        <p:txBody>
+          <a:bodyPr/>
+          <a:lstStyle/>
+          <a:p/>
+        </p:txBody>
+      </p:sp>
+      <p:sp>
+        <p:nvSpPr>
+          <p:cNvPr id="64" name="mt"/>
+          <p:cNvSpPr/>
+          <p:nvPr/>
+        </p:nvSpPr>
+        <p:spPr>
+          <a:xfrm>
+            <a:off x="5806440" y="1371600"/>
+            <a:ext cx="91440" cy="914400"/>
+          </a:xfrm>
+          <a:prstGeom prst="rect">
+            <a:avLst/>
+          </a:prstGeom>
+          <a:solidFill>
+            <a:srgbClr val="1565C0"/>
+          </a:solidFill>
+          <a:ln>
+            <a:noFill/>
+          </a:ln>
+        </p:spPr>
+        <p:txBody>
+          <a:bodyPr/>
+          <a:lstStyle/>
+          <a:p/>
+        </p:txBody>
+      </p:sp>
+      <p:sp>
+        <p:nvSpPr>
+          <p:cNvPr id="65" name="mc"/>
+          <p:cNvSpPr txBox="1"/>
+          <p:nvPr/>
+        </p:nvSpPr>
+        <p:spPr>
+          <a:xfrm>
+            <a:off x="6025896" y="1463040"/>
+            <a:ext cx="4709160" cy="777240"/>
+          </a:xfrm>
+          <a:prstGeom prst="rect">
+            <a:avLst/>
+          </a:prstGeom>
+          <a:noFill/>
+        </p:spPr>
+        <p:txBody>
+          <a:bodyPr wrap="square" anchor="ctr" rtlCol="0">
+            <a:normAutofit/>
+          </a:bodyPr>
+          <a:lstStyle/>
+          <a:p>
+            <a:pPr marL="0" indent="0" algn="l">
+              <a:spcBef>
+                <a:spcPts val="0"/>
+              </a:spcBef>
+              <a:spcAft>
+                <a:spcPts val="80"/>
+              </a:spcAft>
+              <a:buNone/>
+            </a:pPr>
+            <a:r>
+              <a:rPr lang="en-US" sz="1400" b="1" dirty="0">
+                <a:solidFill>
+                  <a:srgbClr val="1565C0"/>
+                </a:solidFill>
+                <a:latin typeface="Calibri"/>
+              </a:rPr>
+              <a:t>Vivek Gupta</a:t>
+            </a:r>
+          </a:p>
+          <a:p>
+            <a:pPr marL="0" indent="0" algn="l">
+              <a:spcBef>
+                <a:spcPts val="0"/>
+              </a:spcBef>
+              <a:spcAft>
+                <a:spcPts val="0"/>
+              </a:spcAft>
+              <a:buNone/>
+            </a:pPr>
+            <a:r>
+              <a:rPr lang="en-US" sz="1100" dirty="0">
+                <a:solidFill>
+                  <a:srgbClr val="1A2421"/>
+                </a:solidFill>
+                <a:latin typeface="Calibri"/>
+              </a:rPr>
+              <a:t>Mechanical Engineering, IIT Bombay</a:t>
+            </a:r>
+          </a:p>
+        </p:txBody>
+      </p:sp>
+      <p:sp>
+        <p:nvSpPr>
+          <p:cNvPr id="66" name="m"/>
+          <p:cNvSpPr/>
+          <p:nvPr/>
+        </p:nvSpPr>
+        <p:spPr>
+          <a:xfrm>
+            <a:off x="502920" y="2423160"/>
+            <a:ext cx="5074920" cy="914400"/>
+          </a:xfrm>
+          <a:prstGeom prst="roundRect">
+            <a:avLst>
+              <a:gd name="adj" fmla="val 8000"/>
+            </a:avLst>
+          </a:prstGeom>
+          <a:solidFill>
+            <a:srgbClr val="F3F8F1"/>
+          </a:solidFill>
+          <a:ln w="14000">
+            <a:solidFill>
+              <a:srgbClr val="6A1B9A"/>
+            </a:solidFill>
+          </a:ln>
+        </p:spPr>
+        <p:txBody>
+          <a:bodyPr/>
+          <a:lstStyle/>
+          <a:p/>
+        </p:txBody>
+      </p:sp>
+      <p:sp>
+        <p:nvSpPr>
+          <p:cNvPr id="67" name="mt"/>
+          <p:cNvSpPr/>
+          <p:nvPr/>
+        </p:nvSpPr>
+        <p:spPr>
+          <a:xfrm>
+            <a:off x="502920" y="2423160"/>
+            <a:ext cx="91440" cy="914400"/>
+          </a:xfrm>
+          <a:prstGeom prst="rect">
+            <a:avLst/>
+          </a:prstGeom>
+          <a:solidFill>
+            <a:srgbClr val="6A1B9A"/>
+          </a:solidFill>
+          <a:ln>
+            <a:noFill/>
+          </a:ln>
+        </p:spPr>
+        <p:txBody>
+          <a:bodyPr/>
+          <a:lstStyle/>
+          <a:p/>
+        </p:txBody>
+      </p:sp>
+      <p:sp>
+        <p:nvSpPr>
+          <p:cNvPr id="68" name="mc"/>
+          <p:cNvSpPr txBox="1"/>
+          <p:nvPr/>
+        </p:nvSpPr>
+        <p:spPr>
+          <a:xfrm>
+            <a:off x="722376" y="2514600"/>
+            <a:ext cx="4709160" cy="777240"/>
+          </a:xfrm>
+          <a:prstGeom prst="rect">
+            <a:avLst/>
+          </a:prstGeom>
+          <a:noFill/>
+        </p:spPr>
+        <p:txBody>
+          <a:bodyPr wrap="square" anchor="ctr" rtlCol="0">
+            <a:normAutofit/>
+          </a:bodyPr>
+          <a:lstStyle/>
+          <a:p>
+            <a:pPr marL="0" indent="0" algn="l">
+              <a:spcBef>
+                <a:spcPts val="0"/>
+              </a:spcBef>
+              <a:spcAft>
+                <a:spcPts val="80"/>
+              </a:spcAft>
+              <a:buNone/>
+            </a:pPr>
+            <a:r>
+              <a:rPr lang="en-US" sz="1400" b="1" dirty="0">
+                <a:solidFill>
+                  <a:srgbClr val="6A1B9A"/>
+                </a:solidFill>
+                <a:latin typeface="Calibri"/>
+              </a:rPr>
+              <a:t>Shreyash Wagh</a:t>
+            </a:r>
+          </a:p>
+          <a:p>
+            <a:pPr marL="0" indent="0" algn="l">
+              <a:spcBef>
+                <a:spcPts val="0"/>
+              </a:spcBef>
+              <a:spcAft>
+                <a:spcPts val="0"/>
+              </a:spcAft>
+              <a:buNone/>
+            </a:pPr>
+            <a:r>
+              <a:rPr lang="en-US" sz="1100" dirty="0">
+                <a:solidFill>
+                  <a:srgbClr val="1A2421"/>
+                </a:solidFill>
+                <a:latin typeface="Calibri"/>
+              </a:rPr>
+              <a:t>Mechanical Engineering, IIT Bombay</a:t>
+            </a:r>
+          </a:p>
+        </p:txBody>
+      </p:sp>
+      <p:sp>
+        <p:nvSpPr>
+          <p:cNvPr id="69" name="m"/>
+          <p:cNvSpPr/>
+          <p:nvPr/>
+        </p:nvSpPr>
+        <p:spPr>
+          <a:xfrm>
+            <a:off x="5806440" y="2423160"/>
+            <a:ext cx="5074920" cy="914400"/>
+          </a:xfrm>
+          <a:prstGeom prst="roundRect">
+            <a:avLst>
+              <a:gd name="adj" fmla="val 8000"/>
+            </a:avLst>
+          </a:prstGeom>
+          <a:solidFill>
+            <a:srgbClr val="F3F8F1"/>
+          </a:solidFill>
+          <a:ln w="14000">
+            <a:solidFill>
+              <a:srgbClr val="EF6C00"/>
+            </a:solidFill>
+          </a:ln>
+        </p:spPr>
+        <p:txBody>
+          <a:bodyPr/>
+          <a:lstStyle/>
+          <a:p/>
+        </p:txBody>
+      </p:sp>
+      <p:sp>
+        <p:nvSpPr>
+          <p:cNvPr id="70" name="mt"/>
+          <p:cNvSpPr/>
+          <p:nvPr/>
+        </p:nvSpPr>
+        <p:spPr>
+          <a:xfrm>
+            <a:off x="5806440" y="2423160"/>
+            <a:ext cx="91440" cy="914400"/>
+          </a:xfrm>
+          <a:prstGeom prst="rect">
+            <a:avLst/>
+          </a:prstGeom>
+          <a:solidFill>
+            <a:srgbClr val="EF6C00"/>
+          </a:solidFill>
+          <a:ln>
+            <a:noFill/>
+          </a:ln>
+        </p:spPr>
+        <p:txBody>
+          <a:bodyPr/>
+          <a:lstStyle/>
+          <a:p/>
+        </p:txBody>
+      </p:sp>
+      <p:sp>
+        <p:nvSpPr>
+          <p:cNvPr id="71" name="mc"/>
+          <p:cNvSpPr txBox="1"/>
+          <p:nvPr/>
+        </p:nvSpPr>
+        <p:spPr>
+          <a:xfrm>
+            <a:off x="6025896" y="2514600"/>
+            <a:ext cx="4709160" cy="777240"/>
+          </a:xfrm>
+          <a:prstGeom prst="rect">
+            <a:avLst/>
+          </a:prstGeom>
+          <a:noFill/>
+        </p:spPr>
+        <p:txBody>
+          <a:bodyPr wrap="square" anchor="ctr" rtlCol="0">
+            <a:normAutofit/>
+          </a:bodyPr>
+          <a:lstStyle/>
+          <a:p>
+            <a:pPr marL="0" indent="0" algn="l">
+              <a:spcBef>
+                <a:spcPts val="0"/>
+              </a:spcBef>
+              <a:spcAft>
+                <a:spcPts val="80"/>
+              </a:spcAft>
+              <a:buNone/>
+            </a:pPr>
+            <a:r>
+              <a:rPr lang="en-US" sz="1400" b="1" dirty="0">
+                <a:solidFill>
+                  <a:srgbClr val="EF6C00"/>
+                </a:solidFill>
+                <a:latin typeface="Calibri"/>
+              </a:rPr>
+              <a:t>Pritish Nandy</a:t>
+            </a:r>
+          </a:p>
+          <a:p>
+            <a:pPr marL="0" indent="0" algn="l">
+              <a:spcBef>
+                <a:spcPts val="0"/>
+              </a:spcBef>
+              <a:spcAft>
+                <a:spcPts val="0"/>
+              </a:spcAft>
+              <a:buNone/>
+            </a:pPr>
+            <a:r>
+              <a:rPr lang="en-US" sz="1100" dirty="0">
+                <a:solidFill>
+                  <a:srgbClr val="1A2421"/>
+                </a:solidFill>
+                <a:latin typeface="Calibri"/>
+              </a:rPr>
+              <a:t>Aerospace Engineering, IIT Bombay</a:t>
+            </a:r>
+          </a:p>
+        </p:txBody>
+      </p:sp>
+      <p:sp>
+        <p:nvSpPr>
+          <p:cNvPr id="72" name="imp"/>
+          <p:cNvSpPr txBox="1"/>
+          <p:nvPr/>
+        </p:nvSpPr>
+        <p:spPr>
+          <a:xfrm>
+            <a:off x="502920" y="3703320"/>
+            <a:ext cx="10698480" cy="2468880"/>
+          </a:xfrm>
+          <a:prstGeom prst="rect">
+            <a:avLst/>
+          </a:prstGeom>
+          <a:noFill/>
+        </p:spPr>
+        <p:txBody>
+          <a:bodyPr wrap="square" anchor="t" rtlCol="0">
+            <a:normAutofit/>
+          </a:bodyPr>
+          <a:lstStyle/>
+          <a:p>
+            <a:pPr marL="0" indent="0" algn="l">
+              <a:spcBef>
+                <a:spcPts val="0"/>
+              </a:spcBef>
+              <a:spcAft>
+                <a:spcPts val="220"/>
+              </a:spcAft>
+              <a:buNone/>
+            </a:pPr>
+            <a:r>
+              <a:rPr lang="en-US" sz="1600" b="1" dirty="0">
+                <a:solidFill>
+                  <a:srgbClr val="2E7D32"/>
+                </a:solidFill>
+                <a:latin typeface="Calibri"/>
+              </a:rPr>
+              <a:t>Why us</a:t>
+            </a:r>
+          </a:p>
+          <a:p>
+            <a:pPr marL="292608" indent="-292608" algn="l">
+              <a:spcBef>
+                <a:spcPts val="0"/>
+              </a:spcBef>
+              <a:spcAft>
+                <a:spcPts val="380"/>
+              </a:spcAft>
+              <a:buFont typeface="Arial"/>
+              <a:buChar char="•"/>
+            </a:pPr>
+            <a:r>
+              <a:rPr lang="en-US" sz="1500" dirty="0">
+                <a:solidFill>
+                  <a:srgbClr val="1A2421"/>
+                </a:solidFill>
+                <a:latin typeface="Calibri"/>
+              </a:rPr>
+              <a:t>An IIT Bombay team of 4 that built the full software stack, circuit design and complete mechanical fabrication - end to end.</a:t>
+            </a:r>
+          </a:p>
+          <a:p>
+            <a:pPr marL="0" indent="0" algn="l">
+              <a:spcBef>
+                <a:spcPts val="0"/>
+              </a:spcBef>
+              <a:spcAft>
+                <a:spcPts val="220"/>
+              </a:spcAft>
+              <a:buNone/>
+            </a:pPr>
+            <a:r>
+              <a:rPr lang="en-US" sz="1600" b="1" dirty="0">
+                <a:solidFill>
+                  <a:srgbClr val="2E7D32"/>
+                </a:solidFill>
+                <a:latin typeface="Calibri"/>
+              </a:rPr>
+              <a:t>Impact</a:t>
+            </a:r>
+          </a:p>
+          <a:p>
+            <a:pPr marL="292608" indent="-292608" algn="l">
+              <a:spcBef>
+                <a:spcPts val="0"/>
+              </a:spcBef>
+              <a:spcAft>
+                <a:spcPts val="380"/>
+              </a:spcAft>
+              <a:buFont typeface="Arial"/>
+              <a:buChar char="•"/>
+            </a:pPr>
+            <a:r>
+              <a:rPr lang="en-US" sz="1500" dirty="0">
+                <a:solidFill>
+                  <a:srgbClr val="1A2421"/>
+                </a:solidFill>
+                <a:latin typeface="Calibri"/>
+              </a:rPr>
+              <a:t>Lower input cost for small farmers, less fertilizer/pesticide runoff, healthier soil and higher net income.</a:t>
+            </a:r>
+          </a:p>
+          <a:p>
+            <a:pPr marL="292608" indent="-292608" algn="l">
+              <a:spcBef>
+                <a:spcPts val="0"/>
+              </a:spcBef>
+              <a:spcAft>
+                <a:spcPts val="380"/>
+              </a:spcAft>
+              <a:buFont typeface="Arial"/>
+              <a:buChar char="•"/>
+            </a:pPr>
+            <a:r>
+              <a:rPr lang="en-US" sz="1500" dirty="0">
+                <a:solidFill>
+                  <a:srgbClr val="1A2421"/>
+                </a:solidFill>
+                <a:latin typeface="Calibri"/>
+              </a:rPr>
+              <a:t>Long-term: affordable precision farming for every smallholder; shared rover fleets via FPOs.</a:t>
+            </a:r>
+          </a:p>
+        </p:txBody>
+      </p:sp>
+    </p:spTree>
+  </p:cSld>
+  <p:clrMapOvr>
+    <a:masterClrMapping/>
+  </p:clrMapOvr>
+</p:sld>
+</file>
+
+<file path=ppt/slides/slide12.xml><?xml version="1.0" encoding="utf-8"?>
 <p:sld xmlns:a="http://schemas.openxmlformats.org/drawingml/2006/main" xmlns:r="http://schemas.openxmlformats.org/officeDocument/2006/relationships" xmlns:p="http://schemas.openxmlformats.org/presentationml/2006/main">
   <p:cSld>
     <p:bg>
@@ -7072,7 +7414,7 @@
                 </a:solidFill>
                 <a:latin typeface="Calibri"/>
               </a:rPr>
-              <a:t>Execution &amp; Next Milestones</a:t>
+              <a:t>Projected Impact &amp; Scale  (Simulation)</a:t>
             </a:r>
           </a:p>
         </p:txBody>
@@ -7122,14 +7464,45 @@
       </p:sp>
       <p:sp>
         <p:nvSpPr>
-          <p:cNvPr id="30" name="b"/>
+          <p:cNvPr id="200" name="pnl"/>
+          <p:cNvSpPr/>
+          <p:nvPr/>
+        </p:nvSpPr>
+        <p:spPr>
+          <a:xfrm>
+            <a:off x="502920" y="1325880"/>
+            <a:ext cx="3383280" cy="3063240"/>
+          </a:xfrm>
+          <a:prstGeom prst="roundRect">
+            <a:avLst>
+              <a:gd name="adj" fmla="val 8000"/>
+            </a:avLst>
+          </a:prstGeom>
+          <a:solidFill>
+            <a:srgbClr val="FFFFFF"/>
+          </a:solidFill>
+          <a:ln w="12700">
+            <a:solidFill>
+              <a:srgbClr val="D7E3D1"/>
+            </a:solidFill>
+          </a:ln>
+        </p:spPr>
+        <p:txBody>
+          <a:bodyPr/>
+          <a:lstStyle/>
+          <a:p/>
+        </p:txBody>
+      </p:sp>
+      <p:sp>
+        <p:nvSpPr>
+          <p:cNvPr id="201" name="pt"/>
           <p:cNvSpPr txBox="1"/>
           <p:nvPr/>
         </p:nvSpPr>
         <p:spPr>
           <a:xfrm>
-            <a:off x="548640" y="1325880"/>
-            <a:ext cx="10698480" cy="4754880"/>
+            <a:off x="667512" y="1417320"/>
+            <a:ext cx="3054096" cy="365760"/>
           </a:xfrm>
           <a:prstGeom prst="rect">
             <a:avLst/>
@@ -7142,148 +7515,1935 @@
           </a:bodyPr>
           <a:lstStyle/>
           <a:p>
+            <a:pPr marL="0" indent="0" algn="ctr">
+              <a:spcBef>
+                <a:spcPts val="0"/>
+              </a:spcBef>
+              <a:spcAft>
+                <a:spcPts val="600"/>
+              </a:spcAft>
+              <a:buNone/>
+            </a:pPr>
+            <a:r>
+              <a:rPr lang="en-US" sz="1200" b="1" dirty="0">
+                <a:solidFill>
+                  <a:srgbClr val="14532D"/>
+                </a:solidFill>
+                <a:latin typeface="Calibri"/>
+              </a:rPr>
+              <a:t>Fertilizer use per acre (kg)</a:t>
+            </a:r>
+          </a:p>
+        </p:txBody>
+      </p:sp>
+      <p:sp>
+        <p:nvSpPr>
+          <p:cNvPr id="202" name="gl"/>
+          <p:cNvSpPr/>
+          <p:nvPr/>
+        </p:nvSpPr>
+        <p:spPr>
+          <a:xfrm>
+            <a:off x="758952" y="3417570"/>
+            <a:ext cx="2926080" cy="10058"/>
+          </a:xfrm>
+          <a:prstGeom prst="rect">
+            <a:avLst/>
+          </a:prstGeom>
+          <a:solidFill>
+            <a:srgbClr val="E3E8E3"/>
+          </a:solidFill>
+          <a:ln>
+            <a:noFill/>
+          </a:ln>
+        </p:spPr>
+        <p:txBody>
+          <a:bodyPr/>
+          <a:lstStyle/>
+          <a:p/>
+        </p:txBody>
+      </p:sp>
+      <p:sp>
+        <p:nvSpPr>
+          <p:cNvPr id="203" name="gl"/>
+          <p:cNvSpPr/>
+          <p:nvPr/>
+        </p:nvSpPr>
+        <p:spPr>
+          <a:xfrm>
+            <a:off x="758952" y="2921508"/>
+            <a:ext cx="2926080" cy="10058"/>
+          </a:xfrm>
+          <a:prstGeom prst="rect">
+            <a:avLst/>
+          </a:prstGeom>
+          <a:solidFill>
+            <a:srgbClr val="E3E8E3"/>
+          </a:solidFill>
+          <a:ln>
+            <a:noFill/>
+          </a:ln>
+        </p:spPr>
+        <p:txBody>
+          <a:bodyPr/>
+          <a:lstStyle/>
+          <a:p/>
+        </p:txBody>
+      </p:sp>
+      <p:sp>
+        <p:nvSpPr>
+          <p:cNvPr id="204" name="gl"/>
+          <p:cNvSpPr/>
+          <p:nvPr/>
+        </p:nvSpPr>
+        <p:spPr>
+          <a:xfrm>
+            <a:off x="758952" y="2425446"/>
+            <a:ext cx="2926080" cy="10058"/>
+          </a:xfrm>
+          <a:prstGeom prst="rect">
+            <a:avLst/>
+          </a:prstGeom>
+          <a:solidFill>
+            <a:srgbClr val="E3E8E3"/>
+          </a:solidFill>
+          <a:ln>
+            <a:noFill/>
+          </a:ln>
+        </p:spPr>
+        <p:txBody>
+          <a:bodyPr/>
+          <a:lstStyle/>
+          <a:p/>
+        </p:txBody>
+      </p:sp>
+      <p:sp>
+        <p:nvSpPr>
+          <p:cNvPr id="205" name="bl"/>
+          <p:cNvSpPr/>
+          <p:nvPr/>
+        </p:nvSpPr>
+        <p:spPr>
+          <a:xfrm>
+            <a:off x="758952" y="3913632"/>
+            <a:ext cx="2926080" cy="16459"/>
+          </a:xfrm>
+          <a:prstGeom prst="rect">
+            <a:avLst/>
+          </a:prstGeom>
+          <a:solidFill>
+            <a:srgbClr val="9AAE9A"/>
+          </a:solidFill>
+          <a:ln>
+            <a:noFill/>
+          </a:ln>
+        </p:spPr>
+        <p:txBody>
+          <a:bodyPr/>
+          <a:lstStyle/>
+          <a:p/>
+        </p:txBody>
+      </p:sp>
+      <p:sp>
+        <p:nvSpPr>
+          <p:cNvPr id="206" name="bar"/>
+          <p:cNvSpPr/>
+          <p:nvPr/>
+        </p:nvSpPr>
+        <p:spPr>
+          <a:xfrm>
+            <a:off x="1153973" y="2109771"/>
+            <a:ext cx="672998" cy="1803861"/>
+          </a:xfrm>
+          <a:prstGeom prst="rect">
+            <a:avLst/>
+          </a:prstGeom>
+          <a:solidFill>
+            <a:srgbClr val="E0934B"/>
+          </a:solidFill>
+          <a:ln>
+            <a:noFill/>
+          </a:ln>
+        </p:spPr>
+        <p:txBody>
+          <a:bodyPr/>
+          <a:lstStyle/>
+          <a:p/>
+        </p:txBody>
+      </p:sp>
+      <p:sp>
+        <p:nvSpPr>
+          <p:cNvPr id="207" name="vl"/>
+          <p:cNvSpPr txBox="1"/>
+          <p:nvPr/>
+        </p:nvSpPr>
+        <p:spPr>
+          <a:xfrm>
+            <a:off x="758952" y="1817163"/>
+            <a:ext cx="1463040" cy="274320"/>
+          </a:xfrm>
+          <a:prstGeom prst="rect">
+            <a:avLst/>
+          </a:prstGeom>
+          <a:noFill/>
+        </p:spPr>
+        <p:txBody>
+          <a:bodyPr wrap="square" anchor="t" rtlCol="0">
+            <a:normAutofit/>
+          </a:bodyPr>
+          <a:lstStyle/>
+          <a:p>
+            <a:pPr marL="0" indent="0" algn="ctr">
+              <a:spcBef>
+                <a:spcPts val="0"/>
+              </a:spcBef>
+              <a:spcAft>
+                <a:spcPts val="600"/>
+              </a:spcAft>
+              <a:buNone/>
+            </a:pPr>
+            <a:r>
+              <a:rPr lang="en-US" sz="1150" b="1" dirty="0">
+                <a:solidFill>
+                  <a:srgbClr val="1A2421"/>
+                </a:solidFill>
+                <a:latin typeface="Calibri"/>
+              </a:rPr>
+              <a:t>100</a:t>
+            </a:r>
+          </a:p>
+        </p:txBody>
+      </p:sp>
+      <p:sp>
+        <p:nvSpPr>
+          <p:cNvPr id="208" name="cl"/>
+          <p:cNvSpPr txBox="1"/>
+          <p:nvPr/>
+        </p:nvSpPr>
+        <p:spPr>
+          <a:xfrm>
+            <a:off x="758952" y="3950208"/>
+            <a:ext cx="1463040" cy="384048"/>
+          </a:xfrm>
+          <a:prstGeom prst="rect">
+            <a:avLst/>
+          </a:prstGeom>
+          <a:noFill/>
+        </p:spPr>
+        <p:txBody>
+          <a:bodyPr wrap="square" anchor="t" rtlCol="0">
+            <a:normAutofit/>
+          </a:bodyPr>
+          <a:lstStyle/>
+          <a:p>
+            <a:pPr marL="0" indent="0" algn="ctr">
+              <a:spcBef>
+                <a:spcPts val="0"/>
+              </a:spcBef>
+              <a:spcAft>
+                <a:spcPts val="600"/>
+              </a:spcAft>
+              <a:buNone/>
+            </a:pPr>
+            <a:r>
+              <a:rPr lang="en-US" sz="1000" dirty="0">
+                <a:solidFill>
+                  <a:srgbClr val="5B6B63"/>
+                </a:solidFill>
+                <a:latin typeface="Calibri"/>
+              </a:rPr>
+              <a:t>Broadcast</a:t>
+            </a:r>
+          </a:p>
+        </p:txBody>
+      </p:sp>
+      <p:sp>
+        <p:nvSpPr>
+          <p:cNvPr id="209" name="bar"/>
+          <p:cNvSpPr/>
+          <p:nvPr/>
+        </p:nvSpPr>
+        <p:spPr>
+          <a:xfrm>
+            <a:off x="2617013" y="2921508"/>
+            <a:ext cx="672998" cy="992124"/>
+          </a:xfrm>
+          <a:prstGeom prst="rect">
+            <a:avLst/>
+          </a:prstGeom>
+          <a:solidFill>
+            <a:srgbClr val="2E7D32"/>
+          </a:solidFill>
+          <a:ln>
+            <a:noFill/>
+          </a:ln>
+        </p:spPr>
+        <p:txBody>
+          <a:bodyPr/>
+          <a:lstStyle/>
+          <a:p/>
+        </p:txBody>
+      </p:sp>
+      <p:sp>
+        <p:nvSpPr>
+          <p:cNvPr id="210" name="vl"/>
+          <p:cNvSpPr txBox="1"/>
+          <p:nvPr/>
+        </p:nvSpPr>
+        <p:spPr>
+          <a:xfrm>
+            <a:off x="2221992" y="2628900"/>
+            <a:ext cx="1463040" cy="274320"/>
+          </a:xfrm>
+          <a:prstGeom prst="rect">
+            <a:avLst/>
+          </a:prstGeom>
+          <a:noFill/>
+        </p:spPr>
+        <p:txBody>
+          <a:bodyPr wrap="square" anchor="t" rtlCol="0">
+            <a:normAutofit/>
+          </a:bodyPr>
+          <a:lstStyle/>
+          <a:p>
+            <a:pPr marL="0" indent="0" algn="ctr">
+              <a:spcBef>
+                <a:spcPts val="0"/>
+              </a:spcBef>
+              <a:spcAft>
+                <a:spcPts val="600"/>
+              </a:spcAft>
+              <a:buNone/>
+            </a:pPr>
+            <a:r>
+              <a:rPr lang="en-US" sz="1150" b="1" dirty="0">
+                <a:solidFill>
+                  <a:srgbClr val="1A2421"/>
+                </a:solidFill>
+                <a:latin typeface="Calibri"/>
+              </a:rPr>
+              <a:t>55</a:t>
+            </a:r>
+          </a:p>
+        </p:txBody>
+      </p:sp>
+      <p:sp>
+        <p:nvSpPr>
+          <p:cNvPr id="211" name="cl"/>
+          <p:cNvSpPr txBox="1"/>
+          <p:nvPr/>
+        </p:nvSpPr>
+        <p:spPr>
+          <a:xfrm>
+            <a:off x="2221992" y="3950208"/>
+            <a:ext cx="1463040" cy="384048"/>
+          </a:xfrm>
+          <a:prstGeom prst="rect">
+            <a:avLst/>
+          </a:prstGeom>
+          <a:noFill/>
+        </p:spPr>
+        <p:txBody>
+          <a:bodyPr wrap="square" anchor="t" rtlCol="0">
+            <a:normAutofit/>
+          </a:bodyPr>
+          <a:lstStyle/>
+          <a:p>
+            <a:pPr marL="0" indent="0" algn="ctr">
+              <a:spcBef>
+                <a:spcPts val="0"/>
+              </a:spcBef>
+              <a:spcAft>
+                <a:spcPts val="600"/>
+              </a:spcAft>
+              <a:buNone/>
+            </a:pPr>
+            <a:r>
+              <a:rPr lang="en-US" sz="1000" dirty="0">
+                <a:solidFill>
+                  <a:srgbClr val="5B6B63"/>
+                </a:solidFill>
+                <a:latin typeface="Calibri"/>
+              </a:rPr>
+              <a:t>AgriRover</a:t>
+            </a:r>
+          </a:p>
+        </p:txBody>
+      </p:sp>
+      <p:sp>
+        <p:nvSpPr>
+          <p:cNvPr id="212" name="pnl"/>
+          <p:cNvSpPr/>
+          <p:nvPr/>
+        </p:nvSpPr>
+        <p:spPr>
+          <a:xfrm>
+            <a:off x="4160520" y="1325880"/>
+            <a:ext cx="3383280" cy="3063240"/>
+          </a:xfrm>
+          <a:prstGeom prst="roundRect">
+            <a:avLst>
+              <a:gd name="adj" fmla="val 8000"/>
+            </a:avLst>
+          </a:prstGeom>
+          <a:solidFill>
+            <a:srgbClr val="FFFFFF"/>
+          </a:solidFill>
+          <a:ln w="12700">
+            <a:solidFill>
+              <a:srgbClr val="D7E3D1"/>
+            </a:solidFill>
+          </a:ln>
+        </p:spPr>
+        <p:txBody>
+          <a:bodyPr/>
+          <a:lstStyle/>
+          <a:p/>
+        </p:txBody>
+      </p:sp>
+      <p:sp>
+        <p:nvSpPr>
+          <p:cNvPr id="213" name="pt"/>
+          <p:cNvSpPr txBox="1"/>
+          <p:nvPr/>
+        </p:nvSpPr>
+        <p:spPr>
+          <a:xfrm>
+            <a:off x="4325112" y="1417320"/>
+            <a:ext cx="3054096" cy="365760"/>
+          </a:xfrm>
+          <a:prstGeom prst="rect">
+            <a:avLst/>
+          </a:prstGeom>
+          <a:noFill/>
+        </p:spPr>
+        <p:txBody>
+          <a:bodyPr wrap="square" anchor="t" rtlCol="0">
+            <a:normAutofit/>
+          </a:bodyPr>
+          <a:lstStyle/>
+          <a:p>
+            <a:pPr marL="0" indent="0" algn="ctr">
+              <a:spcBef>
+                <a:spcPts val="0"/>
+              </a:spcBef>
+              <a:spcAft>
+                <a:spcPts val="600"/>
+              </a:spcAft>
+              <a:buNone/>
+            </a:pPr>
+            <a:r>
+              <a:rPr lang="en-US" sz="1200" b="1" dirty="0">
+                <a:solidFill>
+                  <a:srgbClr val="14532D"/>
+                </a:solidFill>
+                <a:latin typeface="Calibri"/>
+              </a:rPr>
+              <a:t>Input cost per acre / season (Rs)</a:t>
+            </a:r>
+          </a:p>
+        </p:txBody>
+      </p:sp>
+      <p:sp>
+        <p:nvSpPr>
+          <p:cNvPr id="214" name="gl"/>
+          <p:cNvSpPr/>
+          <p:nvPr/>
+        </p:nvSpPr>
+        <p:spPr>
+          <a:xfrm>
+            <a:off x="4416552" y="3417570"/>
+            <a:ext cx="2926080" cy="10058"/>
+          </a:xfrm>
+          <a:prstGeom prst="rect">
+            <a:avLst/>
+          </a:prstGeom>
+          <a:solidFill>
+            <a:srgbClr val="E3E8E3"/>
+          </a:solidFill>
+          <a:ln>
+            <a:noFill/>
+          </a:ln>
+        </p:spPr>
+        <p:txBody>
+          <a:bodyPr/>
+          <a:lstStyle/>
+          <a:p/>
+        </p:txBody>
+      </p:sp>
+      <p:sp>
+        <p:nvSpPr>
+          <p:cNvPr id="215" name="gl"/>
+          <p:cNvSpPr/>
+          <p:nvPr/>
+        </p:nvSpPr>
+        <p:spPr>
+          <a:xfrm>
+            <a:off x="4416552" y="2921508"/>
+            <a:ext cx="2926080" cy="10058"/>
+          </a:xfrm>
+          <a:prstGeom prst="rect">
+            <a:avLst/>
+          </a:prstGeom>
+          <a:solidFill>
+            <a:srgbClr val="E3E8E3"/>
+          </a:solidFill>
+          <a:ln>
+            <a:noFill/>
+          </a:ln>
+        </p:spPr>
+        <p:txBody>
+          <a:bodyPr/>
+          <a:lstStyle/>
+          <a:p/>
+        </p:txBody>
+      </p:sp>
+      <p:sp>
+        <p:nvSpPr>
+          <p:cNvPr id="216" name="gl"/>
+          <p:cNvSpPr/>
+          <p:nvPr/>
+        </p:nvSpPr>
+        <p:spPr>
+          <a:xfrm>
+            <a:off x="4416552" y="2425446"/>
+            <a:ext cx="2926080" cy="10058"/>
+          </a:xfrm>
+          <a:prstGeom prst="rect">
+            <a:avLst/>
+          </a:prstGeom>
+          <a:solidFill>
+            <a:srgbClr val="E3E8E3"/>
+          </a:solidFill>
+          <a:ln>
+            <a:noFill/>
+          </a:ln>
+        </p:spPr>
+        <p:txBody>
+          <a:bodyPr/>
+          <a:lstStyle/>
+          <a:p/>
+        </p:txBody>
+      </p:sp>
+      <p:sp>
+        <p:nvSpPr>
+          <p:cNvPr id="217" name="bl"/>
+          <p:cNvSpPr/>
+          <p:nvPr/>
+        </p:nvSpPr>
+        <p:spPr>
+          <a:xfrm>
+            <a:off x="4416552" y="3913632"/>
+            <a:ext cx="2926080" cy="16459"/>
+          </a:xfrm>
+          <a:prstGeom prst="rect">
+            <a:avLst/>
+          </a:prstGeom>
+          <a:solidFill>
+            <a:srgbClr val="9AAE9A"/>
+          </a:solidFill>
+          <a:ln>
+            <a:noFill/>
+          </a:ln>
+        </p:spPr>
+        <p:txBody>
+          <a:bodyPr/>
+          <a:lstStyle/>
+          <a:p/>
+        </p:txBody>
+      </p:sp>
+      <p:sp>
+        <p:nvSpPr>
+          <p:cNvPr id="218" name="bar"/>
+          <p:cNvSpPr/>
+          <p:nvPr/>
+        </p:nvSpPr>
+        <p:spPr>
+          <a:xfrm>
+            <a:off x="4811573" y="2109771"/>
+            <a:ext cx="672998" cy="1803861"/>
+          </a:xfrm>
+          <a:prstGeom prst="rect">
+            <a:avLst/>
+          </a:prstGeom>
+          <a:solidFill>
+            <a:srgbClr val="E0934B"/>
+          </a:solidFill>
+          <a:ln>
+            <a:noFill/>
+          </a:ln>
+        </p:spPr>
+        <p:txBody>
+          <a:bodyPr/>
+          <a:lstStyle/>
+          <a:p/>
+        </p:txBody>
+      </p:sp>
+      <p:sp>
+        <p:nvSpPr>
+          <p:cNvPr id="219" name="vl"/>
+          <p:cNvSpPr txBox="1"/>
+          <p:nvPr/>
+        </p:nvSpPr>
+        <p:spPr>
+          <a:xfrm>
+            <a:off x="4416552" y="1817163"/>
+            <a:ext cx="1463040" cy="274320"/>
+          </a:xfrm>
+          <a:prstGeom prst="rect">
+            <a:avLst/>
+          </a:prstGeom>
+          <a:noFill/>
+        </p:spPr>
+        <p:txBody>
+          <a:bodyPr wrap="square" anchor="t" rtlCol="0">
+            <a:normAutofit/>
+          </a:bodyPr>
+          <a:lstStyle/>
+          <a:p>
+            <a:pPr marL="0" indent="0" algn="ctr">
+              <a:spcBef>
+                <a:spcPts val="0"/>
+              </a:spcBef>
+              <a:spcAft>
+                <a:spcPts val="600"/>
+              </a:spcAft>
+              <a:buNone/>
+            </a:pPr>
+            <a:r>
+              <a:rPr lang="en-US" sz="1150" b="1" dirty="0">
+                <a:solidFill>
+                  <a:srgbClr val="1A2421"/>
+                </a:solidFill>
+                <a:latin typeface="Calibri"/>
+              </a:rPr>
+              <a:t>6,000</a:t>
+            </a:r>
+          </a:p>
+        </p:txBody>
+      </p:sp>
+      <p:sp>
+        <p:nvSpPr>
+          <p:cNvPr id="220" name="cl"/>
+          <p:cNvSpPr txBox="1"/>
+          <p:nvPr/>
+        </p:nvSpPr>
+        <p:spPr>
+          <a:xfrm>
+            <a:off x="4416552" y="3950208"/>
+            <a:ext cx="1463040" cy="384048"/>
+          </a:xfrm>
+          <a:prstGeom prst="rect">
+            <a:avLst/>
+          </a:prstGeom>
+          <a:noFill/>
+        </p:spPr>
+        <p:txBody>
+          <a:bodyPr wrap="square" anchor="t" rtlCol="0">
+            <a:normAutofit/>
+          </a:bodyPr>
+          <a:lstStyle/>
+          <a:p>
+            <a:pPr marL="0" indent="0" algn="ctr">
+              <a:spcBef>
+                <a:spcPts val="0"/>
+              </a:spcBef>
+              <a:spcAft>
+                <a:spcPts val="600"/>
+              </a:spcAft>
+              <a:buNone/>
+            </a:pPr>
+            <a:r>
+              <a:rPr lang="en-US" sz="1000" dirty="0">
+                <a:solidFill>
+                  <a:srgbClr val="5B6B63"/>
+                </a:solidFill>
+                <a:latin typeface="Calibri"/>
+              </a:rPr>
+              <a:t>Before</a:t>
+            </a:r>
+          </a:p>
+        </p:txBody>
+      </p:sp>
+      <p:sp>
+        <p:nvSpPr>
+          <p:cNvPr id="221" name="bar"/>
+          <p:cNvSpPr/>
+          <p:nvPr/>
+        </p:nvSpPr>
+        <p:spPr>
+          <a:xfrm>
+            <a:off x="6274613" y="2831315"/>
+            <a:ext cx="672998" cy="1082317"/>
+          </a:xfrm>
+          <a:prstGeom prst="rect">
+            <a:avLst/>
+          </a:prstGeom>
+          <a:solidFill>
+            <a:srgbClr val="2E7D32"/>
+          </a:solidFill>
+          <a:ln>
+            <a:noFill/>
+          </a:ln>
+        </p:spPr>
+        <p:txBody>
+          <a:bodyPr/>
+          <a:lstStyle/>
+          <a:p/>
+        </p:txBody>
+      </p:sp>
+      <p:sp>
+        <p:nvSpPr>
+          <p:cNvPr id="222" name="vl"/>
+          <p:cNvSpPr txBox="1"/>
+          <p:nvPr/>
+        </p:nvSpPr>
+        <p:spPr>
+          <a:xfrm>
+            <a:off x="5879592" y="2538707"/>
+            <a:ext cx="1463040" cy="274320"/>
+          </a:xfrm>
+          <a:prstGeom prst="rect">
+            <a:avLst/>
+          </a:prstGeom>
+          <a:noFill/>
+        </p:spPr>
+        <p:txBody>
+          <a:bodyPr wrap="square" anchor="t" rtlCol="0">
+            <a:normAutofit/>
+          </a:bodyPr>
+          <a:lstStyle/>
+          <a:p>
+            <a:pPr marL="0" indent="0" algn="ctr">
+              <a:spcBef>
+                <a:spcPts val="0"/>
+              </a:spcBef>
+              <a:spcAft>
+                <a:spcPts val="600"/>
+              </a:spcAft>
+              <a:buNone/>
+            </a:pPr>
+            <a:r>
+              <a:rPr lang="en-US" sz="1150" b="1" dirty="0">
+                <a:solidFill>
+                  <a:srgbClr val="1A2421"/>
+                </a:solidFill>
+                <a:latin typeface="Calibri"/>
+              </a:rPr>
+              <a:t>3,600</a:t>
+            </a:r>
+          </a:p>
+        </p:txBody>
+      </p:sp>
+      <p:sp>
+        <p:nvSpPr>
+          <p:cNvPr id="223" name="cl"/>
+          <p:cNvSpPr txBox="1"/>
+          <p:nvPr/>
+        </p:nvSpPr>
+        <p:spPr>
+          <a:xfrm>
+            <a:off x="5879592" y="3950208"/>
+            <a:ext cx="1463040" cy="384048"/>
+          </a:xfrm>
+          <a:prstGeom prst="rect">
+            <a:avLst/>
+          </a:prstGeom>
+          <a:noFill/>
+        </p:spPr>
+        <p:txBody>
+          <a:bodyPr wrap="square" anchor="t" rtlCol="0">
+            <a:normAutofit/>
+          </a:bodyPr>
+          <a:lstStyle/>
+          <a:p>
+            <a:pPr marL="0" indent="0" algn="ctr">
+              <a:spcBef>
+                <a:spcPts val="0"/>
+              </a:spcBef>
+              <a:spcAft>
+                <a:spcPts val="600"/>
+              </a:spcAft>
+              <a:buNone/>
+            </a:pPr>
+            <a:r>
+              <a:rPr lang="en-US" sz="1000" dirty="0">
+                <a:solidFill>
+                  <a:srgbClr val="5B6B63"/>
+                </a:solidFill>
+                <a:latin typeface="Calibri"/>
+              </a:rPr>
+              <a:t>With AgriRover</a:t>
+            </a:r>
+          </a:p>
+        </p:txBody>
+      </p:sp>
+      <p:sp>
+        <p:nvSpPr>
+          <p:cNvPr id="224" name="pnl"/>
+          <p:cNvSpPr/>
+          <p:nvPr/>
+        </p:nvSpPr>
+        <p:spPr>
+          <a:xfrm>
+            <a:off x="7818120" y="1325880"/>
+            <a:ext cx="3383280" cy="3063240"/>
+          </a:xfrm>
+          <a:prstGeom prst="roundRect">
+            <a:avLst>
+              <a:gd name="adj" fmla="val 8000"/>
+            </a:avLst>
+          </a:prstGeom>
+          <a:solidFill>
+            <a:srgbClr val="FFFFFF"/>
+          </a:solidFill>
+          <a:ln w="12700">
+            <a:solidFill>
+              <a:srgbClr val="D7E3D1"/>
+            </a:solidFill>
+          </a:ln>
+        </p:spPr>
+        <p:txBody>
+          <a:bodyPr/>
+          <a:lstStyle/>
+          <a:p/>
+        </p:txBody>
+      </p:sp>
+      <p:sp>
+        <p:nvSpPr>
+          <p:cNvPr id="225" name="pt"/>
+          <p:cNvSpPr txBox="1"/>
+          <p:nvPr/>
+        </p:nvSpPr>
+        <p:spPr>
+          <a:xfrm>
+            <a:off x="7982712" y="1417320"/>
+            <a:ext cx="3054096" cy="365760"/>
+          </a:xfrm>
+          <a:prstGeom prst="rect">
+            <a:avLst/>
+          </a:prstGeom>
+          <a:noFill/>
+        </p:spPr>
+        <p:txBody>
+          <a:bodyPr wrap="square" anchor="t" rtlCol="0">
+            <a:normAutofit/>
+          </a:bodyPr>
+          <a:lstStyle/>
+          <a:p>
+            <a:pPr marL="0" indent="0" algn="ctr">
+              <a:spcBef>
+                <a:spcPts val="0"/>
+              </a:spcBef>
+              <a:spcAft>
+                <a:spcPts val="600"/>
+              </a:spcAft>
+              <a:buNone/>
+            </a:pPr>
+            <a:r>
+              <a:rPr lang="en-US" sz="1200" b="1" dirty="0">
+                <a:solidFill>
+                  <a:srgbClr val="14532D"/>
+                </a:solidFill>
+                <a:latin typeface="Calibri"/>
+              </a:rPr>
+              <a:t>Farms served (3-yr projection)</a:t>
+            </a:r>
+          </a:p>
+        </p:txBody>
+      </p:sp>
+      <p:sp>
+        <p:nvSpPr>
+          <p:cNvPr id="226" name="gl"/>
+          <p:cNvSpPr/>
+          <p:nvPr/>
+        </p:nvSpPr>
+        <p:spPr>
+          <a:xfrm>
+            <a:off x="8074152" y="3417570"/>
+            <a:ext cx="2926080" cy="10058"/>
+          </a:xfrm>
+          <a:prstGeom prst="rect">
+            <a:avLst/>
+          </a:prstGeom>
+          <a:solidFill>
+            <a:srgbClr val="E3E8E3"/>
+          </a:solidFill>
+          <a:ln>
+            <a:noFill/>
+          </a:ln>
+        </p:spPr>
+        <p:txBody>
+          <a:bodyPr/>
+          <a:lstStyle/>
+          <a:p/>
+        </p:txBody>
+      </p:sp>
+      <p:sp>
+        <p:nvSpPr>
+          <p:cNvPr id="227" name="gl"/>
+          <p:cNvSpPr/>
+          <p:nvPr/>
+        </p:nvSpPr>
+        <p:spPr>
+          <a:xfrm>
+            <a:off x="8074152" y="2921508"/>
+            <a:ext cx="2926080" cy="10058"/>
+          </a:xfrm>
+          <a:prstGeom prst="rect">
+            <a:avLst/>
+          </a:prstGeom>
+          <a:solidFill>
+            <a:srgbClr val="E3E8E3"/>
+          </a:solidFill>
+          <a:ln>
+            <a:noFill/>
+          </a:ln>
+        </p:spPr>
+        <p:txBody>
+          <a:bodyPr/>
+          <a:lstStyle/>
+          <a:p/>
+        </p:txBody>
+      </p:sp>
+      <p:sp>
+        <p:nvSpPr>
+          <p:cNvPr id="228" name="gl"/>
+          <p:cNvSpPr/>
+          <p:nvPr/>
+        </p:nvSpPr>
+        <p:spPr>
+          <a:xfrm>
+            <a:off x="8074152" y="2425446"/>
+            <a:ext cx="2926080" cy="10058"/>
+          </a:xfrm>
+          <a:prstGeom prst="rect">
+            <a:avLst/>
+          </a:prstGeom>
+          <a:solidFill>
+            <a:srgbClr val="E3E8E3"/>
+          </a:solidFill>
+          <a:ln>
+            <a:noFill/>
+          </a:ln>
+        </p:spPr>
+        <p:txBody>
+          <a:bodyPr/>
+          <a:lstStyle/>
+          <a:p/>
+        </p:txBody>
+      </p:sp>
+      <p:sp>
+        <p:nvSpPr>
+          <p:cNvPr id="229" name="bl"/>
+          <p:cNvSpPr/>
+          <p:nvPr/>
+        </p:nvSpPr>
+        <p:spPr>
+          <a:xfrm>
+            <a:off x="8074152" y="3913632"/>
+            <a:ext cx="2926080" cy="16459"/>
+          </a:xfrm>
+          <a:prstGeom prst="rect">
+            <a:avLst/>
+          </a:prstGeom>
+          <a:solidFill>
+            <a:srgbClr val="9AAE9A"/>
+          </a:solidFill>
+          <a:ln>
+            <a:noFill/>
+          </a:ln>
+        </p:spPr>
+        <p:txBody>
+          <a:bodyPr/>
+          <a:lstStyle/>
+          <a:p/>
+        </p:txBody>
+      </p:sp>
+      <p:sp>
+        <p:nvSpPr>
+          <p:cNvPr id="230" name="bar"/>
+          <p:cNvSpPr/>
+          <p:nvPr/>
+        </p:nvSpPr>
+        <p:spPr>
+          <a:xfrm>
+            <a:off x="8337499" y="3868536"/>
+            <a:ext cx="448665" cy="45096"/>
+          </a:xfrm>
+          <a:prstGeom prst="rect">
+            <a:avLst/>
+          </a:prstGeom>
+          <a:solidFill>
+            <a:srgbClr val="66BB6A"/>
+          </a:solidFill>
+          <a:ln>
+            <a:noFill/>
+          </a:ln>
+        </p:spPr>
+        <p:txBody>
+          <a:bodyPr/>
+          <a:lstStyle/>
+          <a:p/>
+        </p:txBody>
+      </p:sp>
+      <p:sp>
+        <p:nvSpPr>
+          <p:cNvPr id="231" name="vl"/>
+          <p:cNvSpPr txBox="1"/>
+          <p:nvPr/>
+        </p:nvSpPr>
+        <p:spPr>
+          <a:xfrm>
+            <a:off x="8074152" y="3575928"/>
+            <a:ext cx="975360" cy="274320"/>
+          </a:xfrm>
+          <a:prstGeom prst="rect">
+            <a:avLst/>
+          </a:prstGeom>
+          <a:noFill/>
+        </p:spPr>
+        <p:txBody>
+          <a:bodyPr wrap="square" anchor="t" rtlCol="0">
+            <a:normAutofit/>
+          </a:bodyPr>
+          <a:lstStyle/>
+          <a:p>
+            <a:pPr marL="0" indent="0" algn="ctr">
+              <a:spcBef>
+                <a:spcPts val="0"/>
+              </a:spcBef>
+              <a:spcAft>
+                <a:spcPts val="600"/>
+              </a:spcAft>
+              <a:buNone/>
+            </a:pPr>
+            <a:r>
+              <a:rPr lang="en-US" sz="1150" b="1" dirty="0">
+                <a:solidFill>
+                  <a:srgbClr val="1A2421"/>
+                </a:solidFill>
+                <a:latin typeface="Calibri"/>
+              </a:rPr>
+              <a:t>10</a:t>
+            </a:r>
+          </a:p>
+        </p:txBody>
+      </p:sp>
+      <p:sp>
+        <p:nvSpPr>
+          <p:cNvPr id="232" name="cl"/>
+          <p:cNvSpPr txBox="1"/>
+          <p:nvPr/>
+        </p:nvSpPr>
+        <p:spPr>
+          <a:xfrm>
+            <a:off x="8074152" y="3950208"/>
+            <a:ext cx="975360" cy="384048"/>
+          </a:xfrm>
+          <a:prstGeom prst="rect">
+            <a:avLst/>
+          </a:prstGeom>
+          <a:noFill/>
+        </p:spPr>
+        <p:txBody>
+          <a:bodyPr wrap="square" anchor="t" rtlCol="0">
+            <a:normAutofit/>
+          </a:bodyPr>
+          <a:lstStyle/>
+          <a:p>
+            <a:pPr marL="0" indent="0" algn="ctr">
+              <a:spcBef>
+                <a:spcPts val="0"/>
+              </a:spcBef>
+              <a:spcAft>
+                <a:spcPts val="600"/>
+              </a:spcAft>
+              <a:buNone/>
+            </a:pPr>
+            <a:r>
+              <a:rPr lang="en-US" sz="1000" dirty="0">
+                <a:solidFill>
+                  <a:srgbClr val="5B6B63"/>
+                </a:solidFill>
+                <a:latin typeface="Calibri"/>
+              </a:rPr>
+              <a:t>Yr 1</a:t>
+            </a:r>
+          </a:p>
+        </p:txBody>
+      </p:sp>
+      <p:sp>
+        <p:nvSpPr>
+          <p:cNvPr id="233" name="bar"/>
+          <p:cNvSpPr/>
+          <p:nvPr/>
+        </p:nvSpPr>
+        <p:spPr>
+          <a:xfrm>
+            <a:off x="9312859" y="3552860"/>
+            <a:ext cx="448665" cy="360772"/>
+          </a:xfrm>
+          <a:prstGeom prst="rect">
+            <a:avLst/>
+          </a:prstGeom>
+          <a:solidFill>
+            <a:srgbClr val="2E7D32"/>
+          </a:solidFill>
+          <a:ln>
+            <a:noFill/>
+          </a:ln>
+        </p:spPr>
+        <p:txBody>
+          <a:bodyPr/>
+          <a:lstStyle/>
+          <a:p/>
+        </p:txBody>
+      </p:sp>
+      <p:sp>
+        <p:nvSpPr>
+          <p:cNvPr id="234" name="vl"/>
+          <p:cNvSpPr txBox="1"/>
+          <p:nvPr/>
+        </p:nvSpPr>
+        <p:spPr>
+          <a:xfrm>
+            <a:off x="9049512" y="3260252"/>
+            <a:ext cx="975360" cy="274320"/>
+          </a:xfrm>
+          <a:prstGeom prst="rect">
+            <a:avLst/>
+          </a:prstGeom>
+          <a:noFill/>
+        </p:spPr>
+        <p:txBody>
+          <a:bodyPr wrap="square" anchor="t" rtlCol="0">
+            <a:normAutofit/>
+          </a:bodyPr>
+          <a:lstStyle/>
+          <a:p>
+            <a:pPr marL="0" indent="0" algn="ctr">
+              <a:spcBef>
+                <a:spcPts val="0"/>
+              </a:spcBef>
+              <a:spcAft>
+                <a:spcPts val="600"/>
+              </a:spcAft>
+              <a:buNone/>
+            </a:pPr>
+            <a:r>
+              <a:rPr lang="en-US" sz="1150" b="1" dirty="0">
+                <a:solidFill>
+                  <a:srgbClr val="1A2421"/>
+                </a:solidFill>
+                <a:latin typeface="Calibri"/>
+              </a:rPr>
+              <a:t>80</a:t>
+            </a:r>
+          </a:p>
+        </p:txBody>
+      </p:sp>
+      <p:sp>
+        <p:nvSpPr>
+          <p:cNvPr id="235" name="cl"/>
+          <p:cNvSpPr txBox="1"/>
+          <p:nvPr/>
+        </p:nvSpPr>
+        <p:spPr>
+          <a:xfrm>
+            <a:off x="9049512" y="3950208"/>
+            <a:ext cx="975360" cy="384048"/>
+          </a:xfrm>
+          <a:prstGeom prst="rect">
+            <a:avLst/>
+          </a:prstGeom>
+          <a:noFill/>
+        </p:spPr>
+        <p:txBody>
+          <a:bodyPr wrap="square" anchor="t" rtlCol="0">
+            <a:normAutofit/>
+          </a:bodyPr>
+          <a:lstStyle/>
+          <a:p>
+            <a:pPr marL="0" indent="0" algn="ctr">
+              <a:spcBef>
+                <a:spcPts val="0"/>
+              </a:spcBef>
+              <a:spcAft>
+                <a:spcPts val="600"/>
+              </a:spcAft>
+              <a:buNone/>
+            </a:pPr>
+            <a:r>
+              <a:rPr lang="en-US" sz="1000" dirty="0">
+                <a:solidFill>
+                  <a:srgbClr val="5B6B63"/>
+                </a:solidFill>
+                <a:latin typeface="Calibri"/>
+              </a:rPr>
+              <a:t>Yr 2</a:t>
+            </a:r>
+          </a:p>
+        </p:txBody>
+      </p:sp>
+      <p:sp>
+        <p:nvSpPr>
+          <p:cNvPr id="236" name="bar"/>
+          <p:cNvSpPr/>
+          <p:nvPr/>
+        </p:nvSpPr>
+        <p:spPr>
+          <a:xfrm>
+            <a:off x="10288219" y="2109771"/>
+            <a:ext cx="448665" cy="1803861"/>
+          </a:xfrm>
+          <a:prstGeom prst="rect">
+            <a:avLst/>
+          </a:prstGeom>
+          <a:solidFill>
+            <a:srgbClr val="14532D"/>
+          </a:solidFill>
+          <a:ln>
+            <a:noFill/>
+          </a:ln>
+        </p:spPr>
+        <p:txBody>
+          <a:bodyPr/>
+          <a:lstStyle/>
+          <a:p/>
+        </p:txBody>
+      </p:sp>
+      <p:sp>
+        <p:nvSpPr>
+          <p:cNvPr id="237" name="vl"/>
+          <p:cNvSpPr txBox="1"/>
+          <p:nvPr/>
+        </p:nvSpPr>
+        <p:spPr>
+          <a:xfrm>
+            <a:off x="10024872" y="1817163"/>
+            <a:ext cx="975360" cy="274320"/>
+          </a:xfrm>
+          <a:prstGeom prst="rect">
+            <a:avLst/>
+          </a:prstGeom>
+          <a:noFill/>
+        </p:spPr>
+        <p:txBody>
+          <a:bodyPr wrap="square" anchor="t" rtlCol="0">
+            <a:normAutofit/>
+          </a:bodyPr>
+          <a:lstStyle/>
+          <a:p>
+            <a:pPr marL="0" indent="0" algn="ctr">
+              <a:spcBef>
+                <a:spcPts val="0"/>
+              </a:spcBef>
+              <a:spcAft>
+                <a:spcPts val="600"/>
+              </a:spcAft>
+              <a:buNone/>
+            </a:pPr>
+            <a:r>
+              <a:rPr lang="en-US" sz="1150" b="1" dirty="0">
+                <a:solidFill>
+                  <a:srgbClr val="1A2421"/>
+                </a:solidFill>
+                <a:latin typeface="Calibri"/>
+              </a:rPr>
+              <a:t>400</a:t>
+            </a:r>
+          </a:p>
+        </p:txBody>
+      </p:sp>
+      <p:sp>
+        <p:nvSpPr>
+          <p:cNvPr id="238" name="cl"/>
+          <p:cNvSpPr txBox="1"/>
+          <p:nvPr/>
+        </p:nvSpPr>
+        <p:spPr>
+          <a:xfrm>
+            <a:off x="10024872" y="3950208"/>
+            <a:ext cx="975360" cy="384048"/>
+          </a:xfrm>
+          <a:prstGeom prst="rect">
+            <a:avLst/>
+          </a:prstGeom>
+          <a:noFill/>
+        </p:spPr>
+        <p:txBody>
+          <a:bodyPr wrap="square" anchor="t" rtlCol="0">
+            <a:normAutofit/>
+          </a:bodyPr>
+          <a:lstStyle/>
+          <a:p>
+            <a:pPr marL="0" indent="0" algn="ctr">
+              <a:spcBef>
+                <a:spcPts val="0"/>
+              </a:spcBef>
+              <a:spcAft>
+                <a:spcPts val="600"/>
+              </a:spcAft>
+              <a:buNone/>
+            </a:pPr>
+            <a:r>
+              <a:rPr lang="en-US" sz="1000" dirty="0">
+                <a:solidFill>
+                  <a:srgbClr val="5B6B63"/>
+                </a:solidFill>
+                <a:latin typeface="Calibri"/>
+              </a:rPr>
+              <a:t>Yr 3</a:t>
+            </a:r>
+          </a:p>
+        </p:txBody>
+      </p:sp>
+      <p:sp>
+        <p:nvSpPr>
+          <p:cNvPr id="239" name="k"/>
+          <p:cNvSpPr/>
+          <p:nvPr/>
+        </p:nvSpPr>
+        <p:spPr>
+          <a:xfrm>
+            <a:off x="502920" y="4617720"/>
+            <a:ext cx="3383280" cy="1143000"/>
+          </a:xfrm>
+          <a:prstGeom prst="roundRect">
+            <a:avLst>
+              <a:gd name="adj" fmla="val 8000"/>
+            </a:avLst>
+          </a:prstGeom>
+          <a:solidFill>
+            <a:srgbClr val="F3F8F1"/>
+          </a:solidFill>
+          <a:ln w="14000">
+            <a:solidFill>
+              <a:srgbClr val="1565C0"/>
+            </a:solidFill>
+          </a:ln>
+        </p:spPr>
+        <p:txBody>
+          <a:bodyPr/>
+          <a:lstStyle/>
+          <a:p/>
+        </p:txBody>
+      </p:sp>
+      <p:sp>
+        <p:nvSpPr>
+          <p:cNvPr id="240" name="kt"/>
+          <p:cNvSpPr/>
+          <p:nvPr/>
+        </p:nvSpPr>
+        <p:spPr>
+          <a:xfrm>
+            <a:off x="502920" y="4617720"/>
+            <a:ext cx="91440" cy="1143000"/>
+          </a:xfrm>
+          <a:prstGeom prst="rect">
+            <a:avLst/>
+          </a:prstGeom>
+          <a:solidFill>
+            <a:srgbClr val="1565C0"/>
+          </a:solidFill>
+          <a:ln>
+            <a:noFill/>
+          </a:ln>
+        </p:spPr>
+        <p:txBody>
+          <a:bodyPr/>
+          <a:lstStyle/>
+          <a:p/>
+        </p:txBody>
+      </p:sp>
+      <p:sp>
+        <p:nvSpPr>
+          <p:cNvPr id="241" name="kl"/>
+          <p:cNvSpPr txBox="1"/>
+          <p:nvPr/>
+        </p:nvSpPr>
+        <p:spPr>
+          <a:xfrm>
+            <a:off x="740664" y="4727448"/>
+            <a:ext cx="2971800" cy="365760"/>
+          </a:xfrm>
+          <a:prstGeom prst="rect">
+            <a:avLst/>
+          </a:prstGeom>
+          <a:noFill/>
+        </p:spPr>
+        <p:txBody>
+          <a:bodyPr wrap="square" anchor="t" rtlCol="0">
+            <a:normAutofit/>
+          </a:bodyPr>
+          <a:lstStyle/>
+          <a:p>
             <a:pPr marL="0" indent="0" algn="l">
               <a:spcBef>
                 <a:spcPts val="0"/>
               </a:spcBef>
               <a:spcAft>
-                <a:spcPts val="220"/>
-              </a:spcAft>
-              <a:buNone/>
-            </a:pPr>
-            <a:r>
-              <a:rPr lang="en-US" sz="1600" b="1" dirty="0">
+                <a:spcPts val="600"/>
+              </a:spcAft>
+              <a:buNone/>
+            </a:pPr>
+            <a:r>
+              <a:rPr lang="en-US" sz="1150" b="1" dirty="0">
+                <a:solidFill>
+                  <a:srgbClr val="1A2421"/>
+                </a:solidFill>
+                <a:latin typeface="Calibri"/>
+              </a:rPr>
+              <a:t>AI detection accuracy</a:t>
+            </a:r>
+          </a:p>
+        </p:txBody>
+      </p:sp>
+      <p:sp>
+        <p:nvSpPr>
+          <p:cNvPr id="242" name="kp"/>
+          <p:cNvSpPr txBox="1"/>
+          <p:nvPr/>
+        </p:nvSpPr>
+        <p:spPr>
+          <a:xfrm>
+            <a:off x="740664" y="5001768"/>
+            <a:ext cx="2971800" cy="457200"/>
+          </a:xfrm>
+          <a:prstGeom prst="rect">
+            <a:avLst/>
+          </a:prstGeom>
+          <a:noFill/>
+        </p:spPr>
+        <p:txBody>
+          <a:bodyPr wrap="square" anchor="t" rtlCol="0">
+            <a:normAutofit/>
+          </a:bodyPr>
+          <a:lstStyle/>
+          <a:p>
+            <a:pPr marL="0" indent="0" algn="l">
+              <a:spcBef>
+                <a:spcPts val="0"/>
+              </a:spcBef>
+              <a:spcAft>
+                <a:spcPts val="600"/>
+              </a:spcAft>
+              <a:buNone/>
+            </a:pPr>
+            <a:r>
+              <a:rPr lang="en-US" sz="2200" b="1" dirty="0">
+                <a:solidFill>
+                  <a:srgbClr val="1565C0"/>
+                </a:solidFill>
+                <a:latin typeface="Calibri"/>
+              </a:rPr>
+              <a:t>88%</a:t>
+            </a:r>
+          </a:p>
+        </p:txBody>
+      </p:sp>
+      <p:sp>
+        <p:nvSpPr>
+          <p:cNvPr id="243" name="trk"/>
+          <p:cNvSpPr/>
+          <p:nvPr/>
+        </p:nvSpPr>
+        <p:spPr>
+          <a:xfrm>
+            <a:off x="758952" y="5468112"/>
+            <a:ext cx="2871216" cy="146304"/>
+          </a:xfrm>
+          <a:prstGeom prst="roundRect">
+            <a:avLst>
+              <a:gd name="adj" fmla="val 50000"/>
+            </a:avLst>
+          </a:prstGeom>
+          <a:solidFill>
+            <a:srgbClr val="E1E8E0"/>
+          </a:solidFill>
+          <a:ln>
+            <a:noFill/>
+          </a:ln>
+        </p:spPr>
+        <p:txBody>
+          <a:bodyPr/>
+          <a:lstStyle/>
+          <a:p/>
+        </p:txBody>
+      </p:sp>
+      <p:sp>
+        <p:nvSpPr>
+          <p:cNvPr id="244" name="fil"/>
+          <p:cNvSpPr/>
+          <p:nvPr/>
+        </p:nvSpPr>
+        <p:spPr>
+          <a:xfrm>
+            <a:off x="758952" y="5468112"/>
+            <a:ext cx="2526670" cy="146304"/>
+          </a:xfrm>
+          <a:prstGeom prst="roundRect">
+            <a:avLst>
+              <a:gd name="adj" fmla="val 50000"/>
+            </a:avLst>
+          </a:prstGeom>
+          <a:solidFill>
+            <a:srgbClr val="1565C0"/>
+          </a:solidFill>
+          <a:ln>
+            <a:noFill/>
+          </a:ln>
+        </p:spPr>
+        <p:txBody>
+          <a:bodyPr/>
+          <a:lstStyle/>
+          <a:p/>
+        </p:txBody>
+      </p:sp>
+      <p:sp>
+        <p:nvSpPr>
+          <p:cNvPr id="245" name="k"/>
+          <p:cNvSpPr/>
+          <p:nvPr/>
+        </p:nvSpPr>
+        <p:spPr>
+          <a:xfrm>
+            <a:off x="4160520" y="4617720"/>
+            <a:ext cx="3383280" cy="1143000"/>
+          </a:xfrm>
+          <a:prstGeom prst="roundRect">
+            <a:avLst>
+              <a:gd name="adj" fmla="val 8000"/>
+            </a:avLst>
+          </a:prstGeom>
+          <a:solidFill>
+            <a:srgbClr val="F3F8F1"/>
+          </a:solidFill>
+          <a:ln w="14000">
+            <a:solidFill>
+              <a:srgbClr val="2E7D32"/>
+            </a:solidFill>
+          </a:ln>
+        </p:spPr>
+        <p:txBody>
+          <a:bodyPr/>
+          <a:lstStyle/>
+          <a:p/>
+        </p:txBody>
+      </p:sp>
+      <p:sp>
+        <p:nvSpPr>
+          <p:cNvPr id="246" name="kt"/>
+          <p:cNvSpPr/>
+          <p:nvPr/>
+        </p:nvSpPr>
+        <p:spPr>
+          <a:xfrm>
+            <a:off x="4160520" y="4617720"/>
+            <a:ext cx="91440" cy="1143000"/>
+          </a:xfrm>
+          <a:prstGeom prst="rect">
+            <a:avLst/>
+          </a:prstGeom>
+          <a:solidFill>
+            <a:srgbClr val="2E7D32"/>
+          </a:solidFill>
+          <a:ln>
+            <a:noFill/>
+          </a:ln>
+        </p:spPr>
+        <p:txBody>
+          <a:bodyPr/>
+          <a:lstStyle/>
+          <a:p/>
+        </p:txBody>
+      </p:sp>
+      <p:sp>
+        <p:nvSpPr>
+          <p:cNvPr id="247" name="kl"/>
+          <p:cNvSpPr txBox="1"/>
+          <p:nvPr/>
+        </p:nvSpPr>
+        <p:spPr>
+          <a:xfrm>
+            <a:off x="4398264" y="4727448"/>
+            <a:ext cx="2971800" cy="365760"/>
+          </a:xfrm>
+          <a:prstGeom prst="rect">
+            <a:avLst/>
+          </a:prstGeom>
+          <a:noFill/>
+        </p:spPr>
+        <p:txBody>
+          <a:bodyPr wrap="square" anchor="t" rtlCol="0">
+            <a:normAutofit/>
+          </a:bodyPr>
+          <a:lstStyle/>
+          <a:p>
+            <a:pPr marL="0" indent="0" algn="l">
+              <a:spcBef>
+                <a:spcPts val="0"/>
+              </a:spcBef>
+              <a:spcAft>
+                <a:spcPts val="600"/>
+              </a:spcAft>
+              <a:buNone/>
+            </a:pPr>
+            <a:r>
+              <a:rPr lang="en-US" sz="1150" b="1" dirty="0">
+                <a:solidFill>
+                  <a:srgbClr val="1A2421"/>
+                </a:solidFill>
+                <a:latin typeface="Calibri"/>
+              </a:rPr>
+              <a:t>Fertilizer reduction</a:t>
+            </a:r>
+          </a:p>
+        </p:txBody>
+      </p:sp>
+      <p:sp>
+        <p:nvSpPr>
+          <p:cNvPr id="248" name="kp"/>
+          <p:cNvSpPr txBox="1"/>
+          <p:nvPr/>
+        </p:nvSpPr>
+        <p:spPr>
+          <a:xfrm>
+            <a:off x="4398264" y="5001768"/>
+            <a:ext cx="2971800" cy="457200"/>
+          </a:xfrm>
+          <a:prstGeom prst="rect">
+            <a:avLst/>
+          </a:prstGeom>
+          <a:noFill/>
+        </p:spPr>
+        <p:txBody>
+          <a:bodyPr wrap="square" anchor="t" rtlCol="0">
+            <a:normAutofit/>
+          </a:bodyPr>
+          <a:lstStyle/>
+          <a:p>
+            <a:pPr marL="0" indent="0" algn="l">
+              <a:spcBef>
+                <a:spcPts val="0"/>
+              </a:spcBef>
+              <a:spcAft>
+                <a:spcPts val="600"/>
+              </a:spcAft>
+              <a:buNone/>
+            </a:pPr>
+            <a:r>
+              <a:rPr lang="en-US" sz="2200" b="1" dirty="0">
                 <a:solidFill>
                   <a:srgbClr val="2E7D32"/>
                 </a:solidFill>
                 <a:latin typeface="Calibri"/>
               </a:rPr>
-              <a:t>Next milestones</a:t>
-            </a:r>
-          </a:p>
-          <a:p>
-            <a:pPr marL="292608" indent="-292608" algn="l">
-              <a:spcBef>
-                <a:spcPts val="0"/>
-              </a:spcBef>
-              <a:spcAft>
-                <a:spcPts val="380"/>
-              </a:spcAft>
-              <a:buFont typeface="Arial"/>
-              <a:buChar char="•"/>
-            </a:pPr>
-            <a:r>
-              <a:rPr lang="en-US" sz="1500" dirty="0">
+              <a:t>45%</a:t>
+            </a:r>
+          </a:p>
+        </p:txBody>
+      </p:sp>
+      <p:sp>
+        <p:nvSpPr>
+          <p:cNvPr id="249" name="trk"/>
+          <p:cNvSpPr/>
+          <p:nvPr/>
+        </p:nvSpPr>
+        <p:spPr>
+          <a:xfrm>
+            <a:off x="4416552" y="5468112"/>
+            <a:ext cx="2871216" cy="146304"/>
+          </a:xfrm>
+          <a:prstGeom prst="roundRect">
+            <a:avLst>
+              <a:gd name="adj" fmla="val 50000"/>
+            </a:avLst>
+          </a:prstGeom>
+          <a:solidFill>
+            <a:srgbClr val="E1E8E0"/>
+          </a:solidFill>
+          <a:ln>
+            <a:noFill/>
+          </a:ln>
+        </p:spPr>
+        <p:txBody>
+          <a:bodyPr/>
+          <a:lstStyle/>
+          <a:p/>
+        </p:txBody>
+      </p:sp>
+      <p:sp>
+        <p:nvSpPr>
+          <p:cNvPr id="250" name="fil"/>
+          <p:cNvSpPr/>
+          <p:nvPr/>
+        </p:nvSpPr>
+        <p:spPr>
+          <a:xfrm>
+            <a:off x="4416552" y="5468112"/>
+            <a:ext cx="1292047" cy="146304"/>
+          </a:xfrm>
+          <a:prstGeom prst="roundRect">
+            <a:avLst>
+              <a:gd name="adj" fmla="val 50000"/>
+            </a:avLst>
+          </a:prstGeom>
+          <a:solidFill>
+            <a:srgbClr val="2E7D32"/>
+          </a:solidFill>
+          <a:ln>
+            <a:noFill/>
+          </a:ln>
+        </p:spPr>
+        <p:txBody>
+          <a:bodyPr/>
+          <a:lstStyle/>
+          <a:p/>
+        </p:txBody>
+      </p:sp>
+      <p:sp>
+        <p:nvSpPr>
+          <p:cNvPr id="251" name="k"/>
+          <p:cNvSpPr/>
+          <p:nvPr/>
+        </p:nvSpPr>
+        <p:spPr>
+          <a:xfrm>
+            <a:off x="7818120" y="4617720"/>
+            <a:ext cx="3383280" cy="1143000"/>
+          </a:xfrm>
+          <a:prstGeom prst="roundRect">
+            <a:avLst>
+              <a:gd name="adj" fmla="val 8000"/>
+            </a:avLst>
+          </a:prstGeom>
+          <a:solidFill>
+            <a:srgbClr val="F3F8F1"/>
+          </a:solidFill>
+          <a:ln w="14000">
+            <a:solidFill>
+              <a:srgbClr val="EF6C00"/>
+            </a:solidFill>
+          </a:ln>
+        </p:spPr>
+        <p:txBody>
+          <a:bodyPr/>
+          <a:lstStyle/>
+          <a:p/>
+        </p:txBody>
+      </p:sp>
+      <p:sp>
+        <p:nvSpPr>
+          <p:cNvPr id="252" name="kt"/>
+          <p:cNvSpPr/>
+          <p:nvPr/>
+        </p:nvSpPr>
+        <p:spPr>
+          <a:xfrm>
+            <a:off x="7818120" y="4617720"/>
+            <a:ext cx="91440" cy="1143000"/>
+          </a:xfrm>
+          <a:prstGeom prst="rect">
+            <a:avLst/>
+          </a:prstGeom>
+          <a:solidFill>
+            <a:srgbClr val="EF6C00"/>
+          </a:solidFill>
+          <a:ln>
+            <a:noFill/>
+          </a:ln>
+        </p:spPr>
+        <p:txBody>
+          <a:bodyPr/>
+          <a:lstStyle/>
+          <a:p/>
+        </p:txBody>
+      </p:sp>
+      <p:sp>
+        <p:nvSpPr>
+          <p:cNvPr id="253" name="kl"/>
+          <p:cNvSpPr txBox="1"/>
+          <p:nvPr/>
+        </p:nvSpPr>
+        <p:spPr>
+          <a:xfrm>
+            <a:off x="8055864" y="4727448"/>
+            <a:ext cx="2971800" cy="365760"/>
+          </a:xfrm>
+          <a:prstGeom prst="rect">
+            <a:avLst/>
+          </a:prstGeom>
+          <a:noFill/>
+        </p:spPr>
+        <p:txBody>
+          <a:bodyPr wrap="square" anchor="t" rtlCol="0">
+            <a:normAutofit/>
+          </a:bodyPr>
+          <a:lstStyle/>
+          <a:p>
+            <a:pPr marL="0" indent="0" algn="l">
+              <a:spcBef>
+                <a:spcPts val="0"/>
+              </a:spcBef>
+              <a:spcAft>
+                <a:spcPts val="600"/>
+              </a:spcAft>
+              <a:buNone/>
+            </a:pPr>
+            <a:r>
+              <a:rPr lang="en-US" sz="1150" b="1" dirty="0">
                 <a:solidFill>
                   <a:srgbClr val="1A2421"/>
                 </a:solidFill>
                 <a:latin typeface="Calibri"/>
               </a:rPr>
-              <a:t>Build: assemble hardware prototype (BTS7960 drive, NPK probe, pan/tilt sprayer, LiFePO4) - ~3 months.</a:t>
-            </a:r>
-          </a:p>
-          <a:p>
-            <a:pPr marL="292608" indent="-292608" algn="l">
-              <a:spcBef>
-                <a:spcPts val="0"/>
-              </a:spcBef>
-              <a:spcAft>
-                <a:spcPts val="380"/>
-              </a:spcAft>
-              <a:buFont typeface="Arial"/>
-              <a:buChar char="•"/>
-            </a:pPr>
-            <a:r>
-              <a:rPr lang="en-US" sz="1500" dirty="0">
-                <a:solidFill>
-                  <a:srgbClr val="1A2421"/>
-                </a:solidFill>
-                <a:latin typeface="Calibri"/>
-              </a:rPr>
-              <a:t>Test: pilot on 5-10 small farms; measure input savings, accuracy and uptime.</a:t>
-            </a:r>
-          </a:p>
-          <a:p>
-            <a:pPr marL="292608" indent="-292608" algn="l">
-              <a:spcBef>
-                <a:spcPts val="0"/>
-              </a:spcBef>
-              <a:spcAft>
-                <a:spcPts val="380"/>
-              </a:spcAft>
-              <a:buFont typeface="Arial"/>
-              <a:buChar char="•"/>
-            </a:pPr>
-            <a:r>
-              <a:rPr lang="en-US" sz="1500" dirty="0">
-                <a:solidFill>
-                  <a:srgbClr val="1A2421"/>
-                </a:solidFill>
-                <a:latin typeface="Calibri"/>
-              </a:rPr>
-              <a:t>Iterate: refine dosing + AI from field data; harden for dust and 40-45C heat.</a:t>
-            </a:r>
-          </a:p>
+              <a:t>Cost saving / acre</a:t>
+            </a:r>
+          </a:p>
+        </p:txBody>
+      </p:sp>
+      <p:sp>
+        <p:nvSpPr>
+          <p:cNvPr id="254" name="kp"/>
+          <p:cNvSpPr txBox="1"/>
+          <p:nvPr/>
+        </p:nvSpPr>
+        <p:spPr>
+          <a:xfrm>
+            <a:off x="8055864" y="5001768"/>
+            <a:ext cx="2971800" cy="457200"/>
+          </a:xfrm>
+          <a:prstGeom prst="rect">
+            <a:avLst/>
+          </a:prstGeom>
+          <a:noFill/>
+        </p:spPr>
+        <p:txBody>
+          <a:bodyPr wrap="square" anchor="t" rtlCol="0">
+            <a:normAutofit/>
+          </a:bodyPr>
+          <a:lstStyle/>
           <a:p>
             <a:pPr marL="0" indent="0" algn="l">
               <a:spcBef>
                 <a:spcPts val="0"/>
               </a:spcBef>
               <a:spcAft>
-                <a:spcPts val="220"/>
-              </a:spcAft>
-              <a:buNone/>
-            </a:pPr>
-            <a:r>
-              <a:rPr lang="en-US" sz="1600" b="1" dirty="0">
-                <a:solidFill>
-                  <a:srgbClr val="2E7D32"/>
-                </a:solidFill>
-                <a:latin typeface="Calibri"/>
-              </a:rPr>
-              <a:t>Go-to-market</a:t>
-            </a:r>
-          </a:p>
-          <a:p>
-            <a:pPr marL="292608" indent="-292608" algn="l">
-              <a:spcBef>
-                <a:spcPts val="0"/>
-              </a:spcBef>
-              <a:spcAft>
-                <a:spcPts val="380"/>
-              </a:spcAft>
-              <a:buFont typeface="Arial"/>
-              <a:buChar char="•"/>
-            </a:pPr>
-            <a:r>
-              <a:rPr lang="en-US" sz="1500" dirty="0">
-                <a:solidFill>
-                  <a:srgbClr val="1A2421"/>
-                </a:solidFill>
-                <a:latin typeface="Calibri"/>
-              </a:rPr>
-              <a:t>Pilot with a local FPO / Custom Hiring Centre; use SMAM/AIF support to lower farmer cost.</a:t>
-            </a:r>
-          </a:p>
-          <a:p>
-            <a:pPr marL="292608" indent="-292608" algn="l">
-              <a:spcBef>
-                <a:spcPts val="0"/>
-              </a:spcBef>
-              <a:spcAft>
-                <a:spcPts val="380"/>
-              </a:spcAft>
-              <a:buFont typeface="Arial"/>
-              <a:buChar char="•"/>
-            </a:pPr>
-            <a:r>
-              <a:rPr lang="en-US" sz="1500" dirty="0">
-                <a:solidFill>
-                  <a:srgbClr val="1A2421"/>
-                </a:solidFill>
-                <a:latin typeface="Calibri"/>
-              </a:rPr>
-              <a:t>Expand from sale to Rover-as-a-Service + data subscription.</a:t>
+                <a:spcPts val="600"/>
+              </a:spcAft>
+              <a:buNone/>
+            </a:pPr>
+            <a:r>
+              <a:rPr lang="en-US" sz="2200" b="1" dirty="0">
+                <a:solidFill>
+                  <a:srgbClr val="EF6C00"/>
+                </a:solidFill>
+                <a:latin typeface="Calibri"/>
+              </a:rPr>
+              <a:t>40%</a:t>
+            </a:r>
+          </a:p>
+        </p:txBody>
+      </p:sp>
+      <p:sp>
+        <p:nvSpPr>
+          <p:cNvPr id="255" name="trk"/>
+          <p:cNvSpPr/>
+          <p:nvPr/>
+        </p:nvSpPr>
+        <p:spPr>
+          <a:xfrm>
+            <a:off x="8074152" y="5468112"/>
+            <a:ext cx="2871216" cy="146304"/>
+          </a:xfrm>
+          <a:prstGeom prst="roundRect">
+            <a:avLst>
+              <a:gd name="adj" fmla="val 50000"/>
+            </a:avLst>
+          </a:prstGeom>
+          <a:solidFill>
+            <a:srgbClr val="E1E8E0"/>
+          </a:solidFill>
+          <a:ln>
+            <a:noFill/>
+          </a:ln>
+        </p:spPr>
+        <p:txBody>
+          <a:bodyPr/>
+          <a:lstStyle/>
+          <a:p/>
+        </p:txBody>
+      </p:sp>
+      <p:sp>
+        <p:nvSpPr>
+          <p:cNvPr id="256" name="fil"/>
+          <p:cNvSpPr/>
+          <p:nvPr/>
+        </p:nvSpPr>
+        <p:spPr>
+          <a:xfrm>
+            <a:off x="8074152" y="5468112"/>
+            <a:ext cx="1148486" cy="146304"/>
+          </a:xfrm>
+          <a:prstGeom prst="roundRect">
+            <a:avLst>
+              <a:gd name="adj" fmla="val 50000"/>
+            </a:avLst>
+          </a:prstGeom>
+          <a:solidFill>
+            <a:srgbClr val="EF6C00"/>
+          </a:solidFill>
+          <a:ln>
+            <a:noFill/>
+          </a:ln>
+        </p:spPr>
+        <p:txBody>
+          <a:bodyPr/>
+          <a:lstStyle/>
+          <a:p/>
+        </p:txBody>
+      </p:sp>
+      <p:sp>
+        <p:nvSpPr>
+          <p:cNvPr id="257" name="simnote"/>
+          <p:cNvSpPr txBox="1"/>
+          <p:nvPr/>
+        </p:nvSpPr>
+        <p:spPr>
+          <a:xfrm>
+            <a:off x="502920" y="5897880"/>
+            <a:ext cx="10698480" cy="365760"/>
+          </a:xfrm>
+          <a:prstGeom prst="rect">
+            <a:avLst/>
+          </a:prstGeom>
+          <a:noFill/>
+        </p:spPr>
+        <p:txBody>
+          <a:bodyPr wrap="square" anchor="t" rtlCol="0">
+            <a:normAutofit/>
+          </a:bodyPr>
+          <a:lstStyle/>
+          <a:p>
+            <a:pPr marL="0" indent="0" algn="l">
+              <a:spcBef>
+                <a:spcPts val="0"/>
+              </a:spcBef>
+              <a:spcAft>
+                <a:spcPts val="600"/>
+              </a:spcAft>
+              <a:buNone/>
+            </a:pPr>
+            <a:r>
+              <a:rPr lang="en-US" sz="1000" i="1" dirty="0">
+                <a:solidFill>
+                  <a:srgbClr val="5B6B63"/>
+                </a:solidFill>
+                <a:latin typeface="Calibri"/>
+              </a:rPr>
+              <a:t>Projected from our simulation model &amp; targets - to be validated in field pilots (not yet measured on hardware).</a:t>
             </a:r>
           </a:p>
         </p:txBody>

</xml_diff>

<commit_message>
Add BTS7960 wiring checklist + appendix drive-wiring schematic slide in deck
</commit_message>
<xml_diff>
--- a/AgriRover_Pitch.pptx
+++ b/AgriRover_Pitch.pptx
@@ -17,6 +17,7 @@
     <p:sldId id="265" r:id="rId11"/>
     <p:sldId id="266" r:id="rId12"/>
     <p:sldId id="267" r:id="rId13"/>
+    <p:sldId id="268" r:id="rId15"/>
   </p:sldIdLst>
   <p:sldSz cx="12192000" cy="6858000"/>
   <p:notesSz cx="6858000" cy="9144000"/>
@@ -2631,6 +2632,1851 @@
           </a:p>
         </p:txBody>
       </p:sp>
+    </p:spTree>
+  </p:cSld>
+  <p:clrMapOvr>
+    <a:masterClrMapping/>
+  </p:clrMapOvr>
+</p:sld>
+</file>
+
+<file path=ppt/slides/slide13.xml><?xml version="1.0" encoding="utf-8"?>
+<p:sld xmlns:a="http://schemas.openxmlformats.org/drawingml/2006/main" xmlns:r="http://schemas.openxmlformats.org/officeDocument/2006/relationships" xmlns:p="http://schemas.openxmlformats.org/presentationml/2006/main">
+  <p:cSld>
+    <p:bg>
+      <p:bgPr>
+        <a:solidFill>
+          <a:srgbClr val="FFFFFF"/>
+        </a:solidFill>
+        <a:effectLst/>
+      </p:bgPr>
+    </p:bg>
+    <p:spTree>
+      <p:nvGrpSpPr>
+        <p:cNvPr id="1" name=""/>
+        <p:cNvGrpSpPr/>
+        <p:nvPr/>
+      </p:nvGrpSpPr>
+      <p:grpSpPr>
+        <a:xfrm>
+          <a:off x="0" y="0"/>
+          <a:ext cx="0" cy="0"/>
+          <a:chOff x="0" y="0"/>
+          <a:chExt cx="0" cy="0"/>
+        </a:xfrm>
+      </p:grpSpPr>
+      <p:sp>
+        <p:nvSpPr>
+          <p:cNvPr id="10" name="band"/>
+          <p:cNvSpPr/>
+          <p:nvPr/>
+        </p:nvSpPr>
+        <p:spPr>
+          <a:xfrm>
+            <a:off x="0" y="0"/>
+            <a:ext cx="12192000" cy="960120"/>
+          </a:xfrm>
+          <a:prstGeom prst="rect">
+            <a:avLst/>
+          </a:prstGeom>
+          <a:solidFill>
+            <a:srgbClr val="2E7D32"/>
+          </a:solidFill>
+          <a:ln>
+            <a:noFill/>
+          </a:ln>
+        </p:spPr>
+        <p:txBody>
+          <a:bodyPr/>
+          <a:lstStyle/>
+          <a:p/>
+        </p:txBody>
+      </p:sp>
+      <p:sp>
+        <p:nvSpPr>
+          <p:cNvPr id="11" name="acc"/>
+          <p:cNvSpPr/>
+          <p:nvPr/>
+        </p:nvSpPr>
+        <p:spPr>
+          <a:xfrm>
+            <a:off x="0" y="960120"/>
+            <a:ext cx="12192000" cy="45720"/>
+          </a:xfrm>
+          <a:prstGeom prst="rect">
+            <a:avLst/>
+          </a:prstGeom>
+          <a:solidFill>
+            <a:srgbClr val="F9A825"/>
+          </a:solidFill>
+          <a:ln>
+            <a:noFill/>
+          </a:ln>
+        </p:spPr>
+        <p:txBody>
+          <a:bodyPr/>
+          <a:lstStyle/>
+          <a:p/>
+        </p:txBody>
+      </p:sp>
+      <p:sp>
+        <p:nvSpPr>
+          <p:cNvPr id="12" name="title"/>
+          <p:cNvSpPr txBox="1"/>
+          <p:nvPr/>
+        </p:nvSpPr>
+        <p:spPr>
+          <a:xfrm>
+            <a:off x="457200" y="109728"/>
+            <a:ext cx="11247120" cy="731520"/>
+          </a:xfrm>
+          <a:prstGeom prst="rect">
+            <a:avLst/>
+          </a:prstGeom>
+          <a:noFill/>
+        </p:spPr>
+        <p:txBody>
+          <a:bodyPr wrap="square" anchor="ctr" rtlCol="0">
+            <a:normAutofit/>
+          </a:bodyPr>
+          <a:lstStyle/>
+          <a:p>
+            <a:pPr algn="l">
+              <a:spcAft>
+                <a:spcPts val="300"/>
+              </a:spcAft>
+              <a:buNone/>
+            </a:pPr>
+            <a:r>
+              <a:rPr lang="en-US" sz="2500" b="1" dirty="0">
+                <a:solidFill>
+                  <a:srgbClr val="FFFFFF"/>
+                </a:solidFill>
+                <a:latin typeface="Calibri"/>
+              </a:rPr>
+              <a:t>Appendix - BTS7960 Drive Wiring (each pin)</a:t>
+            </a:r>
+          </a:p>
+        </p:txBody>
+      </p:sp>
+      <p:sp>
+        <p:nvSpPr>
+          <p:cNvPr id="13" name="foot"/>
+          <p:cNvSpPr txBox="1"/>
+          <p:nvPr/>
+        </p:nvSpPr>
+        <p:spPr>
+          <a:xfrm>
+            <a:off x="457200" y="6419088"/>
+            <a:ext cx="11247120" cy="320040"/>
+          </a:xfrm>
+          <a:prstGeom prst="rect">
+            <a:avLst/>
+          </a:prstGeom>
+          <a:noFill/>
+        </p:spPr>
+        <p:txBody>
+          <a:bodyPr wrap="square" anchor="t" rtlCol="0">
+            <a:normAutofit/>
+          </a:bodyPr>
+          <a:lstStyle/>
+          <a:p>
+            <a:pPr algn="l">
+              <a:spcAft>
+                <a:spcPts val="300"/>
+              </a:spcAft>
+              <a:buNone/>
+            </a:pPr>
+            <a:r>
+              <a:rPr lang="en-US" sz="950" dirty="0">
+                <a:solidFill>
+                  <a:srgbClr val="5B6B63"/>
+                </a:solidFill>
+                <a:latin typeface="Calibri"/>
+              </a:rPr>
+              <a:t>AgriRover  -  IITB-Groww INV.ENT  -  Track A  -  FC-10: 2x L298N -&gt; 2x BTS7960</a:t>
+            </a:r>
+          </a:p>
+        </p:txBody>
+      </p:sp>
+      <p:sp>
+        <p:nvSpPr>
+          <p:cNvPr id="20" name="blk"/>
+          <p:cNvSpPr/>
+          <p:nvPr/>
+        </p:nvSpPr>
+        <p:spPr>
+          <a:xfrm>
+            <a:off x="411480" y="1234440"/>
+            <a:ext cx="2606040" cy="2606040"/>
+          </a:xfrm>
+          <a:prstGeom prst="roundRect">
+            <a:avLst>
+              <a:gd name="adj" fmla="val 7000"/>
+            </a:avLst>
+          </a:prstGeom>
+          <a:solidFill>
+            <a:srgbClr val="E3F2FD"/>
+          </a:solidFill>
+          <a:ln w="14000">
+            <a:solidFill>
+              <a:srgbClr val="1565C0"/>
+            </a:solidFill>
+          </a:ln>
+        </p:spPr>
+        <p:txBody>
+          <a:bodyPr/>
+          <a:lstStyle/>
+          <a:p/>
+        </p:txBody>
+      </p:sp>
+      <p:sp>
+        <p:nvSpPr>
+          <p:cNvPr id="21" name="blkt"/>
+          <p:cNvSpPr txBox="1"/>
+          <p:nvPr/>
+        </p:nvSpPr>
+        <p:spPr>
+          <a:xfrm>
+            <a:off x="576072" y="1325880"/>
+            <a:ext cx="2295144" cy="2423160"/>
+          </a:xfrm>
+          <a:prstGeom prst="rect">
+            <a:avLst/>
+          </a:prstGeom>
+          <a:noFill/>
+        </p:spPr>
+        <p:txBody>
+          <a:bodyPr wrap="square" anchor="t" rtlCol="0">
+            <a:normAutofit/>
+          </a:bodyPr>
+          <a:lstStyle/>
+          <a:p>
+            <a:pPr algn="l">
+              <a:spcAft>
+                <a:spcPts val="120"/>
+              </a:spcAft>
+              <a:buNone/>
+            </a:pPr>
+            <a:r>
+              <a:rPr lang="en-US" sz="1250" b="1" dirty="0">
+                <a:solidFill>
+                  <a:srgbClr val="1565C0"/>
+                </a:solidFill>
+                <a:latin typeface="Calibri"/>
+              </a:rPr>
+              <a:t>ESP32 DevKit V1</a:t>
+            </a:r>
+          </a:p>
+          <a:p>
+            <a:pPr algn="l">
+              <a:spcAft>
+                <a:spcPts val="120"/>
+              </a:spcAft>
+              <a:buNone/>
+            </a:pPr>
+            <a:r>
+              <a:rPr lang="en-US" sz="1050" dirty="0">
+                <a:solidFill>
+                  <a:srgbClr val="1A2421"/>
+                </a:solidFill>
+                <a:latin typeface="Calibri"/>
+              </a:rPr>
+              <a:t>GPIO19  -&gt;  L_RPWM</a:t>
+            </a:r>
+          </a:p>
+          <a:p>
+            <a:pPr algn="l">
+              <a:spcAft>
+                <a:spcPts val="120"/>
+              </a:spcAft>
+              <a:buNone/>
+            </a:pPr>
+            <a:r>
+              <a:rPr lang="en-US" sz="1050" dirty="0">
+                <a:solidFill>
+                  <a:srgbClr val="1A2421"/>
+                </a:solidFill>
+                <a:latin typeface="Calibri"/>
+              </a:rPr>
+              <a:t>GPIO21  -&gt;  L_LPWM</a:t>
+            </a:r>
+          </a:p>
+          <a:p>
+            <a:pPr algn="l">
+              <a:spcAft>
+                <a:spcPts val="120"/>
+              </a:spcAft>
+              <a:buNone/>
+            </a:pPr>
+            <a:r>
+              <a:rPr lang="en-US" sz="1050" dirty="0">
+                <a:solidFill>
+                  <a:srgbClr val="1A2421"/>
+                </a:solidFill>
+                <a:latin typeface="Calibri"/>
+              </a:rPr>
+              <a:t>GPIO22  -&gt;  R_RPWM</a:t>
+            </a:r>
+          </a:p>
+          <a:p>
+            <a:pPr algn="l">
+              <a:spcAft>
+                <a:spcPts val="120"/>
+              </a:spcAft>
+              <a:buNone/>
+            </a:pPr>
+            <a:r>
+              <a:rPr lang="en-US" sz="1050" dirty="0">
+                <a:solidFill>
+                  <a:srgbClr val="1A2421"/>
+                </a:solidFill>
+                <a:latin typeface="Calibri"/>
+              </a:rPr>
+              <a:t>GPIO23  -&gt;  R_LPWM</a:t>
+            </a:r>
+          </a:p>
+          <a:p>
+            <a:pPr algn="l">
+              <a:spcAft>
+                <a:spcPts val="120"/>
+              </a:spcAft>
+              <a:buNone/>
+            </a:pPr>
+            <a:r>
+              <a:rPr lang="en-US" sz="1050" b="1" dirty="0">
+                <a:solidFill>
+                  <a:srgbClr val="2E7D32"/>
+                </a:solidFill>
+                <a:latin typeface="Calibri"/>
+              </a:rPr>
+              <a:t>3V3  -&gt;  R_EN/L_EN/VCC</a:t>
+            </a:r>
+          </a:p>
+          <a:p>
+            <a:pPr algn="l">
+              <a:spcAft>
+                <a:spcPts val="120"/>
+              </a:spcAft>
+              <a:buNone/>
+            </a:pPr>
+            <a:r>
+              <a:rPr lang="en-US" sz="1050" b="1" dirty="0">
+                <a:solidFill>
+                  <a:srgbClr val="37474F"/>
+                </a:solidFill>
+                <a:latin typeface="Calibri"/>
+              </a:rPr>
+              <a:t>GND  -&gt;  common star</a:t>
+            </a:r>
+          </a:p>
+          <a:p>
+            <a:pPr algn="l">
+              <a:spcAft>
+                <a:spcPts val="120"/>
+              </a:spcAft>
+              <a:buNone/>
+            </a:pPr>
+            <a:r>
+              <a:rPr lang="en-US" sz="1000" dirty="0">
+                <a:solidFill>
+                  <a:srgbClr val="B26A00"/>
+                </a:solidFill>
+                <a:latin typeface="Calibri"/>
+              </a:rPr>
+              <a:t>GPIO32/33  FREE (old ENA/ENB)</a:t>
+            </a:r>
+          </a:p>
+        </p:txBody>
+      </p:sp>
+      <p:sp>
+        <p:nvSpPr>
+          <p:cNvPr id="24" name="blk"/>
+          <p:cNvSpPr/>
+          <p:nvPr/>
+        </p:nvSpPr>
+        <p:spPr>
+          <a:xfrm>
+            <a:off x="3383280" y="1234440"/>
+            <a:ext cx="3200400" cy="1207008"/>
+          </a:xfrm>
+          <a:prstGeom prst="roundRect">
+            <a:avLst>
+              <a:gd name="adj" fmla="val 7000"/>
+            </a:avLst>
+          </a:prstGeom>
+          <a:solidFill>
+            <a:srgbClr val="FCE4EC"/>
+          </a:solidFill>
+          <a:ln w="14000">
+            <a:solidFill>
+              <a:srgbClr val="C62828"/>
+            </a:solidFill>
+          </a:ln>
+        </p:spPr>
+        <p:txBody>
+          <a:bodyPr/>
+          <a:lstStyle/>
+          <a:p/>
+        </p:txBody>
+      </p:sp>
+      <p:sp>
+        <p:nvSpPr>
+          <p:cNvPr id="25" name="blkt"/>
+          <p:cNvSpPr txBox="1"/>
+          <p:nvPr/>
+        </p:nvSpPr>
+        <p:spPr>
+          <a:xfrm>
+            <a:off x="3547872" y="1325880"/>
+            <a:ext cx="2889504" cy="1024128"/>
+          </a:xfrm>
+          <a:prstGeom prst="rect">
+            <a:avLst/>
+          </a:prstGeom>
+          <a:noFill/>
+        </p:spPr>
+        <p:txBody>
+          <a:bodyPr wrap="square" anchor="t" rtlCol="0">
+            <a:normAutofit/>
+          </a:bodyPr>
+          <a:lstStyle/>
+          <a:p>
+            <a:pPr algn="l">
+              <a:spcAft>
+                <a:spcPts val="120"/>
+              </a:spcAft>
+              <a:buNone/>
+            </a:pPr>
+            <a:r>
+              <a:rPr lang="en-US" sz="1200" b="1" dirty="0">
+                <a:solidFill>
+                  <a:srgbClr val="C62828"/>
+                </a:solidFill>
+                <a:latin typeface="Calibri"/>
+              </a:rPr>
+              <a:t>BTS7960 #1  -  LEFT</a:t>
+            </a:r>
+          </a:p>
+          <a:p>
+            <a:pPr algn="l">
+              <a:spcAft>
+                <a:spcPts val="120"/>
+              </a:spcAft>
+              <a:buNone/>
+            </a:pPr>
+            <a:r>
+              <a:rPr lang="en-US" sz="1000" dirty="0">
+                <a:solidFill>
+                  <a:srgbClr val="1A2421"/>
+                </a:solidFill>
+                <a:latin typeface="Calibri"/>
+              </a:rPr>
+              <a:t>in: RPWM LPWM R_EN L_EN VCC GND</a:t>
+            </a:r>
+          </a:p>
+          <a:p>
+            <a:pPr algn="l">
+              <a:spcAft>
+                <a:spcPts val="120"/>
+              </a:spcAft>
+              <a:buNone/>
+            </a:pPr>
+            <a:r>
+              <a:rPr lang="en-US" sz="1050" b="1" dirty="0">
+                <a:solidFill>
+                  <a:srgbClr val="1A2421"/>
+                </a:solidFill>
+                <a:latin typeface="Calibri"/>
+              </a:rPr>
+              <a:t>power/out: B+  B-  M+  M-</a:t>
+            </a:r>
+          </a:p>
+        </p:txBody>
+      </p:sp>
+      <p:sp>
+        <p:nvSpPr>
+          <p:cNvPr id="28" name="blk"/>
+          <p:cNvSpPr/>
+          <p:nvPr/>
+        </p:nvSpPr>
+        <p:spPr>
+          <a:xfrm>
+            <a:off x="3383280" y="2633472"/>
+            <a:ext cx="3200400" cy="1207008"/>
+          </a:xfrm>
+          <a:prstGeom prst="roundRect">
+            <a:avLst>
+              <a:gd name="adj" fmla="val 7000"/>
+            </a:avLst>
+          </a:prstGeom>
+          <a:solidFill>
+            <a:srgbClr val="FCE4EC"/>
+          </a:solidFill>
+          <a:ln w="14000">
+            <a:solidFill>
+              <a:srgbClr val="C62828"/>
+            </a:solidFill>
+          </a:ln>
+        </p:spPr>
+        <p:txBody>
+          <a:bodyPr/>
+          <a:lstStyle/>
+          <a:p/>
+        </p:txBody>
+      </p:sp>
+      <p:sp>
+        <p:nvSpPr>
+          <p:cNvPr id="29" name="blkt"/>
+          <p:cNvSpPr txBox="1"/>
+          <p:nvPr/>
+        </p:nvSpPr>
+        <p:spPr>
+          <a:xfrm>
+            <a:off x="3547872" y="2724912"/>
+            <a:ext cx="2889504" cy="1024128"/>
+          </a:xfrm>
+          <a:prstGeom prst="rect">
+            <a:avLst/>
+          </a:prstGeom>
+          <a:noFill/>
+        </p:spPr>
+        <p:txBody>
+          <a:bodyPr wrap="square" anchor="t" rtlCol="0">
+            <a:normAutofit/>
+          </a:bodyPr>
+          <a:lstStyle/>
+          <a:p>
+            <a:pPr algn="l">
+              <a:spcAft>
+                <a:spcPts val="120"/>
+              </a:spcAft>
+              <a:buNone/>
+            </a:pPr>
+            <a:r>
+              <a:rPr lang="en-US" sz="1200" b="1" dirty="0">
+                <a:solidFill>
+                  <a:srgbClr val="C62828"/>
+                </a:solidFill>
+                <a:latin typeface="Calibri"/>
+              </a:rPr>
+              <a:t>BTS7960 #2  -  RIGHT</a:t>
+            </a:r>
+          </a:p>
+          <a:p>
+            <a:pPr algn="l">
+              <a:spcAft>
+                <a:spcPts val="120"/>
+              </a:spcAft>
+              <a:buNone/>
+            </a:pPr>
+            <a:r>
+              <a:rPr lang="en-US" sz="1000" dirty="0">
+                <a:solidFill>
+                  <a:srgbClr val="1A2421"/>
+                </a:solidFill>
+                <a:latin typeface="Calibri"/>
+              </a:rPr>
+              <a:t>in: RPWM LPWM R_EN L_EN VCC GND</a:t>
+            </a:r>
+          </a:p>
+          <a:p>
+            <a:pPr algn="l">
+              <a:spcAft>
+                <a:spcPts val="120"/>
+              </a:spcAft>
+              <a:buNone/>
+            </a:pPr>
+            <a:r>
+              <a:rPr lang="en-US" sz="1050" b="1" dirty="0">
+                <a:solidFill>
+                  <a:srgbClr val="1A2421"/>
+                </a:solidFill>
+                <a:latin typeface="Calibri"/>
+              </a:rPr>
+              <a:t>power/out: B+  B-  M+  M-</a:t>
+            </a:r>
+          </a:p>
+        </p:txBody>
+      </p:sp>
+      <p:sp>
+        <p:nvSpPr>
+          <p:cNvPr id="32" name="blk"/>
+          <p:cNvSpPr/>
+          <p:nvPr/>
+        </p:nvSpPr>
+        <p:spPr>
+          <a:xfrm>
+            <a:off x="6995160" y="1234440"/>
+            <a:ext cx="2286000" cy="1207008"/>
+          </a:xfrm>
+          <a:prstGeom prst="roundRect">
+            <a:avLst>
+              <a:gd name="adj" fmla="val 7000"/>
+            </a:avLst>
+          </a:prstGeom>
+          <a:solidFill>
+            <a:srgbClr val="ECEFF1"/>
+          </a:solidFill>
+          <a:ln w="14000">
+            <a:solidFill>
+              <a:srgbClr val="37474F"/>
+            </a:solidFill>
+          </a:ln>
+        </p:spPr>
+        <p:txBody>
+          <a:bodyPr/>
+          <a:lstStyle/>
+          <a:p/>
+        </p:txBody>
+      </p:sp>
+      <p:sp>
+        <p:nvSpPr>
+          <p:cNvPr id="33" name="blkt"/>
+          <p:cNvSpPr txBox="1"/>
+          <p:nvPr/>
+        </p:nvSpPr>
+        <p:spPr>
+          <a:xfrm>
+            <a:off x="7159752" y="1325880"/>
+            <a:ext cx="1975104" cy="1024128"/>
+          </a:xfrm>
+          <a:prstGeom prst="rect">
+            <a:avLst/>
+          </a:prstGeom>
+          <a:noFill/>
+        </p:spPr>
+        <p:txBody>
+          <a:bodyPr wrap="square" anchor="t" rtlCol="0">
+            <a:normAutofit/>
+          </a:bodyPr>
+          <a:lstStyle/>
+          <a:p>
+            <a:pPr algn="l">
+              <a:spcAft>
+                <a:spcPts val="120"/>
+              </a:spcAft>
+              <a:buNone/>
+            </a:pPr>
+            <a:r>
+              <a:rPr lang="en-US" sz="1200" b="1" dirty="0">
+                <a:solidFill>
+                  <a:srgbClr val="37474F"/>
+                </a:solidFill>
+                <a:latin typeface="Calibri"/>
+              </a:rPr>
+              <a:t>Left motors</a:t>
+            </a:r>
+          </a:p>
+          <a:p>
+            <a:pPr algn="l">
+              <a:spcAft>
+                <a:spcPts val="120"/>
+              </a:spcAft>
+              <a:buNone/>
+            </a:pPr>
+            <a:r>
+              <a:rPr lang="en-US" sz="1050" dirty="0">
+                <a:solidFill>
+                  <a:srgbClr val="1A2421"/>
+                </a:solidFill>
+                <a:latin typeface="Calibri"/>
+              </a:rPr>
+              <a:t>FL + RL (parallel)</a:t>
+            </a:r>
+          </a:p>
+          <a:p>
+            <a:pPr algn="l">
+              <a:spcAft>
+                <a:spcPts val="120"/>
+              </a:spcAft>
+              <a:buNone/>
+            </a:pPr>
+            <a:r>
+              <a:rPr lang="en-US" sz="1000" dirty="0">
+                <a:solidFill>
+                  <a:srgbClr val="5B6B63"/>
+                </a:solidFill>
+                <a:latin typeface="Calibri"/>
+              </a:rPr>
+              <a:t>1N5819 flyback each</a:t>
+            </a:r>
+          </a:p>
+        </p:txBody>
+      </p:sp>
+      <p:sp>
+        <p:nvSpPr>
+          <p:cNvPr id="36" name="blk"/>
+          <p:cNvSpPr/>
+          <p:nvPr/>
+        </p:nvSpPr>
+        <p:spPr>
+          <a:xfrm>
+            <a:off x="6995160" y="2633472"/>
+            <a:ext cx="2286000" cy="1207008"/>
+          </a:xfrm>
+          <a:prstGeom prst="roundRect">
+            <a:avLst>
+              <a:gd name="adj" fmla="val 7000"/>
+            </a:avLst>
+          </a:prstGeom>
+          <a:solidFill>
+            <a:srgbClr val="ECEFF1"/>
+          </a:solidFill>
+          <a:ln w="14000">
+            <a:solidFill>
+              <a:srgbClr val="37474F"/>
+            </a:solidFill>
+          </a:ln>
+        </p:spPr>
+        <p:txBody>
+          <a:bodyPr/>
+          <a:lstStyle/>
+          <a:p/>
+        </p:txBody>
+      </p:sp>
+      <p:sp>
+        <p:nvSpPr>
+          <p:cNvPr id="37" name="blkt"/>
+          <p:cNvSpPr txBox="1"/>
+          <p:nvPr/>
+        </p:nvSpPr>
+        <p:spPr>
+          <a:xfrm>
+            <a:off x="7159752" y="2724912"/>
+            <a:ext cx="1975104" cy="1024128"/>
+          </a:xfrm>
+          <a:prstGeom prst="rect">
+            <a:avLst/>
+          </a:prstGeom>
+          <a:noFill/>
+        </p:spPr>
+        <p:txBody>
+          <a:bodyPr wrap="square" anchor="t" rtlCol="0">
+            <a:normAutofit/>
+          </a:bodyPr>
+          <a:lstStyle/>
+          <a:p>
+            <a:pPr algn="l">
+              <a:spcAft>
+                <a:spcPts val="120"/>
+              </a:spcAft>
+              <a:buNone/>
+            </a:pPr>
+            <a:r>
+              <a:rPr lang="en-US" sz="1200" b="1" dirty="0">
+                <a:solidFill>
+                  <a:srgbClr val="37474F"/>
+                </a:solidFill>
+                <a:latin typeface="Calibri"/>
+              </a:rPr>
+              <a:t>Right motors</a:t>
+            </a:r>
+          </a:p>
+          <a:p>
+            <a:pPr algn="l">
+              <a:spcAft>
+                <a:spcPts val="120"/>
+              </a:spcAft>
+              <a:buNone/>
+            </a:pPr>
+            <a:r>
+              <a:rPr lang="en-US" sz="1050" dirty="0">
+                <a:solidFill>
+                  <a:srgbClr val="1A2421"/>
+                </a:solidFill>
+                <a:latin typeface="Calibri"/>
+              </a:rPr>
+              <a:t>FR + RR (parallel)</a:t>
+            </a:r>
+          </a:p>
+          <a:p>
+            <a:pPr algn="l">
+              <a:spcAft>
+                <a:spcPts val="120"/>
+              </a:spcAft>
+              <a:buNone/>
+            </a:pPr>
+            <a:r>
+              <a:rPr lang="en-US" sz="1000" dirty="0">
+                <a:solidFill>
+                  <a:srgbClr val="5B6B63"/>
+                </a:solidFill>
+                <a:latin typeface="Calibri"/>
+              </a:rPr>
+              <a:t>1N5819 flyback each</a:t>
+            </a:r>
+          </a:p>
+        </p:txBody>
+      </p:sp>
+      <p:sp>
+        <p:nvSpPr>
+          <p:cNvPr id="40" name="blk"/>
+          <p:cNvSpPr/>
+          <p:nvPr/>
+        </p:nvSpPr>
+        <p:spPr>
+          <a:xfrm>
+            <a:off x="9464040" y="1234440"/>
+            <a:ext cx="2240280" cy="2606040"/>
+          </a:xfrm>
+          <a:prstGeom prst="roundRect">
+            <a:avLst>
+              <a:gd name="adj" fmla="val 7000"/>
+            </a:avLst>
+          </a:prstGeom>
+          <a:solidFill>
+            <a:srgbClr val="FFF3E0"/>
+          </a:solidFill>
+          <a:ln w="14000">
+            <a:solidFill>
+              <a:srgbClr val="E65100"/>
+            </a:solidFill>
+          </a:ln>
+        </p:spPr>
+        <p:txBody>
+          <a:bodyPr/>
+          <a:lstStyle/>
+          <a:p/>
+        </p:txBody>
+      </p:sp>
+      <p:sp>
+        <p:nvSpPr>
+          <p:cNvPr id="41" name="blkt"/>
+          <p:cNvSpPr txBox="1"/>
+          <p:nvPr/>
+        </p:nvSpPr>
+        <p:spPr>
+          <a:xfrm>
+            <a:off x="9628632" y="1325880"/>
+            <a:ext cx="1929384" cy="2423160"/>
+          </a:xfrm>
+          <a:prstGeom prst="rect">
+            <a:avLst/>
+          </a:prstGeom>
+          <a:noFill/>
+        </p:spPr>
+        <p:txBody>
+          <a:bodyPr wrap="square" anchor="t" rtlCol="0">
+            <a:normAutofit/>
+          </a:bodyPr>
+          <a:lstStyle/>
+          <a:p>
+            <a:pPr algn="l">
+              <a:spcAft>
+                <a:spcPts val="120"/>
+              </a:spcAft>
+              <a:buNone/>
+            </a:pPr>
+            <a:r>
+              <a:rPr lang="en-US" sz="1200" b="1" dirty="0">
+                <a:solidFill>
+                  <a:srgbClr val="B26A00"/>
+                </a:solidFill>
+                <a:latin typeface="Calibri"/>
+              </a:rPr>
+              <a:t>Power &amp; ground</a:t>
+            </a:r>
+          </a:p>
+          <a:p>
+            <a:pPr algn="l">
+              <a:spcAft>
+                <a:spcPts val="120"/>
+              </a:spcAft>
+              <a:buNone/>
+            </a:pPr>
+            <a:r>
+              <a:rPr lang="en-US" sz="1050" dirty="0">
+                <a:solidFill>
+                  <a:srgbClr val="1A2421"/>
+                </a:solidFill>
+                <a:latin typeface="Calibri"/>
+              </a:rPr>
+              <a:t>B+  &lt;-  11.1 V bus</a:t>
+            </a:r>
+          </a:p>
+          <a:p>
+            <a:pPr algn="l">
+              <a:spcAft>
+                <a:spcPts val="120"/>
+              </a:spcAft>
+              <a:buNone/>
+            </a:pPr>
+            <a:r>
+              <a:rPr lang="en-US" sz="950" dirty="0">
+                <a:solidFill>
+                  <a:srgbClr val="5B6B63"/>
+                </a:solidFill>
+                <a:latin typeface="Calibri"/>
+              </a:rPr>
+              <a:t>(after fuse + XT60)</a:t>
+            </a:r>
+          </a:p>
+          <a:p>
+            <a:pPr algn="l">
+              <a:spcAft>
+                <a:spcPts val="120"/>
+              </a:spcAft>
+              <a:buNone/>
+            </a:pPr>
+            <a:r>
+              <a:rPr lang="en-US" sz="1050" dirty="0">
+                <a:solidFill>
+                  <a:srgbClr val="1A2421"/>
+                </a:solidFill>
+                <a:latin typeface="Calibri"/>
+              </a:rPr>
+              <a:t>B-  -&gt;  common GND</a:t>
+            </a:r>
+          </a:p>
+          <a:p>
+            <a:pPr algn="l">
+              <a:spcAft>
+                <a:spcPts val="120"/>
+              </a:spcAft>
+              <a:buNone/>
+            </a:pPr>
+            <a:r>
+              <a:rPr lang="en-US" sz="1000" dirty="0">
+                <a:solidFill>
+                  <a:srgbClr val="1A2421"/>
+                </a:solidFill>
+                <a:latin typeface="Calibri"/>
+              </a:rPr>
+              <a:t>VCC/GND -&gt; 3.3V / GND</a:t>
+            </a:r>
+          </a:p>
+          <a:p>
+            <a:pPr algn="l">
+              <a:spcAft>
+                <a:spcPts val="120"/>
+              </a:spcAft>
+              <a:buNone/>
+            </a:pPr>
+            <a:r>
+              <a:rPr lang="en-US" sz="1000" dirty="0">
+                <a:solidFill>
+                  <a:srgbClr val="5B6B63"/>
+                </a:solidFill>
+                <a:latin typeface="Calibri"/>
+              </a:rPr>
+              <a:t>P6KE15A TVS on bus</a:t>
+            </a:r>
+          </a:p>
+        </p:txBody>
+      </p:sp>
+      <p:sp>
+        <p:nvSpPr>
+          <p:cNvPr id="44" name="w1"/>
+          <p:cNvSpPr/>
+          <p:nvPr/>
+        </p:nvSpPr>
+        <p:spPr>
+          <a:xfrm>
+            <a:off x="3017520" y="1792224"/>
+            <a:ext cx="365760" cy="27432"/>
+          </a:xfrm>
+          <a:prstGeom prst="rect">
+            <a:avLst/>
+          </a:prstGeom>
+          <a:solidFill>
+            <a:srgbClr val="1565C0"/>
+          </a:solidFill>
+          <a:ln>
+            <a:noFill/>
+          </a:ln>
+        </p:spPr>
+        <p:txBody>
+          <a:bodyPr/>
+          <a:lstStyle/>
+          <a:p/>
+        </p:txBody>
+      </p:sp>
+      <p:sp>
+        <p:nvSpPr>
+          <p:cNvPr id="45" name="w2"/>
+          <p:cNvSpPr/>
+          <p:nvPr/>
+        </p:nvSpPr>
+        <p:spPr>
+          <a:xfrm>
+            <a:off x="3017520" y="3191256"/>
+            <a:ext cx="365760" cy="27432"/>
+          </a:xfrm>
+          <a:prstGeom prst="rect">
+            <a:avLst/>
+          </a:prstGeom>
+          <a:solidFill>
+            <a:srgbClr val="1565C0"/>
+          </a:solidFill>
+          <a:ln>
+            <a:noFill/>
+          </a:ln>
+        </p:spPr>
+        <p:txBody>
+          <a:bodyPr/>
+          <a:lstStyle/>
+          <a:p/>
+        </p:txBody>
+      </p:sp>
+      <p:sp>
+        <p:nvSpPr>
+          <p:cNvPr id="46" name="w3"/>
+          <p:cNvSpPr/>
+          <p:nvPr/>
+        </p:nvSpPr>
+        <p:spPr>
+          <a:xfrm>
+            <a:off x="6583680" y="1792224"/>
+            <a:ext cx="411480" cy="27432"/>
+          </a:xfrm>
+          <a:prstGeom prst="rect">
+            <a:avLst/>
+          </a:prstGeom>
+          <a:solidFill>
+            <a:srgbClr val="37474F"/>
+          </a:solidFill>
+          <a:ln>
+            <a:noFill/>
+          </a:ln>
+        </p:spPr>
+        <p:txBody>
+          <a:bodyPr/>
+          <a:lstStyle/>
+          <a:p/>
+        </p:txBody>
+      </p:sp>
+      <p:sp>
+        <p:nvSpPr>
+          <p:cNvPr id="47" name="w4"/>
+          <p:cNvSpPr/>
+          <p:nvPr/>
+        </p:nvSpPr>
+        <p:spPr>
+          <a:xfrm>
+            <a:off x="6583680" y="3191256"/>
+            <a:ext cx="411480" cy="27432"/>
+          </a:xfrm>
+          <a:prstGeom prst="rect">
+            <a:avLst/>
+          </a:prstGeom>
+          <a:solidFill>
+            <a:srgbClr val="37474F"/>
+          </a:solidFill>
+          <a:ln>
+            <a:noFill/>
+          </a:ln>
+        </p:spPr>
+        <p:txBody>
+          <a:bodyPr/>
+          <a:lstStyle/>
+          <a:p/>
+        </p:txBody>
+      </p:sp>
+      <p:sp>
+        <p:nvSpPr>
+          <p:cNvPr id="48" name="l1"/>
+          <p:cNvSpPr txBox="1"/>
+          <p:nvPr/>
+        </p:nvSpPr>
+        <p:spPr>
+          <a:xfrm>
+            <a:off x="2999232" y="1463040"/>
+            <a:ext cx="457200" cy="274320"/>
+          </a:xfrm>
+          <a:prstGeom prst="rect">
+            <a:avLst/>
+          </a:prstGeom>
+          <a:noFill/>
+        </p:spPr>
+        <p:txBody>
+          <a:bodyPr wrap="square" anchor="t" rtlCol="0">
+            <a:normAutofit/>
+          </a:bodyPr>
+          <a:lstStyle/>
+          <a:p>
+            <a:pPr algn="ctr">
+              <a:spcAft>
+                <a:spcPts val="300"/>
+              </a:spcAft>
+              <a:buNone/>
+            </a:pPr>
+            <a:r>
+              <a:rPr lang="en-US" sz="850" b="1" dirty="0">
+                <a:solidFill>
+                  <a:srgbClr val="1565C0"/>
+                </a:solidFill>
+                <a:latin typeface="Calibri"/>
+              </a:rPr>
+              <a:t>19/21</a:t>
+            </a:r>
+          </a:p>
+        </p:txBody>
+      </p:sp>
+      <p:sp>
+        <p:nvSpPr>
+          <p:cNvPr id="49" name="l2"/>
+          <p:cNvSpPr txBox="1"/>
+          <p:nvPr/>
+        </p:nvSpPr>
+        <p:spPr>
+          <a:xfrm>
+            <a:off x="2999232" y="2862072"/>
+            <a:ext cx="457200" cy="274320"/>
+          </a:xfrm>
+          <a:prstGeom prst="rect">
+            <a:avLst/>
+          </a:prstGeom>
+          <a:noFill/>
+        </p:spPr>
+        <p:txBody>
+          <a:bodyPr wrap="square" anchor="t" rtlCol="0">
+            <a:normAutofit/>
+          </a:bodyPr>
+          <a:lstStyle/>
+          <a:p>
+            <a:pPr algn="ctr">
+              <a:spcAft>
+                <a:spcPts val="300"/>
+              </a:spcAft>
+              <a:buNone/>
+            </a:pPr>
+            <a:r>
+              <a:rPr lang="en-US" sz="850" b="1" dirty="0">
+                <a:solidFill>
+                  <a:srgbClr val="1565C0"/>
+                </a:solidFill>
+                <a:latin typeface="Calibri"/>
+              </a:rPr>
+              <a:t>22/23</a:t>
+            </a:r>
+          </a:p>
+        </p:txBody>
+      </p:sp>
+      <p:sp>
+        <p:nvSpPr>
+          <p:cNvPr id="50" name="note"/>
+          <p:cNvSpPr txBox="1"/>
+          <p:nvPr/>
+        </p:nvSpPr>
+        <p:spPr>
+          <a:xfrm>
+            <a:off x="411480" y="3913632"/>
+            <a:ext cx="11292840" cy="292608"/>
+          </a:xfrm>
+          <a:prstGeom prst="rect">
+            <a:avLst/>
+          </a:prstGeom>
+          <a:noFill/>
+        </p:spPr>
+        <p:txBody>
+          <a:bodyPr wrap="square" anchor="t" rtlCol="0">
+            <a:normAutofit/>
+          </a:bodyPr>
+          <a:lstStyle/>
+          <a:p>
+            <a:pPr algn="l">
+              <a:spcAft>
+                <a:spcPts val="300"/>
+              </a:spcAft>
+              <a:buNone/>
+            </a:pPr>
+            <a:r>
+              <a:rPr lang="en-US" sz="1050" i="1" dirty="0">
+                <a:solidFill>
+                  <a:srgbClr val="5B6B63"/>
+                </a:solidFill>
+                <a:latin typeface="Calibri"/>
+              </a:rPr>
+              <a:t>GPIO32/33 (old L298N ENA/ENB) now FREE   -   optional R_IS/L_IS -&gt; ADS1115 A0/A1 can replace the 2x ACS712 (stall sensing).</a:t>
+            </a:r>
+          </a:p>
+        </p:txBody>
+      </p:sp>
+      <p:graphicFrame>
+        <p:nvGraphicFramePr>
+          <p:cNvPr id="60" name="pinmap"/>
+          <p:cNvGraphicFramePr/>
+          <p:nvPr/>
+        </p:nvGraphicFramePr>
+        <p:xfrm>
+          <a:off x="411480" y="4224528"/>
+          <a:ext cx="11292840" cy="2080260"/>
+        </p:xfrm>
+        <a:graphic>
+          <a:graphicData uri="http://schemas.openxmlformats.org/drawingml/2006/table">
+            <a:tbl>
+              <a:tblPr firstRow="1">
+                <a:tableStyleId>{5C22544A-7EE6-4342-B048-85BDC9FD1C3A}</a:tableStyleId>
+              </a:tblPr>
+              <a:tblGrid>
+                <a:gridCol w="2194560"/>
+                <a:gridCol w="3108960"/>
+                <a:gridCol w="3108960"/>
+                <a:gridCol w="2880360"/>
+              </a:tblGrid>
+              <a:tr h="297180">
+                <a:tc>
+                  <a:txBody>
+                    <a:bodyPr/>
+                    <a:lstStyle/>
+                    <a:p>
+                      <a:pPr algn="l"/>
+                      <a:r>
+                        <a:rPr lang="en-US" sz="1100" b="1" dirty="0">
+                          <a:solidFill>
+                            <a:srgbClr val="FFFFFF"/>
+                          </a:solidFill>
+                          <a:latin typeface="Calibri"/>
+                        </a:rPr>
+                        <a:t>Signal</a:t>
+                      </a:r>
+                    </a:p>
+                  </a:txBody>
+                  <a:tcPr marL="55000" marR="55000" marT="16000" marB="16000" anchor="ctr">
+                    <a:solidFill>
+                      <a:srgbClr val="2E7D32"/>
+                    </a:solidFill>
+                  </a:tcPr>
+                </a:tc>
+                <a:tc>
+                  <a:txBody>
+                    <a:bodyPr/>
+                    <a:lstStyle/>
+                    <a:p>
+                      <a:pPr algn="l"/>
+                      <a:r>
+                        <a:rPr lang="en-US" sz="1100" b="1" dirty="0">
+                          <a:solidFill>
+                            <a:srgbClr val="FFFFFF"/>
+                          </a:solidFill>
+                          <a:latin typeface="Calibri"/>
+                        </a:rPr>
+                        <a:t>Driver #1 (LEFT)</a:t>
+                      </a:r>
+                    </a:p>
+                  </a:txBody>
+                  <a:tcPr marL="55000" marR="55000" marT="16000" marB="16000" anchor="ctr">
+                    <a:solidFill>
+                      <a:srgbClr val="2E7D32"/>
+                    </a:solidFill>
+                  </a:tcPr>
+                </a:tc>
+                <a:tc>
+                  <a:txBody>
+                    <a:bodyPr/>
+                    <a:lstStyle/>
+                    <a:p>
+                      <a:pPr algn="l"/>
+                      <a:r>
+                        <a:rPr lang="en-US" sz="1100" b="1" dirty="0">
+                          <a:solidFill>
+                            <a:srgbClr val="FFFFFF"/>
+                          </a:solidFill>
+                          <a:latin typeface="Calibri"/>
+                        </a:rPr>
+                        <a:t>Driver #2 (RIGHT)</a:t>
+                      </a:r>
+                    </a:p>
+                  </a:txBody>
+                  <a:tcPr marL="55000" marR="55000" marT="16000" marB="16000" anchor="ctr">
+                    <a:solidFill>
+                      <a:srgbClr val="2E7D32"/>
+                    </a:solidFill>
+                  </a:tcPr>
+                </a:tc>
+                <a:tc>
+                  <a:txBody>
+                    <a:bodyPr/>
+                    <a:lstStyle/>
+                    <a:p>
+                      <a:pPr algn="l"/>
+                      <a:r>
+                        <a:rPr lang="en-US" sz="1100" b="1" dirty="0">
+                          <a:solidFill>
+                            <a:srgbClr val="FFFFFF"/>
+                          </a:solidFill>
+                          <a:latin typeface="Calibri"/>
+                        </a:rPr>
+                        <a:t>Notes</a:t>
+                      </a:r>
+                    </a:p>
+                  </a:txBody>
+                  <a:tcPr marL="55000" marR="55000" marT="16000" marB="16000" anchor="ctr">
+                    <a:solidFill>
+                      <a:srgbClr val="2E7D32"/>
+                    </a:solidFill>
+                  </a:tcPr>
+                </a:tc>
+              </a:tr>
+              <a:tr h="297180">
+                <a:tc>
+                  <a:txBody>
+                    <a:bodyPr/>
+                    <a:lstStyle/>
+                    <a:p>
+                      <a:pPr algn="l"/>
+                      <a:r>
+                        <a:rPr lang="en-US" sz="1050" b="1" dirty="0">
+                          <a:solidFill>
+                            <a:srgbClr val="1A2421"/>
+                          </a:solidFill>
+                          <a:latin typeface="Calibri"/>
+                        </a:rPr>
+                        <a:t>RPWM (forward)</a:t>
+                      </a:r>
+                    </a:p>
+                  </a:txBody>
+                  <a:tcPr marL="55000" marR="55000" marT="16000" marB="16000" anchor="ctr">
+                    <a:solidFill>
+                      <a:srgbClr val="F3F8F1"/>
+                    </a:solidFill>
+                  </a:tcPr>
+                </a:tc>
+                <a:tc>
+                  <a:txBody>
+                    <a:bodyPr/>
+                    <a:lstStyle/>
+                    <a:p>
+                      <a:pPr algn="l"/>
+                      <a:r>
+                        <a:rPr lang="en-US" sz="1050" dirty="0">
+                          <a:solidFill>
+                            <a:srgbClr val="1A2421"/>
+                          </a:solidFill>
+                          <a:latin typeface="Calibri"/>
+                        </a:rPr>
+                        <a:t>ESP32 GPIO19 (LEDC0)</a:t>
+                      </a:r>
+                    </a:p>
+                  </a:txBody>
+                  <a:tcPr marL="55000" marR="55000" marT="16000" marB="16000" anchor="ctr">
+                    <a:solidFill>
+                      <a:srgbClr val="F3F8F1"/>
+                    </a:solidFill>
+                  </a:tcPr>
+                </a:tc>
+                <a:tc>
+                  <a:txBody>
+                    <a:bodyPr/>
+                    <a:lstStyle/>
+                    <a:p>
+                      <a:pPr algn="l"/>
+                      <a:r>
+                        <a:rPr lang="en-US" sz="1050" dirty="0">
+                          <a:solidFill>
+                            <a:srgbClr val="1A2421"/>
+                          </a:solidFill>
+                          <a:latin typeface="Calibri"/>
+                        </a:rPr>
+                        <a:t>ESP32 GPIO22 (LEDC2)</a:t>
+                      </a:r>
+                    </a:p>
+                  </a:txBody>
+                  <a:tcPr marL="55000" marR="55000" marT="16000" marB="16000" anchor="ctr">
+                    <a:solidFill>
+                      <a:srgbClr val="F3F8F1"/>
+                    </a:solidFill>
+                  </a:tcPr>
+                </a:tc>
+                <a:tc>
+                  <a:txBody>
+                    <a:bodyPr/>
+                    <a:lstStyle/>
+                    <a:p>
+                      <a:pPr algn="l"/>
+                      <a:r>
+                        <a:rPr lang="en-US" sz="1050" dirty="0">
+                          <a:solidFill>
+                            <a:srgbClr val="1A2421"/>
+                          </a:solidFill>
+                          <a:latin typeface="Calibri"/>
+                        </a:rPr>
+                        <a:t>PWM, 1 kHz</a:t>
+                      </a:r>
+                    </a:p>
+                  </a:txBody>
+                  <a:tcPr marL="55000" marR="55000" marT="16000" marB="16000" anchor="ctr">
+                    <a:solidFill>
+                      <a:srgbClr val="F3F8F1"/>
+                    </a:solidFill>
+                  </a:tcPr>
+                </a:tc>
+              </a:tr>
+              <a:tr h="297180">
+                <a:tc>
+                  <a:txBody>
+                    <a:bodyPr/>
+                    <a:lstStyle/>
+                    <a:p>
+                      <a:pPr algn="l"/>
+                      <a:r>
+                        <a:rPr lang="en-US" sz="1050" b="1" dirty="0">
+                          <a:solidFill>
+                            <a:srgbClr val="1A2421"/>
+                          </a:solidFill>
+                          <a:latin typeface="Calibri"/>
+                        </a:rPr>
+                        <a:t>LPWM (reverse)</a:t>
+                      </a:r>
+                    </a:p>
+                  </a:txBody>
+                  <a:tcPr marL="55000" marR="55000" marT="16000" marB="16000" anchor="ctr">
+                    <a:solidFill>
+                      <a:srgbClr val="FFFFFF"/>
+                    </a:solidFill>
+                  </a:tcPr>
+                </a:tc>
+                <a:tc>
+                  <a:txBody>
+                    <a:bodyPr/>
+                    <a:lstStyle/>
+                    <a:p>
+                      <a:pPr algn="l"/>
+                      <a:r>
+                        <a:rPr lang="en-US" sz="1050" dirty="0">
+                          <a:solidFill>
+                            <a:srgbClr val="1A2421"/>
+                          </a:solidFill>
+                          <a:latin typeface="Calibri"/>
+                        </a:rPr>
+                        <a:t>ESP32 GPIO21 (LEDC1)</a:t>
+                      </a:r>
+                    </a:p>
+                  </a:txBody>
+                  <a:tcPr marL="55000" marR="55000" marT="16000" marB="16000" anchor="ctr">
+                    <a:solidFill>
+                      <a:srgbClr val="FFFFFF"/>
+                    </a:solidFill>
+                  </a:tcPr>
+                </a:tc>
+                <a:tc>
+                  <a:txBody>
+                    <a:bodyPr/>
+                    <a:lstStyle/>
+                    <a:p>
+                      <a:pPr algn="l"/>
+                      <a:r>
+                        <a:rPr lang="en-US" sz="1050" dirty="0">
+                          <a:solidFill>
+                            <a:srgbClr val="1A2421"/>
+                          </a:solidFill>
+                          <a:latin typeface="Calibri"/>
+                        </a:rPr>
+                        <a:t>ESP32 GPIO23 (LEDC3)</a:t>
+                      </a:r>
+                    </a:p>
+                  </a:txBody>
+                  <a:tcPr marL="55000" marR="55000" marT="16000" marB="16000" anchor="ctr">
+                    <a:solidFill>
+                      <a:srgbClr val="FFFFFF"/>
+                    </a:solidFill>
+                  </a:tcPr>
+                </a:tc>
+                <a:tc>
+                  <a:txBody>
+                    <a:bodyPr/>
+                    <a:lstStyle/>
+                    <a:p>
+                      <a:pPr algn="l"/>
+                      <a:r>
+                        <a:rPr lang="en-US" sz="1050" dirty="0">
+                          <a:solidFill>
+                            <a:srgbClr val="1A2421"/>
+                          </a:solidFill>
+                          <a:latin typeface="Calibri"/>
+                        </a:rPr>
+                        <a:t>PWM, 1 kHz</a:t>
+                      </a:r>
+                    </a:p>
+                  </a:txBody>
+                  <a:tcPr marL="55000" marR="55000" marT="16000" marB="16000" anchor="ctr">
+                    <a:solidFill>
+                      <a:srgbClr val="FFFFFF"/>
+                    </a:solidFill>
+                  </a:tcPr>
+                </a:tc>
+              </a:tr>
+              <a:tr h="297180">
+                <a:tc>
+                  <a:txBody>
+                    <a:bodyPr/>
+                    <a:lstStyle/>
+                    <a:p>
+                      <a:pPr algn="l"/>
+                      <a:r>
+                        <a:rPr lang="en-US" sz="1050" b="1" dirty="0">
+                          <a:solidFill>
+                            <a:srgbClr val="1A2421"/>
+                          </a:solidFill>
+                          <a:latin typeface="Calibri"/>
+                        </a:rPr>
+                        <a:t>R_EN &amp; L_EN</a:t>
+                      </a:r>
+                    </a:p>
+                  </a:txBody>
+                  <a:tcPr marL="55000" marR="55000" marT="16000" marB="16000" anchor="ctr">
+                    <a:solidFill>
+                      <a:srgbClr val="F3F8F1"/>
+                    </a:solidFill>
+                  </a:tcPr>
+                </a:tc>
+                <a:tc>
+                  <a:txBody>
+                    <a:bodyPr/>
+                    <a:lstStyle/>
+                    <a:p>
+                      <a:pPr algn="l"/>
+                      <a:r>
+                        <a:rPr lang="en-US" sz="1050" dirty="0">
+                          <a:solidFill>
+                            <a:srgbClr val="1A2421"/>
+                          </a:solidFill>
+                          <a:latin typeface="Calibri"/>
+                        </a:rPr>
+                        <a:t>3.3 V (tied)</a:t>
+                      </a:r>
+                    </a:p>
+                  </a:txBody>
+                  <a:tcPr marL="55000" marR="55000" marT="16000" marB="16000" anchor="ctr">
+                    <a:solidFill>
+                      <a:srgbClr val="F3F8F1"/>
+                    </a:solidFill>
+                  </a:tcPr>
+                </a:tc>
+                <a:tc>
+                  <a:txBody>
+                    <a:bodyPr/>
+                    <a:lstStyle/>
+                    <a:p>
+                      <a:pPr algn="l"/>
+                      <a:r>
+                        <a:rPr lang="en-US" sz="1050" dirty="0">
+                          <a:solidFill>
+                            <a:srgbClr val="1A2421"/>
+                          </a:solidFill>
+                          <a:latin typeface="Calibri"/>
+                        </a:rPr>
+                        <a:t>3.3 V (tied)</a:t>
+                      </a:r>
+                    </a:p>
+                  </a:txBody>
+                  <a:tcPr marL="55000" marR="55000" marT="16000" marB="16000" anchor="ctr">
+                    <a:solidFill>
+                      <a:srgbClr val="F3F8F1"/>
+                    </a:solidFill>
+                  </a:tcPr>
+                </a:tc>
+                <a:tc>
+                  <a:txBody>
+                    <a:bodyPr/>
+                    <a:lstStyle/>
+                    <a:p>
+                      <a:pPr algn="l"/>
+                      <a:r>
+                        <a:rPr lang="en-US" sz="1050" dirty="0">
+                          <a:solidFill>
+                            <a:srgbClr val="1A2421"/>
+                          </a:solidFill>
+                          <a:latin typeface="Calibri"/>
+                        </a:rPr>
+                        <a:t>always enabled</a:t>
+                      </a:r>
+                    </a:p>
+                  </a:txBody>
+                  <a:tcPr marL="55000" marR="55000" marT="16000" marB="16000" anchor="ctr">
+                    <a:solidFill>
+                      <a:srgbClr val="F3F8F1"/>
+                    </a:solidFill>
+                  </a:tcPr>
+                </a:tc>
+              </a:tr>
+              <a:tr h="297180">
+                <a:tc>
+                  <a:txBody>
+                    <a:bodyPr/>
+                    <a:lstStyle/>
+                    <a:p>
+                      <a:pPr algn="l"/>
+                      <a:r>
+                        <a:rPr lang="en-US" sz="1050" b="1" dirty="0">
+                          <a:solidFill>
+                            <a:srgbClr val="1A2421"/>
+                          </a:solidFill>
+                          <a:latin typeface="Calibri"/>
+                        </a:rPr>
+                        <a:t>VCC / GND</a:t>
+                      </a:r>
+                    </a:p>
+                  </a:txBody>
+                  <a:tcPr marL="55000" marR="55000" marT="16000" marB="16000" anchor="ctr">
+                    <a:solidFill>
+                      <a:srgbClr val="FFFFFF"/>
+                    </a:solidFill>
+                  </a:tcPr>
+                </a:tc>
+                <a:tc>
+                  <a:txBody>
+                    <a:bodyPr/>
+                    <a:lstStyle/>
+                    <a:p>
+                      <a:pPr algn="l"/>
+                      <a:r>
+                        <a:rPr lang="en-US" sz="1050" dirty="0">
+                          <a:solidFill>
+                            <a:srgbClr val="1A2421"/>
+                          </a:solidFill>
+                          <a:latin typeface="Calibri"/>
+                        </a:rPr>
+                        <a:t>3.3 V / star GND</a:t>
+                      </a:r>
+                    </a:p>
+                  </a:txBody>
+                  <a:tcPr marL="55000" marR="55000" marT="16000" marB="16000" anchor="ctr">
+                    <a:solidFill>
+                      <a:srgbClr val="FFFFFF"/>
+                    </a:solidFill>
+                  </a:tcPr>
+                </a:tc>
+                <a:tc>
+                  <a:txBody>
+                    <a:bodyPr/>
+                    <a:lstStyle/>
+                    <a:p>
+                      <a:pPr algn="l"/>
+                      <a:r>
+                        <a:rPr lang="en-US" sz="1050" dirty="0">
+                          <a:solidFill>
+                            <a:srgbClr val="1A2421"/>
+                          </a:solidFill>
+                          <a:latin typeface="Calibri"/>
+                        </a:rPr>
+                        <a:t>3.3 V / star GND</a:t>
+                      </a:r>
+                    </a:p>
+                  </a:txBody>
+                  <a:tcPr marL="55000" marR="55000" marT="16000" marB="16000" anchor="ctr">
+                    <a:solidFill>
+                      <a:srgbClr val="FFFFFF"/>
+                    </a:solidFill>
+                  </a:tcPr>
+                </a:tc>
+                <a:tc>
+                  <a:txBody>
+                    <a:bodyPr/>
+                    <a:lstStyle/>
+                    <a:p>
+                      <a:pPr algn="l"/>
+                      <a:r>
+                        <a:rPr lang="en-US" sz="1050" dirty="0">
+                          <a:solidFill>
+                            <a:srgbClr val="1A2421"/>
+                          </a:solidFill>
+                          <a:latin typeface="Calibri"/>
+                        </a:rPr>
+                        <a:t>logic + common ground</a:t>
+                      </a:r>
+                    </a:p>
+                  </a:txBody>
+                  <a:tcPr marL="55000" marR="55000" marT="16000" marB="16000" anchor="ctr">
+                    <a:solidFill>
+                      <a:srgbClr val="FFFFFF"/>
+                    </a:solidFill>
+                  </a:tcPr>
+                </a:tc>
+              </a:tr>
+              <a:tr h="297180">
+                <a:tc>
+                  <a:txBody>
+                    <a:bodyPr/>
+                    <a:lstStyle/>
+                    <a:p>
+                      <a:pPr algn="l"/>
+                      <a:r>
+                        <a:rPr lang="en-US" sz="1050" b="1" dirty="0">
+                          <a:solidFill>
+                            <a:srgbClr val="1A2421"/>
+                          </a:solidFill>
+                          <a:latin typeface="Calibri"/>
+                        </a:rPr>
+                        <a:t>B+ / B-</a:t>
+                      </a:r>
+                    </a:p>
+                  </a:txBody>
+                  <a:tcPr marL="55000" marR="55000" marT="16000" marB="16000" anchor="ctr">
+                    <a:solidFill>
+                      <a:srgbClr val="F3F8F1"/>
+                    </a:solidFill>
+                  </a:tcPr>
+                </a:tc>
+                <a:tc>
+                  <a:txBody>
+                    <a:bodyPr/>
+                    <a:lstStyle/>
+                    <a:p>
+                      <a:pPr algn="l"/>
+                      <a:r>
+                        <a:rPr lang="en-US" sz="1050" dirty="0">
+                          <a:solidFill>
+                            <a:srgbClr val="1A2421"/>
+                          </a:solidFill>
+                          <a:latin typeface="Calibri"/>
+                        </a:rPr>
+                        <a:t>11.1 V bus / GND</a:t>
+                      </a:r>
+                    </a:p>
+                  </a:txBody>
+                  <a:tcPr marL="55000" marR="55000" marT="16000" marB="16000" anchor="ctr">
+                    <a:solidFill>
+                      <a:srgbClr val="F3F8F1"/>
+                    </a:solidFill>
+                  </a:tcPr>
+                </a:tc>
+                <a:tc>
+                  <a:txBody>
+                    <a:bodyPr/>
+                    <a:lstStyle/>
+                    <a:p>
+                      <a:pPr algn="l"/>
+                      <a:r>
+                        <a:rPr lang="en-US" sz="1050" dirty="0">
+                          <a:solidFill>
+                            <a:srgbClr val="1A2421"/>
+                          </a:solidFill>
+                          <a:latin typeface="Calibri"/>
+                        </a:rPr>
+                        <a:t>11.1 V bus / GND</a:t>
+                      </a:r>
+                    </a:p>
+                  </a:txBody>
+                  <a:tcPr marL="55000" marR="55000" marT="16000" marB="16000" anchor="ctr">
+                    <a:solidFill>
+                      <a:srgbClr val="F3F8F1"/>
+                    </a:solidFill>
+                  </a:tcPr>
+                </a:tc>
+                <a:tc>
+                  <a:txBody>
+                    <a:bodyPr/>
+                    <a:lstStyle/>
+                    <a:p>
+                      <a:pPr algn="l"/>
+                      <a:r>
+                        <a:rPr lang="en-US" sz="1050" dirty="0">
+                          <a:solidFill>
+                            <a:srgbClr val="1A2421"/>
+                          </a:solidFill>
+                          <a:latin typeface="Calibri"/>
+                        </a:rPr>
+                        <a:t>battery power (fused)</a:t>
+                      </a:r>
+                    </a:p>
+                  </a:txBody>
+                  <a:tcPr marL="55000" marR="55000" marT="16000" marB="16000" anchor="ctr">
+                    <a:solidFill>
+                      <a:srgbClr val="F3F8F1"/>
+                    </a:solidFill>
+                  </a:tcPr>
+                </a:tc>
+              </a:tr>
+              <a:tr h="297180">
+                <a:tc>
+                  <a:txBody>
+                    <a:bodyPr/>
+                    <a:lstStyle/>
+                    <a:p>
+                      <a:pPr algn="l"/>
+                      <a:r>
+                        <a:rPr lang="en-US" sz="1050" b="1" dirty="0">
+                          <a:solidFill>
+                            <a:srgbClr val="1A2421"/>
+                          </a:solidFill>
+                          <a:latin typeface="Calibri"/>
+                        </a:rPr>
+                        <a:t>M+ / M-</a:t>
+                      </a:r>
+                    </a:p>
+                  </a:txBody>
+                  <a:tcPr marL="55000" marR="55000" marT="16000" marB="16000" anchor="ctr">
+                    <a:solidFill>
+                      <a:srgbClr val="FFFFFF"/>
+                    </a:solidFill>
+                  </a:tcPr>
+                </a:tc>
+                <a:tc>
+                  <a:txBody>
+                    <a:bodyPr/>
+                    <a:lstStyle/>
+                    <a:p>
+                      <a:pPr algn="l"/>
+                      <a:r>
+                        <a:rPr lang="en-US" sz="1050" dirty="0">
+                          <a:solidFill>
+                            <a:srgbClr val="1A2421"/>
+                          </a:solidFill>
+                          <a:latin typeface="Calibri"/>
+                        </a:rPr>
+                        <a:t>FL + RL motors</a:t>
+                      </a:r>
+                    </a:p>
+                  </a:txBody>
+                  <a:tcPr marL="55000" marR="55000" marT="16000" marB="16000" anchor="ctr">
+                    <a:solidFill>
+                      <a:srgbClr val="FFFFFF"/>
+                    </a:solidFill>
+                  </a:tcPr>
+                </a:tc>
+                <a:tc>
+                  <a:txBody>
+                    <a:bodyPr/>
+                    <a:lstStyle/>
+                    <a:p>
+                      <a:pPr algn="l"/>
+                      <a:r>
+                        <a:rPr lang="en-US" sz="1050" dirty="0">
+                          <a:solidFill>
+                            <a:srgbClr val="1A2421"/>
+                          </a:solidFill>
+                          <a:latin typeface="Calibri"/>
+                        </a:rPr>
+                        <a:t>FR + RR motors</a:t>
+                      </a:r>
+                    </a:p>
+                  </a:txBody>
+                  <a:tcPr marL="55000" marR="55000" marT="16000" marB="16000" anchor="ctr">
+                    <a:solidFill>
+                      <a:srgbClr val="FFFFFF"/>
+                    </a:solidFill>
+                  </a:tcPr>
+                </a:tc>
+                <a:tc>
+                  <a:txBody>
+                    <a:bodyPr/>
+                    <a:lstStyle/>
+                    <a:p>
+                      <a:pPr algn="l"/>
+                      <a:r>
+                        <a:rPr lang="en-US" sz="1050" dirty="0">
+                          <a:solidFill>
+                            <a:srgbClr val="1A2421"/>
+                          </a:solidFill>
+                          <a:latin typeface="Calibri"/>
+                        </a:rPr>
+                        <a:t>1N5819 flyback each</a:t>
+                      </a:r>
+                    </a:p>
+                  </a:txBody>
+                  <a:tcPr marL="55000" marR="55000" marT="16000" marB="16000" anchor="ctr">
+                    <a:solidFill>
+                      <a:srgbClr val="FFFFFF"/>
+                    </a:solidFill>
+                  </a:tcPr>
+                </a:tc>
+              </a:tr>
+            </a:tbl>
+          </a:graphicData>
+        </a:graphic>
+      </p:graphicFrame>
     </p:spTree>
   </p:cSld>
   <p:clrMapOvr>

</xml_diff>